<commit_message>
organoid: update build deck inspect loops
</commit_message>
<xml_diff>
--- a/collections/organoid/presentation/brain-organoid-question-journey/outputs/output.pptx
+++ b/collections/organoid/presentation/brain-organoid-question-journey/outputs/output.pptx
@@ -2,24 +2,24 @@
 <file path=ppt/presentation.xml><?xml version="1.0" encoding="utf-8"?>
 <p:presentation xmlns:p="http://schemas.openxmlformats.org/presentationml/2006/main">
   <p:sldMasterIdLst>
-    <p:sldMasterId xmlns:r="http://schemas.openxmlformats.org/officeDocument/2006/relationships" id="2147483648" r:id="R9d5f23c3fb244cc5"/>
+    <p:sldMasterId xmlns:r="http://schemas.openxmlformats.org/officeDocument/2006/relationships" id="2147483648" r:id="Ra720de4a084f4755"/>
   </p:sldMasterIdLst>
   <p:notesMasterIdLst>
-    <p:notesMasterId xmlns:r="http://schemas.openxmlformats.org/officeDocument/2006/relationships" r:id="R08ccb8f0aa7c4714"/>
+    <p:notesMasterId xmlns:r="http://schemas.openxmlformats.org/officeDocument/2006/relationships" r:id="R76e9172c755447dd"/>
   </p:notesMasterIdLst>
   <p:sldIdLst>
-    <p:sldId xmlns:r="http://schemas.openxmlformats.org/officeDocument/2006/relationships" id="256" r:id="R59c04cdb98bb4e76"/>
-    <p:sldId xmlns:r="http://schemas.openxmlformats.org/officeDocument/2006/relationships" id="257" r:id="Re43cd2630277410c"/>
-    <p:sldId xmlns:r="http://schemas.openxmlformats.org/officeDocument/2006/relationships" id="258" r:id="R850cccb3155340c9"/>
-    <p:sldId xmlns:r="http://schemas.openxmlformats.org/officeDocument/2006/relationships" id="259" r:id="R44c3a14260a94b1f"/>
-    <p:sldId xmlns:r="http://schemas.openxmlformats.org/officeDocument/2006/relationships" id="260" r:id="Rd863f9937c1742be"/>
-    <p:sldId xmlns:r="http://schemas.openxmlformats.org/officeDocument/2006/relationships" id="261" r:id="R4f5ce802c25b416c"/>
-    <p:sldId xmlns:r="http://schemas.openxmlformats.org/officeDocument/2006/relationships" id="262" r:id="R86969ac528e94134"/>
-    <p:sldId xmlns:r="http://schemas.openxmlformats.org/officeDocument/2006/relationships" id="263" r:id="R4e9798e2c3f243a7"/>
-    <p:sldId xmlns:r="http://schemas.openxmlformats.org/officeDocument/2006/relationships" id="264" r:id="Ra03f0ca77dce4f87"/>
-    <p:sldId xmlns:r="http://schemas.openxmlformats.org/officeDocument/2006/relationships" id="265" r:id="Rda58534a370d4182"/>
-    <p:sldId xmlns:r="http://schemas.openxmlformats.org/officeDocument/2006/relationships" id="266" r:id="R8355f16126db44c6"/>
-    <p:sldId xmlns:r="http://schemas.openxmlformats.org/officeDocument/2006/relationships" id="267" r:id="R4a8ff96e7f67477f"/>
+    <p:sldId xmlns:r="http://schemas.openxmlformats.org/officeDocument/2006/relationships" id="256" r:id="R706598e340ab4774"/>
+    <p:sldId xmlns:r="http://schemas.openxmlformats.org/officeDocument/2006/relationships" id="257" r:id="Rf151b712f4924a42"/>
+    <p:sldId xmlns:r="http://schemas.openxmlformats.org/officeDocument/2006/relationships" id="258" r:id="Rba5018f0c18c4f2e"/>
+    <p:sldId xmlns:r="http://schemas.openxmlformats.org/officeDocument/2006/relationships" id="259" r:id="Raa0650c5e6b54bb0"/>
+    <p:sldId xmlns:r="http://schemas.openxmlformats.org/officeDocument/2006/relationships" id="260" r:id="Rd7aa1865fa7f4e98"/>
+    <p:sldId xmlns:r="http://schemas.openxmlformats.org/officeDocument/2006/relationships" id="261" r:id="R25e1ddfab04a466f"/>
+    <p:sldId xmlns:r="http://schemas.openxmlformats.org/officeDocument/2006/relationships" id="262" r:id="R23f84669911c4111"/>
+    <p:sldId xmlns:r="http://schemas.openxmlformats.org/officeDocument/2006/relationships" id="263" r:id="Re4f7d62a1da24a2e"/>
+    <p:sldId xmlns:r="http://schemas.openxmlformats.org/officeDocument/2006/relationships" id="264" r:id="R8cb5aae19a764d09"/>
+    <p:sldId xmlns:r="http://schemas.openxmlformats.org/officeDocument/2006/relationships" id="265" r:id="R7679f6f03c6f44f1"/>
+    <p:sldId xmlns:r="http://schemas.openxmlformats.org/officeDocument/2006/relationships" id="266" r:id="R138a8f5a0d8448b6"/>
+    <p:sldId xmlns:r="http://schemas.openxmlformats.org/officeDocument/2006/relationships" id="267" r:id="Refceca85e91f4fb0"/>
   </p:sldIdLst>
   <p:sldSz cx="12192000" cy="6858000"/>
   <p:notesSz cx="6858000" cy="9144000"/>
@@ -1905,7 +1905,7 @@
           <p:cNvPr id="1" name="Title 1">
             <a:extLst xmlns:a="http://schemas.openxmlformats.org/drawingml/2006/main">
               <a:ext uri="{FF2B5EF4-FFF2-40B4-BE49-F238E27FC236}">
-                <a16:creationId xmlns:a16="http://schemas.microsoft.com/office/drawing/2014/main" id="{B594F4D4-7053-413B-AA06-E9FB569EB34A}"/>
+                <a16:creationId xmlns:a16="http://schemas.microsoft.com/office/drawing/2014/main" id="{ECC3B110-96BF-440A-A1B6-CBD5345734F3}"/>
               </a:ext>
             </a:extLst>
           </p:cNvPr>
@@ -1936,7 +1936,7 @@
           <p:cNvPr id="2" name="Subtitle 2">
             <a:extLst xmlns:a="http://schemas.openxmlformats.org/drawingml/2006/main">
               <a:ext uri="{FF2B5EF4-FFF2-40B4-BE49-F238E27FC236}">
-                <a16:creationId xmlns:a16="http://schemas.microsoft.com/office/drawing/2014/main" id="{9C04EAD1-CBDD-4069-A4BA-AA4ECC609695}"/>
+                <a16:creationId xmlns:a16="http://schemas.microsoft.com/office/drawing/2014/main" id="{29F5EAB8-9E93-44B6-9A8F-677A9BD04D04}"/>
               </a:ext>
             </a:extLst>
           </p:cNvPr>
@@ -1999,7 +1999,7 @@
           <p:cNvPr id="3" name="Date Placeholder 3">
             <a:extLst xmlns:a="http://schemas.openxmlformats.org/drawingml/2006/main">
               <a:ext uri="{FF2B5EF4-FFF2-40B4-BE49-F238E27FC236}">
-                <a16:creationId xmlns:a16="http://schemas.microsoft.com/office/drawing/2014/main" id="{9A0EA56D-F042-4F53-B965-BDDD6EEC1F21}"/>
+                <a16:creationId xmlns:a16="http://schemas.microsoft.com/office/drawing/2014/main" id="{26BD9A40-0D29-4897-A413-E6B2E6BBFE8C}"/>
               </a:ext>
             </a:extLst>
           </p:cNvPr>
@@ -2020,7 +2020,7 @@
           <p:cNvPr id="4" name="Footer Placeholder 4">
             <a:extLst xmlns:a="http://schemas.openxmlformats.org/drawingml/2006/main">
               <a:ext uri="{FF2B5EF4-FFF2-40B4-BE49-F238E27FC236}">
-                <a16:creationId xmlns:a16="http://schemas.microsoft.com/office/drawing/2014/main" id="{9AE38D5D-2DA4-4A1B-89C3-83D6AD8F91A4}"/>
+                <a16:creationId xmlns:a16="http://schemas.microsoft.com/office/drawing/2014/main" id="{EDBB824B-FD9D-4EC1-92AF-BEFAFB3D13A3}"/>
               </a:ext>
             </a:extLst>
           </p:cNvPr>
@@ -2041,7 +2041,7 @@
           <p:cNvPr id="5" name="Slide Number Placeholder 5">
             <a:extLst xmlns:a="http://schemas.openxmlformats.org/drawingml/2006/main">
               <a:ext uri="{FF2B5EF4-FFF2-40B4-BE49-F238E27FC236}">
-                <a16:creationId xmlns:a16="http://schemas.microsoft.com/office/drawing/2014/main" id="{821508BF-91E3-4E78-84B3-DCBD229C8660}"/>
+                <a16:creationId xmlns:a16="http://schemas.microsoft.com/office/drawing/2014/main" id="{11DAD1DA-DD27-4C25-AFB7-E057ACC56EC0}"/>
               </a:ext>
             </a:extLst>
           </p:cNvPr>
@@ -2084,7 +2084,7 @@
           <p:cNvPr id="1" name="Slide Number Placeholder 5">
             <a:extLst xmlns:a="http://schemas.openxmlformats.org/drawingml/2006/main">
               <a:ext uri="{FF2B5EF4-FFF2-40B4-BE49-F238E27FC236}">
-                <a16:creationId xmlns:a16="http://schemas.microsoft.com/office/drawing/2014/main" id="{62CAA3AB-91E2-4307-BCD7-126A01FC7DD5}"/>
+                <a16:creationId xmlns:a16="http://schemas.microsoft.com/office/drawing/2014/main" id="{E3B211BA-1583-47AF-A4CA-25141E837EC6}"/>
               </a:ext>
             </a:extLst>
           </p:cNvPr>
@@ -2123,7 +2123,7 @@
   </p:cSld>
   <p:clrMap bg1="lt1" tx1="dk1" bg2="lt2" tx2="dk2" accent1="accent1" accent2="accent2" accent3="accent3" accent4="accent4" accent5="accent5" accent6="accent6" hlink="hlink" folHlink="folHlink"/>
   <p:sldLayoutIdLst>
-    <p:sldLayoutId xmlns:r="http://schemas.openxmlformats.org/officeDocument/2006/relationships" id="2147483649" r:id="R3f567348ddb84e00"/>
+    <p:sldLayoutId xmlns:r="http://schemas.openxmlformats.org/officeDocument/2006/relationships" id="2147483649" r:id="R2c25b305d1b64e69"/>
   </p:sldLayoutIdLst>
   <p:txStyles>
     <p:titleStyle>
@@ -2429,7 +2429,7 @@
           <p:cNvPr id="1" name="Slide Number Placeholder 5">
             <a:extLst xmlns:a="http://schemas.openxmlformats.org/drawingml/2006/main">
               <a:ext uri="{FF2B5EF4-FFF2-40B4-BE49-F238E27FC236}">
-                <a16:creationId xmlns:a16="http://schemas.microsoft.com/office/drawing/2014/main" id="{821508BF-91E3-4E78-84B3-DCBD229C8660}"/>
+                <a16:creationId xmlns:a16="http://schemas.microsoft.com/office/drawing/2014/main" id="{11DAD1DA-DD27-4C25-AFB7-E057ACC56EC0}"/>
               </a:ext>
             </a:extLst>
           </p:cNvPr>
@@ -2465,7 +2465,7 @@
           <p:nvPr/>
         </p:nvPicPr>
         <p:blipFill>
-          <a:blip xmlns:r="http://schemas.openxmlformats.org/officeDocument/2006/relationships" xmlns:a="http://schemas.openxmlformats.org/drawingml/2006/main" r:embed="R95fcabfdd68a4c73"/>
+          <a:blip xmlns:r="http://schemas.openxmlformats.org/officeDocument/2006/relationships" xmlns:a="http://schemas.openxmlformats.org/drawingml/2006/main" r:embed="R4a5e0179826d4513"/>
           <a:srcRect xmlns:a="http://schemas.openxmlformats.org/drawingml/2006/main" l="0" t="21875" r="0" b="21875"/>
           <a:stretch xmlns:a="http://schemas.openxmlformats.org/drawingml/2006/main">
             <a:fillRect l="0" t="0" r="0" b="0"/>
@@ -2486,7 +2486,7 @@
           <p:cNvPr id="3" name="">
             <a:extLst xmlns:a="http://schemas.openxmlformats.org/drawingml/2006/main">
               <a:ext uri="{FF2B5EF4-FFF2-40B4-BE49-F238E27FC236}">
-                <a16:creationId xmlns:a16="http://schemas.microsoft.com/office/drawing/2014/main" id="{4135203F-E698-4D19-9ED9-AA9E7F389468}"/>
+                <a16:creationId xmlns:a16="http://schemas.microsoft.com/office/drawing/2014/main" id="{77339EF0-8F1E-49C0-AA20-AB70083193BB}"/>
               </a:ext>
             </a:extLst>
           </p:cNvPr>
@@ -2521,7 +2521,7 @@
           <p:cNvPr id="4" name="">
             <a:extLst xmlns:a="http://schemas.openxmlformats.org/drawingml/2006/main">
               <a:ext uri="{FF2B5EF4-FFF2-40B4-BE49-F238E27FC236}">
-                <a16:creationId xmlns:a16="http://schemas.microsoft.com/office/drawing/2014/main" id="{F002336D-5AD2-4ADD-9262-822687A62145}"/>
+                <a16:creationId xmlns:a16="http://schemas.microsoft.com/office/drawing/2014/main" id="{E1E90DB7-7C6E-4CA9-B74D-C96B63075758}"/>
               </a:ext>
             </a:extLst>
           </p:cNvPr>
@@ -2556,7 +2556,7 @@
           <p:cNvPr id="5" name="">
             <a:extLst xmlns:a="http://schemas.openxmlformats.org/drawingml/2006/main">
               <a:ext uri="{FF2B5EF4-FFF2-40B4-BE49-F238E27FC236}">
-                <a16:creationId xmlns:a16="http://schemas.microsoft.com/office/drawing/2014/main" id="{E60CE9B8-B881-4A5E-852B-50DFE5D4C899}"/>
+                <a16:creationId xmlns:a16="http://schemas.microsoft.com/office/drawing/2014/main" id="{0F421652-C795-4D0C-AFAE-D290A4EE3A13}"/>
               </a:ext>
             </a:extLst>
           </p:cNvPr>
@@ -2593,7 +2593,7 @@
           <p:cNvPr id="6" name="">
             <a:extLst xmlns:a="http://schemas.openxmlformats.org/drawingml/2006/main">
               <a:ext uri="{FF2B5EF4-FFF2-40B4-BE49-F238E27FC236}">
-                <a16:creationId xmlns:a16="http://schemas.microsoft.com/office/drawing/2014/main" id="{00E68DD0-4A9D-48EE-9CA9-11594A5923B9}"/>
+                <a16:creationId xmlns:a16="http://schemas.microsoft.com/office/drawing/2014/main" id="{9CB5977C-0EA1-44AC-B755-7306A61E9120}"/>
               </a:ext>
             </a:extLst>
           </p:cNvPr>
@@ -2630,7 +2630,7 @@
           <p:cNvPr id="7" name="">
             <a:extLst xmlns:a="http://schemas.openxmlformats.org/drawingml/2006/main">
               <a:ext uri="{FF2B5EF4-FFF2-40B4-BE49-F238E27FC236}">
-                <a16:creationId xmlns:a16="http://schemas.microsoft.com/office/drawing/2014/main" id="{2400C212-CD8B-4A34-A88B-B75F0D6D7DCE}"/>
+                <a16:creationId xmlns:a16="http://schemas.microsoft.com/office/drawing/2014/main" id="{4263FC6D-6119-4C7D-A5AA-41DA7C26F210}"/>
               </a:ext>
             </a:extLst>
           </p:cNvPr>
@@ -2667,7 +2667,7 @@
           <p:cNvPr id="8" name="">
             <a:extLst xmlns:a="http://schemas.openxmlformats.org/drawingml/2006/main">
               <a:ext uri="{FF2B5EF4-FFF2-40B4-BE49-F238E27FC236}">
-                <a16:creationId xmlns:a16="http://schemas.microsoft.com/office/drawing/2014/main" id="{7B134B4A-E7E5-4705-AC43-C9BAEDCCF8C1}"/>
+                <a16:creationId xmlns:a16="http://schemas.microsoft.com/office/drawing/2014/main" id="{A696CBEF-BE49-4E98-AA90-A7990C6FBD55}"/>
               </a:ext>
             </a:extLst>
           </p:cNvPr>
@@ -2704,7 +2704,7 @@
           <p:cNvPr id="9" name="">
             <a:extLst xmlns:a="http://schemas.openxmlformats.org/drawingml/2006/main">
               <a:ext uri="{FF2B5EF4-FFF2-40B4-BE49-F238E27FC236}">
-                <a16:creationId xmlns:a16="http://schemas.microsoft.com/office/drawing/2014/main" id="{CD752D20-5207-4A92-A34C-CE7DEEADC505}"/>
+                <a16:creationId xmlns:a16="http://schemas.microsoft.com/office/drawing/2014/main" id="{C0E0E9BB-2157-4012-B01A-277177FA9844}"/>
               </a:ext>
             </a:extLst>
           </p:cNvPr>
@@ -2739,7 +2739,7 @@
           <p:cNvPr id="10" name="">
             <a:extLst xmlns:a="http://schemas.openxmlformats.org/drawingml/2006/main">
               <a:ext uri="{FF2B5EF4-FFF2-40B4-BE49-F238E27FC236}">
-                <a16:creationId xmlns:a16="http://schemas.microsoft.com/office/drawing/2014/main" id="{EC69A68A-A88F-4DE3-AEEE-D5E0C5E44BBC}"/>
+                <a16:creationId xmlns:a16="http://schemas.microsoft.com/office/drawing/2014/main" id="{FD976BF8-754B-44F4-9DB1-A41466A50AC4}"/>
               </a:ext>
             </a:extLst>
           </p:cNvPr>
@@ -2797,7 +2797,7 @@
           <p:cNvPr id="11" name="">
             <a:extLst xmlns:a="http://schemas.openxmlformats.org/drawingml/2006/main">
               <a:ext uri="{FF2B5EF4-FFF2-40B4-BE49-F238E27FC236}">
-                <a16:creationId xmlns:a16="http://schemas.microsoft.com/office/drawing/2014/main" id="{E7941980-7445-4161-AF3D-D1FA45EEB487}"/>
+                <a16:creationId xmlns:a16="http://schemas.microsoft.com/office/drawing/2014/main" id="{624584EA-83F8-4D56-B030-984AA4014673}"/>
               </a:ext>
             </a:extLst>
           </p:cNvPr>
@@ -2872,7 +2872,7 @@
           <p:cNvPr id="12" name="">
             <a:extLst xmlns:a="http://schemas.openxmlformats.org/drawingml/2006/main">
               <a:ext uri="{FF2B5EF4-FFF2-40B4-BE49-F238E27FC236}">
-                <a16:creationId xmlns:a16="http://schemas.microsoft.com/office/drawing/2014/main" id="{23443940-25C1-473E-B83A-9D790F00148F}"/>
+                <a16:creationId xmlns:a16="http://schemas.microsoft.com/office/drawing/2014/main" id="{90017FA9-3222-4781-8123-1E68877C4F88}"/>
               </a:ext>
             </a:extLst>
           </p:cNvPr>
@@ -2947,7 +2947,7 @@
           <p:cNvPr id="13" name="">
             <a:extLst xmlns:a="http://schemas.openxmlformats.org/drawingml/2006/main">
               <a:ext uri="{FF2B5EF4-FFF2-40B4-BE49-F238E27FC236}">
-                <a16:creationId xmlns:a16="http://schemas.microsoft.com/office/drawing/2014/main" id="{6F2D9D53-E184-40D5-AFA9-228AAD70F461}"/>
+                <a16:creationId xmlns:a16="http://schemas.microsoft.com/office/drawing/2014/main" id="{7DC74DB7-240D-4EB0-B65E-165F70538A6E}"/>
               </a:ext>
             </a:extLst>
           </p:cNvPr>
@@ -2984,7 +2984,7 @@
           <p:cNvPr id="14" name="">
             <a:extLst xmlns:a="http://schemas.openxmlformats.org/drawingml/2006/main">
               <a:ext uri="{FF2B5EF4-FFF2-40B4-BE49-F238E27FC236}">
-                <a16:creationId xmlns:a16="http://schemas.microsoft.com/office/drawing/2014/main" id="{EBAEC967-ACFE-4E53-B3E3-2E4511DB46F7}"/>
+                <a16:creationId xmlns:a16="http://schemas.microsoft.com/office/drawing/2014/main" id="{F51B54BB-F896-410C-B679-45317198576A}"/>
               </a:ext>
             </a:extLst>
           </p:cNvPr>
@@ -3042,7 +3042,7 @@
           <p:cNvPr id="15" name="">
             <a:extLst xmlns:a="http://schemas.openxmlformats.org/drawingml/2006/main">
               <a:ext uri="{FF2B5EF4-FFF2-40B4-BE49-F238E27FC236}">
-                <a16:creationId xmlns:a16="http://schemas.microsoft.com/office/drawing/2014/main" id="{7EAA2DD1-1CD7-4B6C-B1E8-0A2F6D0B6AC2}"/>
+                <a16:creationId xmlns:a16="http://schemas.microsoft.com/office/drawing/2014/main" id="{A35F55F9-A16E-41AB-A46C-74A7497B4540}"/>
               </a:ext>
             </a:extLst>
           </p:cNvPr>
@@ -3077,7 +3077,7 @@
           <p:cNvPr id="16" name="">
             <a:extLst xmlns:a="http://schemas.openxmlformats.org/drawingml/2006/main">
               <a:ext uri="{FF2B5EF4-FFF2-40B4-BE49-F238E27FC236}">
-                <a16:creationId xmlns:a16="http://schemas.microsoft.com/office/drawing/2014/main" id="{1C4BD8C6-BE38-4BD5-8BC5-54DAAABCBAAF}"/>
+                <a16:creationId xmlns:a16="http://schemas.microsoft.com/office/drawing/2014/main" id="{7C9690DE-6E36-422A-B665-1610B27D5F92}"/>
               </a:ext>
             </a:extLst>
           </p:cNvPr>
@@ -3112,7 +3112,7 @@
           <p:cNvPr id="17" name="">
             <a:extLst xmlns:a="http://schemas.openxmlformats.org/drawingml/2006/main">
               <a:ext uri="{FF2B5EF4-FFF2-40B4-BE49-F238E27FC236}">
-                <a16:creationId xmlns:a16="http://schemas.microsoft.com/office/drawing/2014/main" id="{D33EDC71-79A8-4931-B4CA-86057250E3FC}"/>
+                <a16:creationId xmlns:a16="http://schemas.microsoft.com/office/drawing/2014/main" id="{201A1D4E-6207-48CF-A878-C534EBFC9391}"/>
               </a:ext>
             </a:extLst>
           </p:cNvPr>
@@ -3166,7 +3166,7 @@
           <p:cNvPr id="18" name="">
             <a:extLst xmlns:a="http://schemas.openxmlformats.org/drawingml/2006/main">
               <a:ext uri="{FF2B5EF4-FFF2-40B4-BE49-F238E27FC236}">
-                <a16:creationId xmlns:a16="http://schemas.microsoft.com/office/drawing/2014/main" id="{BEF1D92C-E63F-451C-A480-03978193D812}"/>
+                <a16:creationId xmlns:a16="http://schemas.microsoft.com/office/drawing/2014/main" id="{0707ACEE-CB88-4FE1-8B86-F8AD4F556F02}"/>
               </a:ext>
             </a:extLst>
           </p:cNvPr>
@@ -3224,7 +3224,7 @@
           <p:cNvPr id="19" name="">
             <a:extLst xmlns:a="http://schemas.openxmlformats.org/drawingml/2006/main">
               <a:ext uri="{FF2B5EF4-FFF2-40B4-BE49-F238E27FC236}">
-                <a16:creationId xmlns:a16="http://schemas.microsoft.com/office/drawing/2014/main" id="{319C1CF3-F704-4E39-A329-17C738548D79}"/>
+                <a16:creationId xmlns:a16="http://schemas.microsoft.com/office/drawing/2014/main" id="{0CE1A79B-C8FB-4FB6-92CE-231B997E3177}"/>
               </a:ext>
             </a:extLst>
           </p:cNvPr>
@@ -3299,7 +3299,7 @@
           <p:cNvPr id="20" name="">
             <a:extLst xmlns:a="http://schemas.openxmlformats.org/drawingml/2006/main">
               <a:ext uri="{FF2B5EF4-FFF2-40B4-BE49-F238E27FC236}">
-                <a16:creationId xmlns:a16="http://schemas.microsoft.com/office/drawing/2014/main" id="{B89F2617-D745-4667-AA30-C989158B3EDD}"/>
+                <a16:creationId xmlns:a16="http://schemas.microsoft.com/office/drawing/2014/main" id="{ED06CEF5-37F7-42CC-A4EB-1C6D1814DC8C}"/>
               </a:ext>
             </a:extLst>
           </p:cNvPr>
@@ -3334,7 +3334,7 @@
           <p:cNvPr id="21" name="">
             <a:extLst xmlns:a="http://schemas.openxmlformats.org/drawingml/2006/main">
               <a:ext uri="{FF2B5EF4-FFF2-40B4-BE49-F238E27FC236}">
-                <a16:creationId xmlns:a16="http://schemas.microsoft.com/office/drawing/2014/main" id="{F673671E-8E5E-4CF4-A581-607848400CBB}"/>
+                <a16:creationId xmlns:a16="http://schemas.microsoft.com/office/drawing/2014/main" id="{98B54306-4633-45D7-97E0-70F57C759700}"/>
               </a:ext>
             </a:extLst>
           </p:cNvPr>
@@ -3369,7 +3369,7 @@
           <p:cNvPr id="22" name="">
             <a:extLst xmlns:a="http://schemas.openxmlformats.org/drawingml/2006/main">
               <a:ext uri="{FF2B5EF4-FFF2-40B4-BE49-F238E27FC236}">
-                <a16:creationId xmlns:a16="http://schemas.microsoft.com/office/drawing/2014/main" id="{85883388-EE98-4ABA-B710-B12A85F8283E}"/>
+                <a16:creationId xmlns:a16="http://schemas.microsoft.com/office/drawing/2014/main" id="{86EFA5F7-04F6-45AA-836B-35168A23A427}"/>
               </a:ext>
             </a:extLst>
           </p:cNvPr>
@@ -3423,7 +3423,7 @@
           <p:cNvPr id="23" name="">
             <a:extLst xmlns:a="http://schemas.openxmlformats.org/drawingml/2006/main">
               <a:ext uri="{FF2B5EF4-FFF2-40B4-BE49-F238E27FC236}">
-                <a16:creationId xmlns:a16="http://schemas.microsoft.com/office/drawing/2014/main" id="{B69E5FDD-FA9F-4DCD-8AED-8003A1551617}"/>
+                <a16:creationId xmlns:a16="http://schemas.microsoft.com/office/drawing/2014/main" id="{72C92222-0B5E-414C-B5DA-189656526C75}"/>
               </a:ext>
             </a:extLst>
           </p:cNvPr>
@@ -3481,7 +3481,7 @@
           <p:cNvPr id="24" name="">
             <a:extLst xmlns:a="http://schemas.openxmlformats.org/drawingml/2006/main">
               <a:ext uri="{FF2B5EF4-FFF2-40B4-BE49-F238E27FC236}">
-                <a16:creationId xmlns:a16="http://schemas.microsoft.com/office/drawing/2014/main" id="{3AF96F0F-8C4E-4FE9-AE39-5FB50D4824AF}"/>
+                <a16:creationId xmlns:a16="http://schemas.microsoft.com/office/drawing/2014/main" id="{7FF59A00-372A-4682-B2CC-2C9C290A4918}"/>
               </a:ext>
             </a:extLst>
           </p:cNvPr>
@@ -3556,7 +3556,7 @@
           <p:cNvPr id="25" name="">
             <a:extLst xmlns:a="http://schemas.openxmlformats.org/drawingml/2006/main">
               <a:ext uri="{FF2B5EF4-FFF2-40B4-BE49-F238E27FC236}">
-                <a16:creationId xmlns:a16="http://schemas.microsoft.com/office/drawing/2014/main" id="{C6D61AFA-D7FE-4725-A91D-D17ABBB5D7D1}"/>
+                <a16:creationId xmlns:a16="http://schemas.microsoft.com/office/drawing/2014/main" id="{252783C7-6DFC-4DA7-9500-EEB240153661}"/>
               </a:ext>
             </a:extLst>
           </p:cNvPr>
@@ -3591,7 +3591,7 @@
           <p:cNvPr id="26" name="">
             <a:extLst xmlns:a="http://schemas.openxmlformats.org/drawingml/2006/main">
               <a:ext uri="{FF2B5EF4-FFF2-40B4-BE49-F238E27FC236}">
-                <a16:creationId xmlns:a16="http://schemas.microsoft.com/office/drawing/2014/main" id="{D746FE9E-CC90-4F3B-9D81-5DFCBB28E910}"/>
+                <a16:creationId xmlns:a16="http://schemas.microsoft.com/office/drawing/2014/main" id="{B7C29A70-87D4-4A71-9A05-9EA01401BEA1}"/>
               </a:ext>
             </a:extLst>
           </p:cNvPr>
@@ -3626,7 +3626,7 @@
           <p:cNvPr id="27" name="">
             <a:extLst xmlns:a="http://schemas.openxmlformats.org/drawingml/2006/main">
               <a:ext uri="{FF2B5EF4-FFF2-40B4-BE49-F238E27FC236}">
-                <a16:creationId xmlns:a16="http://schemas.microsoft.com/office/drawing/2014/main" id="{5F01CB18-5DCF-4966-8D83-8D44440DD3A1}"/>
+                <a16:creationId xmlns:a16="http://schemas.microsoft.com/office/drawing/2014/main" id="{E711E8A7-C1B8-4764-A335-8BB85142CF29}"/>
               </a:ext>
             </a:extLst>
           </p:cNvPr>
@@ -3680,7 +3680,7 @@
           <p:cNvPr id="28" name="">
             <a:extLst xmlns:a="http://schemas.openxmlformats.org/drawingml/2006/main">
               <a:ext uri="{FF2B5EF4-FFF2-40B4-BE49-F238E27FC236}">
-                <a16:creationId xmlns:a16="http://schemas.microsoft.com/office/drawing/2014/main" id="{38A82BF3-59FF-4FD5-8EF0-C576631AF9A6}"/>
+                <a16:creationId xmlns:a16="http://schemas.microsoft.com/office/drawing/2014/main" id="{81A49393-3949-4C9B-844A-86B085ED23CA}"/>
               </a:ext>
             </a:extLst>
           </p:cNvPr>
@@ -3738,7 +3738,7 @@
           <p:cNvPr id="29" name="">
             <a:extLst xmlns:a="http://schemas.openxmlformats.org/drawingml/2006/main">
               <a:ext uri="{FF2B5EF4-FFF2-40B4-BE49-F238E27FC236}">
-                <a16:creationId xmlns:a16="http://schemas.microsoft.com/office/drawing/2014/main" id="{3825E9B4-D853-4F9D-B1E9-5413BB4D1330}"/>
+                <a16:creationId xmlns:a16="http://schemas.microsoft.com/office/drawing/2014/main" id="{FE218DBA-DC67-4031-B959-2FF0C09237B4}"/>
               </a:ext>
             </a:extLst>
           </p:cNvPr>
@@ -3813,7 +3813,7 @@
           <p:cNvPr id="30" name="">
             <a:extLst xmlns:a="http://schemas.openxmlformats.org/drawingml/2006/main">
               <a:ext uri="{FF2B5EF4-FFF2-40B4-BE49-F238E27FC236}">
-                <a16:creationId xmlns:a16="http://schemas.microsoft.com/office/drawing/2014/main" id="{F44F6050-7037-49F6-A12E-C7F54943E160}"/>
+                <a16:creationId xmlns:a16="http://schemas.microsoft.com/office/drawing/2014/main" id="{642E8CAB-A9F7-49B5-B474-2138F24B5FF4}"/>
               </a:ext>
             </a:extLst>
           </p:cNvPr>
@@ -3848,7 +3848,7 @@
           <p:cNvPr id="31" name="">
             <a:extLst xmlns:a="http://schemas.openxmlformats.org/drawingml/2006/main">
               <a:ext uri="{FF2B5EF4-FFF2-40B4-BE49-F238E27FC236}">
-                <a16:creationId xmlns:a16="http://schemas.microsoft.com/office/drawing/2014/main" id="{B859E255-CDBF-4CC8-8A36-9D74BB969747}"/>
+                <a16:creationId xmlns:a16="http://schemas.microsoft.com/office/drawing/2014/main" id="{40FEB741-0BD1-484C-A361-F0E7620550C3}"/>
               </a:ext>
             </a:extLst>
           </p:cNvPr>
@@ -3883,7 +3883,7 @@
           <p:cNvPr id="32" name="">
             <a:extLst xmlns:a="http://schemas.openxmlformats.org/drawingml/2006/main">
               <a:ext uri="{FF2B5EF4-FFF2-40B4-BE49-F238E27FC236}">
-                <a16:creationId xmlns:a16="http://schemas.microsoft.com/office/drawing/2014/main" id="{9F0FA9D2-C3B3-4313-9D01-FDA1EA49FA0B}"/>
+                <a16:creationId xmlns:a16="http://schemas.microsoft.com/office/drawing/2014/main" id="{FBD4AA92-CABF-4530-B0A2-BBBA95CD1452}"/>
               </a:ext>
             </a:extLst>
           </p:cNvPr>
@@ -3937,7 +3937,7 @@
           <p:cNvPr id="33" name="">
             <a:extLst xmlns:a="http://schemas.openxmlformats.org/drawingml/2006/main">
               <a:ext uri="{FF2B5EF4-FFF2-40B4-BE49-F238E27FC236}">
-                <a16:creationId xmlns:a16="http://schemas.microsoft.com/office/drawing/2014/main" id="{C57FF973-A83F-4FDC-A266-9244E2AED488}"/>
+                <a16:creationId xmlns:a16="http://schemas.microsoft.com/office/drawing/2014/main" id="{E9DC7D06-779F-436E-BAC4-57AAFDDCB4E5}"/>
               </a:ext>
             </a:extLst>
           </p:cNvPr>
@@ -3995,7 +3995,7 @@
           <p:cNvPr id="34" name="">
             <a:extLst xmlns:a="http://schemas.openxmlformats.org/drawingml/2006/main">
               <a:ext uri="{FF2B5EF4-FFF2-40B4-BE49-F238E27FC236}">
-                <a16:creationId xmlns:a16="http://schemas.microsoft.com/office/drawing/2014/main" id="{1FACE5B2-DFAB-42C6-8AD7-270A4CB16DC8}"/>
+                <a16:creationId xmlns:a16="http://schemas.microsoft.com/office/drawing/2014/main" id="{FFEC52A0-C393-4EC9-AB22-79CFA92640FF}"/>
               </a:ext>
             </a:extLst>
           </p:cNvPr>
@@ -4053,7 +4053,7 @@
           <p:cNvPr id="35" name="">
             <a:extLst xmlns:a="http://schemas.openxmlformats.org/drawingml/2006/main">
               <a:ext uri="{FF2B5EF4-FFF2-40B4-BE49-F238E27FC236}">
-                <a16:creationId xmlns:a16="http://schemas.microsoft.com/office/drawing/2014/main" id="{1334168C-A6D6-43CB-961F-FE7564216903}"/>
+                <a16:creationId xmlns:a16="http://schemas.microsoft.com/office/drawing/2014/main" id="{ED61FC1C-1CDB-4DEB-BC25-73D2A73BF2A4}"/>
               </a:ext>
             </a:extLst>
           </p:cNvPr>
@@ -4088,7 +4088,7 @@
           <p:cNvPr id="36" name="">
             <a:extLst xmlns:a="http://schemas.openxmlformats.org/drawingml/2006/main">
               <a:ext uri="{FF2B5EF4-FFF2-40B4-BE49-F238E27FC236}">
-                <a16:creationId xmlns:a16="http://schemas.microsoft.com/office/drawing/2014/main" id="{D84867D3-2FB7-4D2D-A937-C713BA877B99}"/>
+                <a16:creationId xmlns:a16="http://schemas.microsoft.com/office/drawing/2014/main" id="{04156535-8226-4246-862A-5F99B9CAC964}"/>
               </a:ext>
             </a:extLst>
           </p:cNvPr>
@@ -4123,7 +4123,7 @@
           <p:cNvPr id="37" name="">
             <a:extLst xmlns:a="http://schemas.openxmlformats.org/drawingml/2006/main">
               <a:ext uri="{FF2B5EF4-FFF2-40B4-BE49-F238E27FC236}">
-                <a16:creationId xmlns:a16="http://schemas.microsoft.com/office/drawing/2014/main" id="{76975BD1-441D-4269-9798-A31545D49925}"/>
+                <a16:creationId xmlns:a16="http://schemas.microsoft.com/office/drawing/2014/main" id="{3A193531-8B89-458C-A18F-E94B08A801CC}"/>
               </a:ext>
             </a:extLst>
           </p:cNvPr>
@@ -4158,7 +4158,7 @@
           <p:cNvPr id="38" name="">
             <a:extLst xmlns:a="http://schemas.openxmlformats.org/drawingml/2006/main">
               <a:ext uri="{FF2B5EF4-FFF2-40B4-BE49-F238E27FC236}">
-                <a16:creationId xmlns:a16="http://schemas.microsoft.com/office/drawing/2014/main" id="{10CC3D05-F315-4095-9AFB-F22242C53630}"/>
+                <a16:creationId xmlns:a16="http://schemas.microsoft.com/office/drawing/2014/main" id="{B541EDDF-FBDF-4495-8B72-D85B93719533}"/>
               </a:ext>
             </a:extLst>
           </p:cNvPr>
@@ -4212,7 +4212,7 @@
           <p:cNvPr id="39" name="">
             <a:extLst xmlns:a="http://schemas.openxmlformats.org/drawingml/2006/main">
               <a:ext uri="{FF2B5EF4-FFF2-40B4-BE49-F238E27FC236}">
-                <a16:creationId xmlns:a16="http://schemas.microsoft.com/office/drawing/2014/main" id="{CDE9561F-97F2-4C93-902F-E9E8D5749B1D}"/>
+                <a16:creationId xmlns:a16="http://schemas.microsoft.com/office/drawing/2014/main" id="{59BF53CB-18BC-4A04-937C-891FC0F725FE}"/>
               </a:ext>
             </a:extLst>
           </p:cNvPr>
@@ -4266,7 +4266,7 @@
           <p:cNvPr id="40" name="">
             <a:extLst xmlns:a="http://schemas.openxmlformats.org/drawingml/2006/main">
               <a:ext uri="{FF2B5EF4-FFF2-40B4-BE49-F238E27FC236}">
-                <a16:creationId xmlns:a16="http://schemas.microsoft.com/office/drawing/2014/main" id="{6A4F81BD-0428-4B49-9B45-8C0C10C9C3EF}"/>
+                <a16:creationId xmlns:a16="http://schemas.microsoft.com/office/drawing/2014/main" id="{04E28CDB-6AF1-460B-BCC7-4695FE294912}"/>
               </a:ext>
             </a:extLst>
           </p:cNvPr>
@@ -4322,7 +4322,7 @@
     </p:spTree>
     <p:extLst>
       <p:ext uri="{BB962C8B-B14F-4D97-AF65-F5344CB8AC3E}">
-        <p14:creationId xmlns:p14="http://schemas.microsoft.com/office/powerpoint/2010/main" val="721257982"/>
+        <p14:creationId xmlns:p14="http://schemas.microsoft.com/office/powerpoint/2010/main" val="257606857"/>
       </p:ext>
     </p:extLst>
   </p:cSld>
@@ -4353,7 +4353,7 @@
           <p:cNvPr id="1" name="Slide Number Placeholder 5">
             <a:extLst xmlns:a="http://schemas.openxmlformats.org/drawingml/2006/main">
               <a:ext uri="{FF2B5EF4-FFF2-40B4-BE49-F238E27FC236}">
-                <a16:creationId xmlns:a16="http://schemas.microsoft.com/office/drawing/2014/main" id="{821508BF-91E3-4E78-84B3-DCBD229C8660}"/>
+                <a16:creationId xmlns:a16="http://schemas.microsoft.com/office/drawing/2014/main" id="{11DAD1DA-DD27-4C25-AFB7-E057ACC56EC0}"/>
               </a:ext>
             </a:extLst>
           </p:cNvPr>
@@ -4389,7 +4389,7 @@
           <p:nvPr/>
         </p:nvPicPr>
         <p:blipFill>
-          <a:blip xmlns:r="http://schemas.openxmlformats.org/officeDocument/2006/relationships" xmlns:a="http://schemas.openxmlformats.org/drawingml/2006/main" r:embed="R03a9e792bcc64ca9"/>
+          <a:blip xmlns:r="http://schemas.openxmlformats.org/officeDocument/2006/relationships" xmlns:a="http://schemas.openxmlformats.org/drawingml/2006/main" r:embed="R424ef6cffc1642c7"/>
           <a:srcRect xmlns:a="http://schemas.openxmlformats.org/drawingml/2006/main" l="0" t="21875" r="0" b="21875"/>
           <a:stretch xmlns:a="http://schemas.openxmlformats.org/drawingml/2006/main">
             <a:fillRect l="0" t="0" r="0" b="0"/>
@@ -4410,7 +4410,7 @@
           <p:cNvPr id="3" name="">
             <a:extLst xmlns:a="http://schemas.openxmlformats.org/drawingml/2006/main">
               <a:ext uri="{FF2B5EF4-FFF2-40B4-BE49-F238E27FC236}">
-                <a16:creationId xmlns:a16="http://schemas.microsoft.com/office/drawing/2014/main" id="{C090206B-885B-49A4-87F9-56001D15FFE9}"/>
+                <a16:creationId xmlns:a16="http://schemas.microsoft.com/office/drawing/2014/main" id="{623F2AFF-CC7E-4AC0-AB3B-DC2829B510CE}"/>
               </a:ext>
             </a:extLst>
           </p:cNvPr>
@@ -4445,7 +4445,7 @@
           <p:cNvPr id="4" name="">
             <a:extLst xmlns:a="http://schemas.openxmlformats.org/drawingml/2006/main">
               <a:ext uri="{FF2B5EF4-FFF2-40B4-BE49-F238E27FC236}">
-                <a16:creationId xmlns:a16="http://schemas.microsoft.com/office/drawing/2014/main" id="{CE630618-38E2-4A04-8BD7-D2E34ADFAEF2}"/>
+                <a16:creationId xmlns:a16="http://schemas.microsoft.com/office/drawing/2014/main" id="{7204AA75-EFC1-4ED5-82C5-B311E6946706}"/>
               </a:ext>
             </a:extLst>
           </p:cNvPr>
@@ -4480,7 +4480,7 @@
           <p:cNvPr id="5" name="">
             <a:extLst xmlns:a="http://schemas.openxmlformats.org/drawingml/2006/main">
               <a:ext uri="{FF2B5EF4-FFF2-40B4-BE49-F238E27FC236}">
-                <a16:creationId xmlns:a16="http://schemas.microsoft.com/office/drawing/2014/main" id="{4C6E6C54-E008-49AF-B1AD-25ABCA4D407E}"/>
+                <a16:creationId xmlns:a16="http://schemas.microsoft.com/office/drawing/2014/main" id="{B7A9F4FF-0DEE-4649-9DA9-D9EE575F9178}"/>
               </a:ext>
             </a:extLst>
           </p:cNvPr>
@@ -4517,7 +4517,7 @@
           <p:cNvPr id="6" name="">
             <a:extLst xmlns:a="http://schemas.openxmlformats.org/drawingml/2006/main">
               <a:ext uri="{FF2B5EF4-FFF2-40B4-BE49-F238E27FC236}">
-                <a16:creationId xmlns:a16="http://schemas.microsoft.com/office/drawing/2014/main" id="{F4CAC02F-7DD5-49ED-BD52-6D07FABCAF21}"/>
+                <a16:creationId xmlns:a16="http://schemas.microsoft.com/office/drawing/2014/main" id="{F6F3F18B-4C9B-45DB-B551-EF438B2BA6C4}"/>
               </a:ext>
             </a:extLst>
           </p:cNvPr>
@@ -4554,7 +4554,7 @@
           <p:cNvPr id="7" name="">
             <a:extLst xmlns:a="http://schemas.openxmlformats.org/drawingml/2006/main">
               <a:ext uri="{FF2B5EF4-FFF2-40B4-BE49-F238E27FC236}">
-                <a16:creationId xmlns:a16="http://schemas.microsoft.com/office/drawing/2014/main" id="{DEF273E2-F613-450F-BEED-416797A72D31}"/>
+                <a16:creationId xmlns:a16="http://schemas.microsoft.com/office/drawing/2014/main" id="{CEBD44D9-2D14-4AD0-B1D8-0707EDF91C88}"/>
               </a:ext>
             </a:extLst>
           </p:cNvPr>
@@ -4591,7 +4591,7 @@
           <p:cNvPr id="8" name="">
             <a:extLst xmlns:a="http://schemas.openxmlformats.org/drawingml/2006/main">
               <a:ext uri="{FF2B5EF4-FFF2-40B4-BE49-F238E27FC236}">
-                <a16:creationId xmlns:a16="http://schemas.microsoft.com/office/drawing/2014/main" id="{BBAEAA45-E7A8-4F43-A567-9A84F16EE8C8}"/>
+                <a16:creationId xmlns:a16="http://schemas.microsoft.com/office/drawing/2014/main" id="{D7B94C80-F256-424D-8F67-9A2F43606FD2}"/>
               </a:ext>
             </a:extLst>
           </p:cNvPr>
@@ -4628,7 +4628,7 @@
           <p:cNvPr id="9" name="">
             <a:extLst xmlns:a="http://schemas.openxmlformats.org/drawingml/2006/main">
               <a:ext uri="{FF2B5EF4-FFF2-40B4-BE49-F238E27FC236}">
-                <a16:creationId xmlns:a16="http://schemas.microsoft.com/office/drawing/2014/main" id="{BB98C368-514D-49EF-9B03-CA2F28AB936D}"/>
+                <a16:creationId xmlns:a16="http://schemas.microsoft.com/office/drawing/2014/main" id="{35A4C472-5364-42FC-88A9-E5D599B6C190}"/>
               </a:ext>
             </a:extLst>
           </p:cNvPr>
@@ -4686,7 +4686,7 @@
           <p:cNvPr id="10" name="">
             <a:extLst xmlns:a="http://schemas.openxmlformats.org/drawingml/2006/main">
               <a:ext uri="{FF2B5EF4-FFF2-40B4-BE49-F238E27FC236}">
-                <a16:creationId xmlns:a16="http://schemas.microsoft.com/office/drawing/2014/main" id="{D095EBEB-D630-4598-860A-85029EB03516}"/>
+                <a16:creationId xmlns:a16="http://schemas.microsoft.com/office/drawing/2014/main" id="{719F0A68-7B70-4EBA-A9F4-74B048F7B9DE}"/>
               </a:ext>
             </a:extLst>
           </p:cNvPr>
@@ -4744,7 +4744,7 @@
           <p:cNvPr id="11" name="">
             <a:extLst xmlns:a="http://schemas.openxmlformats.org/drawingml/2006/main">
               <a:ext uri="{FF2B5EF4-FFF2-40B4-BE49-F238E27FC236}">
-                <a16:creationId xmlns:a16="http://schemas.microsoft.com/office/drawing/2014/main" id="{A83C7A56-B01E-452B-944A-40D6092C827B}"/>
+                <a16:creationId xmlns:a16="http://schemas.microsoft.com/office/drawing/2014/main" id="{FC83B0EE-043B-4647-9CF6-FFD79112508B}"/>
               </a:ext>
             </a:extLst>
           </p:cNvPr>
@@ -4779,7 +4779,7 @@
           <p:cNvPr id="12" name="">
             <a:extLst xmlns:a="http://schemas.openxmlformats.org/drawingml/2006/main">
               <a:ext uri="{FF2B5EF4-FFF2-40B4-BE49-F238E27FC236}">
-                <a16:creationId xmlns:a16="http://schemas.microsoft.com/office/drawing/2014/main" id="{AB755F0D-47EE-478E-BF83-21B250F03F23}"/>
+                <a16:creationId xmlns:a16="http://schemas.microsoft.com/office/drawing/2014/main" id="{0E462C1B-0B47-45C5-B8D9-9CB360F41E59}"/>
               </a:ext>
             </a:extLst>
           </p:cNvPr>
@@ -4812,7 +4812,7 @@
           <p:cNvPr id="13" name="">
             <a:extLst xmlns:a="http://schemas.openxmlformats.org/drawingml/2006/main">
               <a:ext uri="{FF2B5EF4-FFF2-40B4-BE49-F238E27FC236}">
-                <a16:creationId xmlns:a16="http://schemas.microsoft.com/office/drawing/2014/main" id="{A48E631F-75E0-4E5D-9F9C-243930E76F2B}"/>
+                <a16:creationId xmlns:a16="http://schemas.microsoft.com/office/drawing/2014/main" id="{000D2091-C43C-45E1-BB8F-87ACCF395DE7}"/>
               </a:ext>
             </a:extLst>
           </p:cNvPr>
@@ -4887,7 +4887,7 @@
           <p:cNvPr id="14" name="">
             <a:extLst xmlns:a="http://schemas.openxmlformats.org/drawingml/2006/main">
               <a:ext uri="{FF2B5EF4-FFF2-40B4-BE49-F238E27FC236}">
-                <a16:creationId xmlns:a16="http://schemas.microsoft.com/office/drawing/2014/main" id="{14566768-CE95-4E50-88D3-1976B67E604F}"/>
+                <a16:creationId xmlns:a16="http://schemas.microsoft.com/office/drawing/2014/main" id="{A39A005D-642F-497E-BE84-298709F61668}"/>
               </a:ext>
             </a:extLst>
           </p:cNvPr>
@@ -4922,7 +4922,7 @@
           <p:cNvPr id="15" name="">
             <a:extLst xmlns:a="http://schemas.openxmlformats.org/drawingml/2006/main">
               <a:ext uri="{FF2B5EF4-FFF2-40B4-BE49-F238E27FC236}">
-                <a16:creationId xmlns:a16="http://schemas.microsoft.com/office/drawing/2014/main" id="{CFA0D215-B8A3-4D8A-A018-F8082487700A}"/>
+                <a16:creationId xmlns:a16="http://schemas.microsoft.com/office/drawing/2014/main" id="{618071BB-5319-4D38-996E-0B0EBA6A44E2}"/>
               </a:ext>
             </a:extLst>
           </p:cNvPr>
@@ -4957,7 +4957,7 @@
           <p:cNvPr id="16" name="">
             <a:extLst xmlns:a="http://schemas.openxmlformats.org/drawingml/2006/main">
               <a:ext uri="{FF2B5EF4-FFF2-40B4-BE49-F238E27FC236}">
-                <a16:creationId xmlns:a16="http://schemas.microsoft.com/office/drawing/2014/main" id="{290714FC-6E44-4942-9621-EE10EA75EEBA}"/>
+                <a16:creationId xmlns:a16="http://schemas.microsoft.com/office/drawing/2014/main" id="{5E1CD931-8B0F-4B6F-8E28-03C319472D9B}"/>
               </a:ext>
             </a:extLst>
           </p:cNvPr>
@@ -5015,7 +5015,7 @@
           <p:cNvPr id="17" name="">
             <a:extLst xmlns:a="http://schemas.openxmlformats.org/drawingml/2006/main">
               <a:ext uri="{FF2B5EF4-FFF2-40B4-BE49-F238E27FC236}">
-                <a16:creationId xmlns:a16="http://schemas.microsoft.com/office/drawing/2014/main" id="{3EB95513-A959-476A-ADC1-67BC00887658}"/>
+                <a16:creationId xmlns:a16="http://schemas.microsoft.com/office/drawing/2014/main" id="{6F562108-5CDD-4039-BB04-7B2341DF6AD0}"/>
               </a:ext>
             </a:extLst>
           </p:cNvPr>
@@ -5158,7 +5158,7 @@
           <p:cNvPr id="18" name="">
             <a:extLst xmlns:a="http://schemas.openxmlformats.org/drawingml/2006/main">
               <a:ext uri="{FF2B5EF4-FFF2-40B4-BE49-F238E27FC236}">
-                <a16:creationId xmlns:a16="http://schemas.microsoft.com/office/drawing/2014/main" id="{C2A8236C-C152-4481-BDB6-98C3B25B2FC3}"/>
+                <a16:creationId xmlns:a16="http://schemas.microsoft.com/office/drawing/2014/main" id="{D4EA852D-A9E8-42AE-B16C-4A154163D93A}"/>
               </a:ext>
             </a:extLst>
           </p:cNvPr>
@@ -5193,7 +5193,7 @@
           <p:cNvPr id="19" name="">
             <a:extLst xmlns:a="http://schemas.openxmlformats.org/drawingml/2006/main">
               <a:ext uri="{FF2B5EF4-FFF2-40B4-BE49-F238E27FC236}">
-                <a16:creationId xmlns:a16="http://schemas.microsoft.com/office/drawing/2014/main" id="{601EFACC-FCE5-48F8-98DD-EE4705A35F09}"/>
+                <a16:creationId xmlns:a16="http://schemas.microsoft.com/office/drawing/2014/main" id="{57DCBBD3-69D6-48D3-8E4A-595D04778CB9}"/>
               </a:ext>
             </a:extLst>
           </p:cNvPr>
@@ -5228,7 +5228,7 @@
           <p:cNvPr id="20" name="">
             <a:extLst xmlns:a="http://schemas.openxmlformats.org/drawingml/2006/main">
               <a:ext uri="{FF2B5EF4-FFF2-40B4-BE49-F238E27FC236}">
-                <a16:creationId xmlns:a16="http://schemas.microsoft.com/office/drawing/2014/main" id="{9FC27201-7147-4468-850E-C43655CD1567}"/>
+                <a16:creationId xmlns:a16="http://schemas.microsoft.com/office/drawing/2014/main" id="{4A7EC523-EBD3-49E7-BA22-02A43D490ECF}"/>
               </a:ext>
             </a:extLst>
           </p:cNvPr>
@@ -5282,7 +5282,7 @@
           <p:cNvPr id="21" name="">
             <a:extLst xmlns:a="http://schemas.openxmlformats.org/drawingml/2006/main">
               <a:ext uri="{FF2B5EF4-FFF2-40B4-BE49-F238E27FC236}">
-                <a16:creationId xmlns:a16="http://schemas.microsoft.com/office/drawing/2014/main" id="{862B034F-C636-448E-AB2A-8FDFA5A3900E}"/>
+                <a16:creationId xmlns:a16="http://schemas.microsoft.com/office/drawing/2014/main" id="{D6A976FB-41E3-43D6-89A7-F29BE0943CF8}"/>
               </a:ext>
             </a:extLst>
           </p:cNvPr>
@@ -5340,7 +5340,7 @@
           <p:cNvPr id="22" name="">
             <a:extLst xmlns:a="http://schemas.openxmlformats.org/drawingml/2006/main">
               <a:ext uri="{FF2B5EF4-FFF2-40B4-BE49-F238E27FC236}">
-                <a16:creationId xmlns:a16="http://schemas.microsoft.com/office/drawing/2014/main" id="{BA918CF9-9B47-42D0-ACEC-9B5326B2FA06}"/>
+                <a16:creationId xmlns:a16="http://schemas.microsoft.com/office/drawing/2014/main" id="{4007E99E-1559-4516-BBBE-B2E32D56753D}"/>
               </a:ext>
             </a:extLst>
           </p:cNvPr>
@@ -5415,7 +5415,7 @@
           <p:cNvPr id="23" name="">
             <a:extLst xmlns:a="http://schemas.openxmlformats.org/drawingml/2006/main">
               <a:ext uri="{FF2B5EF4-FFF2-40B4-BE49-F238E27FC236}">
-                <a16:creationId xmlns:a16="http://schemas.microsoft.com/office/drawing/2014/main" id="{15249BC5-70E7-4141-9F95-7532F8817966}"/>
+                <a16:creationId xmlns:a16="http://schemas.microsoft.com/office/drawing/2014/main" id="{4CE63FCB-302A-4D6D-A56A-C51911049D08}"/>
               </a:ext>
             </a:extLst>
           </p:cNvPr>
@@ -5450,7 +5450,7 @@
           <p:cNvPr id="24" name="">
             <a:extLst xmlns:a="http://schemas.openxmlformats.org/drawingml/2006/main">
               <a:ext uri="{FF2B5EF4-FFF2-40B4-BE49-F238E27FC236}">
-                <a16:creationId xmlns:a16="http://schemas.microsoft.com/office/drawing/2014/main" id="{FB4C32C6-9C50-4BB3-8A5C-5E303E938582}"/>
+                <a16:creationId xmlns:a16="http://schemas.microsoft.com/office/drawing/2014/main" id="{B1F58676-E345-4A08-ABA0-567E2837CD8B}"/>
               </a:ext>
             </a:extLst>
           </p:cNvPr>
@@ -5485,7 +5485,7 @@
           <p:cNvPr id="25" name="">
             <a:extLst xmlns:a="http://schemas.openxmlformats.org/drawingml/2006/main">
               <a:ext uri="{FF2B5EF4-FFF2-40B4-BE49-F238E27FC236}">
-                <a16:creationId xmlns:a16="http://schemas.microsoft.com/office/drawing/2014/main" id="{F4B176F1-4CE1-4A8A-973C-720445D9B2A6}"/>
+                <a16:creationId xmlns:a16="http://schemas.microsoft.com/office/drawing/2014/main" id="{1D041E46-E249-4B52-BD30-D7EC3700AEFD}"/>
               </a:ext>
             </a:extLst>
           </p:cNvPr>
@@ -5539,7 +5539,7 @@
           <p:cNvPr id="26" name="">
             <a:extLst xmlns:a="http://schemas.openxmlformats.org/drawingml/2006/main">
               <a:ext uri="{FF2B5EF4-FFF2-40B4-BE49-F238E27FC236}">
-                <a16:creationId xmlns:a16="http://schemas.microsoft.com/office/drawing/2014/main" id="{E50A460D-4F07-4CD9-9C96-4BBB81C75849}"/>
+                <a16:creationId xmlns:a16="http://schemas.microsoft.com/office/drawing/2014/main" id="{3E0A5A79-591F-4B72-8434-EB1891B9FB30}"/>
               </a:ext>
             </a:extLst>
           </p:cNvPr>
@@ -5597,7 +5597,7 @@
           <p:cNvPr id="27" name="">
             <a:extLst xmlns:a="http://schemas.openxmlformats.org/drawingml/2006/main">
               <a:ext uri="{FF2B5EF4-FFF2-40B4-BE49-F238E27FC236}">
-                <a16:creationId xmlns:a16="http://schemas.microsoft.com/office/drawing/2014/main" id="{B36FC948-407C-4F7D-B563-B339142D7E60}"/>
+                <a16:creationId xmlns:a16="http://schemas.microsoft.com/office/drawing/2014/main" id="{9F092E6A-A0CD-40CC-9E19-7D7BD6E7DB6B}"/>
               </a:ext>
             </a:extLst>
           </p:cNvPr>
@@ -5672,7 +5672,7 @@
           <p:cNvPr id="28" name="">
             <a:extLst xmlns:a="http://schemas.openxmlformats.org/drawingml/2006/main">
               <a:ext uri="{FF2B5EF4-FFF2-40B4-BE49-F238E27FC236}">
-                <a16:creationId xmlns:a16="http://schemas.microsoft.com/office/drawing/2014/main" id="{B0AC76B9-DCE0-41F2-96E4-09F91EAD034E}"/>
+                <a16:creationId xmlns:a16="http://schemas.microsoft.com/office/drawing/2014/main" id="{F428376F-D6E1-4201-90E1-A60C46786BC5}"/>
               </a:ext>
             </a:extLst>
           </p:cNvPr>
@@ -5707,7 +5707,7 @@
           <p:cNvPr id="29" name="">
             <a:extLst xmlns:a="http://schemas.openxmlformats.org/drawingml/2006/main">
               <a:ext uri="{FF2B5EF4-FFF2-40B4-BE49-F238E27FC236}">
-                <a16:creationId xmlns:a16="http://schemas.microsoft.com/office/drawing/2014/main" id="{75738BC3-9EFA-48B4-947E-9FE958D74A1B}"/>
+                <a16:creationId xmlns:a16="http://schemas.microsoft.com/office/drawing/2014/main" id="{BAC12E30-6BBF-4FCB-85DD-EB2876A71351}"/>
               </a:ext>
             </a:extLst>
           </p:cNvPr>
@@ -5742,7 +5742,7 @@
           <p:cNvPr id="30" name="">
             <a:extLst xmlns:a="http://schemas.openxmlformats.org/drawingml/2006/main">
               <a:ext uri="{FF2B5EF4-FFF2-40B4-BE49-F238E27FC236}">
-                <a16:creationId xmlns:a16="http://schemas.microsoft.com/office/drawing/2014/main" id="{4CD06E01-89F8-40D6-A7D7-CBFDEF0B3CB9}"/>
+                <a16:creationId xmlns:a16="http://schemas.microsoft.com/office/drawing/2014/main" id="{0BB3EB25-A308-4505-8069-150550964851}"/>
               </a:ext>
             </a:extLst>
           </p:cNvPr>
@@ -5796,7 +5796,7 @@
           <p:cNvPr id="31" name="">
             <a:extLst xmlns:a="http://schemas.openxmlformats.org/drawingml/2006/main">
               <a:ext uri="{FF2B5EF4-FFF2-40B4-BE49-F238E27FC236}">
-                <a16:creationId xmlns:a16="http://schemas.microsoft.com/office/drawing/2014/main" id="{429F62EA-B903-4FFB-90AE-999C32E0589D}"/>
+                <a16:creationId xmlns:a16="http://schemas.microsoft.com/office/drawing/2014/main" id="{884B20DA-2E3C-4EF0-94B4-A62097EED93E}"/>
               </a:ext>
             </a:extLst>
           </p:cNvPr>
@@ -5854,7 +5854,7 @@
           <p:cNvPr id="32" name="">
             <a:extLst xmlns:a="http://schemas.openxmlformats.org/drawingml/2006/main">
               <a:ext uri="{FF2B5EF4-FFF2-40B4-BE49-F238E27FC236}">
-                <a16:creationId xmlns:a16="http://schemas.microsoft.com/office/drawing/2014/main" id="{32643431-C328-47EB-81B5-C16C7CBDAA5B}"/>
+                <a16:creationId xmlns:a16="http://schemas.microsoft.com/office/drawing/2014/main" id="{3DD76DCC-7E1B-414B-AEC4-5C1CF567093B}"/>
               </a:ext>
             </a:extLst>
           </p:cNvPr>
@@ -5929,7 +5929,7 @@
           <p:cNvPr id="33" name="">
             <a:extLst xmlns:a="http://schemas.openxmlformats.org/drawingml/2006/main">
               <a:ext uri="{FF2B5EF4-FFF2-40B4-BE49-F238E27FC236}">
-                <a16:creationId xmlns:a16="http://schemas.microsoft.com/office/drawing/2014/main" id="{3290A54D-C059-49E2-8D1F-F9789F275193}"/>
+                <a16:creationId xmlns:a16="http://schemas.microsoft.com/office/drawing/2014/main" id="{E91319EF-38C6-45BA-89BB-4FFC7ADE685C}"/>
               </a:ext>
             </a:extLst>
           </p:cNvPr>
@@ -5964,7 +5964,7 @@
           <p:cNvPr id="34" name="">
             <a:extLst xmlns:a="http://schemas.openxmlformats.org/drawingml/2006/main">
               <a:ext uri="{FF2B5EF4-FFF2-40B4-BE49-F238E27FC236}">
-                <a16:creationId xmlns:a16="http://schemas.microsoft.com/office/drawing/2014/main" id="{D92DE7DA-95B4-4ECE-95AE-74465A3E666F}"/>
+                <a16:creationId xmlns:a16="http://schemas.microsoft.com/office/drawing/2014/main" id="{BB5F76A5-F66A-4421-B3C4-0E5772F13C14}"/>
               </a:ext>
             </a:extLst>
           </p:cNvPr>
@@ -5999,7 +5999,7 @@
           <p:cNvPr id="35" name="">
             <a:extLst xmlns:a="http://schemas.openxmlformats.org/drawingml/2006/main">
               <a:ext uri="{FF2B5EF4-FFF2-40B4-BE49-F238E27FC236}">
-                <a16:creationId xmlns:a16="http://schemas.microsoft.com/office/drawing/2014/main" id="{0E6E3534-F705-403F-A19A-7B0319122791}"/>
+                <a16:creationId xmlns:a16="http://schemas.microsoft.com/office/drawing/2014/main" id="{DB251601-555A-4362-8623-B3FD1AE0E768}"/>
               </a:ext>
             </a:extLst>
           </p:cNvPr>
@@ -6053,7 +6053,7 @@
           <p:cNvPr id="36" name="">
             <a:extLst xmlns:a="http://schemas.openxmlformats.org/drawingml/2006/main">
               <a:ext uri="{FF2B5EF4-FFF2-40B4-BE49-F238E27FC236}">
-                <a16:creationId xmlns:a16="http://schemas.microsoft.com/office/drawing/2014/main" id="{9945486C-2AE1-45F0-8F4F-9AF64D26B3D7}"/>
+                <a16:creationId xmlns:a16="http://schemas.microsoft.com/office/drawing/2014/main" id="{1793DA0B-89FD-4F3E-B8D5-158D48C640EE}"/>
               </a:ext>
             </a:extLst>
           </p:cNvPr>
@@ -6111,7 +6111,7 @@
           <p:cNvPr id="37" name="">
             <a:extLst xmlns:a="http://schemas.openxmlformats.org/drawingml/2006/main">
               <a:ext uri="{FF2B5EF4-FFF2-40B4-BE49-F238E27FC236}">
-                <a16:creationId xmlns:a16="http://schemas.microsoft.com/office/drawing/2014/main" id="{6F841BF1-1C2D-4BB2-8D1B-4624257CC4E8}"/>
+                <a16:creationId xmlns:a16="http://schemas.microsoft.com/office/drawing/2014/main" id="{53C14694-FC53-4A6C-B537-A0858096A52E}"/>
               </a:ext>
             </a:extLst>
           </p:cNvPr>
@@ -6186,7 +6186,7 @@
           <p:cNvPr id="38" name="">
             <a:extLst xmlns:a="http://schemas.openxmlformats.org/drawingml/2006/main">
               <a:ext uri="{FF2B5EF4-FFF2-40B4-BE49-F238E27FC236}">
-                <a16:creationId xmlns:a16="http://schemas.microsoft.com/office/drawing/2014/main" id="{12191C65-6305-4773-9A31-E7A31227FC17}"/>
+                <a16:creationId xmlns:a16="http://schemas.microsoft.com/office/drawing/2014/main" id="{D7BAA1E0-7EEA-4CC0-BBFB-ADCE039FDE86}"/>
               </a:ext>
             </a:extLst>
           </p:cNvPr>
@@ -6221,7 +6221,7 @@
           <p:cNvPr id="39" name="">
             <a:extLst xmlns:a="http://schemas.openxmlformats.org/drawingml/2006/main">
               <a:ext uri="{FF2B5EF4-FFF2-40B4-BE49-F238E27FC236}">
-                <a16:creationId xmlns:a16="http://schemas.microsoft.com/office/drawing/2014/main" id="{FD06B8F0-4F4A-4A9D-A8CC-228B32D7B011}"/>
+                <a16:creationId xmlns:a16="http://schemas.microsoft.com/office/drawing/2014/main" id="{D28B03EA-6C2F-427A-8C05-17FCA9F12F67}"/>
               </a:ext>
             </a:extLst>
           </p:cNvPr>
@@ -6256,7 +6256,7 @@
           <p:cNvPr id="40" name="">
             <a:extLst xmlns:a="http://schemas.openxmlformats.org/drawingml/2006/main">
               <a:ext uri="{FF2B5EF4-FFF2-40B4-BE49-F238E27FC236}">
-                <a16:creationId xmlns:a16="http://schemas.microsoft.com/office/drawing/2014/main" id="{75E692B1-C672-47D7-A6F5-8C184FFB82FA}"/>
+                <a16:creationId xmlns:a16="http://schemas.microsoft.com/office/drawing/2014/main" id="{77291D1D-910F-46C3-B472-3A9B4F565DAF}"/>
               </a:ext>
             </a:extLst>
           </p:cNvPr>
@@ -6310,7 +6310,7 @@
           <p:cNvPr id="41" name="">
             <a:extLst xmlns:a="http://schemas.openxmlformats.org/drawingml/2006/main">
               <a:ext uri="{FF2B5EF4-FFF2-40B4-BE49-F238E27FC236}">
-                <a16:creationId xmlns:a16="http://schemas.microsoft.com/office/drawing/2014/main" id="{D05C581A-B066-4D42-B89B-AC2D3EB58777}"/>
+                <a16:creationId xmlns:a16="http://schemas.microsoft.com/office/drawing/2014/main" id="{2246C00D-59EE-4051-8AF7-51BF38AC0A41}"/>
               </a:ext>
             </a:extLst>
           </p:cNvPr>
@@ -6368,7 +6368,7 @@
           <p:cNvPr id="42" name="">
             <a:extLst xmlns:a="http://schemas.openxmlformats.org/drawingml/2006/main">
               <a:ext uri="{FF2B5EF4-FFF2-40B4-BE49-F238E27FC236}">
-                <a16:creationId xmlns:a16="http://schemas.microsoft.com/office/drawing/2014/main" id="{1780D057-0E44-48D7-B328-730F0D168444}"/>
+                <a16:creationId xmlns:a16="http://schemas.microsoft.com/office/drawing/2014/main" id="{C977EB38-FD83-4A0F-83DB-EB02A3C88DC2}"/>
               </a:ext>
             </a:extLst>
           </p:cNvPr>
@@ -6443,7 +6443,7 @@
           <p:cNvPr id="43" name="">
             <a:extLst xmlns:a="http://schemas.openxmlformats.org/drawingml/2006/main">
               <a:ext uri="{FF2B5EF4-FFF2-40B4-BE49-F238E27FC236}">
-                <a16:creationId xmlns:a16="http://schemas.microsoft.com/office/drawing/2014/main" id="{FB0D0291-5949-414B-86F5-EFEF2925819E}"/>
+                <a16:creationId xmlns:a16="http://schemas.microsoft.com/office/drawing/2014/main" id="{F168BD5F-1630-4092-81B3-F1356D8222C4}"/>
               </a:ext>
             </a:extLst>
           </p:cNvPr>
@@ -6478,7 +6478,7 @@
           <p:cNvPr id="44" name="">
             <a:extLst xmlns:a="http://schemas.openxmlformats.org/drawingml/2006/main">
               <a:ext uri="{FF2B5EF4-FFF2-40B4-BE49-F238E27FC236}">
-                <a16:creationId xmlns:a16="http://schemas.microsoft.com/office/drawing/2014/main" id="{8516B33C-0726-4487-8121-19C8F6343A98}"/>
+                <a16:creationId xmlns:a16="http://schemas.microsoft.com/office/drawing/2014/main" id="{0F1138DF-5D54-498E-AA5C-C6486FD7DFE7}"/>
               </a:ext>
             </a:extLst>
           </p:cNvPr>
@@ -6513,7 +6513,7 @@
           <p:cNvPr id="45" name="">
             <a:extLst xmlns:a="http://schemas.openxmlformats.org/drawingml/2006/main">
               <a:ext uri="{FF2B5EF4-FFF2-40B4-BE49-F238E27FC236}">
-                <a16:creationId xmlns:a16="http://schemas.microsoft.com/office/drawing/2014/main" id="{E87FA2F6-CB1F-4CD9-85F6-13CDBA6DF8BC}"/>
+                <a16:creationId xmlns:a16="http://schemas.microsoft.com/office/drawing/2014/main" id="{19759746-2104-43DD-950B-8BC88684D74F}"/>
               </a:ext>
             </a:extLst>
           </p:cNvPr>
@@ -6567,7 +6567,7 @@
           <p:cNvPr id="46" name="">
             <a:extLst xmlns:a="http://schemas.openxmlformats.org/drawingml/2006/main">
               <a:ext uri="{FF2B5EF4-FFF2-40B4-BE49-F238E27FC236}">
-                <a16:creationId xmlns:a16="http://schemas.microsoft.com/office/drawing/2014/main" id="{19ED3336-5F22-4262-9C07-4425BABE5F0E}"/>
+                <a16:creationId xmlns:a16="http://schemas.microsoft.com/office/drawing/2014/main" id="{133541D2-24CC-45CC-B259-09045F1202DF}"/>
               </a:ext>
             </a:extLst>
           </p:cNvPr>
@@ -6625,7 +6625,7 @@
           <p:cNvPr id="47" name="">
             <a:extLst xmlns:a="http://schemas.openxmlformats.org/drawingml/2006/main">
               <a:ext uri="{FF2B5EF4-FFF2-40B4-BE49-F238E27FC236}">
-                <a16:creationId xmlns:a16="http://schemas.microsoft.com/office/drawing/2014/main" id="{E0265174-9959-4E40-9878-0B0A0FFFD198}"/>
+                <a16:creationId xmlns:a16="http://schemas.microsoft.com/office/drawing/2014/main" id="{B6113F9F-DB8E-4561-8F95-D0DA215308EC}"/>
               </a:ext>
             </a:extLst>
           </p:cNvPr>
@@ -6700,7 +6700,7 @@
           <p:cNvPr id="48" name="">
             <a:extLst xmlns:a="http://schemas.openxmlformats.org/drawingml/2006/main">
               <a:ext uri="{FF2B5EF4-FFF2-40B4-BE49-F238E27FC236}">
-                <a16:creationId xmlns:a16="http://schemas.microsoft.com/office/drawing/2014/main" id="{A0CD3C8F-18E3-4E20-97CB-A4712CB636C1}"/>
+                <a16:creationId xmlns:a16="http://schemas.microsoft.com/office/drawing/2014/main" id="{16AF91F6-85A2-4A0D-B5CD-3F5C14F4DC66}"/>
               </a:ext>
             </a:extLst>
           </p:cNvPr>
@@ -6756,7 +6756,7 @@
     </p:spTree>
     <p:extLst>
       <p:ext uri="{BB962C8B-B14F-4D97-AF65-F5344CB8AC3E}">
-        <p14:creationId xmlns:p14="http://schemas.microsoft.com/office/powerpoint/2010/main" val="1747143341"/>
+        <p14:creationId xmlns:p14="http://schemas.microsoft.com/office/powerpoint/2010/main" val="1089379924"/>
       </p:ext>
     </p:extLst>
   </p:cSld>
@@ -6787,7 +6787,7 @@
           <p:cNvPr id="1" name="Slide Number Placeholder 5">
             <a:extLst xmlns:a="http://schemas.openxmlformats.org/drawingml/2006/main">
               <a:ext uri="{FF2B5EF4-FFF2-40B4-BE49-F238E27FC236}">
-                <a16:creationId xmlns:a16="http://schemas.microsoft.com/office/drawing/2014/main" id="{821508BF-91E3-4E78-84B3-DCBD229C8660}"/>
+                <a16:creationId xmlns:a16="http://schemas.microsoft.com/office/drawing/2014/main" id="{11DAD1DA-DD27-4C25-AFB7-E057ACC56EC0}"/>
               </a:ext>
             </a:extLst>
           </p:cNvPr>
@@ -6823,7 +6823,7 @@
           <p:nvPr/>
         </p:nvPicPr>
         <p:blipFill>
-          <a:blip xmlns:r="http://schemas.openxmlformats.org/officeDocument/2006/relationships" xmlns:a="http://schemas.openxmlformats.org/drawingml/2006/main" r:embed="R55a429a8104b4a62"/>
+          <a:blip xmlns:r="http://schemas.openxmlformats.org/officeDocument/2006/relationships" xmlns:a="http://schemas.openxmlformats.org/drawingml/2006/main" r:embed="Rf02569a7d8d44dfb"/>
           <a:srcRect xmlns:a="http://schemas.openxmlformats.org/drawingml/2006/main" l="0" t="21875" r="0" b="21875"/>
           <a:stretch xmlns:a="http://schemas.openxmlformats.org/drawingml/2006/main">
             <a:fillRect l="0" t="0" r="0" b="0"/>
@@ -6844,7 +6844,7 @@
           <p:cNvPr id="3" name="">
             <a:extLst xmlns:a="http://schemas.openxmlformats.org/drawingml/2006/main">
               <a:ext uri="{FF2B5EF4-FFF2-40B4-BE49-F238E27FC236}">
-                <a16:creationId xmlns:a16="http://schemas.microsoft.com/office/drawing/2014/main" id="{952230EC-2926-4373-9A13-11DA5981AA44}"/>
+                <a16:creationId xmlns:a16="http://schemas.microsoft.com/office/drawing/2014/main" id="{024F02A7-94FD-4A54-B686-8B5736DB7C8A}"/>
               </a:ext>
             </a:extLst>
           </p:cNvPr>
@@ -6879,7 +6879,7 @@
           <p:cNvPr id="4" name="">
             <a:extLst xmlns:a="http://schemas.openxmlformats.org/drawingml/2006/main">
               <a:ext uri="{FF2B5EF4-FFF2-40B4-BE49-F238E27FC236}">
-                <a16:creationId xmlns:a16="http://schemas.microsoft.com/office/drawing/2014/main" id="{60E6F7F5-02C7-40D1-A1B8-2FE657025465}"/>
+                <a16:creationId xmlns:a16="http://schemas.microsoft.com/office/drawing/2014/main" id="{FCD14E91-D61A-4599-9998-A104C630DD1F}"/>
               </a:ext>
             </a:extLst>
           </p:cNvPr>
@@ -6914,7 +6914,7 @@
           <p:cNvPr id="5" name="">
             <a:extLst xmlns:a="http://schemas.openxmlformats.org/drawingml/2006/main">
               <a:ext uri="{FF2B5EF4-FFF2-40B4-BE49-F238E27FC236}">
-                <a16:creationId xmlns:a16="http://schemas.microsoft.com/office/drawing/2014/main" id="{33490542-ADDF-4C85-9DF6-5C8E59FAA2A8}"/>
+                <a16:creationId xmlns:a16="http://schemas.microsoft.com/office/drawing/2014/main" id="{600DC0BE-6E9F-4378-9F80-99288E71A352}"/>
               </a:ext>
             </a:extLst>
           </p:cNvPr>
@@ -6951,7 +6951,7 @@
           <p:cNvPr id="6" name="">
             <a:extLst xmlns:a="http://schemas.openxmlformats.org/drawingml/2006/main">
               <a:ext uri="{FF2B5EF4-FFF2-40B4-BE49-F238E27FC236}">
-                <a16:creationId xmlns:a16="http://schemas.microsoft.com/office/drawing/2014/main" id="{2DD9C5F6-7393-488C-BF7D-307F049F70E2}"/>
+                <a16:creationId xmlns:a16="http://schemas.microsoft.com/office/drawing/2014/main" id="{C1933CF6-35AA-4C79-94B7-98E3F39B4C9C}"/>
               </a:ext>
             </a:extLst>
           </p:cNvPr>
@@ -6988,7 +6988,7 @@
           <p:cNvPr id="7" name="">
             <a:extLst xmlns:a="http://schemas.openxmlformats.org/drawingml/2006/main">
               <a:ext uri="{FF2B5EF4-FFF2-40B4-BE49-F238E27FC236}">
-                <a16:creationId xmlns:a16="http://schemas.microsoft.com/office/drawing/2014/main" id="{F5C5D73C-83F1-4923-BD03-EC3A114D77A0}"/>
+                <a16:creationId xmlns:a16="http://schemas.microsoft.com/office/drawing/2014/main" id="{E59D628C-83C0-4D35-9195-DB6E0211F423}"/>
               </a:ext>
             </a:extLst>
           </p:cNvPr>
@@ -7025,7 +7025,7 @@
           <p:cNvPr id="8" name="">
             <a:extLst xmlns:a="http://schemas.openxmlformats.org/drawingml/2006/main">
               <a:ext uri="{FF2B5EF4-FFF2-40B4-BE49-F238E27FC236}">
-                <a16:creationId xmlns:a16="http://schemas.microsoft.com/office/drawing/2014/main" id="{68FC44BF-416E-453A-8779-6381B105D148}"/>
+                <a16:creationId xmlns:a16="http://schemas.microsoft.com/office/drawing/2014/main" id="{79E34280-A68C-43F8-877E-811279204D90}"/>
               </a:ext>
             </a:extLst>
           </p:cNvPr>
@@ -7062,7 +7062,7 @@
           <p:cNvPr id="9" name="">
             <a:extLst xmlns:a="http://schemas.openxmlformats.org/drawingml/2006/main">
               <a:ext uri="{FF2B5EF4-FFF2-40B4-BE49-F238E27FC236}">
-                <a16:creationId xmlns:a16="http://schemas.microsoft.com/office/drawing/2014/main" id="{C1CBA0DE-F33D-4C6A-BACE-FC271A5EC844}"/>
+                <a16:creationId xmlns:a16="http://schemas.microsoft.com/office/drawing/2014/main" id="{3DE211F5-9452-4333-8CBD-A6917DDFC314}"/>
               </a:ext>
             </a:extLst>
           </p:cNvPr>
@@ -7120,7 +7120,7 @@
           <p:cNvPr id="10" name="">
             <a:extLst xmlns:a="http://schemas.openxmlformats.org/drawingml/2006/main">
               <a:ext uri="{FF2B5EF4-FFF2-40B4-BE49-F238E27FC236}">
-                <a16:creationId xmlns:a16="http://schemas.microsoft.com/office/drawing/2014/main" id="{CE9893DB-C1CD-498E-9D01-69F6D95C68A9}"/>
+                <a16:creationId xmlns:a16="http://schemas.microsoft.com/office/drawing/2014/main" id="{6B8F693F-398D-4508-8C04-310676F7CF8B}"/>
               </a:ext>
             </a:extLst>
           </p:cNvPr>
@@ -7178,7 +7178,7 @@
           <p:cNvPr id="11" name="">
             <a:extLst xmlns:a="http://schemas.openxmlformats.org/drawingml/2006/main">
               <a:ext uri="{FF2B5EF4-FFF2-40B4-BE49-F238E27FC236}">
-                <a16:creationId xmlns:a16="http://schemas.microsoft.com/office/drawing/2014/main" id="{D8E04E29-556D-4CE3-A5EC-605CA9893DBF}"/>
+                <a16:creationId xmlns:a16="http://schemas.microsoft.com/office/drawing/2014/main" id="{FF36470D-EDA4-4DAD-884D-44B8A522E2B9}"/>
               </a:ext>
             </a:extLst>
           </p:cNvPr>
@@ -7213,7 +7213,7 @@
           <p:cNvPr id="12" name="">
             <a:extLst xmlns:a="http://schemas.openxmlformats.org/drawingml/2006/main">
               <a:ext uri="{FF2B5EF4-FFF2-40B4-BE49-F238E27FC236}">
-                <a16:creationId xmlns:a16="http://schemas.microsoft.com/office/drawing/2014/main" id="{0157BCBF-0D7A-4158-80F2-6F13FF1825AC}"/>
+                <a16:creationId xmlns:a16="http://schemas.microsoft.com/office/drawing/2014/main" id="{73A2341A-B00F-41D1-AFF7-E18DAD5847BA}"/>
               </a:ext>
             </a:extLst>
           </p:cNvPr>
@@ -7246,7 +7246,7 @@
           <p:cNvPr id="13" name="">
             <a:extLst xmlns:a="http://schemas.openxmlformats.org/drawingml/2006/main">
               <a:ext uri="{FF2B5EF4-FFF2-40B4-BE49-F238E27FC236}">
-                <a16:creationId xmlns:a16="http://schemas.microsoft.com/office/drawing/2014/main" id="{1F7B0E0F-9B1A-4ABE-92EA-21156651B7B9}"/>
+                <a16:creationId xmlns:a16="http://schemas.microsoft.com/office/drawing/2014/main" id="{10DB85DB-E798-4FF5-8ABA-986CEEDDAA98}"/>
               </a:ext>
             </a:extLst>
           </p:cNvPr>
@@ -7321,7 +7321,7 @@
           <p:cNvPr id="14" name="">
             <a:extLst xmlns:a="http://schemas.openxmlformats.org/drawingml/2006/main">
               <a:ext uri="{FF2B5EF4-FFF2-40B4-BE49-F238E27FC236}">
-                <a16:creationId xmlns:a16="http://schemas.microsoft.com/office/drawing/2014/main" id="{E3236730-E948-46D5-977D-7C744856DD72}"/>
+                <a16:creationId xmlns:a16="http://schemas.microsoft.com/office/drawing/2014/main" id="{83DDCBDE-1CE0-4053-9BC2-A683219B70C0}"/>
               </a:ext>
             </a:extLst>
           </p:cNvPr>
@@ -7358,7 +7358,7 @@
           <p:cNvPr id="15" name="">
             <a:extLst xmlns:a="http://schemas.openxmlformats.org/drawingml/2006/main">
               <a:ext uri="{FF2B5EF4-FFF2-40B4-BE49-F238E27FC236}">
-                <a16:creationId xmlns:a16="http://schemas.microsoft.com/office/drawing/2014/main" id="{50361F0B-77A8-4BEB-AE0C-A0BB82B39528}"/>
+                <a16:creationId xmlns:a16="http://schemas.microsoft.com/office/drawing/2014/main" id="{7293095A-6B90-4E83-8C7B-DB75DFB8B43D}"/>
               </a:ext>
             </a:extLst>
           </p:cNvPr>
@@ -7393,7 +7393,7 @@
           <p:cNvPr id="16" name="">
             <a:extLst xmlns:a="http://schemas.openxmlformats.org/drawingml/2006/main">
               <a:ext uri="{FF2B5EF4-FFF2-40B4-BE49-F238E27FC236}">
-                <a16:creationId xmlns:a16="http://schemas.microsoft.com/office/drawing/2014/main" id="{FF5C96E2-0EFF-4E8E-90E5-5DC995712A11}"/>
+                <a16:creationId xmlns:a16="http://schemas.microsoft.com/office/drawing/2014/main" id="{E835AEEC-113B-4175-BC3B-FAAD1F7FA286}"/>
               </a:ext>
             </a:extLst>
           </p:cNvPr>
@@ -7451,7 +7451,7 @@
           <p:cNvPr id="17" name="">
             <a:extLst xmlns:a="http://schemas.openxmlformats.org/drawingml/2006/main">
               <a:ext uri="{FF2B5EF4-FFF2-40B4-BE49-F238E27FC236}">
-                <a16:creationId xmlns:a16="http://schemas.microsoft.com/office/drawing/2014/main" id="{A4C729C8-4E3D-4C8E-B33F-F62046A6C8EC}"/>
+                <a16:creationId xmlns:a16="http://schemas.microsoft.com/office/drawing/2014/main" id="{2E74AFA9-C5BE-4E6F-9DBF-A6289362A6B9}"/>
               </a:ext>
             </a:extLst>
           </p:cNvPr>
@@ -7560,7 +7560,7 @@
           <p:cNvPr id="18" name="">
             <a:extLst xmlns:a="http://schemas.openxmlformats.org/drawingml/2006/main">
               <a:ext uri="{FF2B5EF4-FFF2-40B4-BE49-F238E27FC236}">
-                <a16:creationId xmlns:a16="http://schemas.microsoft.com/office/drawing/2014/main" id="{9EA1337F-4FD2-455A-970B-363F28A6B86C}"/>
+                <a16:creationId xmlns:a16="http://schemas.microsoft.com/office/drawing/2014/main" id="{757387DE-C5A8-4912-80E6-3A718B059F53}"/>
               </a:ext>
             </a:extLst>
           </p:cNvPr>
@@ -7593,7 +7593,7 @@
           <p:cNvPr id="19" name="">
             <a:extLst xmlns:a="http://schemas.openxmlformats.org/drawingml/2006/main">
               <a:ext uri="{FF2B5EF4-FFF2-40B4-BE49-F238E27FC236}">
-                <a16:creationId xmlns:a16="http://schemas.microsoft.com/office/drawing/2014/main" id="{EA668988-77B6-4926-93EE-FDDCB9C4F5E7}"/>
+                <a16:creationId xmlns:a16="http://schemas.microsoft.com/office/drawing/2014/main" id="{16534786-5A0B-4B1C-AF92-A09120D140DA}"/>
               </a:ext>
             </a:extLst>
           </p:cNvPr>
@@ -7630,7 +7630,7 @@
           <p:cNvPr id="20" name="">
             <a:extLst xmlns:a="http://schemas.openxmlformats.org/drawingml/2006/main">
               <a:ext uri="{FF2B5EF4-FFF2-40B4-BE49-F238E27FC236}">
-                <a16:creationId xmlns:a16="http://schemas.microsoft.com/office/drawing/2014/main" id="{0307687A-9FF9-4D6E-9FA3-0E88122C0C11}"/>
+                <a16:creationId xmlns:a16="http://schemas.microsoft.com/office/drawing/2014/main" id="{91E0A471-DC98-4821-B7E6-B9345718BA62}"/>
               </a:ext>
             </a:extLst>
           </p:cNvPr>
@@ -7665,7 +7665,7 @@
           <p:cNvPr id="21" name="">
             <a:extLst xmlns:a="http://schemas.openxmlformats.org/drawingml/2006/main">
               <a:ext uri="{FF2B5EF4-FFF2-40B4-BE49-F238E27FC236}">
-                <a16:creationId xmlns:a16="http://schemas.microsoft.com/office/drawing/2014/main" id="{C90474FA-1F73-49BA-A7E8-7158A0734E14}"/>
+                <a16:creationId xmlns:a16="http://schemas.microsoft.com/office/drawing/2014/main" id="{6FD67013-6B8F-4367-9300-E3992435FD73}"/>
               </a:ext>
             </a:extLst>
           </p:cNvPr>
@@ -7723,7 +7723,7 @@
           <p:cNvPr id="22" name="">
             <a:extLst xmlns:a="http://schemas.openxmlformats.org/drawingml/2006/main">
               <a:ext uri="{FF2B5EF4-FFF2-40B4-BE49-F238E27FC236}">
-                <a16:creationId xmlns:a16="http://schemas.microsoft.com/office/drawing/2014/main" id="{3FD80DB5-EC63-49B5-BD45-D3AD44BE19C6}"/>
+                <a16:creationId xmlns:a16="http://schemas.microsoft.com/office/drawing/2014/main" id="{4FC787B4-9624-4ACA-8F51-8BF1B9BF08E3}"/>
               </a:ext>
             </a:extLst>
           </p:cNvPr>
@@ -7815,7 +7815,7 @@
           <p:cNvPr id="23" name="">
             <a:extLst xmlns:a="http://schemas.openxmlformats.org/drawingml/2006/main">
               <a:ext uri="{FF2B5EF4-FFF2-40B4-BE49-F238E27FC236}">
-                <a16:creationId xmlns:a16="http://schemas.microsoft.com/office/drawing/2014/main" id="{ABA45EDC-C2CD-40B1-BF76-F8F161588161}"/>
+                <a16:creationId xmlns:a16="http://schemas.microsoft.com/office/drawing/2014/main" id="{C2617551-BF59-4210-9337-63715BE8D4CF}"/>
               </a:ext>
             </a:extLst>
           </p:cNvPr>
@@ -7848,7 +7848,7 @@
           <p:cNvPr id="24" name="">
             <a:extLst xmlns:a="http://schemas.openxmlformats.org/drawingml/2006/main">
               <a:ext uri="{FF2B5EF4-FFF2-40B4-BE49-F238E27FC236}">
-                <a16:creationId xmlns:a16="http://schemas.microsoft.com/office/drawing/2014/main" id="{F19BC522-95A2-4D10-B971-474B16DF5A17}"/>
+                <a16:creationId xmlns:a16="http://schemas.microsoft.com/office/drawing/2014/main" id="{65D195EE-9070-4C42-A770-037440E8F812}"/>
               </a:ext>
             </a:extLst>
           </p:cNvPr>
@@ -7885,7 +7885,7 @@
           <p:cNvPr id="25" name="">
             <a:extLst xmlns:a="http://schemas.openxmlformats.org/drawingml/2006/main">
               <a:ext uri="{FF2B5EF4-FFF2-40B4-BE49-F238E27FC236}">
-                <a16:creationId xmlns:a16="http://schemas.microsoft.com/office/drawing/2014/main" id="{D83D6569-1440-4D5D-959D-A29757960CB4}"/>
+                <a16:creationId xmlns:a16="http://schemas.microsoft.com/office/drawing/2014/main" id="{1DEBD550-FB08-4A0A-B89E-031612C1EB96}"/>
               </a:ext>
             </a:extLst>
           </p:cNvPr>
@@ -7920,7 +7920,7 @@
           <p:cNvPr id="26" name="">
             <a:extLst xmlns:a="http://schemas.openxmlformats.org/drawingml/2006/main">
               <a:ext uri="{FF2B5EF4-FFF2-40B4-BE49-F238E27FC236}">
-                <a16:creationId xmlns:a16="http://schemas.microsoft.com/office/drawing/2014/main" id="{8817F1A5-7D89-4777-820E-9B5BB081D7B5}"/>
+                <a16:creationId xmlns:a16="http://schemas.microsoft.com/office/drawing/2014/main" id="{AB60BCF1-CDA8-450C-9BCE-03CF44EB574E}"/>
               </a:ext>
             </a:extLst>
           </p:cNvPr>
@@ -7978,7 +7978,7 @@
           <p:cNvPr id="27" name="">
             <a:extLst xmlns:a="http://schemas.openxmlformats.org/drawingml/2006/main">
               <a:ext uri="{FF2B5EF4-FFF2-40B4-BE49-F238E27FC236}">
-                <a16:creationId xmlns:a16="http://schemas.microsoft.com/office/drawing/2014/main" id="{6C6D2C3A-471E-413A-A278-A60B885BBB28}"/>
+                <a16:creationId xmlns:a16="http://schemas.microsoft.com/office/drawing/2014/main" id="{01B6E976-E079-4B94-9D63-7B13664E6B50}"/>
               </a:ext>
             </a:extLst>
           </p:cNvPr>
@@ -8070,7 +8070,7 @@
           <p:cNvPr id="28" name="">
             <a:extLst xmlns:a="http://schemas.openxmlformats.org/drawingml/2006/main">
               <a:ext uri="{FF2B5EF4-FFF2-40B4-BE49-F238E27FC236}">
-                <a16:creationId xmlns:a16="http://schemas.microsoft.com/office/drawing/2014/main" id="{6AE76FE0-AF64-4D27-B67F-E8994364ADEC}"/>
+                <a16:creationId xmlns:a16="http://schemas.microsoft.com/office/drawing/2014/main" id="{AD992D86-75EB-4010-B7D2-6EABFFED092A}"/>
               </a:ext>
             </a:extLst>
           </p:cNvPr>
@@ -8105,7 +8105,7 @@
           <p:cNvPr id="29" name="">
             <a:extLst xmlns:a="http://schemas.openxmlformats.org/drawingml/2006/main">
               <a:ext uri="{FF2B5EF4-FFF2-40B4-BE49-F238E27FC236}">
-                <a16:creationId xmlns:a16="http://schemas.microsoft.com/office/drawing/2014/main" id="{AFFD26AC-802D-4C70-9420-FB597967DC4C}"/>
+                <a16:creationId xmlns:a16="http://schemas.microsoft.com/office/drawing/2014/main" id="{D7DBA247-5D5F-447C-9634-0E4C809D8C6D}"/>
               </a:ext>
             </a:extLst>
           </p:cNvPr>
@@ -8140,7 +8140,7 @@
           <p:cNvPr id="30" name="">
             <a:extLst xmlns:a="http://schemas.openxmlformats.org/drawingml/2006/main">
               <a:ext uri="{FF2B5EF4-FFF2-40B4-BE49-F238E27FC236}">
-                <a16:creationId xmlns:a16="http://schemas.microsoft.com/office/drawing/2014/main" id="{0967D56F-6A63-4341-A25C-FF8A51870AE7}"/>
+                <a16:creationId xmlns:a16="http://schemas.microsoft.com/office/drawing/2014/main" id="{930A3888-3BC8-4C99-A0E0-4B165DF86433}"/>
               </a:ext>
             </a:extLst>
           </p:cNvPr>
@@ -8198,7 +8198,7 @@
           <p:cNvPr id="31" name="">
             <a:extLst xmlns:a="http://schemas.openxmlformats.org/drawingml/2006/main">
               <a:ext uri="{FF2B5EF4-FFF2-40B4-BE49-F238E27FC236}">
-                <a16:creationId xmlns:a16="http://schemas.microsoft.com/office/drawing/2014/main" id="{BF9CA981-0DD6-4B90-924A-58F3445FBB1B}"/>
+                <a16:creationId xmlns:a16="http://schemas.microsoft.com/office/drawing/2014/main" id="{DAC37E43-FC2D-48A4-819A-2F97F0C2DC44}"/>
               </a:ext>
             </a:extLst>
           </p:cNvPr>
@@ -8254,7 +8254,7 @@
     </p:spTree>
     <p:extLst>
       <p:ext uri="{BB962C8B-B14F-4D97-AF65-F5344CB8AC3E}">
-        <p14:creationId xmlns:p14="http://schemas.microsoft.com/office/powerpoint/2010/main" val="1787582743"/>
+        <p14:creationId xmlns:p14="http://schemas.microsoft.com/office/powerpoint/2010/main" val="1781088976"/>
       </p:ext>
     </p:extLst>
   </p:cSld>
@@ -8285,7 +8285,7 @@
           <p:cNvPr id="1" name="Slide Number Placeholder 5">
             <a:extLst xmlns:a="http://schemas.openxmlformats.org/drawingml/2006/main">
               <a:ext uri="{FF2B5EF4-FFF2-40B4-BE49-F238E27FC236}">
-                <a16:creationId xmlns:a16="http://schemas.microsoft.com/office/drawing/2014/main" id="{821508BF-91E3-4E78-84B3-DCBD229C8660}"/>
+                <a16:creationId xmlns:a16="http://schemas.microsoft.com/office/drawing/2014/main" id="{11DAD1DA-DD27-4C25-AFB7-E057ACC56EC0}"/>
               </a:ext>
             </a:extLst>
           </p:cNvPr>
@@ -8321,7 +8321,7 @@
           <p:nvPr/>
         </p:nvPicPr>
         <p:blipFill>
-          <a:blip xmlns:r="http://schemas.openxmlformats.org/officeDocument/2006/relationships" xmlns:a="http://schemas.openxmlformats.org/drawingml/2006/main" r:embed="R83ce7e75ba5a41cb"/>
+          <a:blip xmlns:r="http://schemas.openxmlformats.org/officeDocument/2006/relationships" xmlns:a="http://schemas.openxmlformats.org/drawingml/2006/main" r:embed="R0e02595e97b74128"/>
           <a:srcRect xmlns:a="http://schemas.openxmlformats.org/drawingml/2006/main" l="0" t="21875" r="0" b="21875"/>
           <a:stretch xmlns:a="http://schemas.openxmlformats.org/drawingml/2006/main">
             <a:fillRect l="0" t="0" r="0" b="0"/>
@@ -8342,7 +8342,7 @@
           <p:cNvPr id="3" name="">
             <a:extLst xmlns:a="http://schemas.openxmlformats.org/drawingml/2006/main">
               <a:ext uri="{FF2B5EF4-FFF2-40B4-BE49-F238E27FC236}">
-                <a16:creationId xmlns:a16="http://schemas.microsoft.com/office/drawing/2014/main" id="{BAB9F881-6422-4547-AA6E-C05F8E98B474}"/>
+                <a16:creationId xmlns:a16="http://schemas.microsoft.com/office/drawing/2014/main" id="{7F53D66D-E3F3-4C3E-B061-D5C8F654B40C}"/>
               </a:ext>
             </a:extLst>
           </p:cNvPr>
@@ -8377,7 +8377,7 @@
           <p:cNvPr id="4" name="">
             <a:extLst xmlns:a="http://schemas.openxmlformats.org/drawingml/2006/main">
               <a:ext uri="{FF2B5EF4-FFF2-40B4-BE49-F238E27FC236}">
-                <a16:creationId xmlns:a16="http://schemas.microsoft.com/office/drawing/2014/main" id="{185835C4-95A7-4D1F-A151-4D4056C69FB5}"/>
+                <a16:creationId xmlns:a16="http://schemas.microsoft.com/office/drawing/2014/main" id="{33680555-CAD7-4C48-AAD8-238494A9B859}"/>
               </a:ext>
             </a:extLst>
           </p:cNvPr>
@@ -8412,7 +8412,7 @@
           <p:cNvPr id="5" name="">
             <a:extLst xmlns:a="http://schemas.openxmlformats.org/drawingml/2006/main">
               <a:ext uri="{FF2B5EF4-FFF2-40B4-BE49-F238E27FC236}">
-                <a16:creationId xmlns:a16="http://schemas.microsoft.com/office/drawing/2014/main" id="{D3ECED67-1EC9-45CB-BD1D-A00FF5B9D9C6}"/>
+                <a16:creationId xmlns:a16="http://schemas.microsoft.com/office/drawing/2014/main" id="{1EAF1C36-53AD-4680-9978-657F3F7D7402}"/>
               </a:ext>
             </a:extLst>
           </p:cNvPr>
@@ -8449,7 +8449,7 @@
           <p:cNvPr id="6" name="">
             <a:extLst xmlns:a="http://schemas.openxmlformats.org/drawingml/2006/main">
               <a:ext uri="{FF2B5EF4-FFF2-40B4-BE49-F238E27FC236}">
-                <a16:creationId xmlns:a16="http://schemas.microsoft.com/office/drawing/2014/main" id="{9E31B7EF-593C-421B-99F9-1B1EA7E71802}"/>
+                <a16:creationId xmlns:a16="http://schemas.microsoft.com/office/drawing/2014/main" id="{81B2AC8D-3924-4194-8A8F-B6AB0C93505E}"/>
               </a:ext>
             </a:extLst>
           </p:cNvPr>
@@ -8486,7 +8486,7 @@
           <p:cNvPr id="7" name="">
             <a:extLst xmlns:a="http://schemas.openxmlformats.org/drawingml/2006/main">
               <a:ext uri="{FF2B5EF4-FFF2-40B4-BE49-F238E27FC236}">
-                <a16:creationId xmlns:a16="http://schemas.microsoft.com/office/drawing/2014/main" id="{1DFDEA9F-25BA-4CA1-8777-4960F5AFA8BC}"/>
+                <a16:creationId xmlns:a16="http://schemas.microsoft.com/office/drawing/2014/main" id="{0812CB29-5BD1-4027-B0DA-EB4885B8EF0F}"/>
               </a:ext>
             </a:extLst>
           </p:cNvPr>
@@ -8523,7 +8523,7 @@
           <p:cNvPr id="8" name="">
             <a:extLst xmlns:a="http://schemas.openxmlformats.org/drawingml/2006/main">
               <a:ext uri="{FF2B5EF4-FFF2-40B4-BE49-F238E27FC236}">
-                <a16:creationId xmlns:a16="http://schemas.microsoft.com/office/drawing/2014/main" id="{1BC3AAE2-42FE-4AA3-9918-813C1957CC4E}"/>
+                <a16:creationId xmlns:a16="http://schemas.microsoft.com/office/drawing/2014/main" id="{BC7B471B-E036-454B-941E-6EE2B7776F91}"/>
               </a:ext>
             </a:extLst>
           </p:cNvPr>
@@ -8560,7 +8560,7 @@
           <p:cNvPr id="9" name="">
             <a:extLst xmlns:a="http://schemas.openxmlformats.org/drawingml/2006/main">
               <a:ext uri="{FF2B5EF4-FFF2-40B4-BE49-F238E27FC236}">
-                <a16:creationId xmlns:a16="http://schemas.microsoft.com/office/drawing/2014/main" id="{1D07CF24-FBF8-4F41-98ED-BB5694072A63}"/>
+                <a16:creationId xmlns:a16="http://schemas.microsoft.com/office/drawing/2014/main" id="{B7B2CDE8-D13C-4D1E-BAF5-54CBF7266671}"/>
               </a:ext>
             </a:extLst>
           </p:cNvPr>
@@ -8618,7 +8618,7 @@
           <p:cNvPr id="10" name="">
             <a:extLst xmlns:a="http://schemas.openxmlformats.org/drawingml/2006/main">
               <a:ext uri="{FF2B5EF4-FFF2-40B4-BE49-F238E27FC236}">
-                <a16:creationId xmlns:a16="http://schemas.microsoft.com/office/drawing/2014/main" id="{7AA1A5C0-A672-4462-A293-AEB1848EF53C}"/>
+                <a16:creationId xmlns:a16="http://schemas.microsoft.com/office/drawing/2014/main" id="{8AF36DA3-8200-427E-AE9C-6B1899BCB132}"/>
               </a:ext>
             </a:extLst>
           </p:cNvPr>
@@ -8676,7 +8676,7 @@
           <p:cNvPr id="11" name="">
             <a:extLst xmlns:a="http://schemas.openxmlformats.org/drawingml/2006/main">
               <a:ext uri="{FF2B5EF4-FFF2-40B4-BE49-F238E27FC236}">
-                <a16:creationId xmlns:a16="http://schemas.microsoft.com/office/drawing/2014/main" id="{BD7928CE-A26E-469B-8F18-CDE0900CB37E}"/>
+                <a16:creationId xmlns:a16="http://schemas.microsoft.com/office/drawing/2014/main" id="{070D3F0C-7DC8-4D23-BA65-CD3AD9EB5574}"/>
               </a:ext>
             </a:extLst>
           </p:cNvPr>
@@ -8711,7 +8711,7 @@
           <p:cNvPr id="12" name="">
             <a:extLst xmlns:a="http://schemas.openxmlformats.org/drawingml/2006/main">
               <a:ext uri="{FF2B5EF4-FFF2-40B4-BE49-F238E27FC236}">
-                <a16:creationId xmlns:a16="http://schemas.microsoft.com/office/drawing/2014/main" id="{98D4D901-9A90-4335-8452-275474670011}"/>
+                <a16:creationId xmlns:a16="http://schemas.microsoft.com/office/drawing/2014/main" id="{9F0074EE-6428-465B-8C7F-BAE1F8C17CDB}"/>
               </a:ext>
             </a:extLst>
           </p:cNvPr>
@@ -8744,7 +8744,7 @@
           <p:cNvPr id="13" name="">
             <a:extLst xmlns:a="http://schemas.openxmlformats.org/drawingml/2006/main">
               <a:ext uri="{FF2B5EF4-FFF2-40B4-BE49-F238E27FC236}">
-                <a16:creationId xmlns:a16="http://schemas.microsoft.com/office/drawing/2014/main" id="{68B98703-462B-4554-9BE7-CF02465DE8B1}"/>
+                <a16:creationId xmlns:a16="http://schemas.microsoft.com/office/drawing/2014/main" id="{C66115A8-75B6-4F69-B8FD-740BA6B9C576}"/>
               </a:ext>
             </a:extLst>
           </p:cNvPr>
@@ -8802,7 +8802,7 @@
           <p:cNvPr id="14" name="">
             <a:extLst xmlns:a="http://schemas.openxmlformats.org/drawingml/2006/main">
               <a:ext uri="{FF2B5EF4-FFF2-40B4-BE49-F238E27FC236}">
-                <a16:creationId xmlns:a16="http://schemas.microsoft.com/office/drawing/2014/main" id="{E48F7597-F743-4F17-81ED-E0D97C721C26}"/>
+                <a16:creationId xmlns:a16="http://schemas.microsoft.com/office/drawing/2014/main" id="{84A04D33-DE35-430E-BBD2-D329C7C25D98}"/>
               </a:ext>
             </a:extLst>
           </p:cNvPr>
@@ -8839,7 +8839,7 @@
           <p:cNvPr id="15" name="">
             <a:extLst xmlns:a="http://schemas.openxmlformats.org/drawingml/2006/main">
               <a:ext uri="{FF2B5EF4-FFF2-40B4-BE49-F238E27FC236}">
-                <a16:creationId xmlns:a16="http://schemas.microsoft.com/office/drawing/2014/main" id="{8F25A314-CE46-45FB-A540-7E40A1C32B38}"/>
+                <a16:creationId xmlns:a16="http://schemas.microsoft.com/office/drawing/2014/main" id="{4941AA70-50FC-4AB2-8B26-9053DAF2C4AA}"/>
               </a:ext>
             </a:extLst>
           </p:cNvPr>
@@ -8874,7 +8874,7 @@
           <p:cNvPr id="16" name="">
             <a:extLst xmlns:a="http://schemas.openxmlformats.org/drawingml/2006/main">
               <a:ext uri="{FF2B5EF4-FFF2-40B4-BE49-F238E27FC236}">
-                <a16:creationId xmlns:a16="http://schemas.microsoft.com/office/drawing/2014/main" id="{B8058516-A541-48BE-8390-8643C3842469}"/>
+                <a16:creationId xmlns:a16="http://schemas.microsoft.com/office/drawing/2014/main" id="{9CD0976B-3D07-4751-BB17-4313839957AC}"/>
               </a:ext>
             </a:extLst>
           </p:cNvPr>
@@ -8932,7 +8932,7 @@
           <p:cNvPr id="17" name="">
             <a:extLst xmlns:a="http://schemas.openxmlformats.org/drawingml/2006/main">
               <a:ext uri="{FF2B5EF4-FFF2-40B4-BE49-F238E27FC236}">
-                <a16:creationId xmlns:a16="http://schemas.microsoft.com/office/drawing/2014/main" id="{1A4817CB-C49C-4CEB-BFF8-2D59FEDCC66D}"/>
+                <a16:creationId xmlns:a16="http://schemas.microsoft.com/office/drawing/2014/main" id="{A86DBF77-AB36-4D10-A742-3B29E5782D8C}"/>
               </a:ext>
             </a:extLst>
           </p:cNvPr>
@@ -9024,7 +9024,7 @@
           <p:cNvPr id="18" name="">
             <a:extLst xmlns:a="http://schemas.openxmlformats.org/drawingml/2006/main">
               <a:ext uri="{FF2B5EF4-FFF2-40B4-BE49-F238E27FC236}">
-                <a16:creationId xmlns:a16="http://schemas.microsoft.com/office/drawing/2014/main" id="{D38BB4BB-789E-4F70-8357-4DA568DADC00}"/>
+                <a16:creationId xmlns:a16="http://schemas.microsoft.com/office/drawing/2014/main" id="{3A569AD4-BA6C-4967-AED6-87CF8926DB53}"/>
               </a:ext>
             </a:extLst>
           </p:cNvPr>
@@ -9061,7 +9061,7 @@
           <p:cNvPr id="19" name="">
             <a:extLst xmlns:a="http://schemas.openxmlformats.org/drawingml/2006/main">
               <a:ext uri="{FF2B5EF4-FFF2-40B4-BE49-F238E27FC236}">
-                <a16:creationId xmlns:a16="http://schemas.microsoft.com/office/drawing/2014/main" id="{B1A4D87A-D7D4-4141-8E97-76B0742F4911}"/>
+                <a16:creationId xmlns:a16="http://schemas.microsoft.com/office/drawing/2014/main" id="{F7FC9D16-8567-4FB2-9380-A2E38B0F4E32}"/>
               </a:ext>
             </a:extLst>
           </p:cNvPr>
@@ -9096,7 +9096,7 @@
           <p:cNvPr id="20" name="">
             <a:extLst xmlns:a="http://schemas.openxmlformats.org/drawingml/2006/main">
               <a:ext uri="{FF2B5EF4-FFF2-40B4-BE49-F238E27FC236}">
-                <a16:creationId xmlns:a16="http://schemas.microsoft.com/office/drawing/2014/main" id="{436298B0-3DE0-4F8F-93E3-79EBBBDFDB66}"/>
+                <a16:creationId xmlns:a16="http://schemas.microsoft.com/office/drawing/2014/main" id="{E71306CB-F701-457E-B306-37E7EB503021}"/>
               </a:ext>
             </a:extLst>
           </p:cNvPr>
@@ -9154,7 +9154,7 @@
           <p:cNvPr id="21" name="">
             <a:extLst xmlns:a="http://schemas.openxmlformats.org/drawingml/2006/main">
               <a:ext uri="{FF2B5EF4-FFF2-40B4-BE49-F238E27FC236}">
-                <a16:creationId xmlns:a16="http://schemas.microsoft.com/office/drawing/2014/main" id="{D4E84F0D-A05B-48D8-B8B2-4656FFA4EB5E}"/>
+                <a16:creationId xmlns:a16="http://schemas.microsoft.com/office/drawing/2014/main" id="{9B591EB6-1E6A-42F5-9948-9E50B4548137}"/>
               </a:ext>
             </a:extLst>
           </p:cNvPr>
@@ -9229,7 +9229,7 @@
           <p:cNvPr id="22" name="">
             <a:extLst xmlns:a="http://schemas.openxmlformats.org/drawingml/2006/main">
               <a:ext uri="{FF2B5EF4-FFF2-40B4-BE49-F238E27FC236}">
-                <a16:creationId xmlns:a16="http://schemas.microsoft.com/office/drawing/2014/main" id="{B2118F55-65FA-4213-8FEE-7B9F93536AE0}"/>
+                <a16:creationId xmlns:a16="http://schemas.microsoft.com/office/drawing/2014/main" id="{D293AD78-B07C-4CBA-BB97-0F5AC346829E}"/>
               </a:ext>
             </a:extLst>
           </p:cNvPr>
@@ -9266,7 +9266,7 @@
           <p:cNvPr id="23" name="">
             <a:extLst xmlns:a="http://schemas.openxmlformats.org/drawingml/2006/main">
               <a:ext uri="{FF2B5EF4-FFF2-40B4-BE49-F238E27FC236}">
-                <a16:creationId xmlns:a16="http://schemas.microsoft.com/office/drawing/2014/main" id="{2AAFEF4F-42D1-4332-8382-15B73EE80F46}"/>
+                <a16:creationId xmlns:a16="http://schemas.microsoft.com/office/drawing/2014/main" id="{E4A67430-18BF-49F3-8E08-EB91734A3BE2}"/>
               </a:ext>
             </a:extLst>
           </p:cNvPr>
@@ -9301,7 +9301,7 @@
           <p:cNvPr id="24" name="">
             <a:extLst xmlns:a="http://schemas.openxmlformats.org/drawingml/2006/main">
               <a:ext uri="{FF2B5EF4-FFF2-40B4-BE49-F238E27FC236}">
-                <a16:creationId xmlns:a16="http://schemas.microsoft.com/office/drawing/2014/main" id="{A623D73F-8FAD-4798-9A78-F62ED26F35CB}"/>
+                <a16:creationId xmlns:a16="http://schemas.microsoft.com/office/drawing/2014/main" id="{531C992F-3485-4D83-BCA7-886103207AD2}"/>
               </a:ext>
             </a:extLst>
           </p:cNvPr>
@@ -9359,7 +9359,7 @@
           <p:cNvPr id="25" name="">
             <a:extLst xmlns:a="http://schemas.openxmlformats.org/drawingml/2006/main">
               <a:ext uri="{FF2B5EF4-FFF2-40B4-BE49-F238E27FC236}">
-                <a16:creationId xmlns:a16="http://schemas.microsoft.com/office/drawing/2014/main" id="{12D32045-5C27-4D3D-963E-3ADCAF901456}"/>
+                <a16:creationId xmlns:a16="http://schemas.microsoft.com/office/drawing/2014/main" id="{84DFB4E9-A017-46D7-ADEC-47EFC76112CD}"/>
               </a:ext>
             </a:extLst>
           </p:cNvPr>
@@ -9451,7 +9451,7 @@
           <p:cNvPr id="26" name="">
             <a:extLst xmlns:a="http://schemas.openxmlformats.org/drawingml/2006/main">
               <a:ext uri="{FF2B5EF4-FFF2-40B4-BE49-F238E27FC236}">
-                <a16:creationId xmlns:a16="http://schemas.microsoft.com/office/drawing/2014/main" id="{D418F945-6B6B-45ED-BB7D-5F595DDE6FF2}"/>
+                <a16:creationId xmlns:a16="http://schemas.microsoft.com/office/drawing/2014/main" id="{7F19D017-AE81-4F02-A2EC-A9A8E016EF0E}"/>
               </a:ext>
             </a:extLst>
           </p:cNvPr>
@@ -9488,7 +9488,7 @@
           <p:cNvPr id="27" name="">
             <a:extLst xmlns:a="http://schemas.openxmlformats.org/drawingml/2006/main">
               <a:ext uri="{FF2B5EF4-FFF2-40B4-BE49-F238E27FC236}">
-                <a16:creationId xmlns:a16="http://schemas.microsoft.com/office/drawing/2014/main" id="{FBD05D49-7D11-475C-B206-654039570BDE}"/>
+                <a16:creationId xmlns:a16="http://schemas.microsoft.com/office/drawing/2014/main" id="{AFDB7B60-BBB7-4F60-90FA-9CB49491A63E}"/>
               </a:ext>
             </a:extLst>
           </p:cNvPr>
@@ -9523,7 +9523,7 @@
           <p:cNvPr id="28" name="">
             <a:extLst xmlns:a="http://schemas.openxmlformats.org/drawingml/2006/main">
               <a:ext uri="{FF2B5EF4-FFF2-40B4-BE49-F238E27FC236}">
-                <a16:creationId xmlns:a16="http://schemas.microsoft.com/office/drawing/2014/main" id="{4977C987-4274-4BFC-9478-57DE14A87BE9}"/>
+                <a16:creationId xmlns:a16="http://schemas.microsoft.com/office/drawing/2014/main" id="{405407C2-B24C-41C6-A01A-108C8E038CF7}"/>
               </a:ext>
             </a:extLst>
           </p:cNvPr>
@@ -9581,7 +9581,7 @@
           <p:cNvPr id="29" name="">
             <a:extLst xmlns:a="http://schemas.openxmlformats.org/drawingml/2006/main">
               <a:ext uri="{FF2B5EF4-FFF2-40B4-BE49-F238E27FC236}">
-                <a16:creationId xmlns:a16="http://schemas.microsoft.com/office/drawing/2014/main" id="{63DE9235-DB6E-4EE6-9473-F5FABFD521C4}"/>
+                <a16:creationId xmlns:a16="http://schemas.microsoft.com/office/drawing/2014/main" id="{D371EF37-7057-490F-9E84-2D592D7D68E6}"/>
               </a:ext>
             </a:extLst>
           </p:cNvPr>
@@ -9616,7 +9616,7 @@
           <p:cNvPr id="30" name="">
             <a:extLst xmlns:a="http://schemas.openxmlformats.org/drawingml/2006/main">
               <a:ext uri="{FF2B5EF4-FFF2-40B4-BE49-F238E27FC236}">
-                <a16:creationId xmlns:a16="http://schemas.microsoft.com/office/drawing/2014/main" id="{17E6150B-8027-41C5-B7AA-65BB9E3A9395}"/>
+                <a16:creationId xmlns:a16="http://schemas.microsoft.com/office/drawing/2014/main" id="{B6102812-2C9F-426B-84CC-9BF39CFBB990}"/>
               </a:ext>
             </a:extLst>
           </p:cNvPr>
@@ -9651,7 +9651,7 @@
           <p:cNvPr id="31" name="">
             <a:extLst xmlns:a="http://schemas.openxmlformats.org/drawingml/2006/main">
               <a:ext uri="{FF2B5EF4-FFF2-40B4-BE49-F238E27FC236}">
-                <a16:creationId xmlns:a16="http://schemas.microsoft.com/office/drawing/2014/main" id="{48D69EBE-1C8B-4CC8-9D65-04E7D2A2645E}"/>
+                <a16:creationId xmlns:a16="http://schemas.microsoft.com/office/drawing/2014/main" id="{6C46254E-FB68-4DE1-B6C8-056A76A81F4F}"/>
               </a:ext>
             </a:extLst>
           </p:cNvPr>
@@ -9709,7 +9709,7 @@
           <p:cNvPr id="32" name="">
             <a:extLst xmlns:a="http://schemas.openxmlformats.org/drawingml/2006/main">
               <a:ext uri="{FF2B5EF4-FFF2-40B4-BE49-F238E27FC236}">
-                <a16:creationId xmlns:a16="http://schemas.microsoft.com/office/drawing/2014/main" id="{F097BD25-2CD7-46D5-BB57-8BA74C40100D}"/>
+                <a16:creationId xmlns:a16="http://schemas.microsoft.com/office/drawing/2014/main" id="{F7BEA0F5-E8C0-47E8-8B41-7B7EEBFFFD86}"/>
               </a:ext>
             </a:extLst>
           </p:cNvPr>
@@ -9765,7 +9765,7 @@
     </p:spTree>
     <p:extLst>
       <p:ext uri="{BB962C8B-B14F-4D97-AF65-F5344CB8AC3E}">
-        <p14:creationId xmlns:p14="http://schemas.microsoft.com/office/powerpoint/2010/main" val="2109635069"/>
+        <p14:creationId xmlns:p14="http://schemas.microsoft.com/office/powerpoint/2010/main" val="1939443377"/>
       </p:ext>
     </p:extLst>
   </p:cSld>
@@ -9796,7 +9796,7 @@
           <p:cNvPr id="1" name="Slide Number Placeholder 5">
             <a:extLst xmlns:a="http://schemas.openxmlformats.org/drawingml/2006/main">
               <a:ext uri="{FF2B5EF4-FFF2-40B4-BE49-F238E27FC236}">
-                <a16:creationId xmlns:a16="http://schemas.microsoft.com/office/drawing/2014/main" id="{821508BF-91E3-4E78-84B3-DCBD229C8660}"/>
+                <a16:creationId xmlns:a16="http://schemas.microsoft.com/office/drawing/2014/main" id="{11DAD1DA-DD27-4C25-AFB7-E057ACC56EC0}"/>
               </a:ext>
             </a:extLst>
           </p:cNvPr>
@@ -9832,7 +9832,7 @@
           <p:nvPr/>
         </p:nvPicPr>
         <p:blipFill>
-          <a:blip xmlns:r="http://schemas.openxmlformats.org/officeDocument/2006/relationships" xmlns:a="http://schemas.openxmlformats.org/drawingml/2006/main" r:embed="R77c6129897444ff4"/>
+          <a:blip xmlns:r="http://schemas.openxmlformats.org/officeDocument/2006/relationships" xmlns:a="http://schemas.openxmlformats.org/drawingml/2006/main" r:embed="Ra0304f5dd0e24df6"/>
           <a:srcRect xmlns:a="http://schemas.openxmlformats.org/drawingml/2006/main" l="0" t="21875" r="0" b="21875"/>
           <a:stretch xmlns:a="http://schemas.openxmlformats.org/drawingml/2006/main">
             <a:fillRect l="0" t="0" r="0" b="0"/>
@@ -9853,7 +9853,7 @@
           <p:cNvPr id="3" name="">
             <a:extLst xmlns:a="http://schemas.openxmlformats.org/drawingml/2006/main">
               <a:ext uri="{FF2B5EF4-FFF2-40B4-BE49-F238E27FC236}">
-                <a16:creationId xmlns:a16="http://schemas.microsoft.com/office/drawing/2014/main" id="{ACC65EC4-058D-4D51-B287-0F141C694AA2}"/>
+                <a16:creationId xmlns:a16="http://schemas.microsoft.com/office/drawing/2014/main" id="{E893E64E-6129-45DA-988E-2B377CED734B}"/>
               </a:ext>
             </a:extLst>
           </p:cNvPr>
@@ -9888,7 +9888,7 @@
           <p:cNvPr id="4" name="">
             <a:extLst xmlns:a="http://schemas.openxmlformats.org/drawingml/2006/main">
               <a:ext uri="{FF2B5EF4-FFF2-40B4-BE49-F238E27FC236}">
-                <a16:creationId xmlns:a16="http://schemas.microsoft.com/office/drawing/2014/main" id="{859696A5-B064-4FC3-9152-D680851FF701}"/>
+                <a16:creationId xmlns:a16="http://schemas.microsoft.com/office/drawing/2014/main" id="{5107458C-4998-40C0-8C8B-050621CD7BE3}"/>
               </a:ext>
             </a:extLst>
           </p:cNvPr>
@@ -9923,7 +9923,7 @@
           <p:cNvPr id="5" name="">
             <a:extLst xmlns:a="http://schemas.openxmlformats.org/drawingml/2006/main">
               <a:ext uri="{FF2B5EF4-FFF2-40B4-BE49-F238E27FC236}">
-                <a16:creationId xmlns:a16="http://schemas.microsoft.com/office/drawing/2014/main" id="{AB3754C4-39E4-446E-849B-AB4B03298F72}"/>
+                <a16:creationId xmlns:a16="http://schemas.microsoft.com/office/drawing/2014/main" id="{83580B83-D042-4367-B994-63229681735D}"/>
               </a:ext>
             </a:extLst>
           </p:cNvPr>
@@ -9960,7 +9960,7 @@
           <p:cNvPr id="6" name="">
             <a:extLst xmlns:a="http://schemas.openxmlformats.org/drawingml/2006/main">
               <a:ext uri="{FF2B5EF4-FFF2-40B4-BE49-F238E27FC236}">
-                <a16:creationId xmlns:a16="http://schemas.microsoft.com/office/drawing/2014/main" id="{61029B04-3CFE-4F04-A734-94454A1190AC}"/>
+                <a16:creationId xmlns:a16="http://schemas.microsoft.com/office/drawing/2014/main" id="{0E50165C-39E9-4D7F-A687-D37B38733E1C}"/>
               </a:ext>
             </a:extLst>
           </p:cNvPr>
@@ -9997,7 +9997,7 @@
           <p:cNvPr id="7" name="">
             <a:extLst xmlns:a="http://schemas.openxmlformats.org/drawingml/2006/main">
               <a:ext uri="{FF2B5EF4-FFF2-40B4-BE49-F238E27FC236}">
-                <a16:creationId xmlns:a16="http://schemas.microsoft.com/office/drawing/2014/main" id="{26C5313D-84DE-4694-8AA4-DAD001AF778A}"/>
+                <a16:creationId xmlns:a16="http://schemas.microsoft.com/office/drawing/2014/main" id="{8E333A1D-83BD-46F5-A535-DFE4BF1D1C56}"/>
               </a:ext>
             </a:extLst>
           </p:cNvPr>
@@ -10034,7 +10034,7 @@
           <p:cNvPr id="8" name="">
             <a:extLst xmlns:a="http://schemas.openxmlformats.org/drawingml/2006/main">
               <a:ext uri="{FF2B5EF4-FFF2-40B4-BE49-F238E27FC236}">
-                <a16:creationId xmlns:a16="http://schemas.microsoft.com/office/drawing/2014/main" id="{CFB5DC2C-0AC0-4AA1-8A90-61CA7A2447F2}"/>
+                <a16:creationId xmlns:a16="http://schemas.microsoft.com/office/drawing/2014/main" id="{A3CD26A6-36C3-408C-A8CD-E1E008E7814D}"/>
               </a:ext>
             </a:extLst>
           </p:cNvPr>
@@ -10071,7 +10071,7 @@
           <p:cNvPr id="9" name="">
             <a:extLst xmlns:a="http://schemas.openxmlformats.org/drawingml/2006/main">
               <a:ext uri="{FF2B5EF4-FFF2-40B4-BE49-F238E27FC236}">
-                <a16:creationId xmlns:a16="http://schemas.microsoft.com/office/drawing/2014/main" id="{E18C55A5-E630-4360-9BC9-8CDEF161171C}"/>
+                <a16:creationId xmlns:a16="http://schemas.microsoft.com/office/drawing/2014/main" id="{83D28E01-5DBF-4D35-97A8-10C56F48E6FD}"/>
               </a:ext>
             </a:extLst>
           </p:cNvPr>
@@ -10129,7 +10129,7 @@
           <p:cNvPr id="10" name="">
             <a:extLst xmlns:a="http://schemas.openxmlformats.org/drawingml/2006/main">
               <a:ext uri="{FF2B5EF4-FFF2-40B4-BE49-F238E27FC236}">
-                <a16:creationId xmlns:a16="http://schemas.microsoft.com/office/drawing/2014/main" id="{305A3FC6-A67F-4EBE-9090-6A65FBDEBC8F}"/>
+                <a16:creationId xmlns:a16="http://schemas.microsoft.com/office/drawing/2014/main" id="{0FAD8CDE-9AF7-4D2C-AB81-AD7ABE9F57B9}"/>
               </a:ext>
             </a:extLst>
           </p:cNvPr>
@@ -10187,7 +10187,7 @@
           <p:cNvPr id="11" name="">
             <a:extLst xmlns:a="http://schemas.openxmlformats.org/drawingml/2006/main">
               <a:ext uri="{FF2B5EF4-FFF2-40B4-BE49-F238E27FC236}">
-                <a16:creationId xmlns:a16="http://schemas.microsoft.com/office/drawing/2014/main" id="{1ED6BD71-A8F9-48CB-90C1-4AA2B53E5576}"/>
+                <a16:creationId xmlns:a16="http://schemas.microsoft.com/office/drawing/2014/main" id="{EF7E2534-E92C-4244-AF04-55C78993184C}"/>
               </a:ext>
             </a:extLst>
           </p:cNvPr>
@@ -10222,7 +10222,7 @@
           <p:cNvPr id="12" name="">
             <a:extLst xmlns:a="http://schemas.openxmlformats.org/drawingml/2006/main">
               <a:ext uri="{FF2B5EF4-FFF2-40B4-BE49-F238E27FC236}">
-                <a16:creationId xmlns:a16="http://schemas.microsoft.com/office/drawing/2014/main" id="{9A58EB6D-8881-413F-A0F8-A668FBBF39E4}"/>
+                <a16:creationId xmlns:a16="http://schemas.microsoft.com/office/drawing/2014/main" id="{2FE12EF6-F5AA-4987-8A0F-E5EB8170CB05}"/>
               </a:ext>
             </a:extLst>
           </p:cNvPr>
@@ -10255,7 +10255,7 @@
           <p:cNvPr id="13" name="">
             <a:extLst xmlns:a="http://schemas.openxmlformats.org/drawingml/2006/main">
               <a:ext uri="{FF2B5EF4-FFF2-40B4-BE49-F238E27FC236}">
-                <a16:creationId xmlns:a16="http://schemas.microsoft.com/office/drawing/2014/main" id="{25EBE1EE-831C-4758-87CD-6CA922FB0D6D}"/>
+                <a16:creationId xmlns:a16="http://schemas.microsoft.com/office/drawing/2014/main" id="{BBFACD09-599A-43A7-8CE6-DAB820C8C25C}"/>
               </a:ext>
             </a:extLst>
           </p:cNvPr>
@@ -10330,7 +10330,7 @@
           <p:cNvPr id="14" name="">
             <a:extLst xmlns:a="http://schemas.openxmlformats.org/drawingml/2006/main">
               <a:ext uri="{FF2B5EF4-FFF2-40B4-BE49-F238E27FC236}">
-                <a16:creationId xmlns:a16="http://schemas.microsoft.com/office/drawing/2014/main" id="{2014B76A-394E-444C-93D9-AC807BB765BF}"/>
+                <a16:creationId xmlns:a16="http://schemas.microsoft.com/office/drawing/2014/main" id="{5B5A5C34-60CC-457E-98AB-E8997F0AB420}"/>
               </a:ext>
             </a:extLst>
           </p:cNvPr>
@@ -10365,7 +10365,7 @@
           <p:cNvPr id="15" name="">
             <a:extLst xmlns:a="http://schemas.openxmlformats.org/drawingml/2006/main">
               <a:ext uri="{FF2B5EF4-FFF2-40B4-BE49-F238E27FC236}">
-                <a16:creationId xmlns:a16="http://schemas.microsoft.com/office/drawing/2014/main" id="{C6C98D76-5DBE-4689-8520-5932796254A9}"/>
+                <a16:creationId xmlns:a16="http://schemas.microsoft.com/office/drawing/2014/main" id="{CC111975-E0A9-41F2-B173-ACD7BF2C950A}"/>
               </a:ext>
             </a:extLst>
           </p:cNvPr>
@@ -10400,7 +10400,7 @@
           <p:cNvPr id="16" name="">
             <a:extLst xmlns:a="http://schemas.openxmlformats.org/drawingml/2006/main">
               <a:ext uri="{FF2B5EF4-FFF2-40B4-BE49-F238E27FC236}">
-                <a16:creationId xmlns:a16="http://schemas.microsoft.com/office/drawing/2014/main" id="{8767C49D-4926-4323-864C-6924882B11FE}"/>
+                <a16:creationId xmlns:a16="http://schemas.microsoft.com/office/drawing/2014/main" id="{EC700934-E756-4964-B3FB-7247A4093027}"/>
               </a:ext>
             </a:extLst>
           </p:cNvPr>
@@ -10458,7 +10458,7 @@
           <p:cNvPr id="17" name="">
             <a:extLst xmlns:a="http://schemas.openxmlformats.org/drawingml/2006/main">
               <a:ext uri="{FF2B5EF4-FFF2-40B4-BE49-F238E27FC236}">
-                <a16:creationId xmlns:a16="http://schemas.microsoft.com/office/drawing/2014/main" id="{A5F28CED-E394-4364-ACEC-970740BFD260}"/>
+                <a16:creationId xmlns:a16="http://schemas.microsoft.com/office/drawing/2014/main" id="{348368ED-BB4F-4627-8B31-DA7E7A5FD6C0}"/>
               </a:ext>
             </a:extLst>
           </p:cNvPr>
@@ -10495,7 +10495,7 @@
           <p:cNvPr id="18" name="">
             <a:extLst xmlns:a="http://schemas.openxmlformats.org/drawingml/2006/main">
               <a:ext uri="{FF2B5EF4-FFF2-40B4-BE49-F238E27FC236}">
-                <a16:creationId xmlns:a16="http://schemas.microsoft.com/office/drawing/2014/main" id="{4055DDA3-CF99-4947-BA18-FF6298CA8BC1}"/>
+                <a16:creationId xmlns:a16="http://schemas.microsoft.com/office/drawing/2014/main" id="{8D78B38D-92F5-4661-A8BE-262CE62FED55}"/>
               </a:ext>
             </a:extLst>
           </p:cNvPr>
@@ -10530,7 +10530,7 @@
           <p:cNvPr id="19" name="">
             <a:extLst xmlns:a="http://schemas.openxmlformats.org/drawingml/2006/main">
               <a:ext uri="{FF2B5EF4-FFF2-40B4-BE49-F238E27FC236}">
-                <a16:creationId xmlns:a16="http://schemas.microsoft.com/office/drawing/2014/main" id="{3882ABA8-34C7-419B-ACA6-8DD58B8A120B}"/>
+                <a16:creationId xmlns:a16="http://schemas.microsoft.com/office/drawing/2014/main" id="{EED22E06-12E6-4149-9415-1CD6A8F1C689}"/>
               </a:ext>
             </a:extLst>
           </p:cNvPr>
@@ -10588,7 +10588,7 @@
           <p:cNvPr id="20" name="">
             <a:extLst xmlns:a="http://schemas.openxmlformats.org/drawingml/2006/main">
               <a:ext uri="{FF2B5EF4-FFF2-40B4-BE49-F238E27FC236}">
-                <a16:creationId xmlns:a16="http://schemas.microsoft.com/office/drawing/2014/main" id="{D6DD3F03-4864-4B9C-8243-510BB19830E5}"/>
+                <a16:creationId xmlns:a16="http://schemas.microsoft.com/office/drawing/2014/main" id="{7DA682C3-CCF0-4BDF-9A36-5C99ED78AD68}"/>
               </a:ext>
             </a:extLst>
           </p:cNvPr>
@@ -10646,7 +10646,7 @@
           <p:cNvPr id="21" name="">
             <a:extLst xmlns:a="http://schemas.openxmlformats.org/drawingml/2006/main">
               <a:ext uri="{FF2B5EF4-FFF2-40B4-BE49-F238E27FC236}">
-                <a16:creationId xmlns:a16="http://schemas.microsoft.com/office/drawing/2014/main" id="{ED47A85A-6F88-4230-94A9-C1802B1731AA}"/>
+                <a16:creationId xmlns:a16="http://schemas.microsoft.com/office/drawing/2014/main" id="{D00459A7-6C47-4146-B239-BFAFC5764081}"/>
               </a:ext>
             </a:extLst>
           </p:cNvPr>
@@ -10704,7 +10704,7 @@
           <p:cNvPr id="22" name="">
             <a:extLst xmlns:a="http://schemas.openxmlformats.org/drawingml/2006/main">
               <a:ext uri="{FF2B5EF4-FFF2-40B4-BE49-F238E27FC236}">
-                <a16:creationId xmlns:a16="http://schemas.microsoft.com/office/drawing/2014/main" id="{67F2EA5E-822A-46D1-B528-AA87E49A11FF}"/>
+                <a16:creationId xmlns:a16="http://schemas.microsoft.com/office/drawing/2014/main" id="{BDC9CAA2-C883-4C8C-84D8-A97EFBF3F1F7}"/>
               </a:ext>
             </a:extLst>
           </p:cNvPr>
@@ -10741,7 +10741,7 @@
           <p:cNvPr id="23" name="">
             <a:extLst xmlns:a="http://schemas.openxmlformats.org/drawingml/2006/main">
               <a:ext uri="{FF2B5EF4-FFF2-40B4-BE49-F238E27FC236}">
-                <a16:creationId xmlns:a16="http://schemas.microsoft.com/office/drawing/2014/main" id="{D3898373-E979-4E08-BB34-6C76048FBEBB}"/>
+                <a16:creationId xmlns:a16="http://schemas.microsoft.com/office/drawing/2014/main" id="{5EE9DD3A-833A-4876-926E-7031099BF309}"/>
               </a:ext>
             </a:extLst>
           </p:cNvPr>
@@ -10776,7 +10776,7 @@
           <p:cNvPr id="24" name="">
             <a:extLst xmlns:a="http://schemas.openxmlformats.org/drawingml/2006/main">
               <a:ext uri="{FF2B5EF4-FFF2-40B4-BE49-F238E27FC236}">
-                <a16:creationId xmlns:a16="http://schemas.microsoft.com/office/drawing/2014/main" id="{0F9DB7B8-993A-4466-BC01-F1EA61CAF81D}"/>
+                <a16:creationId xmlns:a16="http://schemas.microsoft.com/office/drawing/2014/main" id="{AAFFEA89-20F8-4EFC-AE09-734ED955A21E}"/>
               </a:ext>
             </a:extLst>
           </p:cNvPr>
@@ -10834,7 +10834,7 @@
           <p:cNvPr id="25" name="">
             <a:extLst xmlns:a="http://schemas.openxmlformats.org/drawingml/2006/main">
               <a:ext uri="{FF2B5EF4-FFF2-40B4-BE49-F238E27FC236}">
-                <a16:creationId xmlns:a16="http://schemas.microsoft.com/office/drawing/2014/main" id="{CE2DD017-1B51-49DD-A5F6-E43C7176996B}"/>
+                <a16:creationId xmlns:a16="http://schemas.microsoft.com/office/drawing/2014/main" id="{34AA8A49-C335-4C59-9545-90630E04D909}"/>
               </a:ext>
             </a:extLst>
           </p:cNvPr>
@@ -10892,7 +10892,7 @@
           <p:cNvPr id="26" name="">
             <a:extLst xmlns:a="http://schemas.openxmlformats.org/drawingml/2006/main">
               <a:ext uri="{FF2B5EF4-FFF2-40B4-BE49-F238E27FC236}">
-                <a16:creationId xmlns:a16="http://schemas.microsoft.com/office/drawing/2014/main" id="{536070D3-86F2-45E7-A60A-0227BF1E4C49}"/>
+                <a16:creationId xmlns:a16="http://schemas.microsoft.com/office/drawing/2014/main" id="{4FDC5D70-EDA6-40BF-A737-BE2E3AF33837}"/>
               </a:ext>
             </a:extLst>
           </p:cNvPr>
@@ -10950,7 +10950,7 @@
           <p:cNvPr id="27" name="">
             <a:extLst xmlns:a="http://schemas.openxmlformats.org/drawingml/2006/main">
               <a:ext uri="{FF2B5EF4-FFF2-40B4-BE49-F238E27FC236}">
-                <a16:creationId xmlns:a16="http://schemas.microsoft.com/office/drawing/2014/main" id="{3C223EF0-EBE7-448A-B4CC-A9455CAC184F}"/>
+                <a16:creationId xmlns:a16="http://schemas.microsoft.com/office/drawing/2014/main" id="{42B082B9-D4E3-4881-A420-3025A11F8C03}"/>
               </a:ext>
             </a:extLst>
           </p:cNvPr>
@@ -10987,7 +10987,7 @@
           <p:cNvPr id="28" name="">
             <a:extLst xmlns:a="http://schemas.openxmlformats.org/drawingml/2006/main">
               <a:ext uri="{FF2B5EF4-FFF2-40B4-BE49-F238E27FC236}">
-                <a16:creationId xmlns:a16="http://schemas.microsoft.com/office/drawing/2014/main" id="{E048FC8A-C892-4398-92B8-D9A75D8A053C}"/>
+                <a16:creationId xmlns:a16="http://schemas.microsoft.com/office/drawing/2014/main" id="{0500AF2B-3AE3-4C8C-84AE-45686BD1868F}"/>
               </a:ext>
             </a:extLst>
           </p:cNvPr>
@@ -11022,7 +11022,7 @@
           <p:cNvPr id="29" name="">
             <a:extLst xmlns:a="http://schemas.openxmlformats.org/drawingml/2006/main">
               <a:ext uri="{FF2B5EF4-FFF2-40B4-BE49-F238E27FC236}">
-                <a16:creationId xmlns:a16="http://schemas.microsoft.com/office/drawing/2014/main" id="{CBF976F3-0B7D-4B5A-B684-28A572FDD210}"/>
+                <a16:creationId xmlns:a16="http://schemas.microsoft.com/office/drawing/2014/main" id="{4A6D9000-6BF3-49A4-B49F-8FC0E1C53597}"/>
               </a:ext>
             </a:extLst>
           </p:cNvPr>
@@ -11080,7 +11080,7 @@
           <p:cNvPr id="30" name="">
             <a:extLst xmlns:a="http://schemas.openxmlformats.org/drawingml/2006/main">
               <a:ext uri="{FF2B5EF4-FFF2-40B4-BE49-F238E27FC236}">
-                <a16:creationId xmlns:a16="http://schemas.microsoft.com/office/drawing/2014/main" id="{874B01D2-13C5-48FB-9172-97964590A431}"/>
+                <a16:creationId xmlns:a16="http://schemas.microsoft.com/office/drawing/2014/main" id="{9717394E-86F4-49B9-95C3-DB5C2A3329DB}"/>
               </a:ext>
             </a:extLst>
           </p:cNvPr>
@@ -11138,7 +11138,7 @@
           <p:cNvPr id="31" name="">
             <a:extLst xmlns:a="http://schemas.openxmlformats.org/drawingml/2006/main">
               <a:ext uri="{FF2B5EF4-FFF2-40B4-BE49-F238E27FC236}">
-                <a16:creationId xmlns:a16="http://schemas.microsoft.com/office/drawing/2014/main" id="{03C8C4AA-4913-40B0-9BB0-E5F87894A407}"/>
+                <a16:creationId xmlns:a16="http://schemas.microsoft.com/office/drawing/2014/main" id="{DA7A41A6-9D7A-4682-BD8D-20B9ED9150FD}"/>
               </a:ext>
             </a:extLst>
           </p:cNvPr>
@@ -11196,7 +11196,7 @@
           <p:cNvPr id="32" name="">
             <a:extLst xmlns:a="http://schemas.openxmlformats.org/drawingml/2006/main">
               <a:ext uri="{FF2B5EF4-FFF2-40B4-BE49-F238E27FC236}">
-                <a16:creationId xmlns:a16="http://schemas.microsoft.com/office/drawing/2014/main" id="{9962B511-D671-4D8D-8DC8-57B014136C30}"/>
+                <a16:creationId xmlns:a16="http://schemas.microsoft.com/office/drawing/2014/main" id="{BAF80B8A-1081-40DD-94F3-ECC9D29F8D35}"/>
               </a:ext>
             </a:extLst>
           </p:cNvPr>
@@ -11233,7 +11233,7 @@
           <p:cNvPr id="33" name="">
             <a:extLst xmlns:a="http://schemas.openxmlformats.org/drawingml/2006/main">
               <a:ext uri="{FF2B5EF4-FFF2-40B4-BE49-F238E27FC236}">
-                <a16:creationId xmlns:a16="http://schemas.microsoft.com/office/drawing/2014/main" id="{BC20C889-9AED-4276-A80B-BE3ADE777355}"/>
+                <a16:creationId xmlns:a16="http://schemas.microsoft.com/office/drawing/2014/main" id="{D8CB177D-D25D-49DF-A7A3-C6D2CA72FCA8}"/>
               </a:ext>
             </a:extLst>
           </p:cNvPr>
@@ -11268,7 +11268,7 @@
           <p:cNvPr id="34" name="">
             <a:extLst xmlns:a="http://schemas.openxmlformats.org/drawingml/2006/main">
               <a:ext uri="{FF2B5EF4-FFF2-40B4-BE49-F238E27FC236}">
-                <a16:creationId xmlns:a16="http://schemas.microsoft.com/office/drawing/2014/main" id="{CEA28CE8-F1E8-4652-A0E8-9BEE9BE86AC0}"/>
+                <a16:creationId xmlns:a16="http://schemas.microsoft.com/office/drawing/2014/main" id="{1EBFD550-D799-4E62-BBAE-CC02337BB2E4}"/>
               </a:ext>
             </a:extLst>
           </p:cNvPr>
@@ -11326,7 +11326,7 @@
           <p:cNvPr id="35" name="">
             <a:extLst xmlns:a="http://schemas.openxmlformats.org/drawingml/2006/main">
               <a:ext uri="{FF2B5EF4-FFF2-40B4-BE49-F238E27FC236}">
-                <a16:creationId xmlns:a16="http://schemas.microsoft.com/office/drawing/2014/main" id="{4DF73D21-92A8-4B86-BACE-ECCBBB644C99}"/>
+                <a16:creationId xmlns:a16="http://schemas.microsoft.com/office/drawing/2014/main" id="{6EDDDA34-F8B3-4F5D-8039-7D3AC38D17ED}"/>
               </a:ext>
             </a:extLst>
           </p:cNvPr>
@@ -11435,7 +11435,7 @@
           <p:cNvPr id="36" name="">
             <a:extLst xmlns:a="http://schemas.openxmlformats.org/drawingml/2006/main">
               <a:ext uri="{FF2B5EF4-FFF2-40B4-BE49-F238E27FC236}">
-                <a16:creationId xmlns:a16="http://schemas.microsoft.com/office/drawing/2014/main" id="{62527602-52EB-45A5-B421-9BDF6232A100}"/>
+                <a16:creationId xmlns:a16="http://schemas.microsoft.com/office/drawing/2014/main" id="{CEB7D67D-6261-4F3E-B6B9-92F8136908D2}"/>
               </a:ext>
             </a:extLst>
           </p:cNvPr>
@@ -11468,7 +11468,7 @@
           <p:cNvPr id="37" name="">
             <a:extLst xmlns:a="http://schemas.openxmlformats.org/drawingml/2006/main">
               <a:ext uri="{FF2B5EF4-FFF2-40B4-BE49-F238E27FC236}">
-                <a16:creationId xmlns:a16="http://schemas.microsoft.com/office/drawing/2014/main" id="{15A30D3A-DD7B-4B86-924B-C791ACB95E25}"/>
+                <a16:creationId xmlns:a16="http://schemas.microsoft.com/office/drawing/2014/main" id="{8B5B25B2-5BDD-455E-80AB-A578CDE574B9}"/>
               </a:ext>
             </a:extLst>
           </p:cNvPr>
@@ -11505,7 +11505,7 @@
           <p:cNvPr id="38" name="">
             <a:extLst xmlns:a="http://schemas.openxmlformats.org/drawingml/2006/main">
               <a:ext uri="{FF2B5EF4-FFF2-40B4-BE49-F238E27FC236}">
-                <a16:creationId xmlns:a16="http://schemas.microsoft.com/office/drawing/2014/main" id="{4F636B83-8542-4106-ACB5-1576C7D1D705}"/>
+                <a16:creationId xmlns:a16="http://schemas.microsoft.com/office/drawing/2014/main" id="{51504DE1-0571-4B0B-9490-6041D3FB3010}"/>
               </a:ext>
             </a:extLst>
           </p:cNvPr>
@@ -11540,7 +11540,7 @@
           <p:cNvPr id="39" name="">
             <a:extLst xmlns:a="http://schemas.openxmlformats.org/drawingml/2006/main">
               <a:ext uri="{FF2B5EF4-FFF2-40B4-BE49-F238E27FC236}">
-                <a16:creationId xmlns:a16="http://schemas.microsoft.com/office/drawing/2014/main" id="{E581D4C2-CB78-44FC-AB4C-1255323618EF}"/>
+                <a16:creationId xmlns:a16="http://schemas.microsoft.com/office/drawing/2014/main" id="{0376D61F-027E-4D4F-9184-4931C012F6DF}"/>
               </a:ext>
             </a:extLst>
           </p:cNvPr>
@@ -11598,7 +11598,7 @@
           <p:cNvPr id="40" name="">
             <a:extLst xmlns:a="http://schemas.openxmlformats.org/drawingml/2006/main">
               <a:ext uri="{FF2B5EF4-FFF2-40B4-BE49-F238E27FC236}">
-                <a16:creationId xmlns:a16="http://schemas.microsoft.com/office/drawing/2014/main" id="{A2759FAD-6A45-4000-9B09-91B688C5D46B}"/>
+                <a16:creationId xmlns:a16="http://schemas.microsoft.com/office/drawing/2014/main" id="{950F11A0-3F50-45C2-B480-3319E83059B4}"/>
               </a:ext>
             </a:extLst>
           </p:cNvPr>
@@ -11690,7 +11690,7 @@
           <p:cNvPr id="41" name="">
             <a:extLst xmlns:a="http://schemas.openxmlformats.org/drawingml/2006/main">
               <a:ext uri="{FF2B5EF4-FFF2-40B4-BE49-F238E27FC236}">
-                <a16:creationId xmlns:a16="http://schemas.microsoft.com/office/drawing/2014/main" id="{803F3182-4600-41A7-8C24-5D144992A56A}"/>
+                <a16:creationId xmlns:a16="http://schemas.microsoft.com/office/drawing/2014/main" id="{77A9AFD6-AE46-41FA-B05C-6078B3F525EF}"/>
               </a:ext>
             </a:extLst>
           </p:cNvPr>
@@ -11723,7 +11723,7 @@
           <p:cNvPr id="42" name="">
             <a:extLst xmlns:a="http://schemas.openxmlformats.org/drawingml/2006/main">
               <a:ext uri="{FF2B5EF4-FFF2-40B4-BE49-F238E27FC236}">
-                <a16:creationId xmlns:a16="http://schemas.microsoft.com/office/drawing/2014/main" id="{0ABAEC01-6EB3-4B88-B019-95558316B755}"/>
+                <a16:creationId xmlns:a16="http://schemas.microsoft.com/office/drawing/2014/main" id="{0130B438-0D26-451C-9E5E-F129C9698561}"/>
               </a:ext>
             </a:extLst>
           </p:cNvPr>
@@ -11760,7 +11760,7 @@
           <p:cNvPr id="43" name="">
             <a:extLst xmlns:a="http://schemas.openxmlformats.org/drawingml/2006/main">
               <a:ext uri="{FF2B5EF4-FFF2-40B4-BE49-F238E27FC236}">
-                <a16:creationId xmlns:a16="http://schemas.microsoft.com/office/drawing/2014/main" id="{9988100E-A804-4C8F-8BF3-325CE3EB1367}"/>
+                <a16:creationId xmlns:a16="http://schemas.microsoft.com/office/drawing/2014/main" id="{889733F1-229D-484A-8097-18AF38A9216A}"/>
               </a:ext>
             </a:extLst>
           </p:cNvPr>
@@ -11795,7 +11795,7 @@
           <p:cNvPr id="44" name="">
             <a:extLst xmlns:a="http://schemas.openxmlformats.org/drawingml/2006/main">
               <a:ext uri="{FF2B5EF4-FFF2-40B4-BE49-F238E27FC236}">
-                <a16:creationId xmlns:a16="http://schemas.microsoft.com/office/drawing/2014/main" id="{671D9F60-BF80-4961-8719-682F78415D12}"/>
+                <a16:creationId xmlns:a16="http://schemas.microsoft.com/office/drawing/2014/main" id="{5EE9C989-196F-4EFF-9FFB-45319CC94C0A}"/>
               </a:ext>
             </a:extLst>
           </p:cNvPr>
@@ -11853,7 +11853,7 @@
           <p:cNvPr id="45" name="">
             <a:extLst xmlns:a="http://schemas.openxmlformats.org/drawingml/2006/main">
               <a:ext uri="{FF2B5EF4-FFF2-40B4-BE49-F238E27FC236}">
-                <a16:creationId xmlns:a16="http://schemas.microsoft.com/office/drawing/2014/main" id="{AE332DA5-8C18-4DD6-A4DE-A83452311784}"/>
+                <a16:creationId xmlns:a16="http://schemas.microsoft.com/office/drawing/2014/main" id="{C8A4ACE1-CE31-47D9-BF4D-E329B4106179}"/>
               </a:ext>
             </a:extLst>
           </p:cNvPr>
@@ -11945,7 +11945,7 @@
           <p:cNvPr id="46" name="">
             <a:extLst xmlns:a="http://schemas.openxmlformats.org/drawingml/2006/main">
               <a:ext uri="{FF2B5EF4-FFF2-40B4-BE49-F238E27FC236}">
-                <a16:creationId xmlns:a16="http://schemas.microsoft.com/office/drawing/2014/main" id="{1638D1A4-B268-4F9B-86F5-EC23A911CC48}"/>
+                <a16:creationId xmlns:a16="http://schemas.microsoft.com/office/drawing/2014/main" id="{A267C33E-A382-4509-AAE3-9CB5D6033830}"/>
               </a:ext>
             </a:extLst>
           </p:cNvPr>
@@ -12001,7 +12001,7 @@
     </p:spTree>
     <p:extLst>
       <p:ext uri="{BB962C8B-B14F-4D97-AF65-F5344CB8AC3E}">
-        <p14:creationId xmlns:p14="http://schemas.microsoft.com/office/powerpoint/2010/main" val="113637826"/>
+        <p14:creationId xmlns:p14="http://schemas.microsoft.com/office/powerpoint/2010/main" val="150236197"/>
       </p:ext>
     </p:extLst>
   </p:cSld>
@@ -12032,7 +12032,7 @@
           <p:cNvPr id="1" name="Slide Number Placeholder 5">
             <a:extLst xmlns:a="http://schemas.openxmlformats.org/drawingml/2006/main">
               <a:ext uri="{FF2B5EF4-FFF2-40B4-BE49-F238E27FC236}">
-                <a16:creationId xmlns:a16="http://schemas.microsoft.com/office/drawing/2014/main" id="{821508BF-91E3-4E78-84B3-DCBD229C8660}"/>
+                <a16:creationId xmlns:a16="http://schemas.microsoft.com/office/drawing/2014/main" id="{11DAD1DA-DD27-4C25-AFB7-E057ACC56EC0}"/>
               </a:ext>
             </a:extLst>
           </p:cNvPr>
@@ -12068,7 +12068,7 @@
           <p:nvPr/>
         </p:nvPicPr>
         <p:blipFill>
-          <a:blip xmlns:r="http://schemas.openxmlformats.org/officeDocument/2006/relationships" xmlns:a="http://schemas.openxmlformats.org/drawingml/2006/main" r:embed="Rdbae293d94904d67"/>
+          <a:blip xmlns:r="http://schemas.openxmlformats.org/officeDocument/2006/relationships" xmlns:a="http://schemas.openxmlformats.org/drawingml/2006/main" r:embed="Ra9dd5dbe3f0b4712"/>
           <a:srcRect xmlns:a="http://schemas.openxmlformats.org/drawingml/2006/main" l="0" t="21875" r="0" b="21875"/>
           <a:stretch xmlns:a="http://schemas.openxmlformats.org/drawingml/2006/main">
             <a:fillRect l="0" t="0" r="0" b="0"/>
@@ -12089,7 +12089,7 @@
           <p:cNvPr id="3" name="">
             <a:extLst xmlns:a="http://schemas.openxmlformats.org/drawingml/2006/main">
               <a:ext uri="{FF2B5EF4-FFF2-40B4-BE49-F238E27FC236}">
-                <a16:creationId xmlns:a16="http://schemas.microsoft.com/office/drawing/2014/main" id="{E0B3D9B3-A1F3-44BB-914C-3C4A1285A1E5}"/>
+                <a16:creationId xmlns:a16="http://schemas.microsoft.com/office/drawing/2014/main" id="{3C4E4F89-053C-42E3-BBE7-AEB7B10E07E4}"/>
               </a:ext>
             </a:extLst>
           </p:cNvPr>
@@ -12124,7 +12124,7 @@
           <p:cNvPr id="4" name="">
             <a:extLst xmlns:a="http://schemas.openxmlformats.org/drawingml/2006/main">
               <a:ext uri="{FF2B5EF4-FFF2-40B4-BE49-F238E27FC236}">
-                <a16:creationId xmlns:a16="http://schemas.microsoft.com/office/drawing/2014/main" id="{8CE0FCA8-C0DF-412E-84C7-3E257338FE88}"/>
+                <a16:creationId xmlns:a16="http://schemas.microsoft.com/office/drawing/2014/main" id="{9EB6CE44-88FD-4113-B29B-CE0A4E0BF2B4}"/>
               </a:ext>
             </a:extLst>
           </p:cNvPr>
@@ -12159,7 +12159,7 @@
           <p:cNvPr id="5" name="">
             <a:extLst xmlns:a="http://schemas.openxmlformats.org/drawingml/2006/main">
               <a:ext uri="{FF2B5EF4-FFF2-40B4-BE49-F238E27FC236}">
-                <a16:creationId xmlns:a16="http://schemas.microsoft.com/office/drawing/2014/main" id="{8B5DE45A-F75D-4E24-8770-3F2E3A8054C1}"/>
+                <a16:creationId xmlns:a16="http://schemas.microsoft.com/office/drawing/2014/main" id="{F6FAD442-3F6A-40FC-812C-0AC8C5D1B821}"/>
               </a:ext>
             </a:extLst>
           </p:cNvPr>
@@ -12196,7 +12196,7 @@
           <p:cNvPr id="6" name="">
             <a:extLst xmlns:a="http://schemas.openxmlformats.org/drawingml/2006/main">
               <a:ext uri="{FF2B5EF4-FFF2-40B4-BE49-F238E27FC236}">
-                <a16:creationId xmlns:a16="http://schemas.microsoft.com/office/drawing/2014/main" id="{A0BD5025-7669-415C-857C-BC93BBB4B49F}"/>
+                <a16:creationId xmlns:a16="http://schemas.microsoft.com/office/drawing/2014/main" id="{C2673F55-E503-4B06-B4F2-E330EAF668A9}"/>
               </a:ext>
             </a:extLst>
           </p:cNvPr>
@@ -12233,7 +12233,7 @@
           <p:cNvPr id="7" name="">
             <a:extLst xmlns:a="http://schemas.openxmlformats.org/drawingml/2006/main">
               <a:ext uri="{FF2B5EF4-FFF2-40B4-BE49-F238E27FC236}">
-                <a16:creationId xmlns:a16="http://schemas.microsoft.com/office/drawing/2014/main" id="{B9C89542-4EFA-4755-BB1A-CA493D9FEFA4}"/>
+                <a16:creationId xmlns:a16="http://schemas.microsoft.com/office/drawing/2014/main" id="{FBA00386-8697-4553-8174-CD6CC5A5BA89}"/>
               </a:ext>
             </a:extLst>
           </p:cNvPr>
@@ -12270,7 +12270,7 @@
           <p:cNvPr id="8" name="">
             <a:extLst xmlns:a="http://schemas.openxmlformats.org/drawingml/2006/main">
               <a:ext uri="{FF2B5EF4-FFF2-40B4-BE49-F238E27FC236}">
-                <a16:creationId xmlns:a16="http://schemas.microsoft.com/office/drawing/2014/main" id="{98D07353-606A-429A-87A9-9F1D1D345A89}"/>
+                <a16:creationId xmlns:a16="http://schemas.microsoft.com/office/drawing/2014/main" id="{D6D566E1-41FE-4576-B7A7-C00932F8B1F7}"/>
               </a:ext>
             </a:extLst>
           </p:cNvPr>
@@ -12307,7 +12307,7 @@
           <p:cNvPr id="9" name="">
             <a:extLst xmlns:a="http://schemas.openxmlformats.org/drawingml/2006/main">
               <a:ext uri="{FF2B5EF4-FFF2-40B4-BE49-F238E27FC236}">
-                <a16:creationId xmlns:a16="http://schemas.microsoft.com/office/drawing/2014/main" id="{D3CD2E60-6223-41B5-AD10-F6B8F80542C7}"/>
+                <a16:creationId xmlns:a16="http://schemas.microsoft.com/office/drawing/2014/main" id="{F5A06E7D-B0FB-4616-9BFC-3CDEB1DA9896}"/>
               </a:ext>
             </a:extLst>
           </p:cNvPr>
@@ -12365,7 +12365,7 @@
           <p:cNvPr id="10" name="">
             <a:extLst xmlns:a="http://schemas.openxmlformats.org/drawingml/2006/main">
               <a:ext uri="{FF2B5EF4-FFF2-40B4-BE49-F238E27FC236}">
-                <a16:creationId xmlns:a16="http://schemas.microsoft.com/office/drawing/2014/main" id="{51C5CCEE-7F25-4D7C-ACBF-F272AFF10CDC}"/>
+                <a16:creationId xmlns:a16="http://schemas.microsoft.com/office/drawing/2014/main" id="{594178A3-8BAF-4AB1-B54C-737E1390F80E}"/>
               </a:ext>
             </a:extLst>
           </p:cNvPr>
@@ -12423,7 +12423,7 @@
           <p:cNvPr id="11" name="">
             <a:extLst xmlns:a="http://schemas.openxmlformats.org/drawingml/2006/main">
               <a:ext uri="{FF2B5EF4-FFF2-40B4-BE49-F238E27FC236}">
-                <a16:creationId xmlns:a16="http://schemas.microsoft.com/office/drawing/2014/main" id="{222F04D1-B718-4FDB-ACAB-6A7C7AB89148}"/>
+                <a16:creationId xmlns:a16="http://schemas.microsoft.com/office/drawing/2014/main" id="{3B6F4D70-A10A-4F27-A581-16C9A082A0DD}"/>
               </a:ext>
             </a:extLst>
           </p:cNvPr>
@@ -12458,7 +12458,7 @@
           <p:cNvPr id="12" name="">
             <a:extLst xmlns:a="http://schemas.openxmlformats.org/drawingml/2006/main">
               <a:ext uri="{FF2B5EF4-FFF2-40B4-BE49-F238E27FC236}">
-                <a16:creationId xmlns:a16="http://schemas.microsoft.com/office/drawing/2014/main" id="{6549A890-69D2-4CA4-A584-5F14AB83F3FF}"/>
+                <a16:creationId xmlns:a16="http://schemas.microsoft.com/office/drawing/2014/main" id="{9EA16861-73E4-40CE-8BA2-B5FE49EF6FBA}"/>
               </a:ext>
             </a:extLst>
           </p:cNvPr>
@@ -12491,7 +12491,7 @@
           <p:cNvPr id="13" name="">
             <a:extLst xmlns:a="http://schemas.openxmlformats.org/drawingml/2006/main">
               <a:ext uri="{FF2B5EF4-FFF2-40B4-BE49-F238E27FC236}">
-                <a16:creationId xmlns:a16="http://schemas.microsoft.com/office/drawing/2014/main" id="{664D7953-A5AD-4D73-9611-19C53E37A385}"/>
+                <a16:creationId xmlns:a16="http://schemas.microsoft.com/office/drawing/2014/main" id="{8D56011E-DE74-4C9D-967C-70BC4D13DD78}"/>
               </a:ext>
             </a:extLst>
           </p:cNvPr>
@@ -12566,7 +12566,7 @@
           <p:cNvPr id="14" name="">
             <a:extLst xmlns:a="http://schemas.openxmlformats.org/drawingml/2006/main">
               <a:ext uri="{FF2B5EF4-FFF2-40B4-BE49-F238E27FC236}">
-                <a16:creationId xmlns:a16="http://schemas.microsoft.com/office/drawing/2014/main" id="{3675DDEB-55FE-4680-B2DC-114E99E115A2}"/>
+                <a16:creationId xmlns:a16="http://schemas.microsoft.com/office/drawing/2014/main" id="{A858BB7F-C28D-4BF7-B096-9E360ED6A5F6}"/>
               </a:ext>
             </a:extLst>
           </p:cNvPr>
@@ -12603,7 +12603,7 @@
           <p:cNvPr id="15" name="">
             <a:extLst xmlns:a="http://schemas.openxmlformats.org/drawingml/2006/main">
               <a:ext uri="{FF2B5EF4-FFF2-40B4-BE49-F238E27FC236}">
-                <a16:creationId xmlns:a16="http://schemas.microsoft.com/office/drawing/2014/main" id="{D333A0B2-8E81-4849-BBB7-BED0F4E9232E}"/>
+                <a16:creationId xmlns:a16="http://schemas.microsoft.com/office/drawing/2014/main" id="{9B30471F-D138-4AC0-87DB-2C86D77996DD}"/>
               </a:ext>
             </a:extLst>
           </p:cNvPr>
@@ -12638,7 +12638,7 @@
           <p:cNvPr id="16" name="">
             <a:extLst xmlns:a="http://schemas.openxmlformats.org/drawingml/2006/main">
               <a:ext uri="{FF2B5EF4-FFF2-40B4-BE49-F238E27FC236}">
-                <a16:creationId xmlns:a16="http://schemas.microsoft.com/office/drawing/2014/main" id="{69B385C7-D9B5-4D26-9243-6A7BAA445E93}"/>
+                <a16:creationId xmlns:a16="http://schemas.microsoft.com/office/drawing/2014/main" id="{9721CA5C-3306-4B7B-B4EA-C65B428FAB3D}"/>
               </a:ext>
             </a:extLst>
           </p:cNvPr>
@@ -12696,7 +12696,7 @@
           <p:cNvPr id="17" name="">
             <a:extLst xmlns:a="http://schemas.openxmlformats.org/drawingml/2006/main">
               <a:ext uri="{FF2B5EF4-FFF2-40B4-BE49-F238E27FC236}">
-                <a16:creationId xmlns:a16="http://schemas.microsoft.com/office/drawing/2014/main" id="{D1FE0E59-AD52-4933-BFEB-4BBA3EF17606}"/>
+                <a16:creationId xmlns:a16="http://schemas.microsoft.com/office/drawing/2014/main" id="{49D82C79-4C96-4117-80CC-23ACAABD5F67}"/>
               </a:ext>
             </a:extLst>
           </p:cNvPr>
@@ -12754,7 +12754,7 @@
           <p:cNvPr id="18" name="">
             <a:extLst xmlns:a="http://schemas.openxmlformats.org/drawingml/2006/main">
               <a:ext uri="{FF2B5EF4-FFF2-40B4-BE49-F238E27FC236}">
-                <a16:creationId xmlns:a16="http://schemas.microsoft.com/office/drawing/2014/main" id="{A9A5066A-F192-43C6-9E2A-42E9713FBE1A}"/>
+                <a16:creationId xmlns:a16="http://schemas.microsoft.com/office/drawing/2014/main" id="{02624F2E-E019-4BA2-B59E-B2DBCA9A6808}"/>
               </a:ext>
             </a:extLst>
           </p:cNvPr>
@@ -12812,7 +12812,7 @@
           <p:cNvPr id="19" name="">
             <a:extLst xmlns:a="http://schemas.openxmlformats.org/drawingml/2006/main">
               <a:ext uri="{FF2B5EF4-FFF2-40B4-BE49-F238E27FC236}">
-                <a16:creationId xmlns:a16="http://schemas.microsoft.com/office/drawing/2014/main" id="{B4E2547D-DBE0-48A1-8A6E-4DFB9F32016E}"/>
+                <a16:creationId xmlns:a16="http://schemas.microsoft.com/office/drawing/2014/main" id="{E22260D2-72C8-4F19-8269-D8DB3E6560DF}"/>
               </a:ext>
             </a:extLst>
           </p:cNvPr>
@@ -12849,7 +12849,7 @@
           <p:cNvPr id="20" name="">
             <a:extLst xmlns:a="http://schemas.openxmlformats.org/drawingml/2006/main">
               <a:ext uri="{FF2B5EF4-FFF2-40B4-BE49-F238E27FC236}">
-                <a16:creationId xmlns:a16="http://schemas.microsoft.com/office/drawing/2014/main" id="{47884E3A-2064-4F6A-93E2-7D02C0485A86}"/>
+                <a16:creationId xmlns:a16="http://schemas.microsoft.com/office/drawing/2014/main" id="{241BA0B5-BEB4-42AE-B78E-E5DA25508E67}"/>
               </a:ext>
             </a:extLst>
           </p:cNvPr>
@@ -12884,7 +12884,7 @@
           <p:cNvPr id="21" name="">
             <a:extLst xmlns:a="http://schemas.openxmlformats.org/drawingml/2006/main">
               <a:ext uri="{FF2B5EF4-FFF2-40B4-BE49-F238E27FC236}">
-                <a16:creationId xmlns:a16="http://schemas.microsoft.com/office/drawing/2014/main" id="{D096A2D9-EC04-4F8B-9CB9-B8BA5F9579A2}"/>
+                <a16:creationId xmlns:a16="http://schemas.microsoft.com/office/drawing/2014/main" id="{DC9B0BCC-FC2C-4D01-AB2C-49AEF69BB3FC}"/>
               </a:ext>
             </a:extLst>
           </p:cNvPr>
@@ -12942,7 +12942,7 @@
           <p:cNvPr id="22" name="">
             <a:extLst xmlns:a="http://schemas.openxmlformats.org/drawingml/2006/main">
               <a:ext uri="{FF2B5EF4-FFF2-40B4-BE49-F238E27FC236}">
-                <a16:creationId xmlns:a16="http://schemas.microsoft.com/office/drawing/2014/main" id="{D76E4668-F47E-4082-B69E-66D7EA34EA5C}"/>
+                <a16:creationId xmlns:a16="http://schemas.microsoft.com/office/drawing/2014/main" id="{887E3D04-76B9-42CA-B701-6138BCCAF4C2}"/>
               </a:ext>
             </a:extLst>
           </p:cNvPr>
@@ -13000,7 +13000,7 @@
           <p:cNvPr id="23" name="">
             <a:extLst xmlns:a="http://schemas.openxmlformats.org/drawingml/2006/main">
               <a:ext uri="{FF2B5EF4-FFF2-40B4-BE49-F238E27FC236}">
-                <a16:creationId xmlns:a16="http://schemas.microsoft.com/office/drawing/2014/main" id="{53787DC9-6F43-4AF1-B28D-7B10E26B5B88}"/>
+                <a16:creationId xmlns:a16="http://schemas.microsoft.com/office/drawing/2014/main" id="{0673D2AE-BD96-4ABD-A6E2-C4EF72413A5C}"/>
               </a:ext>
             </a:extLst>
           </p:cNvPr>
@@ -13058,7 +13058,7 @@
           <p:cNvPr id="24" name="">
             <a:extLst xmlns:a="http://schemas.openxmlformats.org/drawingml/2006/main">
               <a:ext uri="{FF2B5EF4-FFF2-40B4-BE49-F238E27FC236}">
-                <a16:creationId xmlns:a16="http://schemas.microsoft.com/office/drawing/2014/main" id="{6E41B26D-D282-43FB-A30A-055289E1F116}"/>
+                <a16:creationId xmlns:a16="http://schemas.microsoft.com/office/drawing/2014/main" id="{27E524B7-1245-48A0-985B-79E68D0FA0B7}"/>
               </a:ext>
             </a:extLst>
           </p:cNvPr>
@@ -13095,7 +13095,7 @@
           <p:cNvPr id="25" name="">
             <a:extLst xmlns:a="http://schemas.openxmlformats.org/drawingml/2006/main">
               <a:ext uri="{FF2B5EF4-FFF2-40B4-BE49-F238E27FC236}">
-                <a16:creationId xmlns:a16="http://schemas.microsoft.com/office/drawing/2014/main" id="{A8009134-7666-4F1B-9CBB-483CE06AB96B}"/>
+                <a16:creationId xmlns:a16="http://schemas.microsoft.com/office/drawing/2014/main" id="{F57B177C-7164-41BE-8810-ACE5AFEFBC21}"/>
               </a:ext>
             </a:extLst>
           </p:cNvPr>
@@ -13130,7 +13130,7 @@
           <p:cNvPr id="26" name="">
             <a:extLst xmlns:a="http://schemas.openxmlformats.org/drawingml/2006/main">
               <a:ext uri="{FF2B5EF4-FFF2-40B4-BE49-F238E27FC236}">
-                <a16:creationId xmlns:a16="http://schemas.microsoft.com/office/drawing/2014/main" id="{C59BD3EB-ED18-4C8C-AA59-88161B497095}"/>
+                <a16:creationId xmlns:a16="http://schemas.microsoft.com/office/drawing/2014/main" id="{5FBA155E-66CA-47FF-ADD1-480B246620B9}"/>
               </a:ext>
             </a:extLst>
           </p:cNvPr>
@@ -13188,7 +13188,7 @@
           <p:cNvPr id="27" name="">
             <a:extLst xmlns:a="http://schemas.openxmlformats.org/drawingml/2006/main">
               <a:ext uri="{FF2B5EF4-FFF2-40B4-BE49-F238E27FC236}">
-                <a16:creationId xmlns:a16="http://schemas.microsoft.com/office/drawing/2014/main" id="{DD2DDDB6-7854-45D9-915E-169C915942BD}"/>
+                <a16:creationId xmlns:a16="http://schemas.microsoft.com/office/drawing/2014/main" id="{FB404FE6-8743-41E2-9A68-16052E3292A4}"/>
               </a:ext>
             </a:extLst>
           </p:cNvPr>
@@ -13246,7 +13246,7 @@
           <p:cNvPr id="28" name="">
             <a:extLst xmlns:a="http://schemas.openxmlformats.org/drawingml/2006/main">
               <a:ext uri="{FF2B5EF4-FFF2-40B4-BE49-F238E27FC236}">
-                <a16:creationId xmlns:a16="http://schemas.microsoft.com/office/drawing/2014/main" id="{FAD5EC4A-3A8E-4230-A185-5F685272A3A5}"/>
+                <a16:creationId xmlns:a16="http://schemas.microsoft.com/office/drawing/2014/main" id="{5DCEAAE7-BF74-4536-ACEA-38EF7D442C8A}"/>
               </a:ext>
             </a:extLst>
           </p:cNvPr>
@@ -13304,7 +13304,7 @@
           <p:cNvPr id="29" name="">
             <a:extLst xmlns:a="http://schemas.openxmlformats.org/drawingml/2006/main">
               <a:ext uri="{FF2B5EF4-FFF2-40B4-BE49-F238E27FC236}">
-                <a16:creationId xmlns:a16="http://schemas.microsoft.com/office/drawing/2014/main" id="{E8BF4855-E7DC-472C-AE1E-F683D9BEDDBC}"/>
+                <a16:creationId xmlns:a16="http://schemas.microsoft.com/office/drawing/2014/main" id="{8C5B0C55-C2A3-4DE9-B4C6-9EF888265533}"/>
               </a:ext>
             </a:extLst>
           </p:cNvPr>
@@ -13341,7 +13341,7 @@
           <p:cNvPr id="30" name="">
             <a:extLst xmlns:a="http://schemas.openxmlformats.org/drawingml/2006/main">
               <a:ext uri="{FF2B5EF4-FFF2-40B4-BE49-F238E27FC236}">
-                <a16:creationId xmlns:a16="http://schemas.microsoft.com/office/drawing/2014/main" id="{C3EF6258-1B3D-4EBA-9982-73B770599AF3}"/>
+                <a16:creationId xmlns:a16="http://schemas.microsoft.com/office/drawing/2014/main" id="{40AF74D7-0BB3-49B1-97D9-D0227DBA3DFE}"/>
               </a:ext>
             </a:extLst>
           </p:cNvPr>
@@ -13376,7 +13376,7 @@
           <p:cNvPr id="31" name="">
             <a:extLst xmlns:a="http://schemas.openxmlformats.org/drawingml/2006/main">
               <a:ext uri="{FF2B5EF4-FFF2-40B4-BE49-F238E27FC236}">
-                <a16:creationId xmlns:a16="http://schemas.microsoft.com/office/drawing/2014/main" id="{D946F6B4-3A9E-4465-A153-C1B50A920B5F}"/>
+                <a16:creationId xmlns:a16="http://schemas.microsoft.com/office/drawing/2014/main" id="{1D274B15-D79F-455C-BD50-74EDA75EF169}"/>
               </a:ext>
             </a:extLst>
           </p:cNvPr>
@@ -13434,7 +13434,7 @@
           <p:cNvPr id="32" name="">
             <a:extLst xmlns:a="http://schemas.openxmlformats.org/drawingml/2006/main">
               <a:ext uri="{FF2B5EF4-FFF2-40B4-BE49-F238E27FC236}">
-                <a16:creationId xmlns:a16="http://schemas.microsoft.com/office/drawing/2014/main" id="{CF993867-C577-4634-AFAE-36E14B570358}"/>
+                <a16:creationId xmlns:a16="http://schemas.microsoft.com/office/drawing/2014/main" id="{50D3E824-639B-48F4-BA11-E5921BE55712}"/>
               </a:ext>
             </a:extLst>
           </p:cNvPr>
@@ -13560,7 +13560,7 @@
           <p:cNvPr id="33" name="">
             <a:extLst xmlns:a="http://schemas.openxmlformats.org/drawingml/2006/main">
               <a:ext uri="{FF2B5EF4-FFF2-40B4-BE49-F238E27FC236}">
-                <a16:creationId xmlns:a16="http://schemas.microsoft.com/office/drawing/2014/main" id="{ED789CE5-E431-4892-AE0E-3B5E3AF3AAC8}"/>
+                <a16:creationId xmlns:a16="http://schemas.microsoft.com/office/drawing/2014/main" id="{DBA6429A-3A1E-4C3A-BF7A-E184EA59A547}"/>
               </a:ext>
             </a:extLst>
           </p:cNvPr>
@@ -13597,7 +13597,7 @@
           <p:cNvPr id="34" name="">
             <a:extLst xmlns:a="http://schemas.openxmlformats.org/drawingml/2006/main">
               <a:ext uri="{FF2B5EF4-FFF2-40B4-BE49-F238E27FC236}">
-                <a16:creationId xmlns:a16="http://schemas.microsoft.com/office/drawing/2014/main" id="{079D33E6-64C9-49FB-B4A0-862664C0E255}"/>
+                <a16:creationId xmlns:a16="http://schemas.microsoft.com/office/drawing/2014/main" id="{4D6619E3-D7D7-49BE-9273-2DCC775B0171}"/>
               </a:ext>
             </a:extLst>
           </p:cNvPr>
@@ -13632,7 +13632,7 @@
           <p:cNvPr id="35" name="">
             <a:extLst xmlns:a="http://schemas.openxmlformats.org/drawingml/2006/main">
               <a:ext uri="{FF2B5EF4-FFF2-40B4-BE49-F238E27FC236}">
-                <a16:creationId xmlns:a16="http://schemas.microsoft.com/office/drawing/2014/main" id="{F3E5AA6C-A387-43D9-85EF-599364501439}"/>
+                <a16:creationId xmlns:a16="http://schemas.microsoft.com/office/drawing/2014/main" id="{4A483BD2-4192-4E7D-B7D4-5C0AAC03B61A}"/>
               </a:ext>
             </a:extLst>
           </p:cNvPr>
@@ -13690,7 +13690,7 @@
           <p:cNvPr id="36" name="">
             <a:extLst xmlns:a="http://schemas.openxmlformats.org/drawingml/2006/main">
               <a:ext uri="{FF2B5EF4-FFF2-40B4-BE49-F238E27FC236}">
-                <a16:creationId xmlns:a16="http://schemas.microsoft.com/office/drawing/2014/main" id="{5D38648F-9AF6-4AC8-862D-D9DFD69B6D6A}"/>
+                <a16:creationId xmlns:a16="http://schemas.microsoft.com/office/drawing/2014/main" id="{96C53DBA-BEE9-4999-9118-416C05844DDC}"/>
               </a:ext>
             </a:extLst>
           </p:cNvPr>
@@ -13799,7 +13799,7 @@
           <p:cNvPr id="37" name="">
             <a:extLst xmlns:a="http://schemas.openxmlformats.org/drawingml/2006/main">
               <a:ext uri="{FF2B5EF4-FFF2-40B4-BE49-F238E27FC236}">
-                <a16:creationId xmlns:a16="http://schemas.microsoft.com/office/drawing/2014/main" id="{3A5EC72D-35A1-471B-8358-2850BB73BBB6}"/>
+                <a16:creationId xmlns:a16="http://schemas.microsoft.com/office/drawing/2014/main" id="{C934437D-F2F5-4385-81D5-873450F96C36}"/>
               </a:ext>
             </a:extLst>
           </p:cNvPr>
@@ -13836,7 +13836,7 @@
           <p:cNvPr id="38" name="">
             <a:extLst xmlns:a="http://schemas.openxmlformats.org/drawingml/2006/main">
               <a:ext uri="{FF2B5EF4-FFF2-40B4-BE49-F238E27FC236}">
-                <a16:creationId xmlns:a16="http://schemas.microsoft.com/office/drawing/2014/main" id="{93884BB2-2A45-437C-9078-13463D521615}"/>
+                <a16:creationId xmlns:a16="http://schemas.microsoft.com/office/drawing/2014/main" id="{40B0D508-131F-455F-A87A-78B6607D6313}"/>
               </a:ext>
             </a:extLst>
           </p:cNvPr>
@@ -13871,7 +13871,7 @@
           <p:cNvPr id="39" name="">
             <a:extLst xmlns:a="http://schemas.openxmlformats.org/drawingml/2006/main">
               <a:ext uri="{FF2B5EF4-FFF2-40B4-BE49-F238E27FC236}">
-                <a16:creationId xmlns:a16="http://schemas.microsoft.com/office/drawing/2014/main" id="{180DDC3A-8059-435D-A123-DA1710E73132}"/>
+                <a16:creationId xmlns:a16="http://schemas.microsoft.com/office/drawing/2014/main" id="{51E39ADE-AF2E-4D2F-B029-F71D91E1CE8A}"/>
               </a:ext>
             </a:extLst>
           </p:cNvPr>
@@ -13929,7 +13929,7 @@
           <p:cNvPr id="40" name="">
             <a:extLst xmlns:a="http://schemas.openxmlformats.org/drawingml/2006/main">
               <a:ext uri="{FF2B5EF4-FFF2-40B4-BE49-F238E27FC236}">
-                <a16:creationId xmlns:a16="http://schemas.microsoft.com/office/drawing/2014/main" id="{BCF4D525-814D-4C4A-B472-1626E21DDE6E}"/>
+                <a16:creationId xmlns:a16="http://schemas.microsoft.com/office/drawing/2014/main" id="{7DA479DE-6363-4C30-8441-79C6F836B199}"/>
               </a:ext>
             </a:extLst>
           </p:cNvPr>
@@ -14038,7 +14038,7 @@
           <p:cNvPr id="41" name="">
             <a:extLst xmlns:a="http://schemas.openxmlformats.org/drawingml/2006/main">
               <a:ext uri="{FF2B5EF4-FFF2-40B4-BE49-F238E27FC236}">
-                <a16:creationId xmlns:a16="http://schemas.microsoft.com/office/drawing/2014/main" id="{49F3FFC7-B104-4D5A-8686-7176CFDCEAF1}"/>
+                <a16:creationId xmlns:a16="http://schemas.microsoft.com/office/drawing/2014/main" id="{8BB1D1B8-056E-48E4-B3A4-7BB9E3A4D38F}"/>
               </a:ext>
             </a:extLst>
           </p:cNvPr>
@@ -14094,7 +14094,7 @@
     </p:spTree>
     <p:extLst>
       <p:ext uri="{BB962C8B-B14F-4D97-AF65-F5344CB8AC3E}">
-        <p14:creationId xmlns:p14="http://schemas.microsoft.com/office/powerpoint/2010/main" val="1237867467"/>
+        <p14:creationId xmlns:p14="http://schemas.microsoft.com/office/powerpoint/2010/main" val="134510111"/>
       </p:ext>
     </p:extLst>
   </p:cSld>
@@ -14125,7 +14125,7 @@
           <p:cNvPr id="1" name="Slide Number Placeholder 5">
             <a:extLst xmlns:a="http://schemas.openxmlformats.org/drawingml/2006/main">
               <a:ext uri="{FF2B5EF4-FFF2-40B4-BE49-F238E27FC236}">
-                <a16:creationId xmlns:a16="http://schemas.microsoft.com/office/drawing/2014/main" id="{821508BF-91E3-4E78-84B3-DCBD229C8660}"/>
+                <a16:creationId xmlns:a16="http://schemas.microsoft.com/office/drawing/2014/main" id="{11DAD1DA-DD27-4C25-AFB7-E057ACC56EC0}"/>
               </a:ext>
             </a:extLst>
           </p:cNvPr>
@@ -14161,7 +14161,7 @@
           <p:nvPr/>
         </p:nvPicPr>
         <p:blipFill>
-          <a:blip xmlns:r="http://schemas.openxmlformats.org/officeDocument/2006/relationships" xmlns:a="http://schemas.openxmlformats.org/drawingml/2006/main" r:embed="Re2c25d33617e48fb"/>
+          <a:blip xmlns:r="http://schemas.openxmlformats.org/officeDocument/2006/relationships" xmlns:a="http://schemas.openxmlformats.org/drawingml/2006/main" r:embed="Rb701a0bc86634413"/>
           <a:srcRect xmlns:a="http://schemas.openxmlformats.org/drawingml/2006/main" l="0" t="21875" r="0" b="21875"/>
           <a:stretch xmlns:a="http://schemas.openxmlformats.org/drawingml/2006/main">
             <a:fillRect l="0" t="0" r="0" b="0"/>
@@ -14182,7 +14182,7 @@
           <p:cNvPr id="3" name="">
             <a:extLst xmlns:a="http://schemas.openxmlformats.org/drawingml/2006/main">
               <a:ext uri="{FF2B5EF4-FFF2-40B4-BE49-F238E27FC236}">
-                <a16:creationId xmlns:a16="http://schemas.microsoft.com/office/drawing/2014/main" id="{85F830A1-B52F-46B3-ADE1-625936B0E395}"/>
+                <a16:creationId xmlns:a16="http://schemas.microsoft.com/office/drawing/2014/main" id="{F85B3A74-CFEE-4B4B-BA34-3FE18FE7A39B}"/>
               </a:ext>
             </a:extLst>
           </p:cNvPr>
@@ -14217,7 +14217,7 @@
           <p:cNvPr id="4" name="">
             <a:extLst xmlns:a="http://schemas.openxmlformats.org/drawingml/2006/main">
               <a:ext uri="{FF2B5EF4-FFF2-40B4-BE49-F238E27FC236}">
-                <a16:creationId xmlns:a16="http://schemas.microsoft.com/office/drawing/2014/main" id="{8C6F1B92-DEE9-41A0-A4B2-DE5D7BA73F19}"/>
+                <a16:creationId xmlns:a16="http://schemas.microsoft.com/office/drawing/2014/main" id="{D2B568E6-C8D2-4B51-9FFF-7A666CFC4BF6}"/>
               </a:ext>
             </a:extLst>
           </p:cNvPr>
@@ -14252,7 +14252,7 @@
           <p:cNvPr id="5" name="">
             <a:extLst xmlns:a="http://schemas.openxmlformats.org/drawingml/2006/main">
               <a:ext uri="{FF2B5EF4-FFF2-40B4-BE49-F238E27FC236}">
-                <a16:creationId xmlns:a16="http://schemas.microsoft.com/office/drawing/2014/main" id="{05AF92C3-7100-4F5B-A334-717559CD7317}"/>
+                <a16:creationId xmlns:a16="http://schemas.microsoft.com/office/drawing/2014/main" id="{B697BBF5-645A-4EDB-95D1-EBBCC7F167AF}"/>
               </a:ext>
             </a:extLst>
           </p:cNvPr>
@@ -14289,7 +14289,7 @@
           <p:cNvPr id="6" name="">
             <a:extLst xmlns:a="http://schemas.openxmlformats.org/drawingml/2006/main">
               <a:ext uri="{FF2B5EF4-FFF2-40B4-BE49-F238E27FC236}">
-                <a16:creationId xmlns:a16="http://schemas.microsoft.com/office/drawing/2014/main" id="{91FDD3FB-B4A1-4AB6-93B6-EAD1BA33E6A7}"/>
+                <a16:creationId xmlns:a16="http://schemas.microsoft.com/office/drawing/2014/main" id="{D86B6496-099A-418D-AABE-215CB6880197}"/>
               </a:ext>
             </a:extLst>
           </p:cNvPr>
@@ -14326,7 +14326,7 @@
           <p:cNvPr id="7" name="">
             <a:extLst xmlns:a="http://schemas.openxmlformats.org/drawingml/2006/main">
               <a:ext uri="{FF2B5EF4-FFF2-40B4-BE49-F238E27FC236}">
-                <a16:creationId xmlns:a16="http://schemas.microsoft.com/office/drawing/2014/main" id="{BA448CC0-4FDD-4FBD-8D0B-C99279F0D511}"/>
+                <a16:creationId xmlns:a16="http://schemas.microsoft.com/office/drawing/2014/main" id="{53DBD1D7-5B12-4EB7-9403-CC197A8DA979}"/>
               </a:ext>
             </a:extLst>
           </p:cNvPr>
@@ -14363,7 +14363,7 @@
           <p:cNvPr id="8" name="">
             <a:extLst xmlns:a="http://schemas.openxmlformats.org/drawingml/2006/main">
               <a:ext uri="{FF2B5EF4-FFF2-40B4-BE49-F238E27FC236}">
-                <a16:creationId xmlns:a16="http://schemas.microsoft.com/office/drawing/2014/main" id="{3FF93357-503B-46FB-A417-E05CAEC0B70B}"/>
+                <a16:creationId xmlns:a16="http://schemas.microsoft.com/office/drawing/2014/main" id="{AA81F857-8EB9-4753-B292-222178A42FF8}"/>
               </a:ext>
             </a:extLst>
           </p:cNvPr>
@@ -14400,7 +14400,7 @@
           <p:cNvPr id="9" name="">
             <a:extLst xmlns:a="http://schemas.openxmlformats.org/drawingml/2006/main">
               <a:ext uri="{FF2B5EF4-FFF2-40B4-BE49-F238E27FC236}">
-                <a16:creationId xmlns:a16="http://schemas.microsoft.com/office/drawing/2014/main" id="{28EB9D4A-E3AD-4345-AD06-2F9BB11CD72F}"/>
+                <a16:creationId xmlns:a16="http://schemas.microsoft.com/office/drawing/2014/main" id="{0D5A3FCB-EB87-4167-95B6-3E1444C05F55}"/>
               </a:ext>
             </a:extLst>
           </p:cNvPr>
@@ -14458,7 +14458,7 @@
           <p:cNvPr id="10" name="">
             <a:extLst xmlns:a="http://schemas.openxmlformats.org/drawingml/2006/main">
               <a:ext uri="{FF2B5EF4-FFF2-40B4-BE49-F238E27FC236}">
-                <a16:creationId xmlns:a16="http://schemas.microsoft.com/office/drawing/2014/main" id="{BCDEAA0B-0A07-4ED1-88E7-93FEFD79167B}"/>
+                <a16:creationId xmlns:a16="http://schemas.microsoft.com/office/drawing/2014/main" id="{DA4A6AC2-1C0E-41BC-BE2D-2FD93BBC7E13}"/>
               </a:ext>
             </a:extLst>
           </p:cNvPr>
@@ -14516,7 +14516,7 @@
           <p:cNvPr id="11" name="">
             <a:extLst xmlns:a="http://schemas.openxmlformats.org/drawingml/2006/main">
               <a:ext uri="{FF2B5EF4-FFF2-40B4-BE49-F238E27FC236}">
-                <a16:creationId xmlns:a16="http://schemas.microsoft.com/office/drawing/2014/main" id="{F55E2B99-B97E-4BDF-AABB-735AFA264609}"/>
+                <a16:creationId xmlns:a16="http://schemas.microsoft.com/office/drawing/2014/main" id="{A614AD8C-9446-4524-894A-FE6736E5424D}"/>
               </a:ext>
             </a:extLst>
           </p:cNvPr>
@@ -14551,7 +14551,7 @@
           <p:cNvPr id="12" name="">
             <a:extLst xmlns:a="http://schemas.openxmlformats.org/drawingml/2006/main">
               <a:ext uri="{FF2B5EF4-FFF2-40B4-BE49-F238E27FC236}">
-                <a16:creationId xmlns:a16="http://schemas.microsoft.com/office/drawing/2014/main" id="{5B4E95C6-D9C3-40D3-8A8C-40F64977BD72}"/>
+                <a16:creationId xmlns:a16="http://schemas.microsoft.com/office/drawing/2014/main" id="{D3435FA6-DA60-4D8E-8D74-157EA7250B63}"/>
               </a:ext>
             </a:extLst>
           </p:cNvPr>
@@ -14584,7 +14584,7 @@
           <p:cNvPr id="13" name="">
             <a:extLst xmlns:a="http://schemas.openxmlformats.org/drawingml/2006/main">
               <a:ext uri="{FF2B5EF4-FFF2-40B4-BE49-F238E27FC236}">
-                <a16:creationId xmlns:a16="http://schemas.microsoft.com/office/drawing/2014/main" id="{ACFDF1E2-524A-47FE-B92C-026958DD54A3}"/>
+                <a16:creationId xmlns:a16="http://schemas.microsoft.com/office/drawing/2014/main" id="{21B2A585-4DB7-45B9-82BB-12A43818D9AE}"/>
               </a:ext>
             </a:extLst>
           </p:cNvPr>
@@ -14659,7 +14659,7 @@
           <p:cNvPr id="14" name="">
             <a:extLst xmlns:a="http://schemas.openxmlformats.org/drawingml/2006/main">
               <a:ext uri="{FF2B5EF4-FFF2-40B4-BE49-F238E27FC236}">
-                <a16:creationId xmlns:a16="http://schemas.microsoft.com/office/drawing/2014/main" id="{EECB16AC-EAC1-437D-BB16-B4BF4B12AC90}"/>
+                <a16:creationId xmlns:a16="http://schemas.microsoft.com/office/drawing/2014/main" id="{64666229-7EE7-4F05-B618-E88FEE88B2D5}"/>
               </a:ext>
             </a:extLst>
           </p:cNvPr>
@@ -14694,7 +14694,7 @@
           <p:cNvPr id="15" name="">
             <a:extLst xmlns:a="http://schemas.openxmlformats.org/drawingml/2006/main">
               <a:ext uri="{FF2B5EF4-FFF2-40B4-BE49-F238E27FC236}">
-                <a16:creationId xmlns:a16="http://schemas.microsoft.com/office/drawing/2014/main" id="{6E76B2A5-B3D5-45C3-9296-38C8893774F5}"/>
+                <a16:creationId xmlns:a16="http://schemas.microsoft.com/office/drawing/2014/main" id="{03442357-BCA3-42C6-854A-CB39EE742C9D}"/>
               </a:ext>
             </a:extLst>
           </p:cNvPr>
@@ -14729,7 +14729,7 @@
           <p:cNvPr id="16" name="">
             <a:extLst xmlns:a="http://schemas.openxmlformats.org/drawingml/2006/main">
               <a:ext uri="{FF2B5EF4-FFF2-40B4-BE49-F238E27FC236}">
-                <a16:creationId xmlns:a16="http://schemas.microsoft.com/office/drawing/2014/main" id="{B498026B-AF79-4D0E-A9B1-0D068908E2AF}"/>
+                <a16:creationId xmlns:a16="http://schemas.microsoft.com/office/drawing/2014/main" id="{888E989F-A41A-49E4-9699-9D8140A742DF}"/>
               </a:ext>
             </a:extLst>
           </p:cNvPr>
@@ -14783,7 +14783,7 @@
           <p:cNvPr id="17" name="">
             <a:extLst xmlns:a="http://schemas.openxmlformats.org/drawingml/2006/main">
               <a:ext uri="{FF2B5EF4-FFF2-40B4-BE49-F238E27FC236}">
-                <a16:creationId xmlns:a16="http://schemas.microsoft.com/office/drawing/2014/main" id="{B5B490C8-7F85-46D5-9C62-DA1B9DC5D4B8}"/>
+                <a16:creationId xmlns:a16="http://schemas.microsoft.com/office/drawing/2014/main" id="{9AA7D190-2724-4DFE-BF05-C95E8648644A}"/>
               </a:ext>
             </a:extLst>
           </p:cNvPr>
@@ -14841,7 +14841,7 @@
           <p:cNvPr id="18" name="">
             <a:extLst xmlns:a="http://schemas.openxmlformats.org/drawingml/2006/main">
               <a:ext uri="{FF2B5EF4-FFF2-40B4-BE49-F238E27FC236}">
-                <a16:creationId xmlns:a16="http://schemas.microsoft.com/office/drawing/2014/main" id="{357FD728-C17A-4311-8780-918593AA3D20}"/>
+                <a16:creationId xmlns:a16="http://schemas.microsoft.com/office/drawing/2014/main" id="{65933066-28F1-45DD-BEBD-62CA3D6F5496}"/>
               </a:ext>
             </a:extLst>
           </p:cNvPr>
@@ -14899,7 +14899,7 @@
           <p:cNvPr id="19" name="">
             <a:extLst xmlns:a="http://schemas.openxmlformats.org/drawingml/2006/main">
               <a:ext uri="{FF2B5EF4-FFF2-40B4-BE49-F238E27FC236}">
-                <a16:creationId xmlns:a16="http://schemas.microsoft.com/office/drawing/2014/main" id="{3C3685CC-D5A3-4F9B-A008-459D677FF9B2}"/>
+                <a16:creationId xmlns:a16="http://schemas.microsoft.com/office/drawing/2014/main" id="{5EE22EA8-105A-4238-87BC-E41CF7B4E646}"/>
               </a:ext>
             </a:extLst>
           </p:cNvPr>
@@ -14934,7 +14934,7 @@
           <p:cNvPr id="20" name="">
             <a:extLst xmlns:a="http://schemas.openxmlformats.org/drawingml/2006/main">
               <a:ext uri="{FF2B5EF4-FFF2-40B4-BE49-F238E27FC236}">
-                <a16:creationId xmlns:a16="http://schemas.microsoft.com/office/drawing/2014/main" id="{58204CDC-C681-461A-B9AE-F66E656A0916}"/>
+                <a16:creationId xmlns:a16="http://schemas.microsoft.com/office/drawing/2014/main" id="{B3CB1E16-E632-4273-A521-12587BEDE2C4}"/>
               </a:ext>
             </a:extLst>
           </p:cNvPr>
@@ -14969,7 +14969,7 @@
           <p:cNvPr id="21" name="">
             <a:extLst xmlns:a="http://schemas.openxmlformats.org/drawingml/2006/main">
               <a:ext uri="{FF2B5EF4-FFF2-40B4-BE49-F238E27FC236}">
-                <a16:creationId xmlns:a16="http://schemas.microsoft.com/office/drawing/2014/main" id="{47C6ECB4-5553-43C0-8C8D-41D125B2A895}"/>
+                <a16:creationId xmlns:a16="http://schemas.microsoft.com/office/drawing/2014/main" id="{AB6F4D34-90C7-4D29-8119-A15089249835}"/>
               </a:ext>
             </a:extLst>
           </p:cNvPr>
@@ -15023,7 +15023,7 @@
           <p:cNvPr id="22" name="">
             <a:extLst xmlns:a="http://schemas.openxmlformats.org/drawingml/2006/main">
               <a:ext uri="{FF2B5EF4-FFF2-40B4-BE49-F238E27FC236}">
-                <a16:creationId xmlns:a16="http://schemas.microsoft.com/office/drawing/2014/main" id="{51A1538A-3CBE-4B30-BB56-3C203C44FF2F}"/>
+                <a16:creationId xmlns:a16="http://schemas.microsoft.com/office/drawing/2014/main" id="{BF1AB3E3-93B9-45C8-B6F5-AD75FB5043D6}"/>
               </a:ext>
             </a:extLst>
           </p:cNvPr>
@@ -15081,7 +15081,7 @@
           <p:cNvPr id="23" name="">
             <a:extLst xmlns:a="http://schemas.openxmlformats.org/drawingml/2006/main">
               <a:ext uri="{FF2B5EF4-FFF2-40B4-BE49-F238E27FC236}">
-                <a16:creationId xmlns:a16="http://schemas.microsoft.com/office/drawing/2014/main" id="{D5DC7F29-12EB-4819-B4AE-7F176D4DC485}"/>
+                <a16:creationId xmlns:a16="http://schemas.microsoft.com/office/drawing/2014/main" id="{8EEE65B7-74A6-48D5-8DA8-707726E82D03}"/>
               </a:ext>
             </a:extLst>
           </p:cNvPr>
@@ -15139,7 +15139,7 @@
           <p:cNvPr id="24" name="">
             <a:extLst xmlns:a="http://schemas.openxmlformats.org/drawingml/2006/main">
               <a:ext uri="{FF2B5EF4-FFF2-40B4-BE49-F238E27FC236}">
-                <a16:creationId xmlns:a16="http://schemas.microsoft.com/office/drawing/2014/main" id="{D21AC2A4-11B5-4B60-AFFF-C58F64509328}"/>
+                <a16:creationId xmlns:a16="http://schemas.microsoft.com/office/drawing/2014/main" id="{BEB4B4F3-AB83-4831-9418-F9AD8E50A8FC}"/>
               </a:ext>
             </a:extLst>
           </p:cNvPr>
@@ -15174,7 +15174,7 @@
           <p:cNvPr id="25" name="">
             <a:extLst xmlns:a="http://schemas.openxmlformats.org/drawingml/2006/main">
               <a:ext uri="{FF2B5EF4-FFF2-40B4-BE49-F238E27FC236}">
-                <a16:creationId xmlns:a16="http://schemas.microsoft.com/office/drawing/2014/main" id="{91429D49-EC71-4F9D-B81D-CE007490F8F2}"/>
+                <a16:creationId xmlns:a16="http://schemas.microsoft.com/office/drawing/2014/main" id="{CA30BCC3-8CCA-483E-9695-833DFD5396E4}"/>
               </a:ext>
             </a:extLst>
           </p:cNvPr>
@@ -15209,7 +15209,7 @@
           <p:cNvPr id="26" name="">
             <a:extLst xmlns:a="http://schemas.openxmlformats.org/drawingml/2006/main">
               <a:ext uri="{FF2B5EF4-FFF2-40B4-BE49-F238E27FC236}">
-                <a16:creationId xmlns:a16="http://schemas.microsoft.com/office/drawing/2014/main" id="{27273D1B-1D7C-4B6F-A265-2B443E75F854}"/>
+                <a16:creationId xmlns:a16="http://schemas.microsoft.com/office/drawing/2014/main" id="{EFC6A08E-DCBA-48FA-8ECF-21068CFC128C}"/>
               </a:ext>
             </a:extLst>
           </p:cNvPr>
@@ -15263,7 +15263,7 @@
           <p:cNvPr id="27" name="">
             <a:extLst xmlns:a="http://schemas.openxmlformats.org/drawingml/2006/main">
               <a:ext uri="{FF2B5EF4-FFF2-40B4-BE49-F238E27FC236}">
-                <a16:creationId xmlns:a16="http://schemas.microsoft.com/office/drawing/2014/main" id="{B7AF2AEC-FF4B-4493-B649-C7A9DC08822E}"/>
+                <a16:creationId xmlns:a16="http://schemas.microsoft.com/office/drawing/2014/main" id="{55B8C646-C849-4804-82F1-A7BD485EA5D5}"/>
               </a:ext>
             </a:extLst>
           </p:cNvPr>
@@ -15321,7 +15321,7 @@
           <p:cNvPr id="28" name="">
             <a:extLst xmlns:a="http://schemas.openxmlformats.org/drawingml/2006/main">
               <a:ext uri="{FF2B5EF4-FFF2-40B4-BE49-F238E27FC236}">
-                <a16:creationId xmlns:a16="http://schemas.microsoft.com/office/drawing/2014/main" id="{47B1329D-6EED-425C-847F-B9AF313751A0}"/>
+                <a16:creationId xmlns:a16="http://schemas.microsoft.com/office/drawing/2014/main" id="{6AB41991-BF0C-4C01-8809-133773978BC4}"/>
               </a:ext>
             </a:extLst>
           </p:cNvPr>
@@ -15396,7 +15396,7 @@
           <p:cNvPr id="29" name="">
             <a:extLst xmlns:a="http://schemas.openxmlformats.org/drawingml/2006/main">
               <a:ext uri="{FF2B5EF4-FFF2-40B4-BE49-F238E27FC236}">
-                <a16:creationId xmlns:a16="http://schemas.microsoft.com/office/drawing/2014/main" id="{2A50C413-2E50-4A3F-8994-B358AF23B7AC}"/>
+                <a16:creationId xmlns:a16="http://schemas.microsoft.com/office/drawing/2014/main" id="{F183C3E4-FE4A-4990-8D13-217E9A2630A0}"/>
               </a:ext>
             </a:extLst>
           </p:cNvPr>
@@ -15431,7 +15431,7 @@
           <p:cNvPr id="30" name="">
             <a:extLst xmlns:a="http://schemas.openxmlformats.org/drawingml/2006/main">
               <a:ext uri="{FF2B5EF4-FFF2-40B4-BE49-F238E27FC236}">
-                <a16:creationId xmlns:a16="http://schemas.microsoft.com/office/drawing/2014/main" id="{F44E93E2-AC62-417E-A4D9-C44E5B7C3CE5}"/>
+                <a16:creationId xmlns:a16="http://schemas.microsoft.com/office/drawing/2014/main" id="{6E217F74-478A-415A-A1FE-BD451F6A2F40}"/>
               </a:ext>
             </a:extLst>
           </p:cNvPr>
@@ -15466,7 +15466,7 @@
           <p:cNvPr id="31" name="">
             <a:extLst xmlns:a="http://schemas.openxmlformats.org/drawingml/2006/main">
               <a:ext uri="{FF2B5EF4-FFF2-40B4-BE49-F238E27FC236}">
-                <a16:creationId xmlns:a16="http://schemas.microsoft.com/office/drawing/2014/main" id="{2BC30686-329B-40FB-A685-D8616259A29B}"/>
+                <a16:creationId xmlns:a16="http://schemas.microsoft.com/office/drawing/2014/main" id="{253AA591-9C87-4821-AF51-C4453A330B65}"/>
               </a:ext>
             </a:extLst>
           </p:cNvPr>
@@ -15520,7 +15520,7 @@
           <p:cNvPr id="32" name="">
             <a:extLst xmlns:a="http://schemas.openxmlformats.org/drawingml/2006/main">
               <a:ext uri="{FF2B5EF4-FFF2-40B4-BE49-F238E27FC236}">
-                <a16:creationId xmlns:a16="http://schemas.microsoft.com/office/drawing/2014/main" id="{417E6FD5-036E-44FC-87CB-F3824D5D471E}"/>
+                <a16:creationId xmlns:a16="http://schemas.microsoft.com/office/drawing/2014/main" id="{C653E060-2E89-4CDB-9F3F-608EBD830495}"/>
               </a:ext>
             </a:extLst>
           </p:cNvPr>
@@ -15578,7 +15578,7 @@
           <p:cNvPr id="33" name="">
             <a:extLst xmlns:a="http://schemas.openxmlformats.org/drawingml/2006/main">
               <a:ext uri="{FF2B5EF4-FFF2-40B4-BE49-F238E27FC236}">
-                <a16:creationId xmlns:a16="http://schemas.microsoft.com/office/drawing/2014/main" id="{9B5BD373-A972-436B-A188-D9BF266E029A}"/>
+                <a16:creationId xmlns:a16="http://schemas.microsoft.com/office/drawing/2014/main" id="{382AC8AA-2478-42E0-8D44-4419C204346B}"/>
               </a:ext>
             </a:extLst>
           </p:cNvPr>
@@ -15653,7 +15653,7 @@
           <p:cNvPr id="34" name="">
             <a:extLst xmlns:a="http://schemas.openxmlformats.org/drawingml/2006/main">
               <a:ext uri="{FF2B5EF4-FFF2-40B4-BE49-F238E27FC236}">
-                <a16:creationId xmlns:a16="http://schemas.microsoft.com/office/drawing/2014/main" id="{CC42C6EB-950D-409E-9339-13FD07C3FD5B}"/>
+                <a16:creationId xmlns:a16="http://schemas.microsoft.com/office/drawing/2014/main" id="{A5A97EBF-040B-4B47-B7AE-78942B9162C5}"/>
               </a:ext>
             </a:extLst>
           </p:cNvPr>
@@ -15688,7 +15688,7 @@
           <p:cNvPr id="35" name="">
             <a:extLst xmlns:a="http://schemas.openxmlformats.org/drawingml/2006/main">
               <a:ext uri="{FF2B5EF4-FFF2-40B4-BE49-F238E27FC236}">
-                <a16:creationId xmlns:a16="http://schemas.microsoft.com/office/drawing/2014/main" id="{2A2F96BA-CB5F-409B-815A-D467377367C2}"/>
+                <a16:creationId xmlns:a16="http://schemas.microsoft.com/office/drawing/2014/main" id="{FE10C075-CC77-41AD-9C5F-406A2A595B35}"/>
               </a:ext>
             </a:extLst>
           </p:cNvPr>
@@ -15723,7 +15723,7 @@
           <p:cNvPr id="36" name="">
             <a:extLst xmlns:a="http://schemas.openxmlformats.org/drawingml/2006/main">
               <a:ext uri="{FF2B5EF4-FFF2-40B4-BE49-F238E27FC236}">
-                <a16:creationId xmlns:a16="http://schemas.microsoft.com/office/drawing/2014/main" id="{39323A3A-6FDE-4013-AADB-A898DC845738}"/>
+                <a16:creationId xmlns:a16="http://schemas.microsoft.com/office/drawing/2014/main" id="{978589DF-D7B1-4006-B34E-E827407C855B}"/>
               </a:ext>
             </a:extLst>
           </p:cNvPr>
@@ -15777,7 +15777,7 @@
           <p:cNvPr id="37" name="">
             <a:extLst xmlns:a="http://schemas.openxmlformats.org/drawingml/2006/main">
               <a:ext uri="{FF2B5EF4-FFF2-40B4-BE49-F238E27FC236}">
-                <a16:creationId xmlns:a16="http://schemas.microsoft.com/office/drawing/2014/main" id="{6B74E63E-E255-4CB0-A2C1-6D828D8F45F4}"/>
+                <a16:creationId xmlns:a16="http://schemas.microsoft.com/office/drawing/2014/main" id="{D977B69E-201D-47CA-93DB-A29448EDEB06}"/>
               </a:ext>
             </a:extLst>
           </p:cNvPr>
@@ -15835,7 +15835,7 @@
           <p:cNvPr id="38" name="">
             <a:extLst xmlns:a="http://schemas.openxmlformats.org/drawingml/2006/main">
               <a:ext uri="{FF2B5EF4-FFF2-40B4-BE49-F238E27FC236}">
-                <a16:creationId xmlns:a16="http://schemas.microsoft.com/office/drawing/2014/main" id="{6EF32FAE-E80C-4C4F-8002-E82C242E4041}"/>
+                <a16:creationId xmlns:a16="http://schemas.microsoft.com/office/drawing/2014/main" id="{F118572C-3FC4-4E32-AAB9-766621F33413}"/>
               </a:ext>
             </a:extLst>
           </p:cNvPr>
@@ -15893,7 +15893,7 @@
           <p:cNvPr id="39" name="">
             <a:extLst xmlns:a="http://schemas.openxmlformats.org/drawingml/2006/main">
               <a:ext uri="{FF2B5EF4-FFF2-40B4-BE49-F238E27FC236}">
-                <a16:creationId xmlns:a16="http://schemas.microsoft.com/office/drawing/2014/main" id="{6C4D1EC4-75F1-418D-9EAB-F88460CAF0BC}"/>
+                <a16:creationId xmlns:a16="http://schemas.microsoft.com/office/drawing/2014/main" id="{1E44855E-E5C7-41D4-B3CB-6F8791697ABA}"/>
               </a:ext>
             </a:extLst>
           </p:cNvPr>
@@ -15928,7 +15928,7 @@
           <p:cNvPr id="40" name="">
             <a:extLst xmlns:a="http://schemas.openxmlformats.org/drawingml/2006/main">
               <a:ext uri="{FF2B5EF4-FFF2-40B4-BE49-F238E27FC236}">
-                <a16:creationId xmlns:a16="http://schemas.microsoft.com/office/drawing/2014/main" id="{F0D2E7DC-CA1F-4D42-B8D9-7FDA4ACEB452}"/>
+                <a16:creationId xmlns:a16="http://schemas.microsoft.com/office/drawing/2014/main" id="{5081984D-48BB-4D50-8D18-7FD118EB6569}"/>
               </a:ext>
             </a:extLst>
           </p:cNvPr>
@@ -15963,7 +15963,7 @@
           <p:cNvPr id="41" name="">
             <a:extLst xmlns:a="http://schemas.openxmlformats.org/drawingml/2006/main">
               <a:ext uri="{FF2B5EF4-FFF2-40B4-BE49-F238E27FC236}">
-                <a16:creationId xmlns:a16="http://schemas.microsoft.com/office/drawing/2014/main" id="{A8F10F98-8389-4462-95EE-E859C8C19DEF}"/>
+                <a16:creationId xmlns:a16="http://schemas.microsoft.com/office/drawing/2014/main" id="{A63D93E0-FBBE-4108-916E-35114985C825}"/>
               </a:ext>
             </a:extLst>
           </p:cNvPr>
@@ -16017,7 +16017,7 @@
           <p:cNvPr id="42" name="">
             <a:extLst xmlns:a="http://schemas.openxmlformats.org/drawingml/2006/main">
               <a:ext uri="{FF2B5EF4-FFF2-40B4-BE49-F238E27FC236}">
-                <a16:creationId xmlns:a16="http://schemas.microsoft.com/office/drawing/2014/main" id="{8A49CCD2-784F-4DBB-928D-A222249D184C}"/>
+                <a16:creationId xmlns:a16="http://schemas.microsoft.com/office/drawing/2014/main" id="{CC65BB16-78FD-4687-8E5D-D902E144FCA1}"/>
               </a:ext>
             </a:extLst>
           </p:cNvPr>
@@ -16075,7 +16075,7 @@
           <p:cNvPr id="43" name="">
             <a:extLst xmlns:a="http://schemas.openxmlformats.org/drawingml/2006/main">
               <a:ext uri="{FF2B5EF4-FFF2-40B4-BE49-F238E27FC236}">
-                <a16:creationId xmlns:a16="http://schemas.microsoft.com/office/drawing/2014/main" id="{CD8B06D4-E75C-484E-B855-FE16F947C26B}"/>
+                <a16:creationId xmlns:a16="http://schemas.microsoft.com/office/drawing/2014/main" id="{BC697E51-820E-44BA-9AB3-9544AB00E718}"/>
               </a:ext>
             </a:extLst>
           </p:cNvPr>
@@ -16133,7 +16133,7 @@
           <p:cNvPr id="44" name="">
             <a:extLst xmlns:a="http://schemas.openxmlformats.org/drawingml/2006/main">
               <a:ext uri="{FF2B5EF4-FFF2-40B4-BE49-F238E27FC236}">
-                <a16:creationId xmlns:a16="http://schemas.microsoft.com/office/drawing/2014/main" id="{D4AEBA5C-386E-428E-9C58-3170D27BE2FA}"/>
+                <a16:creationId xmlns:a16="http://schemas.microsoft.com/office/drawing/2014/main" id="{FC6876BD-DA9C-4606-9D39-E633CF2CF251}"/>
               </a:ext>
             </a:extLst>
           </p:cNvPr>
@@ -16168,7 +16168,7 @@
           <p:cNvPr id="45" name="">
             <a:extLst xmlns:a="http://schemas.openxmlformats.org/drawingml/2006/main">
               <a:ext uri="{FF2B5EF4-FFF2-40B4-BE49-F238E27FC236}">
-                <a16:creationId xmlns:a16="http://schemas.microsoft.com/office/drawing/2014/main" id="{A059F9F3-54DD-4532-B732-F00C2AD66F79}"/>
+                <a16:creationId xmlns:a16="http://schemas.microsoft.com/office/drawing/2014/main" id="{4DB284B9-BA32-46AA-8BD2-7E37124BE622}"/>
               </a:ext>
             </a:extLst>
           </p:cNvPr>
@@ -16203,7 +16203,7 @@
           <p:cNvPr id="46" name="">
             <a:extLst xmlns:a="http://schemas.openxmlformats.org/drawingml/2006/main">
               <a:ext uri="{FF2B5EF4-FFF2-40B4-BE49-F238E27FC236}">
-                <a16:creationId xmlns:a16="http://schemas.microsoft.com/office/drawing/2014/main" id="{FA9E4222-967C-4436-9ACD-CFC2C69B2116}"/>
+                <a16:creationId xmlns:a16="http://schemas.microsoft.com/office/drawing/2014/main" id="{1C46C24F-E6DC-4D44-96B0-FF4E26B4E991}"/>
               </a:ext>
             </a:extLst>
           </p:cNvPr>
@@ -16257,7 +16257,7 @@
           <p:cNvPr id="47" name="">
             <a:extLst xmlns:a="http://schemas.openxmlformats.org/drawingml/2006/main">
               <a:ext uri="{FF2B5EF4-FFF2-40B4-BE49-F238E27FC236}">
-                <a16:creationId xmlns:a16="http://schemas.microsoft.com/office/drawing/2014/main" id="{2FB41341-0C97-4982-B076-11A0799C98F3}"/>
+                <a16:creationId xmlns:a16="http://schemas.microsoft.com/office/drawing/2014/main" id="{AE4AD6D5-CA02-4E18-9C30-251B15C03726}"/>
               </a:ext>
             </a:extLst>
           </p:cNvPr>
@@ -16315,7 +16315,7 @@
           <p:cNvPr id="48" name="">
             <a:extLst xmlns:a="http://schemas.openxmlformats.org/drawingml/2006/main">
               <a:ext uri="{FF2B5EF4-FFF2-40B4-BE49-F238E27FC236}">
-                <a16:creationId xmlns:a16="http://schemas.microsoft.com/office/drawing/2014/main" id="{21291009-4293-4BB0-9CAB-12B7B3859CFB}"/>
+                <a16:creationId xmlns:a16="http://schemas.microsoft.com/office/drawing/2014/main" id="{4DE25325-CD49-4EA2-A80F-A7236A5F3B2E}"/>
               </a:ext>
             </a:extLst>
           </p:cNvPr>
@@ -16373,7 +16373,7 @@
           <p:cNvPr id="49" name="">
             <a:extLst xmlns:a="http://schemas.openxmlformats.org/drawingml/2006/main">
               <a:ext uri="{FF2B5EF4-FFF2-40B4-BE49-F238E27FC236}">
-                <a16:creationId xmlns:a16="http://schemas.microsoft.com/office/drawing/2014/main" id="{77DC9F20-319E-467D-A701-3715410362C3}"/>
+                <a16:creationId xmlns:a16="http://schemas.microsoft.com/office/drawing/2014/main" id="{666D59E1-9ACC-485C-B326-1AC27D86344E}"/>
               </a:ext>
             </a:extLst>
           </p:cNvPr>
@@ -16408,7 +16408,7 @@
           <p:cNvPr id="50" name="">
             <a:extLst xmlns:a="http://schemas.openxmlformats.org/drawingml/2006/main">
               <a:ext uri="{FF2B5EF4-FFF2-40B4-BE49-F238E27FC236}">
-                <a16:creationId xmlns:a16="http://schemas.microsoft.com/office/drawing/2014/main" id="{5850A301-5DFC-4154-BF1D-A8EFC83948D4}"/>
+                <a16:creationId xmlns:a16="http://schemas.microsoft.com/office/drawing/2014/main" id="{BE1C07BC-5D33-41EC-A484-C89647366BF9}"/>
               </a:ext>
             </a:extLst>
           </p:cNvPr>
@@ -16443,7 +16443,7 @@
           <p:cNvPr id="51" name="">
             <a:extLst xmlns:a="http://schemas.openxmlformats.org/drawingml/2006/main">
               <a:ext uri="{FF2B5EF4-FFF2-40B4-BE49-F238E27FC236}">
-                <a16:creationId xmlns:a16="http://schemas.microsoft.com/office/drawing/2014/main" id="{D698420A-7D20-494D-A9D5-1AB179E9F82B}"/>
+                <a16:creationId xmlns:a16="http://schemas.microsoft.com/office/drawing/2014/main" id="{367E2A4E-C9E3-4CB5-B468-1BC0B69973A5}"/>
               </a:ext>
             </a:extLst>
           </p:cNvPr>
@@ -16497,7 +16497,7 @@
           <p:cNvPr id="52" name="">
             <a:extLst xmlns:a="http://schemas.openxmlformats.org/drawingml/2006/main">
               <a:ext uri="{FF2B5EF4-FFF2-40B4-BE49-F238E27FC236}">
-                <a16:creationId xmlns:a16="http://schemas.microsoft.com/office/drawing/2014/main" id="{314E4C9B-755B-445A-949D-98201CBE5BDB}"/>
+                <a16:creationId xmlns:a16="http://schemas.microsoft.com/office/drawing/2014/main" id="{D8000B4C-2689-4EA5-B15A-75D93A78147C}"/>
               </a:ext>
             </a:extLst>
           </p:cNvPr>
@@ -16555,7 +16555,7 @@
           <p:cNvPr id="53" name="">
             <a:extLst xmlns:a="http://schemas.openxmlformats.org/drawingml/2006/main">
               <a:ext uri="{FF2B5EF4-FFF2-40B4-BE49-F238E27FC236}">
-                <a16:creationId xmlns:a16="http://schemas.microsoft.com/office/drawing/2014/main" id="{04A6D925-BD6A-4ECF-97FD-068ED51CF83E}"/>
+                <a16:creationId xmlns:a16="http://schemas.microsoft.com/office/drawing/2014/main" id="{0A3AF0DE-2E7D-4AC1-A1C3-B0B3BA659ACA}"/>
               </a:ext>
             </a:extLst>
           </p:cNvPr>
@@ -16613,7 +16613,7 @@
           <p:cNvPr id="54" name="">
             <a:extLst xmlns:a="http://schemas.openxmlformats.org/drawingml/2006/main">
               <a:ext uri="{FF2B5EF4-FFF2-40B4-BE49-F238E27FC236}">
-                <a16:creationId xmlns:a16="http://schemas.microsoft.com/office/drawing/2014/main" id="{2C87A010-9EC3-41B2-B9EC-9A399BBAE162}"/>
+                <a16:creationId xmlns:a16="http://schemas.microsoft.com/office/drawing/2014/main" id="{05C3BDF2-5CB2-409C-BBDE-D9A92E3BBADE}"/>
               </a:ext>
             </a:extLst>
           </p:cNvPr>
@@ -16648,7 +16648,7 @@
           <p:cNvPr id="55" name="">
             <a:extLst xmlns:a="http://schemas.openxmlformats.org/drawingml/2006/main">
               <a:ext uri="{FF2B5EF4-FFF2-40B4-BE49-F238E27FC236}">
-                <a16:creationId xmlns:a16="http://schemas.microsoft.com/office/drawing/2014/main" id="{ADF1849F-7EC3-447B-B6D8-137F7FFE0B40}"/>
+                <a16:creationId xmlns:a16="http://schemas.microsoft.com/office/drawing/2014/main" id="{64D262AA-E6F0-4018-B2FA-245244B106A7}"/>
               </a:ext>
             </a:extLst>
           </p:cNvPr>
@@ -16683,7 +16683,7 @@
           <p:cNvPr id="56" name="">
             <a:extLst xmlns:a="http://schemas.openxmlformats.org/drawingml/2006/main">
               <a:ext uri="{FF2B5EF4-FFF2-40B4-BE49-F238E27FC236}">
-                <a16:creationId xmlns:a16="http://schemas.microsoft.com/office/drawing/2014/main" id="{388F35AE-5912-4916-8146-A2C29F9539B6}"/>
+                <a16:creationId xmlns:a16="http://schemas.microsoft.com/office/drawing/2014/main" id="{F492311A-A9B0-4C6D-A4B2-6318BFE8EA81}"/>
               </a:ext>
             </a:extLst>
           </p:cNvPr>
@@ -16737,7 +16737,7 @@
           <p:cNvPr id="57" name="">
             <a:extLst xmlns:a="http://schemas.openxmlformats.org/drawingml/2006/main">
               <a:ext uri="{FF2B5EF4-FFF2-40B4-BE49-F238E27FC236}">
-                <a16:creationId xmlns:a16="http://schemas.microsoft.com/office/drawing/2014/main" id="{24B83E07-2B1B-4747-A5C2-E0E321E27E26}"/>
+                <a16:creationId xmlns:a16="http://schemas.microsoft.com/office/drawing/2014/main" id="{009A82CD-E6C9-4B89-A83B-1DB3F49B0F3D}"/>
               </a:ext>
             </a:extLst>
           </p:cNvPr>
@@ -16795,7 +16795,7 @@
           <p:cNvPr id="58" name="">
             <a:extLst xmlns:a="http://schemas.openxmlformats.org/drawingml/2006/main">
               <a:ext uri="{FF2B5EF4-FFF2-40B4-BE49-F238E27FC236}">
-                <a16:creationId xmlns:a16="http://schemas.microsoft.com/office/drawing/2014/main" id="{6BD549E6-42B7-4C62-BCCF-6975A33D302E}"/>
+                <a16:creationId xmlns:a16="http://schemas.microsoft.com/office/drawing/2014/main" id="{97D60F9E-BE36-444E-B7DF-742222E95A3C}"/>
               </a:ext>
             </a:extLst>
           </p:cNvPr>
@@ -16853,7 +16853,7 @@
           <p:cNvPr id="59" name="">
             <a:extLst xmlns:a="http://schemas.openxmlformats.org/drawingml/2006/main">
               <a:ext uri="{FF2B5EF4-FFF2-40B4-BE49-F238E27FC236}">
-                <a16:creationId xmlns:a16="http://schemas.microsoft.com/office/drawing/2014/main" id="{A6BE04CD-A395-4EB4-AED1-6767F532A174}"/>
+                <a16:creationId xmlns:a16="http://schemas.microsoft.com/office/drawing/2014/main" id="{7EE4BA6A-B072-45ED-B0CB-BB8572DF1B46}"/>
               </a:ext>
             </a:extLst>
           </p:cNvPr>
@@ -16888,7 +16888,7 @@
           <p:cNvPr id="60" name="">
             <a:extLst xmlns:a="http://schemas.openxmlformats.org/drawingml/2006/main">
               <a:ext uri="{FF2B5EF4-FFF2-40B4-BE49-F238E27FC236}">
-                <a16:creationId xmlns:a16="http://schemas.microsoft.com/office/drawing/2014/main" id="{3043DAC4-D41F-4860-A920-5A6468EC2752}"/>
+                <a16:creationId xmlns:a16="http://schemas.microsoft.com/office/drawing/2014/main" id="{6DF4F8E3-2127-4E4A-8B33-8B721DDBBC19}"/>
               </a:ext>
             </a:extLst>
           </p:cNvPr>
@@ -16923,7 +16923,7 @@
           <p:cNvPr id="61" name="">
             <a:extLst xmlns:a="http://schemas.openxmlformats.org/drawingml/2006/main">
               <a:ext uri="{FF2B5EF4-FFF2-40B4-BE49-F238E27FC236}">
-                <a16:creationId xmlns:a16="http://schemas.microsoft.com/office/drawing/2014/main" id="{B114F453-1242-4CD7-B6AB-F0F708053757}"/>
+                <a16:creationId xmlns:a16="http://schemas.microsoft.com/office/drawing/2014/main" id="{FBD6A8EB-5A07-4E2E-84B1-CAED25F2C854}"/>
               </a:ext>
             </a:extLst>
           </p:cNvPr>
@@ -16958,7 +16958,7 @@
           <p:cNvPr id="62" name="">
             <a:extLst xmlns:a="http://schemas.openxmlformats.org/drawingml/2006/main">
               <a:ext uri="{FF2B5EF4-FFF2-40B4-BE49-F238E27FC236}">
-                <a16:creationId xmlns:a16="http://schemas.microsoft.com/office/drawing/2014/main" id="{AAF40435-E445-49C0-A3A6-9383C83A2475}"/>
+                <a16:creationId xmlns:a16="http://schemas.microsoft.com/office/drawing/2014/main" id="{C289921E-3F3B-487F-A37F-1DC4F4227352}"/>
               </a:ext>
             </a:extLst>
           </p:cNvPr>
@@ -16993,7 +16993,7 @@
           <p:cNvPr id="63" name="">
             <a:extLst xmlns:a="http://schemas.openxmlformats.org/drawingml/2006/main">
               <a:ext uri="{FF2B5EF4-FFF2-40B4-BE49-F238E27FC236}">
-                <a16:creationId xmlns:a16="http://schemas.microsoft.com/office/drawing/2014/main" id="{3AD22275-6D2B-40CE-A383-80315E54ACE9}"/>
+                <a16:creationId xmlns:a16="http://schemas.microsoft.com/office/drawing/2014/main" id="{B5F0A8B7-7D64-4F21-8195-442BBC70114C}"/>
               </a:ext>
             </a:extLst>
           </p:cNvPr>
@@ -17028,7 +17028,7 @@
           <p:cNvPr id="64" name="">
             <a:extLst xmlns:a="http://schemas.openxmlformats.org/drawingml/2006/main">
               <a:ext uri="{FF2B5EF4-FFF2-40B4-BE49-F238E27FC236}">
-                <a16:creationId xmlns:a16="http://schemas.microsoft.com/office/drawing/2014/main" id="{CA4DA60A-EE20-4092-9117-7106A4D9104E}"/>
+                <a16:creationId xmlns:a16="http://schemas.microsoft.com/office/drawing/2014/main" id="{5469886D-9A5D-4E2F-90D3-209BDC87FAD7}"/>
               </a:ext>
             </a:extLst>
           </p:cNvPr>
@@ -17063,7 +17063,7 @@
           <p:cNvPr id="65" name="">
             <a:extLst xmlns:a="http://schemas.openxmlformats.org/drawingml/2006/main">
               <a:ext uri="{FF2B5EF4-FFF2-40B4-BE49-F238E27FC236}">
-                <a16:creationId xmlns:a16="http://schemas.microsoft.com/office/drawing/2014/main" id="{1212DC02-437E-4352-8E87-B978D8281138}"/>
+                <a16:creationId xmlns:a16="http://schemas.microsoft.com/office/drawing/2014/main" id="{5433F1B9-25A3-4681-8F84-1DDC0B131EC1}"/>
               </a:ext>
             </a:extLst>
           </p:cNvPr>
@@ -17098,7 +17098,7 @@
           <p:cNvPr id="66" name="">
             <a:extLst xmlns:a="http://schemas.openxmlformats.org/drawingml/2006/main">
               <a:ext uri="{FF2B5EF4-FFF2-40B4-BE49-F238E27FC236}">
-                <a16:creationId xmlns:a16="http://schemas.microsoft.com/office/drawing/2014/main" id="{7765F66E-5AB3-4CF6-BA1A-182814942076}"/>
+                <a16:creationId xmlns:a16="http://schemas.microsoft.com/office/drawing/2014/main" id="{AB60C332-3BA6-4620-B57D-34DF2E047617}"/>
               </a:ext>
             </a:extLst>
           </p:cNvPr>
@@ -17133,7 +17133,7 @@
           <p:cNvPr id="67" name="">
             <a:extLst xmlns:a="http://schemas.openxmlformats.org/drawingml/2006/main">
               <a:ext uri="{FF2B5EF4-FFF2-40B4-BE49-F238E27FC236}">
-                <a16:creationId xmlns:a16="http://schemas.microsoft.com/office/drawing/2014/main" id="{65E0B8D6-7FC9-440F-9E24-6CC6A1D8604B}"/>
+                <a16:creationId xmlns:a16="http://schemas.microsoft.com/office/drawing/2014/main" id="{58D5172B-9B6F-404E-8473-B3B08AB0E528}"/>
               </a:ext>
             </a:extLst>
           </p:cNvPr>
@@ -17187,7 +17187,7 @@
           <p:cNvPr id="68" name="">
             <a:extLst xmlns:a="http://schemas.openxmlformats.org/drawingml/2006/main">
               <a:ext uri="{FF2B5EF4-FFF2-40B4-BE49-F238E27FC236}">
-                <a16:creationId xmlns:a16="http://schemas.microsoft.com/office/drawing/2014/main" id="{E3DBBE9B-50E8-430E-A12E-D46046E77169}"/>
+                <a16:creationId xmlns:a16="http://schemas.microsoft.com/office/drawing/2014/main" id="{BEA39ACB-1A37-4E19-AA62-9443009FBFA6}"/>
               </a:ext>
             </a:extLst>
           </p:cNvPr>
@@ -17241,7 +17241,7 @@
           <p:cNvPr id="69" name="">
             <a:extLst xmlns:a="http://schemas.openxmlformats.org/drawingml/2006/main">
               <a:ext uri="{FF2B5EF4-FFF2-40B4-BE49-F238E27FC236}">
-                <a16:creationId xmlns:a16="http://schemas.microsoft.com/office/drawing/2014/main" id="{A55EBB1C-05E7-4C40-B7F9-147DBB9FA9B5}"/>
+                <a16:creationId xmlns:a16="http://schemas.microsoft.com/office/drawing/2014/main" id="{63283397-4C07-4A63-90FF-B593B531ED5B}"/>
               </a:ext>
             </a:extLst>
           </p:cNvPr>
@@ -17295,7 +17295,7 @@
           <p:cNvPr id="70" name="">
             <a:extLst xmlns:a="http://schemas.openxmlformats.org/drawingml/2006/main">
               <a:ext uri="{FF2B5EF4-FFF2-40B4-BE49-F238E27FC236}">
-                <a16:creationId xmlns:a16="http://schemas.microsoft.com/office/drawing/2014/main" id="{6E787CA5-012E-4836-BB80-1F6496515F3B}"/>
+                <a16:creationId xmlns:a16="http://schemas.microsoft.com/office/drawing/2014/main" id="{F0967354-21D5-4424-8689-435150DC7FAB}"/>
               </a:ext>
             </a:extLst>
           </p:cNvPr>
@@ -17332,7 +17332,7 @@
           <p:cNvPr id="71" name="">
             <a:extLst xmlns:a="http://schemas.openxmlformats.org/drawingml/2006/main">
               <a:ext uri="{FF2B5EF4-FFF2-40B4-BE49-F238E27FC236}">
-                <a16:creationId xmlns:a16="http://schemas.microsoft.com/office/drawing/2014/main" id="{4740F9C1-1412-42A9-A253-A73C4FF189B1}"/>
+                <a16:creationId xmlns:a16="http://schemas.microsoft.com/office/drawing/2014/main" id="{054785D3-32F8-42A3-A3C3-859705188FE4}"/>
               </a:ext>
             </a:extLst>
           </p:cNvPr>
@@ -17367,7 +17367,7 @@
           <p:cNvPr id="72" name="">
             <a:extLst xmlns:a="http://schemas.openxmlformats.org/drawingml/2006/main">
               <a:ext uri="{FF2B5EF4-FFF2-40B4-BE49-F238E27FC236}">
-                <a16:creationId xmlns:a16="http://schemas.microsoft.com/office/drawing/2014/main" id="{8F625846-7CEA-4B38-AD14-790917D88193}"/>
+                <a16:creationId xmlns:a16="http://schemas.microsoft.com/office/drawing/2014/main" id="{222B734B-39F4-4339-8DA9-789CF6C32028}"/>
               </a:ext>
             </a:extLst>
           </p:cNvPr>
@@ -17425,7 +17425,7 @@
           <p:cNvPr id="73" name="">
             <a:extLst xmlns:a="http://schemas.openxmlformats.org/drawingml/2006/main">
               <a:ext uri="{FF2B5EF4-FFF2-40B4-BE49-F238E27FC236}">
-                <a16:creationId xmlns:a16="http://schemas.microsoft.com/office/drawing/2014/main" id="{34D5919E-297F-46E8-8D38-4B3B8FD694D5}"/>
+                <a16:creationId xmlns:a16="http://schemas.microsoft.com/office/drawing/2014/main" id="{CD551C1D-D9F3-4847-B74E-77DD4EA77061}"/>
               </a:ext>
             </a:extLst>
           </p:cNvPr>
@@ -17481,7 +17481,7 @@
     </p:spTree>
     <p:extLst>
       <p:ext uri="{BB962C8B-B14F-4D97-AF65-F5344CB8AC3E}">
-        <p14:creationId xmlns:p14="http://schemas.microsoft.com/office/powerpoint/2010/main" val="1685945174"/>
+        <p14:creationId xmlns:p14="http://schemas.microsoft.com/office/powerpoint/2010/main" val="311376420"/>
       </p:ext>
     </p:extLst>
   </p:cSld>
@@ -17512,7 +17512,7 @@
           <p:cNvPr id="1" name="Slide Number Placeholder 5">
             <a:extLst xmlns:a="http://schemas.openxmlformats.org/drawingml/2006/main">
               <a:ext uri="{FF2B5EF4-FFF2-40B4-BE49-F238E27FC236}">
-                <a16:creationId xmlns:a16="http://schemas.microsoft.com/office/drawing/2014/main" id="{821508BF-91E3-4E78-84B3-DCBD229C8660}"/>
+                <a16:creationId xmlns:a16="http://schemas.microsoft.com/office/drawing/2014/main" id="{11DAD1DA-DD27-4C25-AFB7-E057ACC56EC0}"/>
               </a:ext>
             </a:extLst>
           </p:cNvPr>
@@ -17548,7 +17548,7 @@
           <p:nvPr/>
         </p:nvPicPr>
         <p:blipFill>
-          <a:blip xmlns:r="http://schemas.openxmlformats.org/officeDocument/2006/relationships" xmlns:a="http://schemas.openxmlformats.org/drawingml/2006/main" r:embed="R1846e2eaf49c4c4e"/>
+          <a:blip xmlns:r="http://schemas.openxmlformats.org/officeDocument/2006/relationships" xmlns:a="http://schemas.openxmlformats.org/drawingml/2006/main" r:embed="R329e59ab59594c65"/>
           <a:srcRect xmlns:a="http://schemas.openxmlformats.org/drawingml/2006/main" l="0" t="21875" r="0" b="21875"/>
           <a:stretch xmlns:a="http://schemas.openxmlformats.org/drawingml/2006/main">
             <a:fillRect l="0" t="0" r="0" b="0"/>
@@ -17569,7 +17569,7 @@
           <p:cNvPr id="3" name="">
             <a:extLst xmlns:a="http://schemas.openxmlformats.org/drawingml/2006/main">
               <a:ext uri="{FF2B5EF4-FFF2-40B4-BE49-F238E27FC236}">
-                <a16:creationId xmlns:a16="http://schemas.microsoft.com/office/drawing/2014/main" id="{8E8B2F91-0A97-41F5-805F-BF2501023068}"/>
+                <a16:creationId xmlns:a16="http://schemas.microsoft.com/office/drawing/2014/main" id="{38DFB42F-9CA0-4646-AC82-86FC81F224D4}"/>
               </a:ext>
             </a:extLst>
           </p:cNvPr>
@@ -17604,7 +17604,7 @@
           <p:cNvPr id="4" name="">
             <a:extLst xmlns:a="http://schemas.openxmlformats.org/drawingml/2006/main">
               <a:ext uri="{FF2B5EF4-FFF2-40B4-BE49-F238E27FC236}">
-                <a16:creationId xmlns:a16="http://schemas.microsoft.com/office/drawing/2014/main" id="{ADB7D0D6-CFAB-4996-B9C3-07A7F611D0BB}"/>
+                <a16:creationId xmlns:a16="http://schemas.microsoft.com/office/drawing/2014/main" id="{80485A3C-5F47-4265-8A9D-03FF4DF53974}"/>
               </a:ext>
             </a:extLst>
           </p:cNvPr>
@@ -17639,7 +17639,7 @@
           <p:cNvPr id="5" name="">
             <a:extLst xmlns:a="http://schemas.openxmlformats.org/drawingml/2006/main">
               <a:ext uri="{FF2B5EF4-FFF2-40B4-BE49-F238E27FC236}">
-                <a16:creationId xmlns:a16="http://schemas.microsoft.com/office/drawing/2014/main" id="{7BC7978E-E9FD-4F23-B812-39E037998672}"/>
+                <a16:creationId xmlns:a16="http://schemas.microsoft.com/office/drawing/2014/main" id="{4AB7A3CC-19C9-4EC9-9EEA-FE236C631218}"/>
               </a:ext>
             </a:extLst>
           </p:cNvPr>
@@ -17676,7 +17676,7 @@
           <p:cNvPr id="6" name="">
             <a:extLst xmlns:a="http://schemas.openxmlformats.org/drawingml/2006/main">
               <a:ext uri="{FF2B5EF4-FFF2-40B4-BE49-F238E27FC236}">
-                <a16:creationId xmlns:a16="http://schemas.microsoft.com/office/drawing/2014/main" id="{60AF29AB-F9A9-4E3D-9125-F635779A4BF0}"/>
+                <a16:creationId xmlns:a16="http://schemas.microsoft.com/office/drawing/2014/main" id="{03C3AE54-34BA-4094-9624-A620DCDC14A2}"/>
               </a:ext>
             </a:extLst>
           </p:cNvPr>
@@ -17713,7 +17713,7 @@
           <p:cNvPr id="7" name="">
             <a:extLst xmlns:a="http://schemas.openxmlformats.org/drawingml/2006/main">
               <a:ext uri="{FF2B5EF4-FFF2-40B4-BE49-F238E27FC236}">
-                <a16:creationId xmlns:a16="http://schemas.microsoft.com/office/drawing/2014/main" id="{547DD3CA-450B-400D-9574-C07965E29768}"/>
+                <a16:creationId xmlns:a16="http://schemas.microsoft.com/office/drawing/2014/main" id="{8109BB89-D6CE-4135-9B6D-E9D029AA9397}"/>
               </a:ext>
             </a:extLst>
           </p:cNvPr>
@@ -17750,7 +17750,7 @@
           <p:cNvPr id="8" name="">
             <a:extLst xmlns:a="http://schemas.openxmlformats.org/drawingml/2006/main">
               <a:ext uri="{FF2B5EF4-FFF2-40B4-BE49-F238E27FC236}">
-                <a16:creationId xmlns:a16="http://schemas.microsoft.com/office/drawing/2014/main" id="{D8B18764-EE6D-42B4-800A-370A2E5B9DD4}"/>
+                <a16:creationId xmlns:a16="http://schemas.microsoft.com/office/drawing/2014/main" id="{6C5261E8-A128-4735-9481-E4F023D4CAAF}"/>
               </a:ext>
             </a:extLst>
           </p:cNvPr>
@@ -17787,7 +17787,7 @@
           <p:cNvPr id="9" name="">
             <a:extLst xmlns:a="http://schemas.openxmlformats.org/drawingml/2006/main">
               <a:ext uri="{FF2B5EF4-FFF2-40B4-BE49-F238E27FC236}">
-                <a16:creationId xmlns:a16="http://schemas.microsoft.com/office/drawing/2014/main" id="{EA6CF537-0232-4E2E-BEAC-587F276201D9}"/>
+                <a16:creationId xmlns:a16="http://schemas.microsoft.com/office/drawing/2014/main" id="{6A0875DD-A20A-4A42-9B3A-918D0B3F9190}"/>
               </a:ext>
             </a:extLst>
           </p:cNvPr>
@@ -17845,7 +17845,7 @@
           <p:cNvPr id="10" name="">
             <a:extLst xmlns:a="http://schemas.openxmlformats.org/drawingml/2006/main">
               <a:ext uri="{FF2B5EF4-FFF2-40B4-BE49-F238E27FC236}">
-                <a16:creationId xmlns:a16="http://schemas.microsoft.com/office/drawing/2014/main" id="{7D641C38-48A6-4AF8-A619-89CD14E42E53}"/>
+                <a16:creationId xmlns:a16="http://schemas.microsoft.com/office/drawing/2014/main" id="{AE7912AA-9BD9-4C74-A3F2-56CB641D3557}"/>
               </a:ext>
             </a:extLst>
           </p:cNvPr>
@@ -17903,7 +17903,7 @@
           <p:cNvPr id="11" name="">
             <a:extLst xmlns:a="http://schemas.openxmlformats.org/drawingml/2006/main">
               <a:ext uri="{FF2B5EF4-FFF2-40B4-BE49-F238E27FC236}">
-                <a16:creationId xmlns:a16="http://schemas.microsoft.com/office/drawing/2014/main" id="{7426FD63-CD0E-4039-AAF9-34280F67D50B}"/>
+                <a16:creationId xmlns:a16="http://schemas.microsoft.com/office/drawing/2014/main" id="{C2DC1DEA-2C4D-4ED3-B401-32FBC6722DDC}"/>
               </a:ext>
             </a:extLst>
           </p:cNvPr>
@@ -17938,7 +17938,7 @@
           <p:cNvPr id="12" name="">
             <a:extLst xmlns:a="http://schemas.openxmlformats.org/drawingml/2006/main">
               <a:ext uri="{FF2B5EF4-FFF2-40B4-BE49-F238E27FC236}">
-                <a16:creationId xmlns:a16="http://schemas.microsoft.com/office/drawing/2014/main" id="{BB03BA19-F47B-46FD-A3A3-5FEACF84B068}"/>
+                <a16:creationId xmlns:a16="http://schemas.microsoft.com/office/drawing/2014/main" id="{B1319827-9EA7-4E32-9508-E2799F65497A}"/>
               </a:ext>
             </a:extLst>
           </p:cNvPr>
@@ -17971,7 +17971,7 @@
           <p:cNvPr id="13" name="">
             <a:extLst xmlns:a="http://schemas.openxmlformats.org/drawingml/2006/main">
               <a:ext uri="{FF2B5EF4-FFF2-40B4-BE49-F238E27FC236}">
-                <a16:creationId xmlns:a16="http://schemas.microsoft.com/office/drawing/2014/main" id="{18EE5782-F268-45A9-9970-33A68B7B7D5F}"/>
+                <a16:creationId xmlns:a16="http://schemas.microsoft.com/office/drawing/2014/main" id="{3A89235A-AF9A-4C4A-9DEB-C9CE87DE3030}"/>
               </a:ext>
             </a:extLst>
           </p:cNvPr>
@@ -18029,7 +18029,7 @@
           <p:cNvPr id="14" name="">
             <a:extLst xmlns:a="http://schemas.openxmlformats.org/drawingml/2006/main">
               <a:ext uri="{FF2B5EF4-FFF2-40B4-BE49-F238E27FC236}">
-                <a16:creationId xmlns:a16="http://schemas.microsoft.com/office/drawing/2014/main" id="{7F4B6C0E-8DAB-47AD-BF06-8CB515C7EFBA}"/>
+                <a16:creationId xmlns:a16="http://schemas.microsoft.com/office/drawing/2014/main" id="{C03245BC-4239-4344-9094-00CB5D0BA954}"/>
               </a:ext>
             </a:extLst>
           </p:cNvPr>
@@ -18066,7 +18066,7 @@
           <p:cNvPr id="15" name="">
             <a:extLst xmlns:a="http://schemas.openxmlformats.org/drawingml/2006/main">
               <a:ext uri="{FF2B5EF4-FFF2-40B4-BE49-F238E27FC236}">
-                <a16:creationId xmlns:a16="http://schemas.microsoft.com/office/drawing/2014/main" id="{43B6F928-F8CC-455C-9BFE-69F51A913508}"/>
+                <a16:creationId xmlns:a16="http://schemas.microsoft.com/office/drawing/2014/main" id="{FB994BC7-7190-49F7-9C5E-E79EB9CDCD6F}"/>
               </a:ext>
             </a:extLst>
           </p:cNvPr>
@@ -18101,7 +18101,7 @@
           <p:cNvPr id="16" name="">
             <a:extLst xmlns:a="http://schemas.openxmlformats.org/drawingml/2006/main">
               <a:ext uri="{FF2B5EF4-FFF2-40B4-BE49-F238E27FC236}">
-                <a16:creationId xmlns:a16="http://schemas.microsoft.com/office/drawing/2014/main" id="{FA2088E7-4A37-4032-8673-2CF84EC59295}"/>
+                <a16:creationId xmlns:a16="http://schemas.microsoft.com/office/drawing/2014/main" id="{793632C9-DA3F-49C2-888A-620AC9DB7A8E}"/>
               </a:ext>
             </a:extLst>
           </p:cNvPr>
@@ -18159,7 +18159,7 @@
           <p:cNvPr id="17" name="">
             <a:extLst xmlns:a="http://schemas.openxmlformats.org/drawingml/2006/main">
               <a:ext uri="{FF2B5EF4-FFF2-40B4-BE49-F238E27FC236}">
-                <a16:creationId xmlns:a16="http://schemas.microsoft.com/office/drawing/2014/main" id="{5B7CBC81-DE08-4660-921D-1534A4F73745}"/>
+                <a16:creationId xmlns:a16="http://schemas.microsoft.com/office/drawing/2014/main" id="{E8ABEAED-F93A-495A-BEDD-8689C3267E40}"/>
               </a:ext>
             </a:extLst>
           </p:cNvPr>
@@ -18285,7 +18285,7 @@
           <p:cNvPr id="18" name="">
             <a:extLst xmlns:a="http://schemas.openxmlformats.org/drawingml/2006/main">
               <a:ext uri="{FF2B5EF4-FFF2-40B4-BE49-F238E27FC236}">
-                <a16:creationId xmlns:a16="http://schemas.microsoft.com/office/drawing/2014/main" id="{5B69BED1-45BE-4A1F-A5FC-FAEF26D55C4B}"/>
+                <a16:creationId xmlns:a16="http://schemas.microsoft.com/office/drawing/2014/main" id="{326BA598-6F5A-418C-B9F4-AF8888976775}"/>
               </a:ext>
             </a:extLst>
           </p:cNvPr>
@@ -18322,7 +18322,7 @@
           <p:cNvPr id="19" name="">
             <a:extLst xmlns:a="http://schemas.openxmlformats.org/drawingml/2006/main">
               <a:ext uri="{FF2B5EF4-FFF2-40B4-BE49-F238E27FC236}">
-                <a16:creationId xmlns:a16="http://schemas.microsoft.com/office/drawing/2014/main" id="{A3115452-4459-444F-A20B-416D293C192B}"/>
+                <a16:creationId xmlns:a16="http://schemas.microsoft.com/office/drawing/2014/main" id="{5F36BAFD-148A-410B-B2CF-F22502874373}"/>
               </a:ext>
             </a:extLst>
           </p:cNvPr>
@@ -18357,7 +18357,7 @@
           <p:cNvPr id="20" name="">
             <a:extLst xmlns:a="http://schemas.openxmlformats.org/drawingml/2006/main">
               <a:ext uri="{FF2B5EF4-FFF2-40B4-BE49-F238E27FC236}">
-                <a16:creationId xmlns:a16="http://schemas.microsoft.com/office/drawing/2014/main" id="{07C3DBE1-A5DF-4CAD-AB22-D4DF622057E8}"/>
+                <a16:creationId xmlns:a16="http://schemas.microsoft.com/office/drawing/2014/main" id="{381532CF-9238-44E3-A972-75AEBAEB256D}"/>
               </a:ext>
             </a:extLst>
           </p:cNvPr>
@@ -18415,7 +18415,7 @@
           <p:cNvPr id="21" name="">
             <a:extLst xmlns:a="http://schemas.openxmlformats.org/drawingml/2006/main">
               <a:ext uri="{FF2B5EF4-FFF2-40B4-BE49-F238E27FC236}">
-                <a16:creationId xmlns:a16="http://schemas.microsoft.com/office/drawing/2014/main" id="{2712609C-DC14-41E6-8F1E-26CCC800DE51}"/>
+                <a16:creationId xmlns:a16="http://schemas.microsoft.com/office/drawing/2014/main" id="{A61D2A84-09A7-49A5-B4FB-1913C300A702}"/>
               </a:ext>
             </a:extLst>
           </p:cNvPr>
@@ -18541,7 +18541,7 @@
           <p:cNvPr id="22" name="">
             <a:extLst xmlns:a="http://schemas.openxmlformats.org/drawingml/2006/main">
               <a:ext uri="{FF2B5EF4-FFF2-40B4-BE49-F238E27FC236}">
-                <a16:creationId xmlns:a16="http://schemas.microsoft.com/office/drawing/2014/main" id="{2A94D741-3E82-41CA-8EC0-5BF608AC3860}"/>
+                <a16:creationId xmlns:a16="http://schemas.microsoft.com/office/drawing/2014/main" id="{868A69CE-22C8-4249-B894-B673AEA61337}"/>
               </a:ext>
             </a:extLst>
           </p:cNvPr>
@@ -18578,7 +18578,7 @@
           <p:cNvPr id="23" name="">
             <a:extLst xmlns:a="http://schemas.openxmlformats.org/drawingml/2006/main">
               <a:ext uri="{FF2B5EF4-FFF2-40B4-BE49-F238E27FC236}">
-                <a16:creationId xmlns:a16="http://schemas.microsoft.com/office/drawing/2014/main" id="{AC0F53A9-EBE0-472E-82E2-6E0AE6E1853B}"/>
+                <a16:creationId xmlns:a16="http://schemas.microsoft.com/office/drawing/2014/main" id="{7C350B84-2EAE-4325-B343-59689DBC848C}"/>
               </a:ext>
             </a:extLst>
           </p:cNvPr>
@@ -18613,7 +18613,7 @@
           <p:cNvPr id="24" name="">
             <a:extLst xmlns:a="http://schemas.openxmlformats.org/drawingml/2006/main">
               <a:ext uri="{FF2B5EF4-FFF2-40B4-BE49-F238E27FC236}">
-                <a16:creationId xmlns:a16="http://schemas.microsoft.com/office/drawing/2014/main" id="{D40D890F-2B0B-4A65-92C1-1EA808827DC8}"/>
+                <a16:creationId xmlns:a16="http://schemas.microsoft.com/office/drawing/2014/main" id="{3276E26E-4974-487C-AF09-7B98C0D49262}"/>
               </a:ext>
             </a:extLst>
           </p:cNvPr>
@@ -18671,7 +18671,7 @@
           <p:cNvPr id="25" name="">
             <a:extLst xmlns:a="http://schemas.openxmlformats.org/drawingml/2006/main">
               <a:ext uri="{FF2B5EF4-FFF2-40B4-BE49-F238E27FC236}">
-                <a16:creationId xmlns:a16="http://schemas.microsoft.com/office/drawing/2014/main" id="{00CD57F8-5288-4D48-ADAE-1447E8940FAA}"/>
+                <a16:creationId xmlns:a16="http://schemas.microsoft.com/office/drawing/2014/main" id="{9B4DFB25-C75D-4C99-A7AB-4BB80919DB1F}"/>
               </a:ext>
             </a:extLst>
           </p:cNvPr>
@@ -18814,7 +18814,7 @@
           <p:cNvPr id="26" name="">
             <a:extLst xmlns:a="http://schemas.openxmlformats.org/drawingml/2006/main">
               <a:ext uri="{FF2B5EF4-FFF2-40B4-BE49-F238E27FC236}">
-                <a16:creationId xmlns:a16="http://schemas.microsoft.com/office/drawing/2014/main" id="{90E35C17-C3D6-4F2B-A9B0-355F633901D7}"/>
+                <a16:creationId xmlns:a16="http://schemas.microsoft.com/office/drawing/2014/main" id="{53B3B8B2-ACE3-4189-BC7C-23970644534D}"/>
               </a:ext>
             </a:extLst>
           </p:cNvPr>
@@ -18849,7 +18849,7 @@
           <p:cNvPr id="27" name="">
             <a:extLst xmlns:a="http://schemas.openxmlformats.org/drawingml/2006/main">
               <a:ext uri="{FF2B5EF4-FFF2-40B4-BE49-F238E27FC236}">
-                <a16:creationId xmlns:a16="http://schemas.microsoft.com/office/drawing/2014/main" id="{D96A606E-451E-4A17-A737-B7D24BB69406}"/>
+                <a16:creationId xmlns:a16="http://schemas.microsoft.com/office/drawing/2014/main" id="{A38AE0B8-BAAD-4148-9221-56368CC69B8A}"/>
               </a:ext>
             </a:extLst>
           </p:cNvPr>
@@ -18884,7 +18884,7 @@
           <p:cNvPr id="28" name="">
             <a:extLst xmlns:a="http://schemas.openxmlformats.org/drawingml/2006/main">
               <a:ext uri="{FF2B5EF4-FFF2-40B4-BE49-F238E27FC236}">
-                <a16:creationId xmlns:a16="http://schemas.microsoft.com/office/drawing/2014/main" id="{801239D8-F7B3-4F38-8E23-0C3F2D489E3B}"/>
+                <a16:creationId xmlns:a16="http://schemas.microsoft.com/office/drawing/2014/main" id="{6D468864-A74B-4B58-A182-770B723FBCB2}"/>
               </a:ext>
             </a:extLst>
           </p:cNvPr>
@@ -18942,7 +18942,7 @@
           <p:cNvPr id="29" name="">
             <a:extLst xmlns:a="http://schemas.openxmlformats.org/drawingml/2006/main">
               <a:ext uri="{FF2B5EF4-FFF2-40B4-BE49-F238E27FC236}">
-                <a16:creationId xmlns:a16="http://schemas.microsoft.com/office/drawing/2014/main" id="{A37A00D7-2FAE-46A3-8125-504BC3ED1D25}"/>
+                <a16:creationId xmlns:a16="http://schemas.microsoft.com/office/drawing/2014/main" id="{B21FBAA6-8F40-44CB-980A-0050F2302BA3}"/>
               </a:ext>
             </a:extLst>
           </p:cNvPr>
@@ -18998,7 +18998,7 @@
     </p:spTree>
     <p:extLst>
       <p:ext uri="{BB962C8B-B14F-4D97-AF65-F5344CB8AC3E}">
-        <p14:creationId xmlns:p14="http://schemas.microsoft.com/office/powerpoint/2010/main" val="2006811059"/>
+        <p14:creationId xmlns:p14="http://schemas.microsoft.com/office/powerpoint/2010/main" val="1908229589"/>
       </p:ext>
     </p:extLst>
   </p:cSld>
@@ -19029,7 +19029,7 @@
           <p:cNvPr id="1" name="Slide Number Placeholder 5">
             <a:extLst xmlns:a="http://schemas.openxmlformats.org/drawingml/2006/main">
               <a:ext uri="{FF2B5EF4-FFF2-40B4-BE49-F238E27FC236}">
-                <a16:creationId xmlns:a16="http://schemas.microsoft.com/office/drawing/2014/main" id="{821508BF-91E3-4E78-84B3-DCBD229C8660}"/>
+                <a16:creationId xmlns:a16="http://schemas.microsoft.com/office/drawing/2014/main" id="{11DAD1DA-DD27-4C25-AFB7-E057ACC56EC0}"/>
               </a:ext>
             </a:extLst>
           </p:cNvPr>
@@ -19065,7 +19065,7 @@
           <p:nvPr/>
         </p:nvPicPr>
         <p:blipFill>
-          <a:blip xmlns:r="http://schemas.openxmlformats.org/officeDocument/2006/relationships" xmlns:a="http://schemas.openxmlformats.org/drawingml/2006/main" r:embed="R82533a4f1c0742c2"/>
+          <a:blip xmlns:r="http://schemas.openxmlformats.org/officeDocument/2006/relationships" xmlns:a="http://schemas.openxmlformats.org/drawingml/2006/main" r:embed="R0f8ad99d1a8745c6"/>
           <a:srcRect xmlns:a="http://schemas.openxmlformats.org/drawingml/2006/main" l="0" t="21875" r="0" b="21875"/>
           <a:stretch xmlns:a="http://schemas.openxmlformats.org/drawingml/2006/main">
             <a:fillRect l="0" t="0" r="0" b="0"/>
@@ -19086,7 +19086,7 @@
           <p:cNvPr id="3" name="">
             <a:extLst xmlns:a="http://schemas.openxmlformats.org/drawingml/2006/main">
               <a:ext uri="{FF2B5EF4-FFF2-40B4-BE49-F238E27FC236}">
-                <a16:creationId xmlns:a16="http://schemas.microsoft.com/office/drawing/2014/main" id="{8997A331-F7ED-4F55-A35B-A9CC14428B75}"/>
+                <a16:creationId xmlns:a16="http://schemas.microsoft.com/office/drawing/2014/main" id="{9F0977C2-42C1-4880-A998-206E6565BF45}"/>
               </a:ext>
             </a:extLst>
           </p:cNvPr>
@@ -19121,7 +19121,7 @@
           <p:cNvPr id="4" name="">
             <a:extLst xmlns:a="http://schemas.openxmlformats.org/drawingml/2006/main">
               <a:ext uri="{FF2B5EF4-FFF2-40B4-BE49-F238E27FC236}">
-                <a16:creationId xmlns:a16="http://schemas.microsoft.com/office/drawing/2014/main" id="{8ED04F50-4404-47E5-95DE-CC44977F8E72}"/>
+                <a16:creationId xmlns:a16="http://schemas.microsoft.com/office/drawing/2014/main" id="{1816F542-96DA-4B15-8C14-A9D64CB170F7}"/>
               </a:ext>
             </a:extLst>
           </p:cNvPr>
@@ -19156,7 +19156,7 @@
           <p:cNvPr id="5" name="">
             <a:extLst xmlns:a="http://schemas.openxmlformats.org/drawingml/2006/main">
               <a:ext uri="{FF2B5EF4-FFF2-40B4-BE49-F238E27FC236}">
-                <a16:creationId xmlns:a16="http://schemas.microsoft.com/office/drawing/2014/main" id="{609235C7-C023-4F41-B119-389DC4DEC11D}"/>
+                <a16:creationId xmlns:a16="http://schemas.microsoft.com/office/drawing/2014/main" id="{44B806AE-0834-4853-BEA8-BC1D2B975895}"/>
               </a:ext>
             </a:extLst>
           </p:cNvPr>
@@ -19193,7 +19193,7 @@
           <p:cNvPr id="6" name="">
             <a:extLst xmlns:a="http://schemas.openxmlformats.org/drawingml/2006/main">
               <a:ext uri="{FF2B5EF4-FFF2-40B4-BE49-F238E27FC236}">
-                <a16:creationId xmlns:a16="http://schemas.microsoft.com/office/drawing/2014/main" id="{44541279-6D7C-4F2B-8903-F84CAC14F883}"/>
+                <a16:creationId xmlns:a16="http://schemas.microsoft.com/office/drawing/2014/main" id="{251CFA0A-BFDE-4ECA-808D-316C38023870}"/>
               </a:ext>
             </a:extLst>
           </p:cNvPr>
@@ -19230,7 +19230,7 @@
           <p:cNvPr id="7" name="">
             <a:extLst xmlns:a="http://schemas.openxmlformats.org/drawingml/2006/main">
               <a:ext uri="{FF2B5EF4-FFF2-40B4-BE49-F238E27FC236}">
-                <a16:creationId xmlns:a16="http://schemas.microsoft.com/office/drawing/2014/main" id="{06ADBAF5-431F-45C3-8A77-62ACF922E183}"/>
+                <a16:creationId xmlns:a16="http://schemas.microsoft.com/office/drawing/2014/main" id="{CCB71084-1E93-42A8-9D0C-A40654ECE769}"/>
               </a:ext>
             </a:extLst>
           </p:cNvPr>
@@ -19267,7 +19267,7 @@
           <p:cNvPr id="8" name="">
             <a:extLst xmlns:a="http://schemas.openxmlformats.org/drawingml/2006/main">
               <a:ext uri="{FF2B5EF4-FFF2-40B4-BE49-F238E27FC236}">
-                <a16:creationId xmlns:a16="http://schemas.microsoft.com/office/drawing/2014/main" id="{00DCFE12-7D1B-4CAB-AC64-2F6DDBD8F72E}"/>
+                <a16:creationId xmlns:a16="http://schemas.microsoft.com/office/drawing/2014/main" id="{1FAC7D28-EC08-4287-8798-38BE74D816CD}"/>
               </a:ext>
             </a:extLst>
           </p:cNvPr>
@@ -19304,7 +19304,7 @@
           <p:cNvPr id="9" name="">
             <a:extLst xmlns:a="http://schemas.openxmlformats.org/drawingml/2006/main">
               <a:ext uri="{FF2B5EF4-FFF2-40B4-BE49-F238E27FC236}">
-                <a16:creationId xmlns:a16="http://schemas.microsoft.com/office/drawing/2014/main" id="{FDE5B5FB-6AA6-410D-BEB0-96491A9E0316}"/>
+                <a16:creationId xmlns:a16="http://schemas.microsoft.com/office/drawing/2014/main" id="{98A5631E-DA51-4C25-B2E6-69D03C180F72}"/>
               </a:ext>
             </a:extLst>
           </p:cNvPr>
@@ -19362,7 +19362,7 @@
           <p:cNvPr id="10" name="">
             <a:extLst xmlns:a="http://schemas.openxmlformats.org/drawingml/2006/main">
               <a:ext uri="{FF2B5EF4-FFF2-40B4-BE49-F238E27FC236}">
-                <a16:creationId xmlns:a16="http://schemas.microsoft.com/office/drawing/2014/main" id="{8B3A45E3-47EF-44CD-A025-83101D9B3789}"/>
+                <a16:creationId xmlns:a16="http://schemas.microsoft.com/office/drawing/2014/main" id="{22C76B1D-7F1B-44AB-AEAA-30E658CD6C74}"/>
               </a:ext>
             </a:extLst>
           </p:cNvPr>
@@ -19420,7 +19420,7 @@
           <p:cNvPr id="11" name="">
             <a:extLst xmlns:a="http://schemas.openxmlformats.org/drawingml/2006/main">
               <a:ext uri="{FF2B5EF4-FFF2-40B4-BE49-F238E27FC236}">
-                <a16:creationId xmlns:a16="http://schemas.microsoft.com/office/drawing/2014/main" id="{BE10A77D-6EEA-41ED-BE02-788B9A2E2235}"/>
+                <a16:creationId xmlns:a16="http://schemas.microsoft.com/office/drawing/2014/main" id="{20B07F4B-C85D-4F0A-A804-08C261425006}"/>
               </a:ext>
             </a:extLst>
           </p:cNvPr>
@@ -19455,7 +19455,7 @@
           <p:cNvPr id="12" name="">
             <a:extLst xmlns:a="http://schemas.openxmlformats.org/drawingml/2006/main">
               <a:ext uri="{FF2B5EF4-FFF2-40B4-BE49-F238E27FC236}">
-                <a16:creationId xmlns:a16="http://schemas.microsoft.com/office/drawing/2014/main" id="{DB38882A-FE28-49A8-9646-44656EE1E4EE}"/>
+                <a16:creationId xmlns:a16="http://schemas.microsoft.com/office/drawing/2014/main" id="{7BE56CA7-E680-460D-BCE8-CFFED2DE7C0D}"/>
               </a:ext>
             </a:extLst>
           </p:cNvPr>
@@ -19488,7 +19488,7 @@
           <p:cNvPr id="13" name="">
             <a:extLst xmlns:a="http://schemas.openxmlformats.org/drawingml/2006/main">
               <a:ext uri="{FF2B5EF4-FFF2-40B4-BE49-F238E27FC236}">
-                <a16:creationId xmlns:a16="http://schemas.microsoft.com/office/drawing/2014/main" id="{0EF8F0E9-3A68-4BC5-AEB6-24F53118CE22}"/>
+                <a16:creationId xmlns:a16="http://schemas.microsoft.com/office/drawing/2014/main" id="{068D5EB0-F9E5-4023-A10D-A36CCF415FBC}"/>
               </a:ext>
             </a:extLst>
           </p:cNvPr>
@@ -19546,7 +19546,7 @@
           <p:cNvPr id="14" name="">
             <a:extLst xmlns:a="http://schemas.openxmlformats.org/drawingml/2006/main">
               <a:ext uri="{FF2B5EF4-FFF2-40B4-BE49-F238E27FC236}">
-                <a16:creationId xmlns:a16="http://schemas.microsoft.com/office/drawing/2014/main" id="{8FD983C7-D0FC-42C4-B3F7-67C2541F0D88}"/>
+                <a16:creationId xmlns:a16="http://schemas.microsoft.com/office/drawing/2014/main" id="{DBBF4DB4-BF92-48EA-9D98-E1D60EBEF4F4}"/>
               </a:ext>
             </a:extLst>
           </p:cNvPr>
@@ -19581,7 +19581,7 @@
           <p:cNvPr id="15" name="">
             <a:extLst xmlns:a="http://schemas.openxmlformats.org/drawingml/2006/main">
               <a:ext uri="{FF2B5EF4-FFF2-40B4-BE49-F238E27FC236}">
-                <a16:creationId xmlns:a16="http://schemas.microsoft.com/office/drawing/2014/main" id="{DCA1B17A-EFFE-414C-B98D-8EF6DF6B0779}"/>
+                <a16:creationId xmlns:a16="http://schemas.microsoft.com/office/drawing/2014/main" id="{A32C9EC9-A9AA-4684-AAEA-753456FE8A60}"/>
               </a:ext>
             </a:extLst>
           </p:cNvPr>
@@ -19616,7 +19616,7 @@
           <p:cNvPr id="16" name="">
             <a:extLst xmlns:a="http://schemas.openxmlformats.org/drawingml/2006/main">
               <a:ext uri="{FF2B5EF4-FFF2-40B4-BE49-F238E27FC236}">
-                <a16:creationId xmlns:a16="http://schemas.microsoft.com/office/drawing/2014/main" id="{615C837C-B2B9-4E4F-A0EF-23A5D9698947}"/>
+                <a16:creationId xmlns:a16="http://schemas.microsoft.com/office/drawing/2014/main" id="{45B6E6FB-09F8-46EA-8138-3FE2CFDA8CFF}"/>
               </a:ext>
             </a:extLst>
           </p:cNvPr>
@@ -19674,7 +19674,7 @@
           <p:cNvPr id="17" name="">
             <a:extLst xmlns:a="http://schemas.openxmlformats.org/drawingml/2006/main">
               <a:ext uri="{FF2B5EF4-FFF2-40B4-BE49-F238E27FC236}">
-                <a16:creationId xmlns:a16="http://schemas.microsoft.com/office/drawing/2014/main" id="{3346162E-BA06-4608-957C-B13FCBA7606D}"/>
+                <a16:creationId xmlns:a16="http://schemas.microsoft.com/office/drawing/2014/main" id="{AC5E9173-2A5A-4DF7-9254-F6924658F072}"/>
               </a:ext>
             </a:extLst>
           </p:cNvPr>
@@ -19711,7 +19711,7 @@
           <p:cNvPr id="18" name="">
             <a:extLst xmlns:a="http://schemas.openxmlformats.org/drawingml/2006/main">
               <a:ext uri="{FF2B5EF4-FFF2-40B4-BE49-F238E27FC236}">
-                <a16:creationId xmlns:a16="http://schemas.microsoft.com/office/drawing/2014/main" id="{063A13F6-ACD5-4E0C-A0D1-55FAAC755BC5}"/>
+                <a16:creationId xmlns:a16="http://schemas.microsoft.com/office/drawing/2014/main" id="{9CD082E5-3FD9-4863-A90B-1B7774F4D95B}"/>
               </a:ext>
             </a:extLst>
           </p:cNvPr>
@@ -19746,7 +19746,7 @@
           <p:cNvPr id="19" name="">
             <a:extLst xmlns:a="http://schemas.openxmlformats.org/drawingml/2006/main">
               <a:ext uri="{FF2B5EF4-FFF2-40B4-BE49-F238E27FC236}">
-                <a16:creationId xmlns:a16="http://schemas.microsoft.com/office/drawing/2014/main" id="{4A944755-D49D-4066-8A23-1AB64517E3DD}"/>
+                <a16:creationId xmlns:a16="http://schemas.microsoft.com/office/drawing/2014/main" id="{B7016E13-23AA-495E-8C46-755630133615}"/>
               </a:ext>
             </a:extLst>
           </p:cNvPr>
@@ -19804,7 +19804,7 @@
           <p:cNvPr id="20" name="">
             <a:extLst xmlns:a="http://schemas.openxmlformats.org/drawingml/2006/main">
               <a:ext uri="{FF2B5EF4-FFF2-40B4-BE49-F238E27FC236}">
-                <a16:creationId xmlns:a16="http://schemas.microsoft.com/office/drawing/2014/main" id="{98A303C6-C7FC-4ED9-95BF-E6F7A054BD33}"/>
+                <a16:creationId xmlns:a16="http://schemas.microsoft.com/office/drawing/2014/main" id="{83BEEFD4-333D-4617-92A4-B1B00CDDEC38}"/>
               </a:ext>
             </a:extLst>
           </p:cNvPr>
@@ -19896,7 +19896,7 @@
           <p:cNvPr id="21" name="">
             <a:extLst xmlns:a="http://schemas.openxmlformats.org/drawingml/2006/main">
               <a:ext uri="{FF2B5EF4-FFF2-40B4-BE49-F238E27FC236}">
-                <a16:creationId xmlns:a16="http://schemas.microsoft.com/office/drawing/2014/main" id="{7EF83724-1653-47C0-9612-FF9FE2B769E3}"/>
+                <a16:creationId xmlns:a16="http://schemas.microsoft.com/office/drawing/2014/main" id="{F88960FB-2334-443B-A63B-41A7D45B8BF4}"/>
               </a:ext>
             </a:extLst>
           </p:cNvPr>
@@ -19933,7 +19933,7 @@
           <p:cNvPr id="22" name="">
             <a:extLst xmlns:a="http://schemas.openxmlformats.org/drawingml/2006/main">
               <a:ext uri="{FF2B5EF4-FFF2-40B4-BE49-F238E27FC236}">
-                <a16:creationId xmlns:a16="http://schemas.microsoft.com/office/drawing/2014/main" id="{B1DFE731-8A47-4C83-80F4-E59F486D67EB}"/>
+                <a16:creationId xmlns:a16="http://schemas.microsoft.com/office/drawing/2014/main" id="{C5B61865-0735-4F7D-950E-A01985D11CCA}"/>
               </a:ext>
             </a:extLst>
           </p:cNvPr>
@@ -19968,7 +19968,7 @@
           <p:cNvPr id="23" name="">
             <a:extLst xmlns:a="http://schemas.openxmlformats.org/drawingml/2006/main">
               <a:ext uri="{FF2B5EF4-FFF2-40B4-BE49-F238E27FC236}">
-                <a16:creationId xmlns:a16="http://schemas.microsoft.com/office/drawing/2014/main" id="{4EDFFA91-93D2-43B1-A587-7456D938887C}"/>
+                <a16:creationId xmlns:a16="http://schemas.microsoft.com/office/drawing/2014/main" id="{E71C35B0-7652-45BD-9086-360A7705E6AB}"/>
               </a:ext>
             </a:extLst>
           </p:cNvPr>
@@ -20026,7 +20026,7 @@
           <p:cNvPr id="24" name="">
             <a:extLst xmlns:a="http://schemas.openxmlformats.org/drawingml/2006/main">
               <a:ext uri="{FF2B5EF4-FFF2-40B4-BE49-F238E27FC236}">
-                <a16:creationId xmlns:a16="http://schemas.microsoft.com/office/drawing/2014/main" id="{3872002D-7B5A-4196-90A9-5000119B7566}"/>
+                <a16:creationId xmlns:a16="http://schemas.microsoft.com/office/drawing/2014/main" id="{DC34EDE8-9647-4B33-AD83-B269EE100FC6}"/>
               </a:ext>
             </a:extLst>
           </p:cNvPr>
@@ -20118,7 +20118,7 @@
           <p:cNvPr id="25" name="">
             <a:extLst xmlns:a="http://schemas.openxmlformats.org/drawingml/2006/main">
               <a:ext uri="{FF2B5EF4-FFF2-40B4-BE49-F238E27FC236}">
-                <a16:creationId xmlns:a16="http://schemas.microsoft.com/office/drawing/2014/main" id="{B7104D2D-8C1B-4C7E-B693-EA77CF95D692}"/>
+                <a16:creationId xmlns:a16="http://schemas.microsoft.com/office/drawing/2014/main" id="{6EAF2159-C976-4FEC-B8AB-94CFED0AA5D7}"/>
               </a:ext>
             </a:extLst>
           </p:cNvPr>
@@ -20155,7 +20155,7 @@
           <p:cNvPr id="26" name="">
             <a:extLst xmlns:a="http://schemas.openxmlformats.org/drawingml/2006/main">
               <a:ext uri="{FF2B5EF4-FFF2-40B4-BE49-F238E27FC236}">
-                <a16:creationId xmlns:a16="http://schemas.microsoft.com/office/drawing/2014/main" id="{9EFE221E-6209-49EC-973E-04C323B874C5}"/>
+                <a16:creationId xmlns:a16="http://schemas.microsoft.com/office/drawing/2014/main" id="{1F31083E-5840-436E-B6D4-3B876DE5E768}"/>
               </a:ext>
             </a:extLst>
           </p:cNvPr>
@@ -20190,7 +20190,7 @@
           <p:cNvPr id="27" name="">
             <a:extLst xmlns:a="http://schemas.openxmlformats.org/drawingml/2006/main">
               <a:ext uri="{FF2B5EF4-FFF2-40B4-BE49-F238E27FC236}">
-                <a16:creationId xmlns:a16="http://schemas.microsoft.com/office/drawing/2014/main" id="{1406D03C-D7B6-4F91-8747-51245C4973E2}"/>
+                <a16:creationId xmlns:a16="http://schemas.microsoft.com/office/drawing/2014/main" id="{AC32B0BE-DE5D-4FF9-B858-10E5DB9D2598}"/>
               </a:ext>
             </a:extLst>
           </p:cNvPr>
@@ -20248,7 +20248,7 @@
           <p:cNvPr id="28" name="">
             <a:extLst xmlns:a="http://schemas.openxmlformats.org/drawingml/2006/main">
               <a:ext uri="{FF2B5EF4-FFF2-40B4-BE49-F238E27FC236}">
-                <a16:creationId xmlns:a16="http://schemas.microsoft.com/office/drawing/2014/main" id="{1654B727-8023-486F-AA16-23C70DE9AC6A}"/>
+                <a16:creationId xmlns:a16="http://schemas.microsoft.com/office/drawing/2014/main" id="{07D64BF5-D088-4B9D-B4F3-189E9F5FE7BB}"/>
               </a:ext>
             </a:extLst>
           </p:cNvPr>
@@ -20340,7 +20340,7 @@
           <p:cNvPr id="29" name="">
             <a:extLst xmlns:a="http://schemas.openxmlformats.org/drawingml/2006/main">
               <a:ext uri="{FF2B5EF4-FFF2-40B4-BE49-F238E27FC236}">
-                <a16:creationId xmlns:a16="http://schemas.microsoft.com/office/drawing/2014/main" id="{D4A5B8CC-7F65-4B95-A604-254A469BF05D}"/>
+                <a16:creationId xmlns:a16="http://schemas.microsoft.com/office/drawing/2014/main" id="{BFC4F915-19FB-49A6-8EED-BA3E91DD4231}"/>
               </a:ext>
             </a:extLst>
           </p:cNvPr>
@@ -20394,7 +20394,7 @@
           <p:cNvPr id="30" name="">
             <a:extLst xmlns:a="http://schemas.openxmlformats.org/drawingml/2006/main">
               <a:ext uri="{FF2B5EF4-FFF2-40B4-BE49-F238E27FC236}">
-                <a16:creationId xmlns:a16="http://schemas.microsoft.com/office/drawing/2014/main" id="{CB2E9EF9-9914-4BA7-B1D9-A949C756AB9D}"/>
+                <a16:creationId xmlns:a16="http://schemas.microsoft.com/office/drawing/2014/main" id="{30A34E63-EC3A-4CEC-9C08-631A0599612C}"/>
               </a:ext>
             </a:extLst>
           </p:cNvPr>
@@ -20450,7 +20450,7 @@
     </p:spTree>
     <p:extLst>
       <p:ext uri="{BB962C8B-B14F-4D97-AF65-F5344CB8AC3E}">
-        <p14:creationId xmlns:p14="http://schemas.microsoft.com/office/powerpoint/2010/main" val="2047330770"/>
+        <p14:creationId xmlns:p14="http://schemas.microsoft.com/office/powerpoint/2010/main" val="448471026"/>
       </p:ext>
     </p:extLst>
   </p:cSld>
@@ -20481,7 +20481,7 @@
           <p:cNvPr id="1" name="Slide Number Placeholder 5">
             <a:extLst xmlns:a="http://schemas.openxmlformats.org/drawingml/2006/main">
               <a:ext uri="{FF2B5EF4-FFF2-40B4-BE49-F238E27FC236}">
-                <a16:creationId xmlns:a16="http://schemas.microsoft.com/office/drawing/2014/main" id="{821508BF-91E3-4E78-84B3-DCBD229C8660}"/>
+                <a16:creationId xmlns:a16="http://schemas.microsoft.com/office/drawing/2014/main" id="{11DAD1DA-DD27-4C25-AFB7-E057ACC56EC0}"/>
               </a:ext>
             </a:extLst>
           </p:cNvPr>
@@ -20517,7 +20517,7 @@
           <p:nvPr/>
         </p:nvPicPr>
         <p:blipFill>
-          <a:blip xmlns:r="http://schemas.openxmlformats.org/officeDocument/2006/relationships" xmlns:a="http://schemas.openxmlformats.org/drawingml/2006/main" r:embed="R9e066834ffc94efc"/>
+          <a:blip xmlns:r="http://schemas.openxmlformats.org/officeDocument/2006/relationships" xmlns:a="http://schemas.openxmlformats.org/drawingml/2006/main" r:embed="R3d2b7887ebd74606"/>
           <a:srcRect xmlns:a="http://schemas.openxmlformats.org/drawingml/2006/main" l="0" t="21875" r="0" b="21875"/>
           <a:stretch xmlns:a="http://schemas.openxmlformats.org/drawingml/2006/main">
             <a:fillRect l="0" t="0" r="0" b="0"/>
@@ -20538,7 +20538,7 @@
           <p:cNvPr id="3" name="">
             <a:extLst xmlns:a="http://schemas.openxmlformats.org/drawingml/2006/main">
               <a:ext uri="{FF2B5EF4-FFF2-40B4-BE49-F238E27FC236}">
-                <a16:creationId xmlns:a16="http://schemas.microsoft.com/office/drawing/2014/main" id="{125A3700-8D23-4725-98B9-C96681BD15A3}"/>
+                <a16:creationId xmlns:a16="http://schemas.microsoft.com/office/drawing/2014/main" id="{A06564FF-1348-4116-A98C-0BCDA66EC083}"/>
               </a:ext>
             </a:extLst>
           </p:cNvPr>
@@ -20573,7 +20573,7 @@
           <p:cNvPr id="4" name="">
             <a:extLst xmlns:a="http://schemas.openxmlformats.org/drawingml/2006/main">
               <a:ext uri="{FF2B5EF4-FFF2-40B4-BE49-F238E27FC236}">
-                <a16:creationId xmlns:a16="http://schemas.microsoft.com/office/drawing/2014/main" id="{224B2E21-8F80-4BC9-A239-2CF5BD16F193}"/>
+                <a16:creationId xmlns:a16="http://schemas.microsoft.com/office/drawing/2014/main" id="{767E2C77-6F2D-445D-89AD-80CE3251E1C0}"/>
               </a:ext>
             </a:extLst>
           </p:cNvPr>
@@ -20608,7 +20608,7 @@
           <p:cNvPr id="5" name="">
             <a:extLst xmlns:a="http://schemas.openxmlformats.org/drawingml/2006/main">
               <a:ext uri="{FF2B5EF4-FFF2-40B4-BE49-F238E27FC236}">
-                <a16:creationId xmlns:a16="http://schemas.microsoft.com/office/drawing/2014/main" id="{684AF2C6-4CE5-4A5D-A061-1AA7BB428AD0}"/>
+                <a16:creationId xmlns:a16="http://schemas.microsoft.com/office/drawing/2014/main" id="{8D0BDBBF-8A63-4E22-843A-15260B64E7FB}"/>
               </a:ext>
             </a:extLst>
           </p:cNvPr>
@@ -20645,7 +20645,7 @@
           <p:cNvPr id="6" name="">
             <a:extLst xmlns:a="http://schemas.openxmlformats.org/drawingml/2006/main">
               <a:ext uri="{FF2B5EF4-FFF2-40B4-BE49-F238E27FC236}">
-                <a16:creationId xmlns:a16="http://schemas.microsoft.com/office/drawing/2014/main" id="{64D5D436-E8CF-4849-A808-A4D257D02A9D}"/>
+                <a16:creationId xmlns:a16="http://schemas.microsoft.com/office/drawing/2014/main" id="{7F394D0A-4E02-4921-B157-41BAB85BD06B}"/>
               </a:ext>
             </a:extLst>
           </p:cNvPr>
@@ -20682,7 +20682,7 @@
           <p:cNvPr id="7" name="">
             <a:extLst xmlns:a="http://schemas.openxmlformats.org/drawingml/2006/main">
               <a:ext uri="{FF2B5EF4-FFF2-40B4-BE49-F238E27FC236}">
-                <a16:creationId xmlns:a16="http://schemas.microsoft.com/office/drawing/2014/main" id="{F8B64131-BFA0-4122-9713-129778394C43}"/>
+                <a16:creationId xmlns:a16="http://schemas.microsoft.com/office/drawing/2014/main" id="{8B4A0466-1C24-4D5F-8DCD-9D04E7B499B2}"/>
               </a:ext>
             </a:extLst>
           </p:cNvPr>
@@ -20719,7 +20719,7 @@
           <p:cNvPr id="8" name="">
             <a:extLst xmlns:a="http://schemas.openxmlformats.org/drawingml/2006/main">
               <a:ext uri="{FF2B5EF4-FFF2-40B4-BE49-F238E27FC236}">
-                <a16:creationId xmlns:a16="http://schemas.microsoft.com/office/drawing/2014/main" id="{2D5285CC-06B5-4316-AA9F-5A947EB587CE}"/>
+                <a16:creationId xmlns:a16="http://schemas.microsoft.com/office/drawing/2014/main" id="{289F16A8-6A18-42DF-979B-2F156E114102}"/>
               </a:ext>
             </a:extLst>
           </p:cNvPr>
@@ -20756,7 +20756,7 @@
           <p:cNvPr id="9" name="">
             <a:extLst xmlns:a="http://schemas.openxmlformats.org/drawingml/2006/main">
               <a:ext uri="{FF2B5EF4-FFF2-40B4-BE49-F238E27FC236}">
-                <a16:creationId xmlns:a16="http://schemas.microsoft.com/office/drawing/2014/main" id="{A5863B54-1A56-4C05-AEBF-01EE4E378028}"/>
+                <a16:creationId xmlns:a16="http://schemas.microsoft.com/office/drawing/2014/main" id="{768F11F9-C320-4BB4-85C0-1ED0B99E518D}"/>
               </a:ext>
             </a:extLst>
           </p:cNvPr>
@@ -20814,7 +20814,7 @@
           <p:cNvPr id="10" name="">
             <a:extLst xmlns:a="http://schemas.openxmlformats.org/drawingml/2006/main">
               <a:ext uri="{FF2B5EF4-FFF2-40B4-BE49-F238E27FC236}">
-                <a16:creationId xmlns:a16="http://schemas.microsoft.com/office/drawing/2014/main" id="{DA268A0B-6C12-4EFE-816A-4D23F2F87777}"/>
+                <a16:creationId xmlns:a16="http://schemas.microsoft.com/office/drawing/2014/main" id="{DE0BFAD4-309E-454D-89E0-431EBB8365A1}"/>
               </a:ext>
             </a:extLst>
           </p:cNvPr>
@@ -20872,7 +20872,7 @@
           <p:cNvPr id="11" name="">
             <a:extLst xmlns:a="http://schemas.openxmlformats.org/drawingml/2006/main">
               <a:ext uri="{FF2B5EF4-FFF2-40B4-BE49-F238E27FC236}">
-                <a16:creationId xmlns:a16="http://schemas.microsoft.com/office/drawing/2014/main" id="{C010A9C3-A85D-4BAB-9D17-E0174B0980A9}"/>
+                <a16:creationId xmlns:a16="http://schemas.microsoft.com/office/drawing/2014/main" id="{786861FC-1593-4522-83E6-4EE1A83E1A62}"/>
               </a:ext>
             </a:extLst>
           </p:cNvPr>
@@ -20907,7 +20907,7 @@
           <p:cNvPr id="12" name="">
             <a:extLst xmlns:a="http://schemas.openxmlformats.org/drawingml/2006/main">
               <a:ext uri="{FF2B5EF4-FFF2-40B4-BE49-F238E27FC236}">
-                <a16:creationId xmlns:a16="http://schemas.microsoft.com/office/drawing/2014/main" id="{2EAF8926-03C7-4DDE-BA05-F25CA4B4BA0A}"/>
+                <a16:creationId xmlns:a16="http://schemas.microsoft.com/office/drawing/2014/main" id="{F973365A-29D9-4398-BFD3-23217288122D}"/>
               </a:ext>
             </a:extLst>
           </p:cNvPr>
@@ -20940,7 +20940,7 @@
           <p:cNvPr id="13" name="">
             <a:extLst xmlns:a="http://schemas.openxmlformats.org/drawingml/2006/main">
               <a:ext uri="{FF2B5EF4-FFF2-40B4-BE49-F238E27FC236}">
-                <a16:creationId xmlns:a16="http://schemas.microsoft.com/office/drawing/2014/main" id="{99585C38-B1A4-4EBE-83E1-DF5BAE988906}"/>
+                <a16:creationId xmlns:a16="http://schemas.microsoft.com/office/drawing/2014/main" id="{D288E78C-B0C1-4853-A752-4DA4F8AD1B58}"/>
               </a:ext>
             </a:extLst>
           </p:cNvPr>
@@ -21015,7 +21015,7 @@
           <p:cNvPr id="14" name="">
             <a:extLst xmlns:a="http://schemas.openxmlformats.org/drawingml/2006/main">
               <a:ext uri="{FF2B5EF4-FFF2-40B4-BE49-F238E27FC236}">
-                <a16:creationId xmlns:a16="http://schemas.microsoft.com/office/drawing/2014/main" id="{ABCE2983-BFEB-418D-8F00-403E8DFED29C}"/>
+                <a16:creationId xmlns:a16="http://schemas.microsoft.com/office/drawing/2014/main" id="{06088249-37F0-431B-A508-824220E624E7}"/>
               </a:ext>
             </a:extLst>
           </p:cNvPr>
@@ -21069,7 +21069,7 @@
           <p:cNvPr id="15" name="">
             <a:extLst xmlns:a="http://schemas.openxmlformats.org/drawingml/2006/main">
               <a:ext uri="{FF2B5EF4-FFF2-40B4-BE49-F238E27FC236}">
-                <a16:creationId xmlns:a16="http://schemas.microsoft.com/office/drawing/2014/main" id="{7CA189B4-5B58-4AA1-8146-1CEA797C8D78}"/>
+                <a16:creationId xmlns:a16="http://schemas.microsoft.com/office/drawing/2014/main" id="{843EC3E2-407D-4E86-969D-6E016EEC4C91}"/>
               </a:ext>
             </a:extLst>
           </p:cNvPr>
@@ -21104,7 +21104,7 @@
           <p:cNvPr id="16" name="">
             <a:extLst xmlns:a="http://schemas.openxmlformats.org/drawingml/2006/main">
               <a:ext uri="{FF2B5EF4-FFF2-40B4-BE49-F238E27FC236}">
-                <a16:creationId xmlns:a16="http://schemas.microsoft.com/office/drawing/2014/main" id="{B5E2B769-B9C7-4E53-98A2-209C318ADE41}"/>
+                <a16:creationId xmlns:a16="http://schemas.microsoft.com/office/drawing/2014/main" id="{B4D62313-DAA7-4992-BB4E-DC8CD6F2F31D}"/>
               </a:ext>
             </a:extLst>
           </p:cNvPr>
@@ -21139,7 +21139,7 @@
           <p:cNvPr id="17" name="">
             <a:extLst xmlns:a="http://schemas.openxmlformats.org/drawingml/2006/main">
               <a:ext uri="{FF2B5EF4-FFF2-40B4-BE49-F238E27FC236}">
-                <a16:creationId xmlns:a16="http://schemas.microsoft.com/office/drawing/2014/main" id="{C988C17A-41AD-429B-B991-1CE26028DE34}"/>
+                <a16:creationId xmlns:a16="http://schemas.microsoft.com/office/drawing/2014/main" id="{029CED18-8BF2-41E7-B26A-8AA561D68CFD}"/>
               </a:ext>
             </a:extLst>
           </p:cNvPr>
@@ -21193,7 +21193,7 @@
           <p:cNvPr id="18" name="">
             <a:extLst xmlns:a="http://schemas.openxmlformats.org/drawingml/2006/main">
               <a:ext uri="{FF2B5EF4-FFF2-40B4-BE49-F238E27FC236}">
-                <a16:creationId xmlns:a16="http://schemas.microsoft.com/office/drawing/2014/main" id="{D91758B5-9B8F-4263-A857-906879E1ACBB}"/>
+                <a16:creationId xmlns:a16="http://schemas.microsoft.com/office/drawing/2014/main" id="{823EBF75-ADA0-49E9-8CF0-A749E8861E3A}"/>
               </a:ext>
             </a:extLst>
           </p:cNvPr>
@@ -21251,7 +21251,7 @@
           <p:cNvPr id="19" name="">
             <a:extLst xmlns:a="http://schemas.openxmlformats.org/drawingml/2006/main">
               <a:ext uri="{FF2B5EF4-FFF2-40B4-BE49-F238E27FC236}">
-                <a16:creationId xmlns:a16="http://schemas.microsoft.com/office/drawing/2014/main" id="{FCE56D77-3CB2-4B8B-92F2-B88E0A0F58DE}"/>
+                <a16:creationId xmlns:a16="http://schemas.microsoft.com/office/drawing/2014/main" id="{B75419FC-584F-420A-A32B-F086CCB622B1}"/>
               </a:ext>
             </a:extLst>
           </p:cNvPr>
@@ -21309,7 +21309,7 @@
           <p:cNvPr id="20" name="">
             <a:extLst xmlns:a="http://schemas.openxmlformats.org/drawingml/2006/main">
               <a:ext uri="{FF2B5EF4-FFF2-40B4-BE49-F238E27FC236}">
-                <a16:creationId xmlns:a16="http://schemas.microsoft.com/office/drawing/2014/main" id="{CEB54C8A-FCC4-4631-A4A0-8300394292E0}"/>
+                <a16:creationId xmlns:a16="http://schemas.microsoft.com/office/drawing/2014/main" id="{06A41DA2-900C-49DA-BF47-314EBC5DB802}"/>
               </a:ext>
             </a:extLst>
           </p:cNvPr>
@@ -21344,7 +21344,7 @@
           <p:cNvPr id="21" name="">
             <a:extLst xmlns:a="http://schemas.openxmlformats.org/drawingml/2006/main">
               <a:ext uri="{FF2B5EF4-FFF2-40B4-BE49-F238E27FC236}">
-                <a16:creationId xmlns:a16="http://schemas.microsoft.com/office/drawing/2014/main" id="{A01A40DF-E91F-40A8-A234-7E49220E4CE7}"/>
+                <a16:creationId xmlns:a16="http://schemas.microsoft.com/office/drawing/2014/main" id="{330D31A2-E3C2-41A3-B740-AFD499B583B2}"/>
               </a:ext>
             </a:extLst>
           </p:cNvPr>
@@ -21379,7 +21379,7 @@
           <p:cNvPr id="22" name="">
             <a:extLst xmlns:a="http://schemas.openxmlformats.org/drawingml/2006/main">
               <a:ext uri="{FF2B5EF4-FFF2-40B4-BE49-F238E27FC236}">
-                <a16:creationId xmlns:a16="http://schemas.microsoft.com/office/drawing/2014/main" id="{B3A5C3F6-EDCC-4A45-82CC-7DF3E0A49D63}"/>
+                <a16:creationId xmlns:a16="http://schemas.microsoft.com/office/drawing/2014/main" id="{086CB6A7-5C46-4B04-90A2-360BC4BA3001}"/>
               </a:ext>
             </a:extLst>
           </p:cNvPr>
@@ -21433,7 +21433,7 @@
           <p:cNvPr id="23" name="">
             <a:extLst xmlns:a="http://schemas.openxmlformats.org/drawingml/2006/main">
               <a:ext uri="{FF2B5EF4-FFF2-40B4-BE49-F238E27FC236}">
-                <a16:creationId xmlns:a16="http://schemas.microsoft.com/office/drawing/2014/main" id="{EE12F20C-A454-42C8-B86E-B08E8B765148}"/>
+                <a16:creationId xmlns:a16="http://schemas.microsoft.com/office/drawing/2014/main" id="{0B57FDE3-C099-4EB5-8056-E729936F25C4}"/>
               </a:ext>
             </a:extLst>
           </p:cNvPr>
@@ -21491,7 +21491,7 @@
           <p:cNvPr id="24" name="">
             <a:extLst xmlns:a="http://schemas.openxmlformats.org/drawingml/2006/main">
               <a:ext uri="{FF2B5EF4-FFF2-40B4-BE49-F238E27FC236}">
-                <a16:creationId xmlns:a16="http://schemas.microsoft.com/office/drawing/2014/main" id="{9E61305A-6614-40D2-9C95-B8DA44D32564}"/>
+                <a16:creationId xmlns:a16="http://schemas.microsoft.com/office/drawing/2014/main" id="{F241C912-4B31-4E87-A31F-DE0FE59F1BAA}"/>
               </a:ext>
             </a:extLst>
           </p:cNvPr>
@@ -21566,7 +21566,7 @@
           <p:cNvPr id="25" name="">
             <a:extLst xmlns:a="http://schemas.openxmlformats.org/drawingml/2006/main">
               <a:ext uri="{FF2B5EF4-FFF2-40B4-BE49-F238E27FC236}">
-                <a16:creationId xmlns:a16="http://schemas.microsoft.com/office/drawing/2014/main" id="{0F52EAD7-4188-4355-98CB-590C7E8C9139}"/>
+                <a16:creationId xmlns:a16="http://schemas.microsoft.com/office/drawing/2014/main" id="{CDD78B5E-3775-47BA-BFE9-BBEE1C03774E}"/>
               </a:ext>
             </a:extLst>
           </p:cNvPr>
@@ -21601,7 +21601,7 @@
           <p:cNvPr id="26" name="">
             <a:extLst xmlns:a="http://schemas.openxmlformats.org/drawingml/2006/main">
               <a:ext uri="{FF2B5EF4-FFF2-40B4-BE49-F238E27FC236}">
-                <a16:creationId xmlns:a16="http://schemas.microsoft.com/office/drawing/2014/main" id="{7EDF99CB-0F75-467C-9FBC-39227244177E}"/>
+                <a16:creationId xmlns:a16="http://schemas.microsoft.com/office/drawing/2014/main" id="{0F9F2749-492D-4CA0-BF28-A6FDA3C1A4C3}"/>
               </a:ext>
             </a:extLst>
           </p:cNvPr>
@@ -21636,7 +21636,7 @@
           <p:cNvPr id="27" name="">
             <a:extLst xmlns:a="http://schemas.openxmlformats.org/drawingml/2006/main">
               <a:ext uri="{FF2B5EF4-FFF2-40B4-BE49-F238E27FC236}">
-                <a16:creationId xmlns:a16="http://schemas.microsoft.com/office/drawing/2014/main" id="{90F96437-348F-4A86-AB7A-2B3D01785393}"/>
+                <a16:creationId xmlns:a16="http://schemas.microsoft.com/office/drawing/2014/main" id="{48256A6B-EFAA-4D80-BB3C-0313C2C5707C}"/>
               </a:ext>
             </a:extLst>
           </p:cNvPr>
@@ -21690,7 +21690,7 @@
           <p:cNvPr id="28" name="">
             <a:extLst xmlns:a="http://schemas.openxmlformats.org/drawingml/2006/main">
               <a:ext uri="{FF2B5EF4-FFF2-40B4-BE49-F238E27FC236}">
-                <a16:creationId xmlns:a16="http://schemas.microsoft.com/office/drawing/2014/main" id="{B3B04DFC-AA15-41AE-98E8-855CB744CA66}"/>
+                <a16:creationId xmlns:a16="http://schemas.microsoft.com/office/drawing/2014/main" id="{3B8E8555-6EAA-42C0-B18D-67B65517B887}"/>
               </a:ext>
             </a:extLst>
           </p:cNvPr>
@@ -21748,7 +21748,7 @@
           <p:cNvPr id="29" name="">
             <a:extLst xmlns:a="http://schemas.openxmlformats.org/drawingml/2006/main">
               <a:ext uri="{FF2B5EF4-FFF2-40B4-BE49-F238E27FC236}">
-                <a16:creationId xmlns:a16="http://schemas.microsoft.com/office/drawing/2014/main" id="{7F273D6A-DE7A-435C-A7D1-5BBDB6BFB533}"/>
+                <a16:creationId xmlns:a16="http://schemas.microsoft.com/office/drawing/2014/main" id="{1459E4BB-CB19-4015-9514-D65C9C51DD2B}"/>
               </a:ext>
             </a:extLst>
           </p:cNvPr>
@@ -21823,7 +21823,7 @@
           <p:cNvPr id="30" name="">
             <a:extLst xmlns:a="http://schemas.openxmlformats.org/drawingml/2006/main">
               <a:ext uri="{FF2B5EF4-FFF2-40B4-BE49-F238E27FC236}">
-                <a16:creationId xmlns:a16="http://schemas.microsoft.com/office/drawing/2014/main" id="{DF5A4458-3C84-4D3E-B6B2-EBF9E0DA2526}"/>
+                <a16:creationId xmlns:a16="http://schemas.microsoft.com/office/drawing/2014/main" id="{691D5B5B-A94D-4963-B6C8-45EB3791022F}"/>
               </a:ext>
             </a:extLst>
           </p:cNvPr>
@@ -21858,7 +21858,7 @@
           <p:cNvPr id="31" name="">
             <a:extLst xmlns:a="http://schemas.openxmlformats.org/drawingml/2006/main">
               <a:ext uri="{FF2B5EF4-FFF2-40B4-BE49-F238E27FC236}">
-                <a16:creationId xmlns:a16="http://schemas.microsoft.com/office/drawing/2014/main" id="{E2C3E8A3-C1C8-41B4-BCC0-AFA5CAAB7404}"/>
+                <a16:creationId xmlns:a16="http://schemas.microsoft.com/office/drawing/2014/main" id="{204E33DA-B886-4A62-93FB-2F760807E911}"/>
               </a:ext>
             </a:extLst>
           </p:cNvPr>
@@ -21893,7 +21893,7 @@
           <p:cNvPr id="32" name="">
             <a:extLst xmlns:a="http://schemas.openxmlformats.org/drawingml/2006/main">
               <a:ext uri="{FF2B5EF4-FFF2-40B4-BE49-F238E27FC236}">
-                <a16:creationId xmlns:a16="http://schemas.microsoft.com/office/drawing/2014/main" id="{7B464AED-D9C2-4BF4-A341-D70F1846478D}"/>
+                <a16:creationId xmlns:a16="http://schemas.microsoft.com/office/drawing/2014/main" id="{19848CE3-0AEC-4F6C-B243-F9F9A66387C8}"/>
               </a:ext>
             </a:extLst>
           </p:cNvPr>
@@ -21947,7 +21947,7 @@
           <p:cNvPr id="33" name="">
             <a:extLst xmlns:a="http://schemas.openxmlformats.org/drawingml/2006/main">
               <a:ext uri="{FF2B5EF4-FFF2-40B4-BE49-F238E27FC236}">
-                <a16:creationId xmlns:a16="http://schemas.microsoft.com/office/drawing/2014/main" id="{2748FC99-D7C4-4754-9258-9CD18AB3657B}"/>
+                <a16:creationId xmlns:a16="http://schemas.microsoft.com/office/drawing/2014/main" id="{3EC4C30C-8D2C-4196-830F-05D970703F1D}"/>
               </a:ext>
             </a:extLst>
           </p:cNvPr>
@@ -22005,7 +22005,7 @@
           <p:cNvPr id="34" name="">
             <a:extLst xmlns:a="http://schemas.openxmlformats.org/drawingml/2006/main">
               <a:ext uri="{FF2B5EF4-FFF2-40B4-BE49-F238E27FC236}">
-                <a16:creationId xmlns:a16="http://schemas.microsoft.com/office/drawing/2014/main" id="{2CD6B731-E7FA-40F1-B205-4336C1CAC185}"/>
+                <a16:creationId xmlns:a16="http://schemas.microsoft.com/office/drawing/2014/main" id="{EEDBCF0A-380B-4E95-A37A-42A08DA8D1D3}"/>
               </a:ext>
             </a:extLst>
           </p:cNvPr>
@@ -22080,7 +22080,7 @@
           <p:cNvPr id="35" name="">
             <a:extLst xmlns:a="http://schemas.openxmlformats.org/drawingml/2006/main">
               <a:ext uri="{FF2B5EF4-FFF2-40B4-BE49-F238E27FC236}">
-                <a16:creationId xmlns:a16="http://schemas.microsoft.com/office/drawing/2014/main" id="{E13B7440-C02F-4EC7-8EFD-189C62192BA5}"/>
+                <a16:creationId xmlns:a16="http://schemas.microsoft.com/office/drawing/2014/main" id="{22CD506D-F641-41DD-88DC-FCA00E9D8611}"/>
               </a:ext>
             </a:extLst>
           </p:cNvPr>
@@ -22115,7 +22115,7 @@
           <p:cNvPr id="36" name="">
             <a:extLst xmlns:a="http://schemas.openxmlformats.org/drawingml/2006/main">
               <a:ext uri="{FF2B5EF4-FFF2-40B4-BE49-F238E27FC236}">
-                <a16:creationId xmlns:a16="http://schemas.microsoft.com/office/drawing/2014/main" id="{BA543EF9-5C5B-4C79-B6D3-4D987E29399B}"/>
+                <a16:creationId xmlns:a16="http://schemas.microsoft.com/office/drawing/2014/main" id="{5920AE66-3884-451B-8F9D-1BAB4E3C3A2E}"/>
               </a:ext>
             </a:extLst>
           </p:cNvPr>
@@ -22150,7 +22150,7 @@
           <p:cNvPr id="37" name="">
             <a:extLst xmlns:a="http://schemas.openxmlformats.org/drawingml/2006/main">
               <a:ext uri="{FF2B5EF4-FFF2-40B4-BE49-F238E27FC236}">
-                <a16:creationId xmlns:a16="http://schemas.microsoft.com/office/drawing/2014/main" id="{5AD0FC12-FFBF-4E35-BA98-15E83B08762A}"/>
+                <a16:creationId xmlns:a16="http://schemas.microsoft.com/office/drawing/2014/main" id="{15403CA1-32C6-463B-9507-998239D9E13A}"/>
               </a:ext>
             </a:extLst>
           </p:cNvPr>
@@ -22204,7 +22204,7 @@
           <p:cNvPr id="38" name="">
             <a:extLst xmlns:a="http://schemas.openxmlformats.org/drawingml/2006/main">
               <a:ext uri="{FF2B5EF4-FFF2-40B4-BE49-F238E27FC236}">
-                <a16:creationId xmlns:a16="http://schemas.microsoft.com/office/drawing/2014/main" id="{89C290EC-621D-43B9-82CD-1E99EF6B652C}"/>
+                <a16:creationId xmlns:a16="http://schemas.microsoft.com/office/drawing/2014/main" id="{6F79E876-D539-4D5F-B7C4-42359F3752E2}"/>
               </a:ext>
             </a:extLst>
           </p:cNvPr>
@@ -22262,7 +22262,7 @@
           <p:cNvPr id="39" name="">
             <a:extLst xmlns:a="http://schemas.openxmlformats.org/drawingml/2006/main">
               <a:ext uri="{FF2B5EF4-FFF2-40B4-BE49-F238E27FC236}">
-                <a16:creationId xmlns:a16="http://schemas.microsoft.com/office/drawing/2014/main" id="{31F8EA1D-81CF-4441-A188-78D82294DE75}"/>
+                <a16:creationId xmlns:a16="http://schemas.microsoft.com/office/drawing/2014/main" id="{6562B66C-F791-416F-90F6-C51F50814C9F}"/>
               </a:ext>
             </a:extLst>
           </p:cNvPr>
@@ -22320,7 +22320,7 @@
           <p:cNvPr id="40" name="">
             <a:extLst xmlns:a="http://schemas.openxmlformats.org/drawingml/2006/main">
               <a:ext uri="{FF2B5EF4-FFF2-40B4-BE49-F238E27FC236}">
-                <a16:creationId xmlns:a16="http://schemas.microsoft.com/office/drawing/2014/main" id="{4C545E09-4AD1-438E-9542-643FABD75D0B}"/>
+                <a16:creationId xmlns:a16="http://schemas.microsoft.com/office/drawing/2014/main" id="{7E6AB907-563F-416C-81BC-7A1C2637B8C4}"/>
               </a:ext>
             </a:extLst>
           </p:cNvPr>
@@ -22355,7 +22355,7 @@
           <p:cNvPr id="41" name="">
             <a:extLst xmlns:a="http://schemas.openxmlformats.org/drawingml/2006/main">
               <a:ext uri="{FF2B5EF4-FFF2-40B4-BE49-F238E27FC236}">
-                <a16:creationId xmlns:a16="http://schemas.microsoft.com/office/drawing/2014/main" id="{69EF7A7C-95DE-4F52-847A-EB7E661CAAC5}"/>
+                <a16:creationId xmlns:a16="http://schemas.microsoft.com/office/drawing/2014/main" id="{A4B501BC-938D-4FCB-B152-8B3100163BAB}"/>
               </a:ext>
             </a:extLst>
           </p:cNvPr>
@@ -22390,7 +22390,7 @@
           <p:cNvPr id="42" name="">
             <a:extLst xmlns:a="http://schemas.openxmlformats.org/drawingml/2006/main">
               <a:ext uri="{FF2B5EF4-FFF2-40B4-BE49-F238E27FC236}">
-                <a16:creationId xmlns:a16="http://schemas.microsoft.com/office/drawing/2014/main" id="{1F038F2F-B4FA-4608-A2D8-E66C9EF52C67}"/>
+                <a16:creationId xmlns:a16="http://schemas.microsoft.com/office/drawing/2014/main" id="{FF491E50-0B03-4462-981B-23E38BFCF817}"/>
               </a:ext>
             </a:extLst>
           </p:cNvPr>
@@ -22444,7 +22444,7 @@
           <p:cNvPr id="43" name="">
             <a:extLst xmlns:a="http://schemas.openxmlformats.org/drawingml/2006/main">
               <a:ext uri="{FF2B5EF4-FFF2-40B4-BE49-F238E27FC236}">
-                <a16:creationId xmlns:a16="http://schemas.microsoft.com/office/drawing/2014/main" id="{6155B6F0-D65E-4B50-9824-C1AE8B412628}"/>
+                <a16:creationId xmlns:a16="http://schemas.microsoft.com/office/drawing/2014/main" id="{5464E2BA-EBB5-4466-B5B0-CD83CDE87DF7}"/>
               </a:ext>
             </a:extLst>
           </p:cNvPr>
@@ -22502,7 +22502,7 @@
           <p:cNvPr id="44" name="">
             <a:extLst xmlns:a="http://schemas.openxmlformats.org/drawingml/2006/main">
               <a:ext uri="{FF2B5EF4-FFF2-40B4-BE49-F238E27FC236}">
-                <a16:creationId xmlns:a16="http://schemas.microsoft.com/office/drawing/2014/main" id="{90F93CD9-0BCD-4873-905D-3CED4F033412}"/>
+                <a16:creationId xmlns:a16="http://schemas.microsoft.com/office/drawing/2014/main" id="{63920550-CEED-4767-BF7F-E82E102E718B}"/>
               </a:ext>
             </a:extLst>
           </p:cNvPr>
@@ -22577,7 +22577,7 @@
           <p:cNvPr id="45" name="">
             <a:extLst xmlns:a="http://schemas.openxmlformats.org/drawingml/2006/main">
               <a:ext uri="{FF2B5EF4-FFF2-40B4-BE49-F238E27FC236}">
-                <a16:creationId xmlns:a16="http://schemas.microsoft.com/office/drawing/2014/main" id="{C51802D3-252C-48B9-AC56-2390EEA8AB1C}"/>
+                <a16:creationId xmlns:a16="http://schemas.microsoft.com/office/drawing/2014/main" id="{0C10FABC-B120-4C5A-97C7-720D26E62A0A}"/>
               </a:ext>
             </a:extLst>
           </p:cNvPr>
@@ -22612,7 +22612,7 @@
           <p:cNvPr id="46" name="">
             <a:extLst xmlns:a="http://schemas.openxmlformats.org/drawingml/2006/main">
               <a:ext uri="{FF2B5EF4-FFF2-40B4-BE49-F238E27FC236}">
-                <a16:creationId xmlns:a16="http://schemas.microsoft.com/office/drawing/2014/main" id="{B19B87B3-76FF-4BF9-9697-A0E29DB9A260}"/>
+                <a16:creationId xmlns:a16="http://schemas.microsoft.com/office/drawing/2014/main" id="{7F875B4C-A895-41E0-BB9F-DC533D761AAD}"/>
               </a:ext>
             </a:extLst>
           </p:cNvPr>
@@ -22647,7 +22647,7 @@
           <p:cNvPr id="47" name="">
             <a:extLst xmlns:a="http://schemas.openxmlformats.org/drawingml/2006/main">
               <a:ext uri="{FF2B5EF4-FFF2-40B4-BE49-F238E27FC236}">
-                <a16:creationId xmlns:a16="http://schemas.microsoft.com/office/drawing/2014/main" id="{7ACD2C6D-F892-4900-8756-2FA9B9660ADC}"/>
+                <a16:creationId xmlns:a16="http://schemas.microsoft.com/office/drawing/2014/main" id="{072048F9-B990-4644-BC8A-9AA5D1C207AB}"/>
               </a:ext>
             </a:extLst>
           </p:cNvPr>
@@ -22682,7 +22682,7 @@
           <p:cNvPr id="48" name="">
             <a:extLst xmlns:a="http://schemas.openxmlformats.org/drawingml/2006/main">
               <a:ext uri="{FF2B5EF4-FFF2-40B4-BE49-F238E27FC236}">
-                <a16:creationId xmlns:a16="http://schemas.microsoft.com/office/drawing/2014/main" id="{27E47690-C0D2-4910-9714-E25213BFECA8}"/>
+                <a16:creationId xmlns:a16="http://schemas.microsoft.com/office/drawing/2014/main" id="{83C34EE9-1F43-4332-A656-7B233F57CB75}"/>
               </a:ext>
             </a:extLst>
           </p:cNvPr>
@@ -22717,7 +22717,7 @@
           <p:cNvPr id="49" name="">
             <a:extLst xmlns:a="http://schemas.openxmlformats.org/drawingml/2006/main">
               <a:ext uri="{FF2B5EF4-FFF2-40B4-BE49-F238E27FC236}">
-                <a16:creationId xmlns:a16="http://schemas.microsoft.com/office/drawing/2014/main" id="{E157E7E5-F9FC-4A27-94F5-EDC08477E230}"/>
+                <a16:creationId xmlns:a16="http://schemas.microsoft.com/office/drawing/2014/main" id="{9CBEC728-ED42-4A82-8345-9552D86192EF}"/>
               </a:ext>
             </a:extLst>
           </p:cNvPr>
@@ -22752,7 +22752,7 @@
           <p:cNvPr id="50" name="">
             <a:extLst xmlns:a="http://schemas.openxmlformats.org/drawingml/2006/main">
               <a:ext uri="{FF2B5EF4-FFF2-40B4-BE49-F238E27FC236}">
-                <a16:creationId xmlns:a16="http://schemas.microsoft.com/office/drawing/2014/main" id="{1D9C8354-5021-464F-A660-F31A803C2987}"/>
+                <a16:creationId xmlns:a16="http://schemas.microsoft.com/office/drawing/2014/main" id="{5A2E8AFC-3793-4E34-A4D2-43D1F3E17A55}"/>
               </a:ext>
             </a:extLst>
           </p:cNvPr>
@@ -22787,7 +22787,7 @@
           <p:cNvPr id="51" name="">
             <a:extLst xmlns:a="http://schemas.openxmlformats.org/drawingml/2006/main">
               <a:ext uri="{FF2B5EF4-FFF2-40B4-BE49-F238E27FC236}">
-                <a16:creationId xmlns:a16="http://schemas.microsoft.com/office/drawing/2014/main" id="{8F2FB8E5-F8B2-4158-B10F-B300C51EEE63}"/>
+                <a16:creationId xmlns:a16="http://schemas.microsoft.com/office/drawing/2014/main" id="{010F8844-770E-4319-8906-71A3430E4BAA}"/>
               </a:ext>
             </a:extLst>
           </p:cNvPr>
@@ -22845,7 +22845,7 @@
           <p:cNvPr id="52" name="">
             <a:extLst xmlns:a="http://schemas.openxmlformats.org/drawingml/2006/main">
               <a:ext uri="{FF2B5EF4-FFF2-40B4-BE49-F238E27FC236}">
-                <a16:creationId xmlns:a16="http://schemas.microsoft.com/office/drawing/2014/main" id="{CCED1B1E-1670-4FFA-AC21-417B0C173E75}"/>
+                <a16:creationId xmlns:a16="http://schemas.microsoft.com/office/drawing/2014/main" id="{DFBEF597-C654-4149-AAF3-343200BE5AFD}"/>
               </a:ext>
             </a:extLst>
           </p:cNvPr>
@@ -22880,7 +22880,7 @@
           <p:cNvPr id="53" name="">
             <a:extLst xmlns:a="http://schemas.openxmlformats.org/drawingml/2006/main">
               <a:ext uri="{FF2B5EF4-FFF2-40B4-BE49-F238E27FC236}">
-                <a16:creationId xmlns:a16="http://schemas.microsoft.com/office/drawing/2014/main" id="{791E1527-6CF3-483D-9FF6-AD89EC0895C6}"/>
+                <a16:creationId xmlns:a16="http://schemas.microsoft.com/office/drawing/2014/main" id="{4BC6D6D1-AD32-4568-A423-6BEBD0013DA4}"/>
               </a:ext>
             </a:extLst>
           </p:cNvPr>
@@ -22938,7 +22938,7 @@
           <p:cNvPr id="54" name="">
             <a:extLst xmlns:a="http://schemas.openxmlformats.org/drawingml/2006/main">
               <a:ext uri="{FF2B5EF4-FFF2-40B4-BE49-F238E27FC236}">
-                <a16:creationId xmlns:a16="http://schemas.microsoft.com/office/drawing/2014/main" id="{8A63AEAE-886B-4F5E-9C3B-ECDE5EA059D8}"/>
+                <a16:creationId xmlns:a16="http://schemas.microsoft.com/office/drawing/2014/main" id="{F9909AA2-985E-49C0-BA79-6764180ADD0A}"/>
               </a:ext>
             </a:extLst>
           </p:cNvPr>
@@ -22975,7 +22975,7 @@
           <p:cNvPr id="55" name="">
             <a:extLst xmlns:a="http://schemas.openxmlformats.org/drawingml/2006/main">
               <a:ext uri="{FF2B5EF4-FFF2-40B4-BE49-F238E27FC236}">
-                <a16:creationId xmlns:a16="http://schemas.microsoft.com/office/drawing/2014/main" id="{8F14BB60-1E74-4761-BC13-C88D6616FE9F}"/>
+                <a16:creationId xmlns:a16="http://schemas.microsoft.com/office/drawing/2014/main" id="{639E0E94-927C-435B-86AD-C11666BEDDBB}"/>
               </a:ext>
             </a:extLst>
           </p:cNvPr>
@@ -23010,7 +23010,7 @@
           <p:cNvPr id="56" name="">
             <a:extLst xmlns:a="http://schemas.openxmlformats.org/drawingml/2006/main">
               <a:ext uri="{FF2B5EF4-FFF2-40B4-BE49-F238E27FC236}">
-                <a16:creationId xmlns:a16="http://schemas.microsoft.com/office/drawing/2014/main" id="{669E1434-AF0F-4C55-9AC5-15106BDE6303}"/>
+                <a16:creationId xmlns:a16="http://schemas.microsoft.com/office/drawing/2014/main" id="{A6425D93-FF10-4AE7-9CC7-8B39AC38B3C5}"/>
               </a:ext>
             </a:extLst>
           </p:cNvPr>
@@ -23068,7 +23068,7 @@
           <p:cNvPr id="57" name="">
             <a:extLst xmlns:a="http://schemas.openxmlformats.org/drawingml/2006/main">
               <a:ext uri="{FF2B5EF4-FFF2-40B4-BE49-F238E27FC236}">
-                <a16:creationId xmlns:a16="http://schemas.microsoft.com/office/drawing/2014/main" id="{B0A40E9D-093C-4F79-95E1-46E08596A736}"/>
+                <a16:creationId xmlns:a16="http://schemas.microsoft.com/office/drawing/2014/main" id="{D57EEF40-D496-482E-A658-BCFC7E139D7A}"/>
               </a:ext>
             </a:extLst>
           </p:cNvPr>
@@ -23124,7 +23124,7 @@
     </p:spTree>
     <p:extLst>
       <p:ext uri="{BB962C8B-B14F-4D97-AF65-F5344CB8AC3E}">
-        <p14:creationId xmlns:p14="http://schemas.microsoft.com/office/powerpoint/2010/main" val="1452701621"/>
+        <p14:creationId xmlns:p14="http://schemas.microsoft.com/office/powerpoint/2010/main" val="1286943054"/>
       </p:ext>
     </p:extLst>
   </p:cSld>
@@ -23155,7 +23155,7 @@
           <p:cNvPr id="1" name="Slide Number Placeholder 5">
             <a:extLst xmlns:a="http://schemas.openxmlformats.org/drawingml/2006/main">
               <a:ext uri="{FF2B5EF4-FFF2-40B4-BE49-F238E27FC236}">
-                <a16:creationId xmlns:a16="http://schemas.microsoft.com/office/drawing/2014/main" id="{821508BF-91E3-4E78-84B3-DCBD229C8660}"/>
+                <a16:creationId xmlns:a16="http://schemas.microsoft.com/office/drawing/2014/main" id="{11DAD1DA-DD27-4C25-AFB7-E057ACC56EC0}"/>
               </a:ext>
             </a:extLst>
           </p:cNvPr>
@@ -23191,7 +23191,7 @@
           <p:nvPr/>
         </p:nvPicPr>
         <p:blipFill>
-          <a:blip xmlns:r="http://schemas.openxmlformats.org/officeDocument/2006/relationships" xmlns:a="http://schemas.openxmlformats.org/drawingml/2006/main" r:embed="R7dc9c9e4be7b4005"/>
+          <a:blip xmlns:r="http://schemas.openxmlformats.org/officeDocument/2006/relationships" xmlns:a="http://schemas.openxmlformats.org/drawingml/2006/main" r:embed="R77907492fdcc4418"/>
           <a:srcRect xmlns:a="http://schemas.openxmlformats.org/drawingml/2006/main" l="0" t="21875" r="0" b="21875"/>
           <a:stretch xmlns:a="http://schemas.openxmlformats.org/drawingml/2006/main">
             <a:fillRect l="0" t="0" r="0" b="0"/>
@@ -23212,7 +23212,7 @@
           <p:cNvPr id="3" name="">
             <a:extLst xmlns:a="http://schemas.openxmlformats.org/drawingml/2006/main">
               <a:ext uri="{FF2B5EF4-FFF2-40B4-BE49-F238E27FC236}">
-                <a16:creationId xmlns:a16="http://schemas.microsoft.com/office/drawing/2014/main" id="{1EE6513C-032F-4295-83E4-6A5527FA59F0}"/>
+                <a16:creationId xmlns:a16="http://schemas.microsoft.com/office/drawing/2014/main" id="{EBCECFEB-BAE1-4047-A719-F9D245A3F623}"/>
               </a:ext>
             </a:extLst>
           </p:cNvPr>
@@ -23247,7 +23247,7 @@
           <p:cNvPr id="4" name="">
             <a:extLst xmlns:a="http://schemas.openxmlformats.org/drawingml/2006/main">
               <a:ext uri="{FF2B5EF4-FFF2-40B4-BE49-F238E27FC236}">
-                <a16:creationId xmlns:a16="http://schemas.microsoft.com/office/drawing/2014/main" id="{78610F57-B1BD-4FCB-AC6F-D02DD75C015E}"/>
+                <a16:creationId xmlns:a16="http://schemas.microsoft.com/office/drawing/2014/main" id="{E9518692-F04D-44E7-BB72-FE49ADE53CE2}"/>
               </a:ext>
             </a:extLst>
           </p:cNvPr>
@@ -23282,7 +23282,7 @@
           <p:cNvPr id="5" name="">
             <a:extLst xmlns:a="http://schemas.openxmlformats.org/drawingml/2006/main">
               <a:ext uri="{FF2B5EF4-FFF2-40B4-BE49-F238E27FC236}">
-                <a16:creationId xmlns:a16="http://schemas.microsoft.com/office/drawing/2014/main" id="{463E0690-8E42-47C6-AA8A-9A84601ED919}"/>
+                <a16:creationId xmlns:a16="http://schemas.microsoft.com/office/drawing/2014/main" id="{60C96497-32CB-46EB-9358-07ED7C62C24A}"/>
               </a:ext>
             </a:extLst>
           </p:cNvPr>
@@ -23319,7 +23319,7 @@
           <p:cNvPr id="6" name="">
             <a:extLst xmlns:a="http://schemas.openxmlformats.org/drawingml/2006/main">
               <a:ext uri="{FF2B5EF4-FFF2-40B4-BE49-F238E27FC236}">
-                <a16:creationId xmlns:a16="http://schemas.microsoft.com/office/drawing/2014/main" id="{26EE496C-91EE-4507-BA41-620A502A6B57}"/>
+                <a16:creationId xmlns:a16="http://schemas.microsoft.com/office/drawing/2014/main" id="{42EB4150-8A37-4902-95EC-C4AB2C969BDC}"/>
               </a:ext>
             </a:extLst>
           </p:cNvPr>
@@ -23356,7 +23356,7 @@
           <p:cNvPr id="7" name="">
             <a:extLst xmlns:a="http://schemas.openxmlformats.org/drawingml/2006/main">
               <a:ext uri="{FF2B5EF4-FFF2-40B4-BE49-F238E27FC236}">
-                <a16:creationId xmlns:a16="http://schemas.microsoft.com/office/drawing/2014/main" id="{1E6E88FD-CFDD-4533-A24B-E419EFE2301C}"/>
+                <a16:creationId xmlns:a16="http://schemas.microsoft.com/office/drawing/2014/main" id="{D63694F7-3E9C-4AA2-A102-2D503E776B01}"/>
               </a:ext>
             </a:extLst>
           </p:cNvPr>
@@ -23393,7 +23393,7 @@
           <p:cNvPr id="8" name="">
             <a:extLst xmlns:a="http://schemas.openxmlformats.org/drawingml/2006/main">
               <a:ext uri="{FF2B5EF4-FFF2-40B4-BE49-F238E27FC236}">
-                <a16:creationId xmlns:a16="http://schemas.microsoft.com/office/drawing/2014/main" id="{BD002ACF-D3D4-4690-94C5-BC24553992B2}"/>
+                <a16:creationId xmlns:a16="http://schemas.microsoft.com/office/drawing/2014/main" id="{44050DC5-57FF-41A4-9920-F1C0141533EB}"/>
               </a:ext>
             </a:extLst>
           </p:cNvPr>
@@ -23430,7 +23430,7 @@
           <p:cNvPr id="9" name="">
             <a:extLst xmlns:a="http://schemas.openxmlformats.org/drawingml/2006/main">
               <a:ext uri="{FF2B5EF4-FFF2-40B4-BE49-F238E27FC236}">
-                <a16:creationId xmlns:a16="http://schemas.microsoft.com/office/drawing/2014/main" id="{9CACEF77-A55B-4409-978E-7009E67CE1A6}"/>
+                <a16:creationId xmlns:a16="http://schemas.microsoft.com/office/drawing/2014/main" id="{03A505DE-4FCF-4EEF-96BB-22D83BEC3FCC}"/>
               </a:ext>
             </a:extLst>
           </p:cNvPr>
@@ -23488,7 +23488,7 @@
           <p:cNvPr id="10" name="">
             <a:extLst xmlns:a="http://schemas.openxmlformats.org/drawingml/2006/main">
               <a:ext uri="{FF2B5EF4-FFF2-40B4-BE49-F238E27FC236}">
-                <a16:creationId xmlns:a16="http://schemas.microsoft.com/office/drawing/2014/main" id="{8444F6E1-78AA-4AC4-B5C0-B09CC1FCB835}"/>
+                <a16:creationId xmlns:a16="http://schemas.microsoft.com/office/drawing/2014/main" id="{4E91D3B5-613F-4AD2-9B49-6BD7670BB379}"/>
               </a:ext>
             </a:extLst>
           </p:cNvPr>
@@ -23546,7 +23546,7 @@
           <p:cNvPr id="11" name="">
             <a:extLst xmlns:a="http://schemas.openxmlformats.org/drawingml/2006/main">
               <a:ext uri="{FF2B5EF4-FFF2-40B4-BE49-F238E27FC236}">
-                <a16:creationId xmlns:a16="http://schemas.microsoft.com/office/drawing/2014/main" id="{732F21EA-99B6-41B1-81E7-AFD1A955B794}"/>
+                <a16:creationId xmlns:a16="http://schemas.microsoft.com/office/drawing/2014/main" id="{D3CFDAC5-9954-489C-9D35-235ECA3527EB}"/>
               </a:ext>
             </a:extLst>
           </p:cNvPr>
@@ -23581,7 +23581,7 @@
           <p:cNvPr id="12" name="">
             <a:extLst xmlns:a="http://schemas.openxmlformats.org/drawingml/2006/main">
               <a:ext uri="{FF2B5EF4-FFF2-40B4-BE49-F238E27FC236}">
-                <a16:creationId xmlns:a16="http://schemas.microsoft.com/office/drawing/2014/main" id="{B0989534-8783-49BD-A476-01BB650091C9}"/>
+                <a16:creationId xmlns:a16="http://schemas.microsoft.com/office/drawing/2014/main" id="{8CE8CD85-8AB8-49DF-8AFC-FE6F0B2AC5DC}"/>
               </a:ext>
             </a:extLst>
           </p:cNvPr>
@@ -23614,7 +23614,7 @@
           <p:cNvPr id="13" name="">
             <a:extLst xmlns:a="http://schemas.openxmlformats.org/drawingml/2006/main">
               <a:ext uri="{FF2B5EF4-FFF2-40B4-BE49-F238E27FC236}">
-                <a16:creationId xmlns:a16="http://schemas.microsoft.com/office/drawing/2014/main" id="{470C0455-423A-4383-8A6C-3CB4C01E4D91}"/>
+                <a16:creationId xmlns:a16="http://schemas.microsoft.com/office/drawing/2014/main" id="{61CAC047-80AF-43EC-9139-1ACB1168DF1F}"/>
               </a:ext>
             </a:extLst>
           </p:cNvPr>
@@ -23689,7 +23689,7 @@
           <p:cNvPr id="14" name="">
             <a:extLst xmlns:a="http://schemas.openxmlformats.org/drawingml/2006/main">
               <a:ext uri="{FF2B5EF4-FFF2-40B4-BE49-F238E27FC236}">
-                <a16:creationId xmlns:a16="http://schemas.microsoft.com/office/drawing/2014/main" id="{BC2E87CE-2484-4BFF-9C41-C6FADDF8F642}"/>
+                <a16:creationId xmlns:a16="http://schemas.microsoft.com/office/drawing/2014/main" id="{9C4FD56F-5E58-4873-8A6C-32828A1DF110}"/>
               </a:ext>
             </a:extLst>
           </p:cNvPr>
@@ -23724,7 +23724,7 @@
           <p:cNvPr id="15" name="">
             <a:extLst xmlns:a="http://schemas.openxmlformats.org/drawingml/2006/main">
               <a:ext uri="{FF2B5EF4-FFF2-40B4-BE49-F238E27FC236}">
-                <a16:creationId xmlns:a16="http://schemas.microsoft.com/office/drawing/2014/main" id="{201E9DE1-C062-47E1-8FF6-C3585E4097B4}"/>
+                <a16:creationId xmlns:a16="http://schemas.microsoft.com/office/drawing/2014/main" id="{994627BF-470D-4FD0-B8D2-2E7963A4E651}"/>
               </a:ext>
             </a:extLst>
           </p:cNvPr>
@@ -23759,7 +23759,7 @@
           <p:cNvPr id="16" name="">
             <a:extLst xmlns:a="http://schemas.openxmlformats.org/drawingml/2006/main">
               <a:ext uri="{FF2B5EF4-FFF2-40B4-BE49-F238E27FC236}">
-                <a16:creationId xmlns:a16="http://schemas.microsoft.com/office/drawing/2014/main" id="{C7A2CDDF-92B8-4B06-A971-3CD0556B6C3F}"/>
+                <a16:creationId xmlns:a16="http://schemas.microsoft.com/office/drawing/2014/main" id="{E0381D60-8070-42BA-A24C-4845B4647092}"/>
               </a:ext>
             </a:extLst>
           </p:cNvPr>
@@ -23817,7 +23817,7 @@
           <p:cNvPr id="17" name="">
             <a:extLst xmlns:a="http://schemas.openxmlformats.org/drawingml/2006/main">
               <a:ext uri="{FF2B5EF4-FFF2-40B4-BE49-F238E27FC236}">
-                <a16:creationId xmlns:a16="http://schemas.microsoft.com/office/drawing/2014/main" id="{212EA124-0C6D-4E82-857A-31208E63C9C2}"/>
+                <a16:creationId xmlns:a16="http://schemas.microsoft.com/office/drawing/2014/main" id="{5393955F-2214-459A-8714-80D95AF4C931}"/>
               </a:ext>
             </a:extLst>
           </p:cNvPr>
@@ -23854,7 +23854,7 @@
           <p:cNvPr id="18" name="">
             <a:extLst xmlns:a="http://schemas.openxmlformats.org/drawingml/2006/main">
               <a:ext uri="{FF2B5EF4-FFF2-40B4-BE49-F238E27FC236}">
-                <a16:creationId xmlns:a16="http://schemas.microsoft.com/office/drawing/2014/main" id="{9EDCD5AF-D9FA-4BCC-9BB9-7390381832D4}"/>
+                <a16:creationId xmlns:a16="http://schemas.microsoft.com/office/drawing/2014/main" id="{C485C26F-7378-49EB-A61F-E0E9BD2D8D00}"/>
               </a:ext>
             </a:extLst>
           </p:cNvPr>
@@ -23889,7 +23889,7 @@
           <p:cNvPr id="19" name="">
             <a:extLst xmlns:a="http://schemas.openxmlformats.org/drawingml/2006/main">
               <a:ext uri="{FF2B5EF4-FFF2-40B4-BE49-F238E27FC236}">
-                <a16:creationId xmlns:a16="http://schemas.microsoft.com/office/drawing/2014/main" id="{8E4B862E-CEA6-40B3-9FA1-E39221F8AA7C}"/>
+                <a16:creationId xmlns:a16="http://schemas.microsoft.com/office/drawing/2014/main" id="{6F42EF5A-98B0-4B88-BEB6-3408FF0BA091}"/>
               </a:ext>
             </a:extLst>
           </p:cNvPr>
@@ -23947,7 +23947,7 @@
           <p:cNvPr id="20" name="">
             <a:extLst xmlns:a="http://schemas.openxmlformats.org/drawingml/2006/main">
               <a:ext uri="{FF2B5EF4-FFF2-40B4-BE49-F238E27FC236}">
-                <a16:creationId xmlns:a16="http://schemas.microsoft.com/office/drawing/2014/main" id="{5F91277C-0396-47B7-ACA6-CB27272B11B7}"/>
+                <a16:creationId xmlns:a16="http://schemas.microsoft.com/office/drawing/2014/main" id="{69E6B4B7-4724-451E-B358-DBBD0F17264B}"/>
               </a:ext>
             </a:extLst>
           </p:cNvPr>
@@ -24039,7 +24039,7 @@
           <p:cNvPr id="21" name="">
             <a:extLst xmlns:a="http://schemas.openxmlformats.org/drawingml/2006/main">
               <a:ext uri="{FF2B5EF4-FFF2-40B4-BE49-F238E27FC236}">
-                <a16:creationId xmlns:a16="http://schemas.microsoft.com/office/drawing/2014/main" id="{91481650-523F-4CF1-AF40-8E32B58DD8D5}"/>
+                <a16:creationId xmlns:a16="http://schemas.microsoft.com/office/drawing/2014/main" id="{932E77E7-F8C6-4E3F-93BE-B27CB3E38190}"/>
               </a:ext>
             </a:extLst>
           </p:cNvPr>
@@ -24076,7 +24076,7 @@
           <p:cNvPr id="22" name="">
             <a:extLst xmlns:a="http://schemas.openxmlformats.org/drawingml/2006/main">
               <a:ext uri="{FF2B5EF4-FFF2-40B4-BE49-F238E27FC236}">
-                <a16:creationId xmlns:a16="http://schemas.microsoft.com/office/drawing/2014/main" id="{B7DC8406-B4A3-4DF4-B589-5289E6D96C76}"/>
+                <a16:creationId xmlns:a16="http://schemas.microsoft.com/office/drawing/2014/main" id="{D1C00CAD-F9FB-45F2-8DF6-15270B4018C6}"/>
               </a:ext>
             </a:extLst>
           </p:cNvPr>
@@ -24111,7 +24111,7 @@
           <p:cNvPr id="23" name="">
             <a:extLst xmlns:a="http://schemas.openxmlformats.org/drawingml/2006/main">
               <a:ext uri="{FF2B5EF4-FFF2-40B4-BE49-F238E27FC236}">
-                <a16:creationId xmlns:a16="http://schemas.microsoft.com/office/drawing/2014/main" id="{E46AEC25-26E8-44AA-89F4-B71921DD7E03}"/>
+                <a16:creationId xmlns:a16="http://schemas.microsoft.com/office/drawing/2014/main" id="{BDF0BA20-C0EC-44CD-9791-0E0AD5FB22FA}"/>
               </a:ext>
             </a:extLst>
           </p:cNvPr>
@@ -24169,7 +24169,7 @@
           <p:cNvPr id="24" name="">
             <a:extLst xmlns:a="http://schemas.openxmlformats.org/drawingml/2006/main">
               <a:ext uri="{FF2B5EF4-FFF2-40B4-BE49-F238E27FC236}">
-                <a16:creationId xmlns:a16="http://schemas.microsoft.com/office/drawing/2014/main" id="{F8E21D70-923A-4588-B711-106DD7E90244}"/>
+                <a16:creationId xmlns:a16="http://schemas.microsoft.com/office/drawing/2014/main" id="{AEA41F58-B439-48AE-AF23-40812F8349E6}"/>
               </a:ext>
             </a:extLst>
           </p:cNvPr>
@@ -24278,7 +24278,7 @@
           <p:cNvPr id="25" name="">
             <a:extLst xmlns:a="http://schemas.openxmlformats.org/drawingml/2006/main">
               <a:ext uri="{FF2B5EF4-FFF2-40B4-BE49-F238E27FC236}">
-                <a16:creationId xmlns:a16="http://schemas.microsoft.com/office/drawing/2014/main" id="{BA86B7A1-CAD8-48D2-A828-0B1EBC83360B}"/>
+                <a16:creationId xmlns:a16="http://schemas.microsoft.com/office/drawing/2014/main" id="{AF3B37D5-E846-4A6A-BFA4-D7F69EF915D8}"/>
               </a:ext>
             </a:extLst>
           </p:cNvPr>
@@ -24311,7 +24311,7 @@
           <p:cNvPr id="26" name="">
             <a:extLst xmlns:a="http://schemas.openxmlformats.org/drawingml/2006/main">
               <a:ext uri="{FF2B5EF4-FFF2-40B4-BE49-F238E27FC236}">
-                <a16:creationId xmlns:a16="http://schemas.microsoft.com/office/drawing/2014/main" id="{4060898C-2D2B-46AA-8E1F-94C100446FDD}"/>
+                <a16:creationId xmlns:a16="http://schemas.microsoft.com/office/drawing/2014/main" id="{FD913233-8FDF-41B7-8506-071476041082}"/>
               </a:ext>
             </a:extLst>
           </p:cNvPr>
@@ -24365,7 +24365,7 @@
           <p:cNvPr id="27" name="">
             <a:extLst xmlns:a="http://schemas.openxmlformats.org/drawingml/2006/main">
               <a:ext uri="{FF2B5EF4-FFF2-40B4-BE49-F238E27FC236}">
-                <a16:creationId xmlns:a16="http://schemas.microsoft.com/office/drawing/2014/main" id="{67E72423-C532-40C2-B81D-1A716F6F203A}"/>
+                <a16:creationId xmlns:a16="http://schemas.microsoft.com/office/drawing/2014/main" id="{8ACAE309-7149-4A2E-BAB1-8D7EBE5EF725}"/>
               </a:ext>
             </a:extLst>
           </p:cNvPr>
@@ -24421,7 +24421,7 @@
     </p:spTree>
     <p:extLst>
       <p:ext uri="{BB962C8B-B14F-4D97-AF65-F5344CB8AC3E}">
-        <p14:creationId xmlns:p14="http://schemas.microsoft.com/office/powerpoint/2010/main" val="808700728"/>
+        <p14:creationId xmlns:p14="http://schemas.microsoft.com/office/powerpoint/2010/main" val="671196923"/>
       </p:ext>
     </p:extLst>
   </p:cSld>
@@ -24452,7 +24452,7 @@
           <p:cNvPr id="1" name="Slide Number Placeholder 5">
             <a:extLst xmlns:a="http://schemas.openxmlformats.org/drawingml/2006/main">
               <a:ext uri="{FF2B5EF4-FFF2-40B4-BE49-F238E27FC236}">
-                <a16:creationId xmlns:a16="http://schemas.microsoft.com/office/drawing/2014/main" id="{821508BF-91E3-4E78-84B3-DCBD229C8660}"/>
+                <a16:creationId xmlns:a16="http://schemas.microsoft.com/office/drawing/2014/main" id="{11DAD1DA-DD27-4C25-AFB7-E057ACC56EC0}"/>
               </a:ext>
             </a:extLst>
           </p:cNvPr>
@@ -24488,7 +24488,7 @@
           <p:nvPr/>
         </p:nvPicPr>
         <p:blipFill>
-          <a:blip xmlns:r="http://schemas.openxmlformats.org/officeDocument/2006/relationships" xmlns:a="http://schemas.openxmlformats.org/drawingml/2006/main" r:embed="R3e61cab364154a35"/>
+          <a:blip xmlns:r="http://schemas.openxmlformats.org/officeDocument/2006/relationships" xmlns:a="http://schemas.openxmlformats.org/drawingml/2006/main" r:embed="R21db6cc0b8e444dd"/>
           <a:srcRect xmlns:a="http://schemas.openxmlformats.org/drawingml/2006/main" l="0" t="21875" r="0" b="21875"/>
           <a:stretch xmlns:a="http://schemas.openxmlformats.org/drawingml/2006/main">
             <a:fillRect l="0" t="0" r="0" b="0"/>
@@ -24509,7 +24509,7 @@
           <p:cNvPr id="3" name="">
             <a:extLst xmlns:a="http://schemas.openxmlformats.org/drawingml/2006/main">
               <a:ext uri="{FF2B5EF4-FFF2-40B4-BE49-F238E27FC236}">
-                <a16:creationId xmlns:a16="http://schemas.microsoft.com/office/drawing/2014/main" id="{656A6253-E556-40BA-BE3F-124296DD255C}"/>
+                <a16:creationId xmlns:a16="http://schemas.microsoft.com/office/drawing/2014/main" id="{37E93583-1522-4598-841A-EB636765C1C5}"/>
               </a:ext>
             </a:extLst>
           </p:cNvPr>
@@ -24544,7 +24544,7 @@
           <p:cNvPr id="4" name="">
             <a:extLst xmlns:a="http://schemas.openxmlformats.org/drawingml/2006/main">
               <a:ext uri="{FF2B5EF4-FFF2-40B4-BE49-F238E27FC236}">
-                <a16:creationId xmlns:a16="http://schemas.microsoft.com/office/drawing/2014/main" id="{468322F4-4ED7-4B36-9FB7-44BE1FBF6FD3}"/>
+                <a16:creationId xmlns:a16="http://schemas.microsoft.com/office/drawing/2014/main" id="{E8A2BD58-47D2-467D-9683-C1A44FFB0F00}"/>
               </a:ext>
             </a:extLst>
           </p:cNvPr>
@@ -24579,7 +24579,7 @@
           <p:cNvPr id="5" name="">
             <a:extLst xmlns:a="http://schemas.openxmlformats.org/drawingml/2006/main">
               <a:ext uri="{FF2B5EF4-FFF2-40B4-BE49-F238E27FC236}">
-                <a16:creationId xmlns:a16="http://schemas.microsoft.com/office/drawing/2014/main" id="{F4C778DD-2938-4232-A16C-EFAE108E43BC}"/>
+                <a16:creationId xmlns:a16="http://schemas.microsoft.com/office/drawing/2014/main" id="{47A7DFB9-1BE4-442F-9611-796DD53EA31B}"/>
               </a:ext>
             </a:extLst>
           </p:cNvPr>
@@ -24616,7 +24616,7 @@
           <p:cNvPr id="6" name="">
             <a:extLst xmlns:a="http://schemas.openxmlformats.org/drawingml/2006/main">
               <a:ext uri="{FF2B5EF4-FFF2-40B4-BE49-F238E27FC236}">
-                <a16:creationId xmlns:a16="http://schemas.microsoft.com/office/drawing/2014/main" id="{B4D58B5F-A4C3-4A19-BC72-89A0C571B4F6}"/>
+                <a16:creationId xmlns:a16="http://schemas.microsoft.com/office/drawing/2014/main" id="{508E146D-526E-46D5-8107-F465A14B4C05}"/>
               </a:ext>
             </a:extLst>
           </p:cNvPr>
@@ -24653,7 +24653,7 @@
           <p:cNvPr id="7" name="">
             <a:extLst xmlns:a="http://schemas.openxmlformats.org/drawingml/2006/main">
               <a:ext uri="{FF2B5EF4-FFF2-40B4-BE49-F238E27FC236}">
-                <a16:creationId xmlns:a16="http://schemas.microsoft.com/office/drawing/2014/main" id="{BED0F2D0-38C7-49AD-B50F-3E68763A0D68}"/>
+                <a16:creationId xmlns:a16="http://schemas.microsoft.com/office/drawing/2014/main" id="{B5A07D5C-A4F1-4F01-965A-5C419776387A}"/>
               </a:ext>
             </a:extLst>
           </p:cNvPr>
@@ -24690,7 +24690,7 @@
           <p:cNvPr id="8" name="">
             <a:extLst xmlns:a="http://schemas.openxmlformats.org/drawingml/2006/main">
               <a:ext uri="{FF2B5EF4-FFF2-40B4-BE49-F238E27FC236}">
-                <a16:creationId xmlns:a16="http://schemas.microsoft.com/office/drawing/2014/main" id="{14D17EA6-52C6-491C-A9BC-AACD43FDAB7A}"/>
+                <a16:creationId xmlns:a16="http://schemas.microsoft.com/office/drawing/2014/main" id="{EDBA643C-F7B4-4A7F-ABB9-A170FF5504E3}"/>
               </a:ext>
             </a:extLst>
           </p:cNvPr>
@@ -24727,7 +24727,7 @@
           <p:cNvPr id="9" name="">
             <a:extLst xmlns:a="http://schemas.openxmlformats.org/drawingml/2006/main">
               <a:ext uri="{FF2B5EF4-FFF2-40B4-BE49-F238E27FC236}">
-                <a16:creationId xmlns:a16="http://schemas.microsoft.com/office/drawing/2014/main" id="{7816107B-B4CD-40A3-9876-D8BB0B4B6301}"/>
+                <a16:creationId xmlns:a16="http://schemas.microsoft.com/office/drawing/2014/main" id="{92D8CEB7-32B4-4050-B538-89EF9B6AB117}"/>
               </a:ext>
             </a:extLst>
           </p:cNvPr>
@@ -24785,7 +24785,7 @@
           <p:cNvPr id="10" name="">
             <a:extLst xmlns:a="http://schemas.openxmlformats.org/drawingml/2006/main">
               <a:ext uri="{FF2B5EF4-FFF2-40B4-BE49-F238E27FC236}">
-                <a16:creationId xmlns:a16="http://schemas.microsoft.com/office/drawing/2014/main" id="{0A0A160A-5C40-410B-B497-2E1F85980B59}"/>
+                <a16:creationId xmlns:a16="http://schemas.microsoft.com/office/drawing/2014/main" id="{6F709C5D-41E9-43C9-A120-45559BDD6932}"/>
               </a:ext>
             </a:extLst>
           </p:cNvPr>
@@ -24843,7 +24843,7 @@
           <p:cNvPr id="11" name="">
             <a:extLst xmlns:a="http://schemas.openxmlformats.org/drawingml/2006/main">
               <a:ext uri="{FF2B5EF4-FFF2-40B4-BE49-F238E27FC236}">
-                <a16:creationId xmlns:a16="http://schemas.microsoft.com/office/drawing/2014/main" id="{61928987-0904-4AF7-B0B6-9C5293974BEE}"/>
+                <a16:creationId xmlns:a16="http://schemas.microsoft.com/office/drawing/2014/main" id="{207181AE-9FDC-4117-B4CC-2AF59F83FB68}"/>
               </a:ext>
             </a:extLst>
           </p:cNvPr>
@@ -24878,7 +24878,7 @@
           <p:cNvPr id="12" name="">
             <a:extLst xmlns:a="http://schemas.openxmlformats.org/drawingml/2006/main">
               <a:ext uri="{FF2B5EF4-FFF2-40B4-BE49-F238E27FC236}">
-                <a16:creationId xmlns:a16="http://schemas.microsoft.com/office/drawing/2014/main" id="{DD8A2B2C-E118-4F1A-88D0-10A3421B7662}"/>
+                <a16:creationId xmlns:a16="http://schemas.microsoft.com/office/drawing/2014/main" id="{2900F7C5-E8CE-43F4-B49F-9D5002815441}"/>
               </a:ext>
             </a:extLst>
           </p:cNvPr>
@@ -24911,7 +24911,7 @@
           <p:cNvPr id="13" name="">
             <a:extLst xmlns:a="http://schemas.openxmlformats.org/drawingml/2006/main">
               <a:ext uri="{FF2B5EF4-FFF2-40B4-BE49-F238E27FC236}">
-                <a16:creationId xmlns:a16="http://schemas.microsoft.com/office/drawing/2014/main" id="{F525F956-9FB8-4266-8731-32A45A613D25}"/>
+                <a16:creationId xmlns:a16="http://schemas.microsoft.com/office/drawing/2014/main" id="{4F4BE5B6-1F12-4F70-A046-4E8E9D09B31E}"/>
               </a:ext>
             </a:extLst>
           </p:cNvPr>
@@ -24969,7 +24969,7 @@
           <p:cNvPr id="14" name="">
             <a:extLst xmlns:a="http://schemas.openxmlformats.org/drawingml/2006/main">
               <a:ext uri="{FF2B5EF4-FFF2-40B4-BE49-F238E27FC236}">
-                <a16:creationId xmlns:a16="http://schemas.microsoft.com/office/drawing/2014/main" id="{65B4E764-5EBE-4E84-86B4-456948E1E427}"/>
+                <a16:creationId xmlns:a16="http://schemas.microsoft.com/office/drawing/2014/main" id="{B600317A-C6A2-449B-820B-4B0AEC172C86}"/>
               </a:ext>
             </a:extLst>
           </p:cNvPr>
@@ -25006,7 +25006,7 @@
           <p:cNvPr id="15" name="">
             <a:extLst xmlns:a="http://schemas.openxmlformats.org/drawingml/2006/main">
               <a:ext uri="{FF2B5EF4-FFF2-40B4-BE49-F238E27FC236}">
-                <a16:creationId xmlns:a16="http://schemas.microsoft.com/office/drawing/2014/main" id="{D5CA1698-6372-4367-A131-E5E3F4FA21B9}"/>
+                <a16:creationId xmlns:a16="http://schemas.microsoft.com/office/drawing/2014/main" id="{A2A2B636-90A7-4168-B489-682AFFB0B89B}"/>
               </a:ext>
             </a:extLst>
           </p:cNvPr>
@@ -25041,7 +25041,7 @@
           <p:cNvPr id="16" name="">
             <a:extLst xmlns:a="http://schemas.openxmlformats.org/drawingml/2006/main">
               <a:ext uri="{FF2B5EF4-FFF2-40B4-BE49-F238E27FC236}">
-                <a16:creationId xmlns:a16="http://schemas.microsoft.com/office/drawing/2014/main" id="{4E2CE8CB-CED9-4FB9-9276-081039518CF9}"/>
+                <a16:creationId xmlns:a16="http://schemas.microsoft.com/office/drawing/2014/main" id="{446BAF00-EC77-4BA3-90A6-04D15AE72946}"/>
               </a:ext>
             </a:extLst>
           </p:cNvPr>
@@ -25099,7 +25099,7 @@
           <p:cNvPr id="17" name="">
             <a:extLst xmlns:a="http://schemas.openxmlformats.org/drawingml/2006/main">
               <a:ext uri="{FF2B5EF4-FFF2-40B4-BE49-F238E27FC236}">
-                <a16:creationId xmlns:a16="http://schemas.microsoft.com/office/drawing/2014/main" id="{07047A2E-CD82-416D-A7CE-D0CD59460C9E}"/>
+                <a16:creationId xmlns:a16="http://schemas.microsoft.com/office/drawing/2014/main" id="{6D309E83-0AF4-4B10-BDAD-A8262B3AF120}"/>
               </a:ext>
             </a:extLst>
           </p:cNvPr>
@@ -25191,7 +25191,7 @@
           <p:cNvPr id="18" name="">
             <a:extLst xmlns:a="http://schemas.openxmlformats.org/drawingml/2006/main">
               <a:ext uri="{FF2B5EF4-FFF2-40B4-BE49-F238E27FC236}">
-                <a16:creationId xmlns:a16="http://schemas.microsoft.com/office/drawing/2014/main" id="{94315ED1-2756-48FA-8987-5B46E5ECE0E6}"/>
+                <a16:creationId xmlns:a16="http://schemas.microsoft.com/office/drawing/2014/main" id="{B0E2C8C1-5F47-4C46-9A73-6EECA8BDC322}"/>
               </a:ext>
             </a:extLst>
           </p:cNvPr>
@@ -25228,7 +25228,7 @@
           <p:cNvPr id="19" name="">
             <a:extLst xmlns:a="http://schemas.openxmlformats.org/drawingml/2006/main">
               <a:ext uri="{FF2B5EF4-FFF2-40B4-BE49-F238E27FC236}">
-                <a16:creationId xmlns:a16="http://schemas.microsoft.com/office/drawing/2014/main" id="{A3D751BB-5026-4C46-88A6-4C4F3E0FBA6A}"/>
+                <a16:creationId xmlns:a16="http://schemas.microsoft.com/office/drawing/2014/main" id="{74F4D1F5-1DBB-4A14-9D5C-DA2F37225C81}"/>
               </a:ext>
             </a:extLst>
           </p:cNvPr>
@@ -25263,7 +25263,7 @@
           <p:cNvPr id="20" name="">
             <a:extLst xmlns:a="http://schemas.openxmlformats.org/drawingml/2006/main">
               <a:ext uri="{FF2B5EF4-FFF2-40B4-BE49-F238E27FC236}">
-                <a16:creationId xmlns:a16="http://schemas.microsoft.com/office/drawing/2014/main" id="{AB6F301B-993E-49B6-AC04-7105C3BEE2F4}"/>
+                <a16:creationId xmlns:a16="http://schemas.microsoft.com/office/drawing/2014/main" id="{6E42B7B8-9CD5-4A48-B930-7CC9BBC1F721}"/>
               </a:ext>
             </a:extLst>
           </p:cNvPr>
@@ -25321,7 +25321,7 @@
           <p:cNvPr id="21" name="">
             <a:extLst xmlns:a="http://schemas.openxmlformats.org/drawingml/2006/main">
               <a:ext uri="{FF2B5EF4-FFF2-40B4-BE49-F238E27FC236}">
-                <a16:creationId xmlns:a16="http://schemas.microsoft.com/office/drawing/2014/main" id="{A1AA2EE1-0D24-4279-AB16-6B2F4B9BC764}"/>
+                <a16:creationId xmlns:a16="http://schemas.microsoft.com/office/drawing/2014/main" id="{4C1E231D-1825-4205-933A-8E279B3ACF48}"/>
               </a:ext>
             </a:extLst>
           </p:cNvPr>
@@ -25413,7 +25413,7 @@
           <p:cNvPr id="22" name="">
             <a:extLst xmlns:a="http://schemas.openxmlformats.org/drawingml/2006/main">
               <a:ext uri="{FF2B5EF4-FFF2-40B4-BE49-F238E27FC236}">
-                <a16:creationId xmlns:a16="http://schemas.microsoft.com/office/drawing/2014/main" id="{CD47AF5D-F89D-40DA-93E4-F6D3BF63FE50}"/>
+                <a16:creationId xmlns:a16="http://schemas.microsoft.com/office/drawing/2014/main" id="{BBD3F051-147A-4814-8654-84F96770726F}"/>
               </a:ext>
             </a:extLst>
           </p:cNvPr>
@@ -25450,7 +25450,7 @@
           <p:cNvPr id="23" name="">
             <a:extLst xmlns:a="http://schemas.openxmlformats.org/drawingml/2006/main">
               <a:ext uri="{FF2B5EF4-FFF2-40B4-BE49-F238E27FC236}">
-                <a16:creationId xmlns:a16="http://schemas.microsoft.com/office/drawing/2014/main" id="{715880A0-BF34-4B11-88DB-8EAA5DBDB5DD}"/>
+                <a16:creationId xmlns:a16="http://schemas.microsoft.com/office/drawing/2014/main" id="{2BBE7E66-4487-4ABC-88AB-1A8882E8580D}"/>
               </a:ext>
             </a:extLst>
           </p:cNvPr>
@@ -25485,7 +25485,7 @@
           <p:cNvPr id="24" name="">
             <a:extLst xmlns:a="http://schemas.openxmlformats.org/drawingml/2006/main">
               <a:ext uri="{FF2B5EF4-FFF2-40B4-BE49-F238E27FC236}">
-                <a16:creationId xmlns:a16="http://schemas.microsoft.com/office/drawing/2014/main" id="{876FC3C3-4BD9-4428-9C2D-786846568C84}"/>
+                <a16:creationId xmlns:a16="http://schemas.microsoft.com/office/drawing/2014/main" id="{D846A6E3-3B87-46EE-8BF8-564430C4F01D}"/>
               </a:ext>
             </a:extLst>
           </p:cNvPr>
@@ -25543,7 +25543,7 @@
           <p:cNvPr id="25" name="">
             <a:extLst xmlns:a="http://schemas.openxmlformats.org/drawingml/2006/main">
               <a:ext uri="{FF2B5EF4-FFF2-40B4-BE49-F238E27FC236}">
-                <a16:creationId xmlns:a16="http://schemas.microsoft.com/office/drawing/2014/main" id="{DCF8B8C3-D60F-4512-9DE7-2D61074C1A70}"/>
+                <a16:creationId xmlns:a16="http://schemas.microsoft.com/office/drawing/2014/main" id="{142747C3-2D70-40D7-8ACB-B511592DC291}"/>
               </a:ext>
             </a:extLst>
           </p:cNvPr>
@@ -25635,7 +25635,7 @@
           <p:cNvPr id="26" name="">
             <a:extLst xmlns:a="http://schemas.openxmlformats.org/drawingml/2006/main">
               <a:ext uri="{FF2B5EF4-FFF2-40B4-BE49-F238E27FC236}">
-                <a16:creationId xmlns:a16="http://schemas.microsoft.com/office/drawing/2014/main" id="{B1F1694A-E662-4B31-AC01-BC1405111C6F}"/>
+                <a16:creationId xmlns:a16="http://schemas.microsoft.com/office/drawing/2014/main" id="{14EDBB0B-B688-403F-8977-80F835948139}"/>
               </a:ext>
             </a:extLst>
           </p:cNvPr>
@@ -25672,7 +25672,7 @@
           <p:cNvPr id="27" name="">
             <a:extLst xmlns:a="http://schemas.openxmlformats.org/drawingml/2006/main">
               <a:ext uri="{FF2B5EF4-FFF2-40B4-BE49-F238E27FC236}">
-                <a16:creationId xmlns:a16="http://schemas.microsoft.com/office/drawing/2014/main" id="{D2103044-4D5B-4A15-9752-3132C46BD814}"/>
+                <a16:creationId xmlns:a16="http://schemas.microsoft.com/office/drawing/2014/main" id="{A2FA5E82-9C40-447B-90FA-BE6F9FA34FB4}"/>
               </a:ext>
             </a:extLst>
           </p:cNvPr>
@@ -25707,7 +25707,7 @@
           <p:cNvPr id="28" name="">
             <a:extLst xmlns:a="http://schemas.openxmlformats.org/drawingml/2006/main">
               <a:ext uri="{FF2B5EF4-FFF2-40B4-BE49-F238E27FC236}">
-                <a16:creationId xmlns:a16="http://schemas.microsoft.com/office/drawing/2014/main" id="{BC50FA7B-E262-42E1-8D94-905E8E50AF13}"/>
+                <a16:creationId xmlns:a16="http://schemas.microsoft.com/office/drawing/2014/main" id="{26605C0A-5379-4119-938B-D64BC2587FDA}"/>
               </a:ext>
             </a:extLst>
           </p:cNvPr>
@@ -25765,7 +25765,7 @@
           <p:cNvPr id="29" name="">
             <a:extLst xmlns:a="http://schemas.openxmlformats.org/drawingml/2006/main">
               <a:ext uri="{FF2B5EF4-FFF2-40B4-BE49-F238E27FC236}">
-                <a16:creationId xmlns:a16="http://schemas.microsoft.com/office/drawing/2014/main" id="{0CCFC469-1A1A-472A-9662-F3EC59F9DC57}"/>
+                <a16:creationId xmlns:a16="http://schemas.microsoft.com/office/drawing/2014/main" id="{8767F25F-8ACB-49A2-8AE8-2333BB8DFD0E}"/>
               </a:ext>
             </a:extLst>
           </p:cNvPr>
@@ -25840,7 +25840,7 @@
           <p:cNvPr id="30" name="">
             <a:extLst xmlns:a="http://schemas.openxmlformats.org/drawingml/2006/main">
               <a:ext uri="{FF2B5EF4-FFF2-40B4-BE49-F238E27FC236}">
-                <a16:creationId xmlns:a16="http://schemas.microsoft.com/office/drawing/2014/main" id="{168B1781-FCB8-48DB-AF55-952A714558B9}"/>
+                <a16:creationId xmlns:a16="http://schemas.microsoft.com/office/drawing/2014/main" id="{7A04B3B3-3697-4DB5-9B71-819C5E3CBA9B}"/>
               </a:ext>
             </a:extLst>
           </p:cNvPr>
@@ -25877,7 +25877,7 @@
           <p:cNvPr id="31" name="">
             <a:extLst xmlns:a="http://schemas.openxmlformats.org/drawingml/2006/main">
               <a:ext uri="{FF2B5EF4-FFF2-40B4-BE49-F238E27FC236}">
-                <a16:creationId xmlns:a16="http://schemas.microsoft.com/office/drawing/2014/main" id="{4CD1A700-F2A1-42E5-B34C-B644A285E5D0}"/>
+                <a16:creationId xmlns:a16="http://schemas.microsoft.com/office/drawing/2014/main" id="{D452D033-54C7-4AC2-8390-87E7C8AD3999}"/>
               </a:ext>
             </a:extLst>
           </p:cNvPr>
@@ -25912,7 +25912,7 @@
           <p:cNvPr id="32" name="">
             <a:extLst xmlns:a="http://schemas.openxmlformats.org/drawingml/2006/main">
               <a:ext uri="{FF2B5EF4-FFF2-40B4-BE49-F238E27FC236}">
-                <a16:creationId xmlns:a16="http://schemas.microsoft.com/office/drawing/2014/main" id="{085013D8-17A0-4C62-B9BE-1BB21217A953}"/>
+                <a16:creationId xmlns:a16="http://schemas.microsoft.com/office/drawing/2014/main" id="{1F16021D-005E-4557-8A34-85E41748BC40}"/>
               </a:ext>
             </a:extLst>
           </p:cNvPr>
@@ -25970,7 +25970,7 @@
           <p:cNvPr id="33" name="">
             <a:extLst xmlns:a="http://schemas.openxmlformats.org/drawingml/2006/main">
               <a:ext uri="{FF2B5EF4-FFF2-40B4-BE49-F238E27FC236}">
-                <a16:creationId xmlns:a16="http://schemas.microsoft.com/office/drawing/2014/main" id="{17C0F41F-74B4-4A74-88FE-65DDEC5B9F86}"/>
+                <a16:creationId xmlns:a16="http://schemas.microsoft.com/office/drawing/2014/main" id="{C4DDF110-23CB-45A2-9304-EC2B02D01A9A}"/>
               </a:ext>
             </a:extLst>
           </p:cNvPr>
@@ -26045,7 +26045,7 @@
           <p:cNvPr id="34" name="">
             <a:extLst xmlns:a="http://schemas.openxmlformats.org/drawingml/2006/main">
               <a:ext uri="{FF2B5EF4-FFF2-40B4-BE49-F238E27FC236}">
-                <a16:creationId xmlns:a16="http://schemas.microsoft.com/office/drawing/2014/main" id="{54047C12-7449-49AB-BFFB-42DFFBDD53FD}"/>
+                <a16:creationId xmlns:a16="http://schemas.microsoft.com/office/drawing/2014/main" id="{000AE5DF-EA8D-4BD0-946E-9CEB2679AC84}"/>
               </a:ext>
             </a:extLst>
           </p:cNvPr>
@@ -26080,7 +26080,7 @@
           <p:cNvPr id="35" name="">
             <a:extLst xmlns:a="http://schemas.openxmlformats.org/drawingml/2006/main">
               <a:ext uri="{FF2B5EF4-FFF2-40B4-BE49-F238E27FC236}">
-                <a16:creationId xmlns:a16="http://schemas.microsoft.com/office/drawing/2014/main" id="{E1DD22AF-27E9-41D3-B35E-431DCA164B48}"/>
+                <a16:creationId xmlns:a16="http://schemas.microsoft.com/office/drawing/2014/main" id="{9FB62016-7B66-4504-8ECD-84B0966273E6}"/>
               </a:ext>
             </a:extLst>
           </p:cNvPr>
@@ -26115,7 +26115,7 @@
           <p:cNvPr id="36" name="">
             <a:extLst xmlns:a="http://schemas.openxmlformats.org/drawingml/2006/main">
               <a:ext uri="{FF2B5EF4-FFF2-40B4-BE49-F238E27FC236}">
-                <a16:creationId xmlns:a16="http://schemas.microsoft.com/office/drawing/2014/main" id="{8C2257F2-B485-4643-8DC0-8250BF310F81}"/>
+                <a16:creationId xmlns:a16="http://schemas.microsoft.com/office/drawing/2014/main" id="{B01EBE91-1CFC-49FA-9DD8-F98B4E097D51}"/>
               </a:ext>
             </a:extLst>
           </p:cNvPr>
@@ -26173,7 +26173,7 @@
           <p:cNvPr id="37" name="">
             <a:extLst xmlns:a="http://schemas.openxmlformats.org/drawingml/2006/main">
               <a:ext uri="{FF2B5EF4-FFF2-40B4-BE49-F238E27FC236}">
-                <a16:creationId xmlns:a16="http://schemas.microsoft.com/office/drawing/2014/main" id="{92E0BC1C-9BE0-41C8-943D-AA783C24255C}"/>
+                <a16:creationId xmlns:a16="http://schemas.microsoft.com/office/drawing/2014/main" id="{85A548BC-909D-4B73-883F-7B8FA7335611}"/>
               </a:ext>
             </a:extLst>
           </p:cNvPr>
@@ -26229,7 +26229,7 @@
     </p:spTree>
     <p:extLst>
       <p:ext uri="{BB962C8B-B14F-4D97-AF65-F5344CB8AC3E}">
-        <p14:creationId xmlns:p14="http://schemas.microsoft.com/office/powerpoint/2010/main" val="250517712"/>
+        <p14:creationId xmlns:p14="http://schemas.microsoft.com/office/powerpoint/2010/main" val="1114534989"/>
       </p:ext>
     </p:extLst>
   </p:cSld>

</xml_diff>

<commit_message>
organoid: update build deck output
</commit_message>
<xml_diff>
--- a/collections/organoid/presentation/brain-organoid-question-journey/outputs/output.pptx
+++ b/collections/organoid/presentation/brain-organoid-question-journey/outputs/output.pptx
@@ -2,24 +2,24 @@
 <file path=ppt/presentation.xml><?xml version="1.0" encoding="utf-8"?>
 <p:presentation xmlns:p="http://schemas.openxmlformats.org/presentationml/2006/main">
   <p:sldMasterIdLst>
-    <p:sldMasterId xmlns:r="http://schemas.openxmlformats.org/officeDocument/2006/relationships" id="2147483648" r:id="R8cff4b57ee774926"/>
+    <p:sldMasterId xmlns:r="http://schemas.openxmlformats.org/officeDocument/2006/relationships" id="2147483648" r:id="R42cd8106476044c2"/>
   </p:sldMasterIdLst>
   <p:notesMasterIdLst>
-    <p:notesMasterId xmlns:r="http://schemas.openxmlformats.org/officeDocument/2006/relationships" r:id="R2fd26eaa1b944b92"/>
+    <p:notesMasterId xmlns:r="http://schemas.openxmlformats.org/officeDocument/2006/relationships" r:id="R581d68f7b7bd4d37"/>
   </p:notesMasterIdLst>
   <p:sldIdLst>
-    <p:sldId xmlns:r="http://schemas.openxmlformats.org/officeDocument/2006/relationships" id="256" r:id="R717709684dc14626"/>
-    <p:sldId xmlns:r="http://schemas.openxmlformats.org/officeDocument/2006/relationships" id="257" r:id="R4def07aeeb1742c8"/>
-    <p:sldId xmlns:r="http://schemas.openxmlformats.org/officeDocument/2006/relationships" id="258" r:id="Rcd000e6ba0854f90"/>
-    <p:sldId xmlns:r="http://schemas.openxmlformats.org/officeDocument/2006/relationships" id="259" r:id="R8575e12be5f04314"/>
-    <p:sldId xmlns:r="http://schemas.openxmlformats.org/officeDocument/2006/relationships" id="260" r:id="R149e19e4c85148e7"/>
-    <p:sldId xmlns:r="http://schemas.openxmlformats.org/officeDocument/2006/relationships" id="261" r:id="R3a48b15967b4462b"/>
-    <p:sldId xmlns:r="http://schemas.openxmlformats.org/officeDocument/2006/relationships" id="262" r:id="R0b3bc42a62644a39"/>
-    <p:sldId xmlns:r="http://schemas.openxmlformats.org/officeDocument/2006/relationships" id="263" r:id="Rd4d0336c1cb34d22"/>
-    <p:sldId xmlns:r="http://schemas.openxmlformats.org/officeDocument/2006/relationships" id="264" r:id="Rc4230a2c35b746e1"/>
-    <p:sldId xmlns:r="http://schemas.openxmlformats.org/officeDocument/2006/relationships" id="265" r:id="Rff3f4a8abf504140"/>
-    <p:sldId xmlns:r="http://schemas.openxmlformats.org/officeDocument/2006/relationships" id="266" r:id="Rf4882302669e4c2b"/>
-    <p:sldId xmlns:r="http://schemas.openxmlformats.org/officeDocument/2006/relationships" id="267" r:id="R5844611e18d649f6"/>
+    <p:sldId xmlns:r="http://schemas.openxmlformats.org/officeDocument/2006/relationships" id="256" r:id="Red2de704d0b343cf"/>
+    <p:sldId xmlns:r="http://schemas.openxmlformats.org/officeDocument/2006/relationships" id="257" r:id="R323670421495409d"/>
+    <p:sldId xmlns:r="http://schemas.openxmlformats.org/officeDocument/2006/relationships" id="258" r:id="Rdcc959b2d3044939"/>
+    <p:sldId xmlns:r="http://schemas.openxmlformats.org/officeDocument/2006/relationships" id="259" r:id="R96bb5c60221342d4"/>
+    <p:sldId xmlns:r="http://schemas.openxmlformats.org/officeDocument/2006/relationships" id="260" r:id="R9fa8cb2c731e42ff"/>
+    <p:sldId xmlns:r="http://schemas.openxmlformats.org/officeDocument/2006/relationships" id="261" r:id="R959bf8efd2504c68"/>
+    <p:sldId xmlns:r="http://schemas.openxmlformats.org/officeDocument/2006/relationships" id="262" r:id="R3ded1b02455a4e72"/>
+    <p:sldId xmlns:r="http://schemas.openxmlformats.org/officeDocument/2006/relationships" id="263" r:id="R91b52064a5db4ffd"/>
+    <p:sldId xmlns:r="http://schemas.openxmlformats.org/officeDocument/2006/relationships" id="264" r:id="Rb8443296857a4762"/>
+    <p:sldId xmlns:r="http://schemas.openxmlformats.org/officeDocument/2006/relationships" id="265" r:id="Rdf33b4fc733c4d49"/>
+    <p:sldId xmlns:r="http://schemas.openxmlformats.org/officeDocument/2006/relationships" id="266" r:id="R7626f40f07124a03"/>
+    <p:sldId xmlns:r="http://schemas.openxmlformats.org/officeDocument/2006/relationships" id="267" r:id="R791628791b7842c1"/>
   </p:sldIdLst>
   <p:sldSz cx="12192000" cy="6858000"/>
   <p:notesSz cx="6858000" cy="9144000"/>
@@ -1880,7 +1880,7 @@
           <p:cNvPr id="1" name="Title 1">
             <a:extLst xmlns:a="http://schemas.openxmlformats.org/drawingml/2006/main">
               <a:ext uri="{FF2B5EF4-FFF2-40B4-BE49-F238E27FC236}">
-                <a16:creationId xmlns:a16="http://schemas.microsoft.com/office/drawing/2014/main" id="{EF6BE441-61BA-4088-9F5C-DD19EC4B6F90}"/>
+                <a16:creationId xmlns:a16="http://schemas.microsoft.com/office/drawing/2014/main" id="{E984C53E-73FF-47C3-BCC4-CD33EEB688C4}"/>
               </a:ext>
             </a:extLst>
           </p:cNvPr>
@@ -1911,7 +1911,7 @@
           <p:cNvPr id="2" name="Subtitle 2">
             <a:extLst xmlns:a="http://schemas.openxmlformats.org/drawingml/2006/main">
               <a:ext uri="{FF2B5EF4-FFF2-40B4-BE49-F238E27FC236}">
-                <a16:creationId xmlns:a16="http://schemas.microsoft.com/office/drawing/2014/main" id="{A0356292-C6B7-4899-BBB4-90F977A58EBE}"/>
+                <a16:creationId xmlns:a16="http://schemas.microsoft.com/office/drawing/2014/main" id="{445E72D9-EF75-47FD-90F3-2978A0053B3E}"/>
               </a:ext>
             </a:extLst>
           </p:cNvPr>
@@ -1974,7 +1974,7 @@
           <p:cNvPr id="3" name="Date Placeholder 3">
             <a:extLst xmlns:a="http://schemas.openxmlformats.org/drawingml/2006/main">
               <a:ext uri="{FF2B5EF4-FFF2-40B4-BE49-F238E27FC236}">
-                <a16:creationId xmlns:a16="http://schemas.microsoft.com/office/drawing/2014/main" id="{47355F26-4ED3-483E-B86F-D5840B2104F0}"/>
+                <a16:creationId xmlns:a16="http://schemas.microsoft.com/office/drawing/2014/main" id="{32BF8197-0EF5-405A-9788-3103C40335C2}"/>
               </a:ext>
             </a:extLst>
           </p:cNvPr>
@@ -1995,7 +1995,7 @@
           <p:cNvPr id="4" name="Footer Placeholder 4">
             <a:extLst xmlns:a="http://schemas.openxmlformats.org/drawingml/2006/main">
               <a:ext uri="{FF2B5EF4-FFF2-40B4-BE49-F238E27FC236}">
-                <a16:creationId xmlns:a16="http://schemas.microsoft.com/office/drawing/2014/main" id="{12C92803-04DF-4118-A1D7-FCAE22C7500A}"/>
+                <a16:creationId xmlns:a16="http://schemas.microsoft.com/office/drawing/2014/main" id="{C92BC197-5FDD-48EB-8886-4BD8BD7EA07A}"/>
               </a:ext>
             </a:extLst>
           </p:cNvPr>
@@ -2016,7 +2016,7 @@
           <p:cNvPr id="5" name="Slide Number Placeholder 5">
             <a:extLst xmlns:a="http://schemas.openxmlformats.org/drawingml/2006/main">
               <a:ext uri="{FF2B5EF4-FFF2-40B4-BE49-F238E27FC236}">
-                <a16:creationId xmlns:a16="http://schemas.microsoft.com/office/drawing/2014/main" id="{C5A324B5-703D-4DE1-A920-5C56CD46E34C}"/>
+                <a16:creationId xmlns:a16="http://schemas.microsoft.com/office/drawing/2014/main" id="{E12CE447-476B-4BAE-A1FF-E669E79965E6}"/>
               </a:ext>
             </a:extLst>
           </p:cNvPr>
@@ -2059,7 +2059,7 @@
           <p:cNvPr id="1" name="Slide Number Placeholder 5">
             <a:extLst xmlns:a="http://schemas.openxmlformats.org/drawingml/2006/main">
               <a:ext uri="{FF2B5EF4-FFF2-40B4-BE49-F238E27FC236}">
-                <a16:creationId xmlns:a16="http://schemas.microsoft.com/office/drawing/2014/main" id="{1152E6E4-4B97-457E-82E1-D5191517F1CC}"/>
+                <a16:creationId xmlns:a16="http://schemas.microsoft.com/office/drawing/2014/main" id="{EFCA763A-768B-4E94-96C4-73A5DD2AF43D}"/>
               </a:ext>
             </a:extLst>
           </p:cNvPr>
@@ -2098,7 +2098,7 @@
   </p:cSld>
   <p:clrMap bg1="lt1" tx1="dk1" bg2="lt2" tx2="dk2" accent1="accent1" accent2="accent2" accent3="accent3" accent4="accent4" accent5="accent5" accent6="accent6" hlink="hlink" folHlink="folHlink"/>
   <p:sldLayoutIdLst>
-    <p:sldLayoutId xmlns:r="http://schemas.openxmlformats.org/officeDocument/2006/relationships" id="2147483649" r:id="R8a2e12e4aa66409f"/>
+    <p:sldLayoutId xmlns:r="http://schemas.openxmlformats.org/officeDocument/2006/relationships" id="2147483649" r:id="R296c6e276f144e4d"/>
   </p:sldLayoutIdLst>
   <p:txStyles>
     <p:titleStyle>
@@ -2404,7 +2404,7 @@
           <p:cNvPr id="1" name="Slide Number Placeholder 5">
             <a:extLst xmlns:a="http://schemas.openxmlformats.org/drawingml/2006/main">
               <a:ext uri="{FF2B5EF4-FFF2-40B4-BE49-F238E27FC236}">
-                <a16:creationId xmlns:a16="http://schemas.microsoft.com/office/drawing/2014/main" id="{C5A324B5-703D-4DE1-A920-5C56CD46E34C}"/>
+                <a16:creationId xmlns:a16="http://schemas.microsoft.com/office/drawing/2014/main" id="{E12CE447-476B-4BAE-A1FF-E669E79965E6}"/>
               </a:ext>
             </a:extLst>
           </p:cNvPr>
@@ -2440,7 +2440,7 @@
           <p:nvPr/>
         </p:nvPicPr>
         <p:blipFill>
-          <a:blip xmlns:r="http://schemas.openxmlformats.org/officeDocument/2006/relationships" xmlns:a="http://schemas.openxmlformats.org/drawingml/2006/main" r:embed="R01ea6a5199474ab8"/>
+          <a:blip xmlns:r="http://schemas.openxmlformats.org/officeDocument/2006/relationships" xmlns:a="http://schemas.openxmlformats.org/drawingml/2006/main" r:embed="Ra9dfebe3f5164d58"/>
           <a:srcRect xmlns:a="http://schemas.openxmlformats.org/drawingml/2006/main" l="0" t="21875" r="0" b="21875"/>
           <a:stretch xmlns:a="http://schemas.openxmlformats.org/drawingml/2006/main">
             <a:fillRect l="0" t="0" r="0" b="0"/>
@@ -2461,7 +2461,7 @@
           <p:cNvPr id="3" name="">
             <a:extLst xmlns:a="http://schemas.openxmlformats.org/drawingml/2006/main">
               <a:ext uri="{FF2B5EF4-FFF2-40B4-BE49-F238E27FC236}">
-                <a16:creationId xmlns:a16="http://schemas.microsoft.com/office/drawing/2014/main" id="{A84F78F3-0FE0-42F4-8EBF-499BAA20D6F4}"/>
+                <a16:creationId xmlns:a16="http://schemas.microsoft.com/office/drawing/2014/main" id="{24F74158-27A2-4528-AC4C-F53A59EA4118}"/>
               </a:ext>
             </a:extLst>
           </p:cNvPr>
@@ -2496,7 +2496,7 @@
           <p:cNvPr id="4" name="">
             <a:extLst xmlns:a="http://schemas.openxmlformats.org/drawingml/2006/main">
               <a:ext uri="{FF2B5EF4-FFF2-40B4-BE49-F238E27FC236}">
-                <a16:creationId xmlns:a16="http://schemas.microsoft.com/office/drawing/2014/main" id="{F8C4AC1D-CCCC-4889-A0A9-1BB024BEB691}"/>
+                <a16:creationId xmlns:a16="http://schemas.microsoft.com/office/drawing/2014/main" id="{EEEDC98F-D4B7-41DC-9495-F1D2EA54EF5C}"/>
               </a:ext>
             </a:extLst>
           </p:cNvPr>
@@ -2531,7 +2531,7 @@
           <p:cNvPr id="5" name="">
             <a:extLst xmlns:a="http://schemas.openxmlformats.org/drawingml/2006/main">
               <a:ext uri="{FF2B5EF4-FFF2-40B4-BE49-F238E27FC236}">
-                <a16:creationId xmlns:a16="http://schemas.microsoft.com/office/drawing/2014/main" id="{F5EAFD7A-2D7F-4689-A027-F06BFDBC5519}"/>
+                <a16:creationId xmlns:a16="http://schemas.microsoft.com/office/drawing/2014/main" id="{579073B7-8261-41B6-BB39-89AA8F6E11D9}"/>
               </a:ext>
             </a:extLst>
           </p:cNvPr>
@@ -2568,7 +2568,7 @@
           <p:cNvPr id="6" name="">
             <a:extLst xmlns:a="http://schemas.openxmlformats.org/drawingml/2006/main">
               <a:ext uri="{FF2B5EF4-FFF2-40B4-BE49-F238E27FC236}">
-                <a16:creationId xmlns:a16="http://schemas.microsoft.com/office/drawing/2014/main" id="{1F55D9D5-9CD8-4BE6-8098-2617846AA819}"/>
+                <a16:creationId xmlns:a16="http://schemas.microsoft.com/office/drawing/2014/main" id="{963E9C87-817A-4608-A097-A44E2F5EECD1}"/>
               </a:ext>
             </a:extLst>
           </p:cNvPr>
@@ -2605,7 +2605,7 @@
           <p:cNvPr id="7" name="">
             <a:extLst xmlns:a="http://schemas.openxmlformats.org/drawingml/2006/main">
               <a:ext uri="{FF2B5EF4-FFF2-40B4-BE49-F238E27FC236}">
-                <a16:creationId xmlns:a16="http://schemas.microsoft.com/office/drawing/2014/main" id="{EB2EC122-510E-47CE-B82A-6C05D81ED7D5}"/>
+                <a16:creationId xmlns:a16="http://schemas.microsoft.com/office/drawing/2014/main" id="{75BB9787-7EB3-49F5-9063-4784F16F8162}"/>
               </a:ext>
             </a:extLst>
           </p:cNvPr>
@@ -2642,7 +2642,7 @@
           <p:cNvPr id="8" name="">
             <a:extLst xmlns:a="http://schemas.openxmlformats.org/drawingml/2006/main">
               <a:ext uri="{FF2B5EF4-FFF2-40B4-BE49-F238E27FC236}">
-                <a16:creationId xmlns:a16="http://schemas.microsoft.com/office/drawing/2014/main" id="{D92E38D4-1CDA-44C9-AE36-6BC72BC091A8}"/>
+                <a16:creationId xmlns:a16="http://schemas.microsoft.com/office/drawing/2014/main" id="{B1864EFD-A2F6-4E52-8A1A-80D2BC0B88F2}"/>
               </a:ext>
             </a:extLst>
           </p:cNvPr>
@@ -2679,7 +2679,7 @@
           <p:cNvPr id="9" name="">
             <a:extLst xmlns:a="http://schemas.openxmlformats.org/drawingml/2006/main">
               <a:ext uri="{FF2B5EF4-FFF2-40B4-BE49-F238E27FC236}">
-                <a16:creationId xmlns:a16="http://schemas.microsoft.com/office/drawing/2014/main" id="{76AD1A94-C5FF-4255-B940-59D084099EE4}"/>
+                <a16:creationId xmlns:a16="http://schemas.microsoft.com/office/drawing/2014/main" id="{AF2FE664-AAC2-4150-8EDB-E741797E735D}"/>
               </a:ext>
             </a:extLst>
           </p:cNvPr>
@@ -2714,7 +2714,7 @@
           <p:cNvPr id="10" name="">
             <a:extLst xmlns:a="http://schemas.openxmlformats.org/drawingml/2006/main">
               <a:ext uri="{FF2B5EF4-FFF2-40B4-BE49-F238E27FC236}">
-                <a16:creationId xmlns:a16="http://schemas.microsoft.com/office/drawing/2014/main" id="{549DAB5F-2BF3-45D9-95E3-9297D737ADF9}"/>
+                <a16:creationId xmlns:a16="http://schemas.microsoft.com/office/drawing/2014/main" id="{C7DEE1ED-F31A-4C6C-BC2A-E2FE26E2272C}"/>
               </a:ext>
             </a:extLst>
           </p:cNvPr>
@@ -2772,7 +2772,7 @@
           <p:cNvPr id="11" name="">
             <a:extLst xmlns:a="http://schemas.openxmlformats.org/drawingml/2006/main">
               <a:ext uri="{FF2B5EF4-FFF2-40B4-BE49-F238E27FC236}">
-                <a16:creationId xmlns:a16="http://schemas.microsoft.com/office/drawing/2014/main" id="{6D8BD306-8ADB-49EB-9CE8-F16AD77FABC9}"/>
+                <a16:creationId xmlns:a16="http://schemas.microsoft.com/office/drawing/2014/main" id="{CD481D7A-AE49-4EE4-87D2-3611EBB99977}"/>
               </a:ext>
             </a:extLst>
           </p:cNvPr>
@@ -2847,7 +2847,7 @@
           <p:cNvPr id="12" name="">
             <a:extLst xmlns:a="http://schemas.openxmlformats.org/drawingml/2006/main">
               <a:ext uri="{FF2B5EF4-FFF2-40B4-BE49-F238E27FC236}">
-                <a16:creationId xmlns:a16="http://schemas.microsoft.com/office/drawing/2014/main" id="{7C43CB43-856E-4B4C-A1BE-756796E4B7C2}"/>
+                <a16:creationId xmlns:a16="http://schemas.microsoft.com/office/drawing/2014/main" id="{230848AB-D272-4F06-9F6F-4D3E384BA491}"/>
               </a:ext>
             </a:extLst>
           </p:cNvPr>
@@ -2922,7 +2922,7 @@
           <p:cNvPr id="13" name="">
             <a:extLst xmlns:a="http://schemas.openxmlformats.org/drawingml/2006/main">
               <a:ext uri="{FF2B5EF4-FFF2-40B4-BE49-F238E27FC236}">
-                <a16:creationId xmlns:a16="http://schemas.microsoft.com/office/drawing/2014/main" id="{5D7FAB69-99DF-42C1-95D1-C8284760A0CC}"/>
+                <a16:creationId xmlns:a16="http://schemas.microsoft.com/office/drawing/2014/main" id="{06E96802-70D9-4CCD-9004-65ED763DCC5A}"/>
               </a:ext>
             </a:extLst>
           </p:cNvPr>
@@ -2959,7 +2959,7 @@
           <p:cNvPr id="14" name="">
             <a:extLst xmlns:a="http://schemas.openxmlformats.org/drawingml/2006/main">
               <a:ext uri="{FF2B5EF4-FFF2-40B4-BE49-F238E27FC236}">
-                <a16:creationId xmlns:a16="http://schemas.microsoft.com/office/drawing/2014/main" id="{BABAB57D-A67A-4FA7-A2B1-B597F9455757}"/>
+                <a16:creationId xmlns:a16="http://schemas.microsoft.com/office/drawing/2014/main" id="{9F67B23D-D9C9-48EB-B690-30376987F23D}"/>
               </a:ext>
             </a:extLst>
           </p:cNvPr>
@@ -3017,7 +3017,7 @@
           <p:cNvPr id="15" name="">
             <a:extLst xmlns:a="http://schemas.openxmlformats.org/drawingml/2006/main">
               <a:ext uri="{FF2B5EF4-FFF2-40B4-BE49-F238E27FC236}">
-                <a16:creationId xmlns:a16="http://schemas.microsoft.com/office/drawing/2014/main" id="{9A23EF34-3EC7-4175-A996-A8C9D280A957}"/>
+                <a16:creationId xmlns:a16="http://schemas.microsoft.com/office/drawing/2014/main" id="{2ABAA598-E3F6-4C3A-A2B5-65C58D494FF0}"/>
               </a:ext>
             </a:extLst>
           </p:cNvPr>
@@ -3052,7 +3052,7 @@
           <p:cNvPr id="16" name="">
             <a:extLst xmlns:a="http://schemas.openxmlformats.org/drawingml/2006/main">
               <a:ext uri="{FF2B5EF4-FFF2-40B4-BE49-F238E27FC236}">
-                <a16:creationId xmlns:a16="http://schemas.microsoft.com/office/drawing/2014/main" id="{6BA0043B-18C2-4254-84C6-B99850622D5D}"/>
+                <a16:creationId xmlns:a16="http://schemas.microsoft.com/office/drawing/2014/main" id="{27029C60-BBC5-449D-BF37-4D44386C83AC}"/>
               </a:ext>
             </a:extLst>
           </p:cNvPr>
@@ -3087,7 +3087,7 @@
           <p:cNvPr id="17" name="">
             <a:extLst xmlns:a="http://schemas.openxmlformats.org/drawingml/2006/main">
               <a:ext uri="{FF2B5EF4-FFF2-40B4-BE49-F238E27FC236}">
-                <a16:creationId xmlns:a16="http://schemas.microsoft.com/office/drawing/2014/main" id="{669943D0-09A4-439C-B30A-4C10B33C48C9}"/>
+                <a16:creationId xmlns:a16="http://schemas.microsoft.com/office/drawing/2014/main" id="{44814FFA-4386-4976-B345-64DEADC69202}"/>
               </a:ext>
             </a:extLst>
           </p:cNvPr>
@@ -3141,7 +3141,7 @@
           <p:cNvPr id="18" name="">
             <a:extLst xmlns:a="http://schemas.openxmlformats.org/drawingml/2006/main">
               <a:ext uri="{FF2B5EF4-FFF2-40B4-BE49-F238E27FC236}">
-                <a16:creationId xmlns:a16="http://schemas.microsoft.com/office/drawing/2014/main" id="{2A8D2B14-78D4-4790-AC9D-9893B7AA3621}"/>
+                <a16:creationId xmlns:a16="http://schemas.microsoft.com/office/drawing/2014/main" id="{03B62286-81A8-4E57-8F06-435F69C7F99A}"/>
               </a:ext>
             </a:extLst>
           </p:cNvPr>
@@ -3199,7 +3199,7 @@
           <p:cNvPr id="19" name="">
             <a:extLst xmlns:a="http://schemas.openxmlformats.org/drawingml/2006/main">
               <a:ext uri="{FF2B5EF4-FFF2-40B4-BE49-F238E27FC236}">
-                <a16:creationId xmlns:a16="http://schemas.microsoft.com/office/drawing/2014/main" id="{9557133F-133A-412A-BBA3-FE3F8BFB872F}"/>
+                <a16:creationId xmlns:a16="http://schemas.microsoft.com/office/drawing/2014/main" id="{B2DCEBFA-2603-4F8D-A026-729AA62772CF}"/>
               </a:ext>
             </a:extLst>
           </p:cNvPr>
@@ -3274,7 +3274,7 @@
           <p:cNvPr id="20" name="">
             <a:extLst xmlns:a="http://schemas.openxmlformats.org/drawingml/2006/main">
               <a:ext uri="{FF2B5EF4-FFF2-40B4-BE49-F238E27FC236}">
-                <a16:creationId xmlns:a16="http://schemas.microsoft.com/office/drawing/2014/main" id="{FB9EC977-F915-40B5-A194-F82D4822182E}"/>
+                <a16:creationId xmlns:a16="http://schemas.microsoft.com/office/drawing/2014/main" id="{48DF6715-AFE9-47FA-87BE-574D2C9E6F7A}"/>
               </a:ext>
             </a:extLst>
           </p:cNvPr>
@@ -3309,7 +3309,7 @@
           <p:cNvPr id="21" name="">
             <a:extLst xmlns:a="http://schemas.openxmlformats.org/drawingml/2006/main">
               <a:ext uri="{FF2B5EF4-FFF2-40B4-BE49-F238E27FC236}">
-                <a16:creationId xmlns:a16="http://schemas.microsoft.com/office/drawing/2014/main" id="{1F9F363E-AA81-4057-B3AE-B5B1C14F36BC}"/>
+                <a16:creationId xmlns:a16="http://schemas.microsoft.com/office/drawing/2014/main" id="{27B8BA6C-A49A-4AC3-8C96-CE6D4850A50C}"/>
               </a:ext>
             </a:extLst>
           </p:cNvPr>
@@ -3344,7 +3344,7 @@
           <p:cNvPr id="22" name="">
             <a:extLst xmlns:a="http://schemas.openxmlformats.org/drawingml/2006/main">
               <a:ext uri="{FF2B5EF4-FFF2-40B4-BE49-F238E27FC236}">
-                <a16:creationId xmlns:a16="http://schemas.microsoft.com/office/drawing/2014/main" id="{F46F95B5-D10E-412E-B2FA-D23C350771B6}"/>
+                <a16:creationId xmlns:a16="http://schemas.microsoft.com/office/drawing/2014/main" id="{ADA6661D-6794-427D-BF38-E84D2B77B103}"/>
               </a:ext>
             </a:extLst>
           </p:cNvPr>
@@ -3398,7 +3398,7 @@
           <p:cNvPr id="23" name="">
             <a:extLst xmlns:a="http://schemas.openxmlformats.org/drawingml/2006/main">
               <a:ext uri="{FF2B5EF4-FFF2-40B4-BE49-F238E27FC236}">
-                <a16:creationId xmlns:a16="http://schemas.microsoft.com/office/drawing/2014/main" id="{E0AC814E-2733-43D1-83EB-0DBF68B672E0}"/>
+                <a16:creationId xmlns:a16="http://schemas.microsoft.com/office/drawing/2014/main" id="{D82C0B55-E8E9-48F0-8C6E-8D413BDD0E9B}"/>
               </a:ext>
             </a:extLst>
           </p:cNvPr>
@@ -3456,7 +3456,7 @@
           <p:cNvPr id="24" name="">
             <a:extLst xmlns:a="http://schemas.openxmlformats.org/drawingml/2006/main">
               <a:ext uri="{FF2B5EF4-FFF2-40B4-BE49-F238E27FC236}">
-                <a16:creationId xmlns:a16="http://schemas.microsoft.com/office/drawing/2014/main" id="{AF379492-A9EB-4101-81BF-62BC3F3E6408}"/>
+                <a16:creationId xmlns:a16="http://schemas.microsoft.com/office/drawing/2014/main" id="{B45CC6DC-BCE5-4770-B7CC-B0C70AB0DDCD}"/>
               </a:ext>
             </a:extLst>
           </p:cNvPr>
@@ -3531,7 +3531,7 @@
           <p:cNvPr id="25" name="">
             <a:extLst xmlns:a="http://schemas.openxmlformats.org/drawingml/2006/main">
               <a:ext uri="{FF2B5EF4-FFF2-40B4-BE49-F238E27FC236}">
-                <a16:creationId xmlns:a16="http://schemas.microsoft.com/office/drawing/2014/main" id="{31CBE313-FDA5-4A8E-BC7F-FA9C318E0667}"/>
+                <a16:creationId xmlns:a16="http://schemas.microsoft.com/office/drawing/2014/main" id="{4C5225BB-C083-4254-ACEE-E4820AA78B3A}"/>
               </a:ext>
             </a:extLst>
           </p:cNvPr>
@@ -3566,7 +3566,7 @@
           <p:cNvPr id="26" name="">
             <a:extLst xmlns:a="http://schemas.openxmlformats.org/drawingml/2006/main">
               <a:ext uri="{FF2B5EF4-FFF2-40B4-BE49-F238E27FC236}">
-                <a16:creationId xmlns:a16="http://schemas.microsoft.com/office/drawing/2014/main" id="{93E1075B-EC78-422C-816F-48131BDD7D4E}"/>
+                <a16:creationId xmlns:a16="http://schemas.microsoft.com/office/drawing/2014/main" id="{53548352-02C0-4531-A017-4BFF9173D178}"/>
               </a:ext>
             </a:extLst>
           </p:cNvPr>
@@ -3601,7 +3601,7 @@
           <p:cNvPr id="27" name="">
             <a:extLst xmlns:a="http://schemas.openxmlformats.org/drawingml/2006/main">
               <a:ext uri="{FF2B5EF4-FFF2-40B4-BE49-F238E27FC236}">
-                <a16:creationId xmlns:a16="http://schemas.microsoft.com/office/drawing/2014/main" id="{8985E300-B97E-4D96-87FD-135D88821B38}"/>
+                <a16:creationId xmlns:a16="http://schemas.microsoft.com/office/drawing/2014/main" id="{3A7FF1A6-4F9B-439A-9482-BFB5F921C164}"/>
               </a:ext>
             </a:extLst>
           </p:cNvPr>
@@ -3655,7 +3655,7 @@
           <p:cNvPr id="28" name="">
             <a:extLst xmlns:a="http://schemas.openxmlformats.org/drawingml/2006/main">
               <a:ext uri="{FF2B5EF4-FFF2-40B4-BE49-F238E27FC236}">
-                <a16:creationId xmlns:a16="http://schemas.microsoft.com/office/drawing/2014/main" id="{040E00BB-4B11-4C5E-84EB-A89EB8E89714}"/>
+                <a16:creationId xmlns:a16="http://schemas.microsoft.com/office/drawing/2014/main" id="{FDD96450-04B1-4450-A255-B3F90ADAA3F0}"/>
               </a:ext>
             </a:extLst>
           </p:cNvPr>
@@ -3713,7 +3713,7 @@
           <p:cNvPr id="29" name="">
             <a:extLst xmlns:a="http://schemas.openxmlformats.org/drawingml/2006/main">
               <a:ext uri="{FF2B5EF4-FFF2-40B4-BE49-F238E27FC236}">
-                <a16:creationId xmlns:a16="http://schemas.microsoft.com/office/drawing/2014/main" id="{D925AC5E-F927-4652-A9C5-5814640AC2DC}"/>
+                <a16:creationId xmlns:a16="http://schemas.microsoft.com/office/drawing/2014/main" id="{59D1D6AD-61CE-48FC-B208-9E4AD8E88E72}"/>
               </a:ext>
             </a:extLst>
           </p:cNvPr>
@@ -3788,7 +3788,7 @@
           <p:cNvPr id="30" name="">
             <a:extLst xmlns:a="http://schemas.openxmlformats.org/drawingml/2006/main">
               <a:ext uri="{FF2B5EF4-FFF2-40B4-BE49-F238E27FC236}">
-                <a16:creationId xmlns:a16="http://schemas.microsoft.com/office/drawing/2014/main" id="{EBCD4D08-EEBE-4CB3-A155-6BD4EE4BD459}"/>
+                <a16:creationId xmlns:a16="http://schemas.microsoft.com/office/drawing/2014/main" id="{3AF87737-3E64-43EF-924B-CB0DFA2A8243}"/>
               </a:ext>
             </a:extLst>
           </p:cNvPr>
@@ -3823,7 +3823,7 @@
           <p:cNvPr id="31" name="">
             <a:extLst xmlns:a="http://schemas.openxmlformats.org/drawingml/2006/main">
               <a:ext uri="{FF2B5EF4-FFF2-40B4-BE49-F238E27FC236}">
-                <a16:creationId xmlns:a16="http://schemas.microsoft.com/office/drawing/2014/main" id="{17E368A8-78F0-49A6-8D62-328DB67EB845}"/>
+                <a16:creationId xmlns:a16="http://schemas.microsoft.com/office/drawing/2014/main" id="{094573C2-8358-42AC-B79A-0B5B3BACBD8A}"/>
               </a:ext>
             </a:extLst>
           </p:cNvPr>
@@ -3858,7 +3858,7 @@
           <p:cNvPr id="32" name="">
             <a:extLst xmlns:a="http://schemas.openxmlformats.org/drawingml/2006/main">
               <a:ext uri="{FF2B5EF4-FFF2-40B4-BE49-F238E27FC236}">
-                <a16:creationId xmlns:a16="http://schemas.microsoft.com/office/drawing/2014/main" id="{B6661046-78FE-4649-A67A-A218317501A8}"/>
+                <a16:creationId xmlns:a16="http://schemas.microsoft.com/office/drawing/2014/main" id="{10B01B08-299D-4619-ADAB-769A96531F33}"/>
               </a:ext>
             </a:extLst>
           </p:cNvPr>
@@ -3912,7 +3912,7 @@
           <p:cNvPr id="33" name="">
             <a:extLst xmlns:a="http://schemas.openxmlformats.org/drawingml/2006/main">
               <a:ext uri="{FF2B5EF4-FFF2-40B4-BE49-F238E27FC236}">
-                <a16:creationId xmlns:a16="http://schemas.microsoft.com/office/drawing/2014/main" id="{7580BE87-B184-429F-B9AD-85EDF060F3E2}"/>
+                <a16:creationId xmlns:a16="http://schemas.microsoft.com/office/drawing/2014/main" id="{A4EC46A9-F2EA-4861-8551-D7821DC9BE2D}"/>
               </a:ext>
             </a:extLst>
           </p:cNvPr>
@@ -3970,7 +3970,7 @@
           <p:cNvPr id="34" name="">
             <a:extLst xmlns:a="http://schemas.openxmlformats.org/drawingml/2006/main">
               <a:ext uri="{FF2B5EF4-FFF2-40B4-BE49-F238E27FC236}">
-                <a16:creationId xmlns:a16="http://schemas.microsoft.com/office/drawing/2014/main" id="{CB2FF5A2-49D7-48DF-A60D-0D5A31A2761A}"/>
+                <a16:creationId xmlns:a16="http://schemas.microsoft.com/office/drawing/2014/main" id="{D2E32441-4FC4-4E7F-A75E-93C7BD78577C}"/>
               </a:ext>
             </a:extLst>
           </p:cNvPr>
@@ -4028,7 +4028,7 @@
           <p:cNvPr id="35" name="">
             <a:extLst xmlns:a="http://schemas.openxmlformats.org/drawingml/2006/main">
               <a:ext uri="{FF2B5EF4-FFF2-40B4-BE49-F238E27FC236}">
-                <a16:creationId xmlns:a16="http://schemas.microsoft.com/office/drawing/2014/main" id="{9A276DC7-2894-4F31-8BDE-9EF91BE763BC}"/>
+                <a16:creationId xmlns:a16="http://schemas.microsoft.com/office/drawing/2014/main" id="{6997A693-E7FB-40F5-B2BE-20C1D425DAEC}"/>
               </a:ext>
             </a:extLst>
           </p:cNvPr>
@@ -4063,7 +4063,7 @@
           <p:cNvPr id="36" name="">
             <a:extLst xmlns:a="http://schemas.openxmlformats.org/drawingml/2006/main">
               <a:ext uri="{FF2B5EF4-FFF2-40B4-BE49-F238E27FC236}">
-                <a16:creationId xmlns:a16="http://schemas.microsoft.com/office/drawing/2014/main" id="{9CB3132C-F277-46B6-BC78-DDA7A51C4055}"/>
+                <a16:creationId xmlns:a16="http://schemas.microsoft.com/office/drawing/2014/main" id="{7FE7DAD8-9073-48B5-8A00-C40BC6FAFA01}"/>
               </a:ext>
             </a:extLst>
           </p:cNvPr>
@@ -4098,7 +4098,7 @@
           <p:cNvPr id="37" name="">
             <a:extLst xmlns:a="http://schemas.openxmlformats.org/drawingml/2006/main">
               <a:ext uri="{FF2B5EF4-FFF2-40B4-BE49-F238E27FC236}">
-                <a16:creationId xmlns:a16="http://schemas.microsoft.com/office/drawing/2014/main" id="{D010A617-B865-4DD6-86B0-32C8F5D38B06}"/>
+                <a16:creationId xmlns:a16="http://schemas.microsoft.com/office/drawing/2014/main" id="{9D3A45F3-1CAF-4E19-9B61-33F037CB9E24}"/>
               </a:ext>
             </a:extLst>
           </p:cNvPr>
@@ -4133,7 +4133,7 @@
           <p:cNvPr id="38" name="">
             <a:extLst xmlns:a="http://schemas.openxmlformats.org/drawingml/2006/main">
               <a:ext uri="{FF2B5EF4-FFF2-40B4-BE49-F238E27FC236}">
-                <a16:creationId xmlns:a16="http://schemas.microsoft.com/office/drawing/2014/main" id="{D431290C-37F2-40E8-8F86-042AA0214146}"/>
+                <a16:creationId xmlns:a16="http://schemas.microsoft.com/office/drawing/2014/main" id="{E59BAF55-3911-4E87-BEE5-0100242B8E3D}"/>
               </a:ext>
             </a:extLst>
           </p:cNvPr>
@@ -4145,7 +4145,7 @@
         <p:spPr>
           <a:xfrm xmlns:a="http://schemas.openxmlformats.org/drawingml/2006/main">
             <a:off x="819150" y="5448300"/>
-            <a:ext cx="1104900" cy="266700"/>
+            <a:ext cx="990600" cy="266700"/>
           </a:xfrm>
           <a:prstGeom xmlns:a="http://schemas.openxmlformats.org/drawingml/2006/main" prst="rect">
             <a:avLst/>
@@ -4177,7 +4177,7 @@
                   <a:srgbClr val="7A5A14"/>
                 </a:solidFill>
               </a:rPr>
-              <a:t>15 min talk</a:t>
+              <a:t>LLM-wiki</a:t>
             </a:r>
           </a:p>
         </p:txBody>
@@ -4187,19 +4187,19 @@
           <p:cNvPr id="39" name="">
             <a:extLst xmlns:a="http://schemas.openxmlformats.org/drawingml/2006/main">
               <a:ext uri="{FF2B5EF4-FFF2-40B4-BE49-F238E27FC236}">
-                <a16:creationId xmlns:a16="http://schemas.microsoft.com/office/drawing/2014/main" id="{31000469-8C2A-4143-8D8A-91C2540E3F8C}"/>
-              </a:ext>
-            </a:extLst>
-          </p:cNvPr>
-          <p:cNvSpPr>
-            <a:spLocks xmlns:a="http://schemas.openxmlformats.org/drawingml/2006/main" noGrp="1"/>
-          </p:cNvSpPr>
-          <p:nvPr/>
-        </p:nvSpPr>
-        <p:spPr>
-          <a:xfrm xmlns:a="http://schemas.openxmlformats.org/drawingml/2006/main">
-            <a:off x="2038350" y="5448300"/>
-            <a:ext cx="1562100" cy="266700"/>
+                <a16:creationId xmlns:a16="http://schemas.microsoft.com/office/drawing/2014/main" id="{9B7431D5-B87A-421F-91A5-0F5DAD4EB2FF}"/>
+              </a:ext>
+            </a:extLst>
+          </p:cNvPr>
+          <p:cNvSpPr>
+            <a:spLocks xmlns:a="http://schemas.openxmlformats.org/drawingml/2006/main" noGrp="1"/>
+          </p:cNvSpPr>
+          <p:nvPr/>
+        </p:nvSpPr>
+        <p:spPr>
+          <a:xfrm xmlns:a="http://schemas.openxmlformats.org/drawingml/2006/main">
+            <a:off x="1924050" y="5448300"/>
+            <a:ext cx="1257300" cy="266700"/>
           </a:xfrm>
           <a:prstGeom xmlns:a="http://schemas.openxmlformats.org/drawingml/2006/main" prst="rect">
             <a:avLst/>
@@ -4231,7 +4231,7 @@
                   <a:srgbClr val="0F5B3F"/>
                 </a:solidFill>
               </a:rPr>
-              <a:t>question journey</a:t>
+              <a:t>brain branch</a:t>
             </a:r>
           </a:p>
         </p:txBody>
@@ -4241,7 +4241,7 @@
           <p:cNvPr id="40" name="">
             <a:extLst xmlns:a="http://schemas.openxmlformats.org/drawingml/2006/main">
               <a:ext uri="{FF2B5EF4-FFF2-40B4-BE49-F238E27FC236}">
-                <a16:creationId xmlns:a16="http://schemas.microsoft.com/office/drawing/2014/main" id="{69031CFD-35A3-4F02-9777-B497817748CB}"/>
+                <a16:creationId xmlns:a16="http://schemas.microsoft.com/office/drawing/2014/main" id="{C96E2656-8A07-45DE-B6F3-1226AD1B8CE9}"/>
               </a:ext>
             </a:extLst>
           </p:cNvPr>
@@ -4289,7 +4289,7 @@
                   <a:srgbClr val="6A767C"/>
                 </a:solidFill>
               </a:rPr>
-              <a:t>발표 구조: 출발 질문 -&gt; 한계 발견 -&gt; 질문 재정의 -&gt; 최종 선택 규칙</a:t>
+              <a:t>흐름: LLM-wiki 운영 -&gt; subregion 질문 -&gt; benchmark -&gt; readout-first rule</a:t>
             </a:r>
           </a:p>
         </p:txBody>
@@ -4297,7 +4297,7 @@
     </p:spTree>
     <p:extLst>
       <p:ext uri="{BB962C8B-B14F-4D97-AF65-F5344CB8AC3E}">
-        <p14:creationId xmlns:p14="http://schemas.microsoft.com/office/powerpoint/2010/main" val="1464981873"/>
+        <p14:creationId xmlns:p14="http://schemas.microsoft.com/office/powerpoint/2010/main" val="779714260"/>
       </p:ext>
     </p:extLst>
   </p:cSld>
@@ -4328,7 +4328,7 @@
           <p:cNvPr id="1" name="Slide Number Placeholder 5">
             <a:extLst xmlns:a="http://schemas.openxmlformats.org/drawingml/2006/main">
               <a:ext uri="{FF2B5EF4-FFF2-40B4-BE49-F238E27FC236}">
-                <a16:creationId xmlns:a16="http://schemas.microsoft.com/office/drawing/2014/main" id="{C5A324B5-703D-4DE1-A920-5C56CD46E34C}"/>
+                <a16:creationId xmlns:a16="http://schemas.microsoft.com/office/drawing/2014/main" id="{E12CE447-476B-4BAE-A1FF-E669E79965E6}"/>
               </a:ext>
             </a:extLst>
           </p:cNvPr>
@@ -4364,7 +4364,7 @@
           <p:nvPr/>
         </p:nvPicPr>
         <p:blipFill>
-          <a:blip xmlns:r="http://schemas.openxmlformats.org/officeDocument/2006/relationships" xmlns:a="http://schemas.openxmlformats.org/drawingml/2006/main" r:embed="R7ce89d589fea49cc"/>
+          <a:blip xmlns:r="http://schemas.openxmlformats.org/officeDocument/2006/relationships" xmlns:a="http://schemas.openxmlformats.org/drawingml/2006/main" r:embed="Ra3610326cacf46f5"/>
           <a:srcRect xmlns:a="http://schemas.openxmlformats.org/drawingml/2006/main" l="0" t="21875" r="0" b="21875"/>
           <a:stretch xmlns:a="http://schemas.openxmlformats.org/drawingml/2006/main">
             <a:fillRect l="0" t="0" r="0" b="0"/>
@@ -4385,7 +4385,7 @@
           <p:cNvPr id="3" name="">
             <a:extLst xmlns:a="http://schemas.openxmlformats.org/drawingml/2006/main">
               <a:ext uri="{FF2B5EF4-FFF2-40B4-BE49-F238E27FC236}">
-                <a16:creationId xmlns:a16="http://schemas.microsoft.com/office/drawing/2014/main" id="{EE839F70-26AD-4636-924A-C4531E551277}"/>
+                <a16:creationId xmlns:a16="http://schemas.microsoft.com/office/drawing/2014/main" id="{6956BC0F-7971-4457-B954-C616E28E1611}"/>
               </a:ext>
             </a:extLst>
           </p:cNvPr>
@@ -4420,7 +4420,7 @@
           <p:cNvPr id="4" name="">
             <a:extLst xmlns:a="http://schemas.openxmlformats.org/drawingml/2006/main">
               <a:ext uri="{FF2B5EF4-FFF2-40B4-BE49-F238E27FC236}">
-                <a16:creationId xmlns:a16="http://schemas.microsoft.com/office/drawing/2014/main" id="{BCB667D2-16D0-4722-8794-540C5FCCBBCC}"/>
+                <a16:creationId xmlns:a16="http://schemas.microsoft.com/office/drawing/2014/main" id="{5264BAB2-84B6-436D-9ADE-5F0561432059}"/>
               </a:ext>
             </a:extLst>
           </p:cNvPr>
@@ -4455,7 +4455,7 @@
           <p:cNvPr id="5" name="">
             <a:extLst xmlns:a="http://schemas.openxmlformats.org/drawingml/2006/main">
               <a:ext uri="{FF2B5EF4-FFF2-40B4-BE49-F238E27FC236}">
-                <a16:creationId xmlns:a16="http://schemas.microsoft.com/office/drawing/2014/main" id="{B1234DB7-7FAC-44BF-9E3B-E4510ED259B3}"/>
+                <a16:creationId xmlns:a16="http://schemas.microsoft.com/office/drawing/2014/main" id="{0A0C9BFF-D65E-45A2-AAEE-7940D739C0AE}"/>
               </a:ext>
             </a:extLst>
           </p:cNvPr>
@@ -4492,7 +4492,7 @@
           <p:cNvPr id="6" name="">
             <a:extLst xmlns:a="http://schemas.openxmlformats.org/drawingml/2006/main">
               <a:ext uri="{FF2B5EF4-FFF2-40B4-BE49-F238E27FC236}">
-                <a16:creationId xmlns:a16="http://schemas.microsoft.com/office/drawing/2014/main" id="{DCFC3784-00F5-46A1-AAD2-22206E178128}"/>
+                <a16:creationId xmlns:a16="http://schemas.microsoft.com/office/drawing/2014/main" id="{CA1AD432-EEAB-4DF4-AEFD-71C6415C77D4}"/>
               </a:ext>
             </a:extLst>
           </p:cNvPr>
@@ -4529,7 +4529,7 @@
           <p:cNvPr id="7" name="">
             <a:extLst xmlns:a="http://schemas.openxmlformats.org/drawingml/2006/main">
               <a:ext uri="{FF2B5EF4-FFF2-40B4-BE49-F238E27FC236}">
-                <a16:creationId xmlns:a16="http://schemas.microsoft.com/office/drawing/2014/main" id="{DAA411E2-39A5-44BD-8F90-86CCEECB1E2E}"/>
+                <a16:creationId xmlns:a16="http://schemas.microsoft.com/office/drawing/2014/main" id="{E897191F-1EAD-47B0-B702-9837419DE286}"/>
               </a:ext>
             </a:extLst>
           </p:cNvPr>
@@ -4566,7 +4566,7 @@
           <p:cNvPr id="8" name="">
             <a:extLst xmlns:a="http://schemas.openxmlformats.org/drawingml/2006/main">
               <a:ext uri="{FF2B5EF4-FFF2-40B4-BE49-F238E27FC236}">
-                <a16:creationId xmlns:a16="http://schemas.microsoft.com/office/drawing/2014/main" id="{CD56F337-8820-4FC4-9A4D-E09FC15FA4B5}"/>
+                <a16:creationId xmlns:a16="http://schemas.microsoft.com/office/drawing/2014/main" id="{435DCA43-07B6-437F-9C7C-CA5352376EBA}"/>
               </a:ext>
             </a:extLst>
           </p:cNvPr>
@@ -4603,7 +4603,7 @@
           <p:cNvPr id="9" name="">
             <a:extLst xmlns:a="http://schemas.openxmlformats.org/drawingml/2006/main">
               <a:ext uri="{FF2B5EF4-FFF2-40B4-BE49-F238E27FC236}">
-                <a16:creationId xmlns:a16="http://schemas.microsoft.com/office/drawing/2014/main" id="{4D70B2FD-3BCE-43C7-BAFC-84661D700670}"/>
+                <a16:creationId xmlns:a16="http://schemas.microsoft.com/office/drawing/2014/main" id="{8578DF86-6C0A-4230-9442-B1147A9F18EE}"/>
               </a:ext>
             </a:extLst>
           </p:cNvPr>
@@ -4661,7 +4661,7 @@
           <p:cNvPr id="10" name="">
             <a:extLst xmlns:a="http://schemas.openxmlformats.org/drawingml/2006/main">
               <a:ext uri="{FF2B5EF4-FFF2-40B4-BE49-F238E27FC236}">
-                <a16:creationId xmlns:a16="http://schemas.microsoft.com/office/drawing/2014/main" id="{9700FBBE-B140-43EF-8D7A-6F5630AE98D6}"/>
+                <a16:creationId xmlns:a16="http://schemas.microsoft.com/office/drawing/2014/main" id="{11797080-E472-456C-A2A4-EC0D82BF21B0}"/>
               </a:ext>
             </a:extLst>
           </p:cNvPr>
@@ -4719,7 +4719,7 @@
           <p:cNvPr id="11" name="">
             <a:extLst xmlns:a="http://schemas.openxmlformats.org/drawingml/2006/main">
               <a:ext uri="{FF2B5EF4-FFF2-40B4-BE49-F238E27FC236}">
-                <a16:creationId xmlns:a16="http://schemas.microsoft.com/office/drawing/2014/main" id="{FEB33465-FB66-49B0-97E7-A78DE46D4628}"/>
+                <a16:creationId xmlns:a16="http://schemas.microsoft.com/office/drawing/2014/main" id="{DCDEAAA6-FFE8-440D-BC2A-BA2400BD1EFC}"/>
               </a:ext>
             </a:extLst>
           </p:cNvPr>
@@ -4754,7 +4754,7 @@
           <p:cNvPr id="12" name="">
             <a:extLst xmlns:a="http://schemas.openxmlformats.org/drawingml/2006/main">
               <a:ext uri="{FF2B5EF4-FFF2-40B4-BE49-F238E27FC236}">
-                <a16:creationId xmlns:a16="http://schemas.microsoft.com/office/drawing/2014/main" id="{EE326095-1563-4210-8A81-68692BF6E196}"/>
+                <a16:creationId xmlns:a16="http://schemas.microsoft.com/office/drawing/2014/main" id="{B4FB6497-5B6B-4142-AE33-1EE6824D0EAA}"/>
               </a:ext>
             </a:extLst>
           </p:cNvPr>
@@ -4787,7 +4787,7 @@
           <p:cNvPr id="13" name="">
             <a:extLst xmlns:a="http://schemas.openxmlformats.org/drawingml/2006/main">
               <a:ext uri="{FF2B5EF4-FFF2-40B4-BE49-F238E27FC236}">
-                <a16:creationId xmlns:a16="http://schemas.microsoft.com/office/drawing/2014/main" id="{00FF0C1B-110A-4D98-870F-5300067C3BEB}"/>
+                <a16:creationId xmlns:a16="http://schemas.microsoft.com/office/drawing/2014/main" id="{AE0BEA8A-627A-4540-BCEA-70E1601824CD}"/>
               </a:ext>
             </a:extLst>
           </p:cNvPr>
@@ -4862,7 +4862,7 @@
           <p:cNvPr id="14" name="">
             <a:extLst xmlns:a="http://schemas.openxmlformats.org/drawingml/2006/main">
               <a:ext uri="{FF2B5EF4-FFF2-40B4-BE49-F238E27FC236}">
-                <a16:creationId xmlns:a16="http://schemas.microsoft.com/office/drawing/2014/main" id="{22170AF3-5916-43F3-820A-80EF1580FF4B}"/>
+                <a16:creationId xmlns:a16="http://schemas.microsoft.com/office/drawing/2014/main" id="{0D9F5C67-4D06-4962-A02B-B2DEF6DC2560}"/>
               </a:ext>
             </a:extLst>
           </p:cNvPr>
@@ -4899,7 +4899,7 @@
           <p:cNvPr id="15" name="">
             <a:extLst xmlns:a="http://schemas.openxmlformats.org/drawingml/2006/main">
               <a:ext uri="{FF2B5EF4-FFF2-40B4-BE49-F238E27FC236}">
-                <a16:creationId xmlns:a16="http://schemas.microsoft.com/office/drawing/2014/main" id="{F3AAC3AA-BD74-4229-80EB-B399EE0B74B2}"/>
+                <a16:creationId xmlns:a16="http://schemas.microsoft.com/office/drawing/2014/main" id="{B2797F29-3082-43BF-B39D-FDFFE6B8BB25}"/>
               </a:ext>
             </a:extLst>
           </p:cNvPr>
@@ -4934,7 +4934,7 @@
           <p:cNvPr id="16" name="">
             <a:extLst xmlns:a="http://schemas.openxmlformats.org/drawingml/2006/main">
               <a:ext uri="{FF2B5EF4-FFF2-40B4-BE49-F238E27FC236}">
-                <a16:creationId xmlns:a16="http://schemas.microsoft.com/office/drawing/2014/main" id="{B4609F9F-BC48-4C97-B5E9-9A906E000B73}"/>
+                <a16:creationId xmlns:a16="http://schemas.microsoft.com/office/drawing/2014/main" id="{1344D1EF-2EFB-42A1-9C0F-FBC7AEAAC878}"/>
               </a:ext>
             </a:extLst>
           </p:cNvPr>
@@ -4992,7 +4992,7 @@
           <p:cNvPr id="17" name="">
             <a:extLst xmlns:a="http://schemas.openxmlformats.org/drawingml/2006/main">
               <a:ext uri="{FF2B5EF4-FFF2-40B4-BE49-F238E27FC236}">
-                <a16:creationId xmlns:a16="http://schemas.microsoft.com/office/drawing/2014/main" id="{6D06162B-787E-4388-8ECB-D054895BB99F}"/>
+                <a16:creationId xmlns:a16="http://schemas.microsoft.com/office/drawing/2014/main" id="{134246AF-1392-4DEA-B373-5DFB9F63C18F}"/>
               </a:ext>
             </a:extLst>
           </p:cNvPr>
@@ -5084,7 +5084,7 @@
           <p:cNvPr id="18" name="">
             <a:extLst xmlns:a="http://schemas.openxmlformats.org/drawingml/2006/main">
               <a:ext uri="{FF2B5EF4-FFF2-40B4-BE49-F238E27FC236}">
-                <a16:creationId xmlns:a16="http://schemas.microsoft.com/office/drawing/2014/main" id="{085B9B93-6C3C-44B3-A2C7-42E36CE94DEB}"/>
+                <a16:creationId xmlns:a16="http://schemas.microsoft.com/office/drawing/2014/main" id="{05A4C597-E516-4A1F-9E0F-D4B3C77B9D65}"/>
               </a:ext>
             </a:extLst>
           </p:cNvPr>
@@ -5121,7 +5121,7 @@
           <p:cNvPr id="19" name="">
             <a:extLst xmlns:a="http://schemas.openxmlformats.org/drawingml/2006/main">
               <a:ext uri="{FF2B5EF4-FFF2-40B4-BE49-F238E27FC236}">
-                <a16:creationId xmlns:a16="http://schemas.microsoft.com/office/drawing/2014/main" id="{688DB952-77AB-4308-85AF-EC907B473248}"/>
+                <a16:creationId xmlns:a16="http://schemas.microsoft.com/office/drawing/2014/main" id="{928F6EA5-D76F-4F52-8F71-511BABC6F66B}"/>
               </a:ext>
             </a:extLst>
           </p:cNvPr>
@@ -5156,7 +5156,7 @@
           <p:cNvPr id="20" name="">
             <a:extLst xmlns:a="http://schemas.openxmlformats.org/drawingml/2006/main">
               <a:ext uri="{FF2B5EF4-FFF2-40B4-BE49-F238E27FC236}">
-                <a16:creationId xmlns:a16="http://schemas.microsoft.com/office/drawing/2014/main" id="{0C984A9E-4798-421F-86E0-0205A2847B7F}"/>
+                <a16:creationId xmlns:a16="http://schemas.microsoft.com/office/drawing/2014/main" id="{F60EDD69-CC40-4599-A732-C1B1CFE4C1F5}"/>
               </a:ext>
             </a:extLst>
           </p:cNvPr>
@@ -5214,7 +5214,7 @@
           <p:cNvPr id="21" name="">
             <a:extLst xmlns:a="http://schemas.openxmlformats.org/drawingml/2006/main">
               <a:ext uri="{FF2B5EF4-FFF2-40B4-BE49-F238E27FC236}">
-                <a16:creationId xmlns:a16="http://schemas.microsoft.com/office/drawing/2014/main" id="{0E4B4AC0-A3F8-4C8C-8D05-1A74675D8443}"/>
+                <a16:creationId xmlns:a16="http://schemas.microsoft.com/office/drawing/2014/main" id="{ED1A6053-2448-4E1E-BC07-BAF4259885DD}"/>
               </a:ext>
             </a:extLst>
           </p:cNvPr>
@@ -5306,7 +5306,7 @@
           <p:cNvPr id="22" name="">
             <a:extLst xmlns:a="http://schemas.openxmlformats.org/drawingml/2006/main">
               <a:ext uri="{FF2B5EF4-FFF2-40B4-BE49-F238E27FC236}">
-                <a16:creationId xmlns:a16="http://schemas.microsoft.com/office/drawing/2014/main" id="{4E8D4894-5F50-44CD-91D3-3118E6AE674B}"/>
+                <a16:creationId xmlns:a16="http://schemas.microsoft.com/office/drawing/2014/main" id="{C04640D6-015F-421B-8D4F-679660949209}"/>
               </a:ext>
             </a:extLst>
           </p:cNvPr>
@@ -5343,7 +5343,7 @@
           <p:cNvPr id="23" name="">
             <a:extLst xmlns:a="http://schemas.openxmlformats.org/drawingml/2006/main">
               <a:ext uri="{FF2B5EF4-FFF2-40B4-BE49-F238E27FC236}">
-                <a16:creationId xmlns:a16="http://schemas.microsoft.com/office/drawing/2014/main" id="{28FECF2F-D78C-45B7-8EE7-D7158E7B657A}"/>
+                <a16:creationId xmlns:a16="http://schemas.microsoft.com/office/drawing/2014/main" id="{62AC9757-2935-48B4-AA79-596C940503D5}"/>
               </a:ext>
             </a:extLst>
           </p:cNvPr>
@@ -5378,7 +5378,7 @@
           <p:cNvPr id="24" name="">
             <a:extLst xmlns:a="http://schemas.openxmlformats.org/drawingml/2006/main">
               <a:ext uri="{FF2B5EF4-FFF2-40B4-BE49-F238E27FC236}">
-                <a16:creationId xmlns:a16="http://schemas.microsoft.com/office/drawing/2014/main" id="{8BAC9702-ED78-4340-9A27-A9898619EC4E}"/>
+                <a16:creationId xmlns:a16="http://schemas.microsoft.com/office/drawing/2014/main" id="{31390366-C997-4E8F-B848-5FDC44871B44}"/>
               </a:ext>
             </a:extLst>
           </p:cNvPr>
@@ -5436,7 +5436,7 @@
           <p:cNvPr id="25" name="">
             <a:extLst xmlns:a="http://schemas.openxmlformats.org/drawingml/2006/main">
               <a:ext uri="{FF2B5EF4-FFF2-40B4-BE49-F238E27FC236}">
-                <a16:creationId xmlns:a16="http://schemas.microsoft.com/office/drawing/2014/main" id="{5F5CA2AA-D7FE-48EA-8CFE-D5F7EA0775F9}"/>
+                <a16:creationId xmlns:a16="http://schemas.microsoft.com/office/drawing/2014/main" id="{9B8CC9E8-2B7F-4D23-B0D1-F401AD4A03FB}"/>
               </a:ext>
             </a:extLst>
           </p:cNvPr>
@@ -5528,7 +5528,7 @@
           <p:cNvPr id="26" name="">
             <a:extLst xmlns:a="http://schemas.openxmlformats.org/drawingml/2006/main">
               <a:ext uri="{FF2B5EF4-FFF2-40B4-BE49-F238E27FC236}">
-                <a16:creationId xmlns:a16="http://schemas.microsoft.com/office/drawing/2014/main" id="{C299C63B-34CB-42E8-A656-663492606118}"/>
+                <a16:creationId xmlns:a16="http://schemas.microsoft.com/office/drawing/2014/main" id="{FC3D7DDE-3C37-4E31-BB70-4120809DC8C9}"/>
               </a:ext>
             </a:extLst>
           </p:cNvPr>
@@ -5565,7 +5565,7 @@
           <p:cNvPr id="27" name="">
             <a:extLst xmlns:a="http://schemas.openxmlformats.org/drawingml/2006/main">
               <a:ext uri="{FF2B5EF4-FFF2-40B4-BE49-F238E27FC236}">
-                <a16:creationId xmlns:a16="http://schemas.microsoft.com/office/drawing/2014/main" id="{0CAACB53-BCDA-46FD-AE5B-DC80337947B5}"/>
+                <a16:creationId xmlns:a16="http://schemas.microsoft.com/office/drawing/2014/main" id="{82BB3830-8E41-425C-AB6A-6AA71DDF621C}"/>
               </a:ext>
             </a:extLst>
           </p:cNvPr>
@@ -5600,7 +5600,7 @@
           <p:cNvPr id="28" name="">
             <a:extLst xmlns:a="http://schemas.openxmlformats.org/drawingml/2006/main">
               <a:ext uri="{FF2B5EF4-FFF2-40B4-BE49-F238E27FC236}">
-                <a16:creationId xmlns:a16="http://schemas.microsoft.com/office/drawing/2014/main" id="{FA144622-5D3C-4966-9FE5-E66230124759}"/>
+                <a16:creationId xmlns:a16="http://schemas.microsoft.com/office/drawing/2014/main" id="{1CD61796-2E2D-4AD9-9348-2F2702DBD5B9}"/>
               </a:ext>
             </a:extLst>
           </p:cNvPr>
@@ -5658,7 +5658,7 @@
           <p:cNvPr id="29" name="">
             <a:extLst xmlns:a="http://schemas.openxmlformats.org/drawingml/2006/main">
               <a:ext uri="{FF2B5EF4-FFF2-40B4-BE49-F238E27FC236}">
-                <a16:creationId xmlns:a16="http://schemas.microsoft.com/office/drawing/2014/main" id="{7295B26B-D5B0-4F32-9CCF-080768626ABA}"/>
+                <a16:creationId xmlns:a16="http://schemas.microsoft.com/office/drawing/2014/main" id="{417128D8-4258-44EE-A4FA-A1066AE49B91}"/>
               </a:ext>
             </a:extLst>
           </p:cNvPr>
@@ -5733,7 +5733,7 @@
           <p:cNvPr id="30" name="">
             <a:extLst xmlns:a="http://schemas.openxmlformats.org/drawingml/2006/main">
               <a:ext uri="{FF2B5EF4-FFF2-40B4-BE49-F238E27FC236}">
-                <a16:creationId xmlns:a16="http://schemas.microsoft.com/office/drawing/2014/main" id="{3B7E2732-E2A0-4CD2-B917-84916739130B}"/>
+                <a16:creationId xmlns:a16="http://schemas.microsoft.com/office/drawing/2014/main" id="{C52394EC-0670-41A7-87D0-E98B185B7BD7}"/>
               </a:ext>
             </a:extLst>
           </p:cNvPr>
@@ -5770,7 +5770,7 @@
           <p:cNvPr id="31" name="">
             <a:extLst xmlns:a="http://schemas.openxmlformats.org/drawingml/2006/main">
               <a:ext uri="{FF2B5EF4-FFF2-40B4-BE49-F238E27FC236}">
-                <a16:creationId xmlns:a16="http://schemas.microsoft.com/office/drawing/2014/main" id="{F3905A18-3E3A-47F2-BB5A-F6777F00AB09}"/>
+                <a16:creationId xmlns:a16="http://schemas.microsoft.com/office/drawing/2014/main" id="{3CB55DB7-AA4C-45E9-A3A1-6E62EF679DF0}"/>
               </a:ext>
             </a:extLst>
           </p:cNvPr>
@@ -5805,7 +5805,7 @@
           <p:cNvPr id="32" name="">
             <a:extLst xmlns:a="http://schemas.openxmlformats.org/drawingml/2006/main">
               <a:ext uri="{FF2B5EF4-FFF2-40B4-BE49-F238E27FC236}">
-                <a16:creationId xmlns:a16="http://schemas.microsoft.com/office/drawing/2014/main" id="{F9C73579-3A6D-4143-A380-800F93E4C35E}"/>
+                <a16:creationId xmlns:a16="http://schemas.microsoft.com/office/drawing/2014/main" id="{501F7918-CC4F-4F09-B056-6678F6EE6443}"/>
               </a:ext>
             </a:extLst>
           </p:cNvPr>
@@ -5863,7 +5863,7 @@
           <p:cNvPr id="33" name="">
             <a:extLst xmlns:a="http://schemas.openxmlformats.org/drawingml/2006/main">
               <a:ext uri="{FF2B5EF4-FFF2-40B4-BE49-F238E27FC236}">
-                <a16:creationId xmlns:a16="http://schemas.microsoft.com/office/drawing/2014/main" id="{CFCD5245-9CA7-498B-A0CD-D7536A3D3562}"/>
+                <a16:creationId xmlns:a16="http://schemas.microsoft.com/office/drawing/2014/main" id="{5606EC4B-786F-41D0-9800-8F542662B54E}"/>
               </a:ext>
             </a:extLst>
           </p:cNvPr>
@@ -5938,7 +5938,7 @@
           <p:cNvPr id="34" name="">
             <a:extLst xmlns:a="http://schemas.openxmlformats.org/drawingml/2006/main">
               <a:ext uri="{FF2B5EF4-FFF2-40B4-BE49-F238E27FC236}">
-                <a16:creationId xmlns:a16="http://schemas.microsoft.com/office/drawing/2014/main" id="{B590F931-1705-467E-9A84-A3DF2D9317D5}"/>
+                <a16:creationId xmlns:a16="http://schemas.microsoft.com/office/drawing/2014/main" id="{1907A304-3B5E-4AEB-B074-176A3ECD9632}"/>
               </a:ext>
             </a:extLst>
           </p:cNvPr>
@@ -5973,7 +5973,7 @@
           <p:cNvPr id="35" name="">
             <a:extLst xmlns:a="http://schemas.openxmlformats.org/drawingml/2006/main">
               <a:ext uri="{FF2B5EF4-FFF2-40B4-BE49-F238E27FC236}">
-                <a16:creationId xmlns:a16="http://schemas.microsoft.com/office/drawing/2014/main" id="{63D238C3-92BF-4915-B1F6-BA1E34427453}"/>
+                <a16:creationId xmlns:a16="http://schemas.microsoft.com/office/drawing/2014/main" id="{ABC98EFA-7954-40F8-BB58-72C960AF46DE}"/>
               </a:ext>
             </a:extLst>
           </p:cNvPr>
@@ -6008,7 +6008,7 @@
           <p:cNvPr id="36" name="">
             <a:extLst xmlns:a="http://schemas.openxmlformats.org/drawingml/2006/main">
               <a:ext uri="{FF2B5EF4-FFF2-40B4-BE49-F238E27FC236}">
-                <a16:creationId xmlns:a16="http://schemas.microsoft.com/office/drawing/2014/main" id="{2AD828A5-A1DB-49F7-AC58-E398DB307E9F}"/>
+                <a16:creationId xmlns:a16="http://schemas.microsoft.com/office/drawing/2014/main" id="{DA6A8A0E-8013-43D4-92A1-C2EAEEA45CAE}"/>
               </a:ext>
             </a:extLst>
           </p:cNvPr>
@@ -6066,7 +6066,7 @@
           <p:cNvPr id="37" name="">
             <a:extLst xmlns:a="http://schemas.openxmlformats.org/drawingml/2006/main">
               <a:ext uri="{FF2B5EF4-FFF2-40B4-BE49-F238E27FC236}">
-                <a16:creationId xmlns:a16="http://schemas.microsoft.com/office/drawing/2014/main" id="{52F95EAF-3E14-4EAE-A6AD-CFA8237EF148}"/>
+                <a16:creationId xmlns:a16="http://schemas.microsoft.com/office/drawing/2014/main" id="{9485E434-3817-461A-935C-BF8263B9751D}"/>
               </a:ext>
             </a:extLst>
           </p:cNvPr>
@@ -6122,7 +6122,7 @@
     </p:spTree>
     <p:extLst>
       <p:ext uri="{BB962C8B-B14F-4D97-AF65-F5344CB8AC3E}">
-        <p14:creationId xmlns:p14="http://schemas.microsoft.com/office/powerpoint/2010/main" val="1034592955"/>
+        <p14:creationId xmlns:p14="http://schemas.microsoft.com/office/powerpoint/2010/main" val="1782805291"/>
       </p:ext>
     </p:extLst>
   </p:cSld>
@@ -6153,7 +6153,7 @@
           <p:cNvPr id="1" name="Slide Number Placeholder 5">
             <a:extLst xmlns:a="http://schemas.openxmlformats.org/drawingml/2006/main">
               <a:ext uri="{FF2B5EF4-FFF2-40B4-BE49-F238E27FC236}">
-                <a16:creationId xmlns:a16="http://schemas.microsoft.com/office/drawing/2014/main" id="{C5A324B5-703D-4DE1-A920-5C56CD46E34C}"/>
+                <a16:creationId xmlns:a16="http://schemas.microsoft.com/office/drawing/2014/main" id="{E12CE447-476B-4BAE-A1FF-E669E79965E6}"/>
               </a:ext>
             </a:extLst>
           </p:cNvPr>
@@ -6189,7 +6189,7 @@
           <p:nvPr/>
         </p:nvPicPr>
         <p:blipFill>
-          <a:blip xmlns:r="http://schemas.openxmlformats.org/officeDocument/2006/relationships" xmlns:a="http://schemas.openxmlformats.org/drawingml/2006/main" r:embed="Reee44c2ace5b48b7"/>
+          <a:blip xmlns:r="http://schemas.openxmlformats.org/officeDocument/2006/relationships" xmlns:a="http://schemas.openxmlformats.org/drawingml/2006/main" r:embed="R5cf176069fa3486b"/>
           <a:srcRect xmlns:a="http://schemas.openxmlformats.org/drawingml/2006/main" l="0" t="21875" r="0" b="21875"/>
           <a:stretch xmlns:a="http://schemas.openxmlformats.org/drawingml/2006/main">
             <a:fillRect l="0" t="0" r="0" b="0"/>
@@ -6210,7 +6210,7 @@
           <p:cNvPr id="3" name="">
             <a:extLst xmlns:a="http://schemas.openxmlformats.org/drawingml/2006/main">
               <a:ext uri="{FF2B5EF4-FFF2-40B4-BE49-F238E27FC236}">
-                <a16:creationId xmlns:a16="http://schemas.microsoft.com/office/drawing/2014/main" id="{E6415012-93CE-419D-8963-5660A4D4D8B8}"/>
+                <a16:creationId xmlns:a16="http://schemas.microsoft.com/office/drawing/2014/main" id="{05FE0591-4EBF-456F-8AC7-839659264A1C}"/>
               </a:ext>
             </a:extLst>
           </p:cNvPr>
@@ -6245,7 +6245,7 @@
           <p:cNvPr id="4" name="">
             <a:extLst xmlns:a="http://schemas.openxmlformats.org/drawingml/2006/main">
               <a:ext uri="{FF2B5EF4-FFF2-40B4-BE49-F238E27FC236}">
-                <a16:creationId xmlns:a16="http://schemas.microsoft.com/office/drawing/2014/main" id="{92626966-6A44-4F64-A0E0-F086DF933677}"/>
+                <a16:creationId xmlns:a16="http://schemas.microsoft.com/office/drawing/2014/main" id="{53E1A65E-7774-444E-9A39-67D67554D12B}"/>
               </a:ext>
             </a:extLst>
           </p:cNvPr>
@@ -6280,7 +6280,7 @@
           <p:cNvPr id="5" name="">
             <a:extLst xmlns:a="http://schemas.openxmlformats.org/drawingml/2006/main">
               <a:ext uri="{FF2B5EF4-FFF2-40B4-BE49-F238E27FC236}">
-                <a16:creationId xmlns:a16="http://schemas.microsoft.com/office/drawing/2014/main" id="{ECF81256-4E17-4D80-9ACB-429AA9840B23}"/>
+                <a16:creationId xmlns:a16="http://schemas.microsoft.com/office/drawing/2014/main" id="{71880B04-6F7E-4879-BB47-32E946BAF024}"/>
               </a:ext>
             </a:extLst>
           </p:cNvPr>
@@ -6317,7 +6317,7 @@
           <p:cNvPr id="6" name="">
             <a:extLst xmlns:a="http://schemas.openxmlformats.org/drawingml/2006/main">
               <a:ext uri="{FF2B5EF4-FFF2-40B4-BE49-F238E27FC236}">
-                <a16:creationId xmlns:a16="http://schemas.microsoft.com/office/drawing/2014/main" id="{1B46640F-5BDA-4076-B7F2-8DC624DFF839}"/>
+                <a16:creationId xmlns:a16="http://schemas.microsoft.com/office/drawing/2014/main" id="{CB584B2F-A9FC-4A16-B060-B73EF2BAD8EE}"/>
               </a:ext>
             </a:extLst>
           </p:cNvPr>
@@ -6354,7 +6354,7 @@
           <p:cNvPr id="7" name="">
             <a:extLst xmlns:a="http://schemas.openxmlformats.org/drawingml/2006/main">
               <a:ext uri="{FF2B5EF4-FFF2-40B4-BE49-F238E27FC236}">
-                <a16:creationId xmlns:a16="http://schemas.microsoft.com/office/drawing/2014/main" id="{93C83A10-A72E-46D4-83D4-9BA9E23F6713}"/>
+                <a16:creationId xmlns:a16="http://schemas.microsoft.com/office/drawing/2014/main" id="{A52FBEFA-C7EF-482C-8527-3799D8585ADB}"/>
               </a:ext>
             </a:extLst>
           </p:cNvPr>
@@ -6391,7 +6391,7 @@
           <p:cNvPr id="8" name="">
             <a:extLst xmlns:a="http://schemas.openxmlformats.org/drawingml/2006/main">
               <a:ext uri="{FF2B5EF4-FFF2-40B4-BE49-F238E27FC236}">
-                <a16:creationId xmlns:a16="http://schemas.microsoft.com/office/drawing/2014/main" id="{E11E8CB7-054F-4F11-9EE1-65BBB637104B}"/>
+                <a16:creationId xmlns:a16="http://schemas.microsoft.com/office/drawing/2014/main" id="{A2E7140B-585D-4EEE-8070-FA653D212BE0}"/>
               </a:ext>
             </a:extLst>
           </p:cNvPr>
@@ -6428,7 +6428,7 @@
           <p:cNvPr id="9" name="">
             <a:extLst xmlns:a="http://schemas.openxmlformats.org/drawingml/2006/main">
               <a:ext uri="{FF2B5EF4-FFF2-40B4-BE49-F238E27FC236}">
-                <a16:creationId xmlns:a16="http://schemas.microsoft.com/office/drawing/2014/main" id="{0251E736-6239-4BEA-9F35-4686A47F9ADE}"/>
+                <a16:creationId xmlns:a16="http://schemas.microsoft.com/office/drawing/2014/main" id="{DF1BFB32-E0E7-4507-81E2-5529271D5CDD}"/>
               </a:ext>
             </a:extLst>
           </p:cNvPr>
@@ -6486,7 +6486,7 @@
           <p:cNvPr id="10" name="">
             <a:extLst xmlns:a="http://schemas.openxmlformats.org/drawingml/2006/main">
               <a:ext uri="{FF2B5EF4-FFF2-40B4-BE49-F238E27FC236}">
-                <a16:creationId xmlns:a16="http://schemas.microsoft.com/office/drawing/2014/main" id="{A0F7E5C4-AE7F-4673-8E41-04EC8E2A0212}"/>
+                <a16:creationId xmlns:a16="http://schemas.microsoft.com/office/drawing/2014/main" id="{ABBD20BE-7227-4841-9AC6-7A1470A28E53}"/>
               </a:ext>
             </a:extLst>
           </p:cNvPr>
@@ -6544,7 +6544,7 @@
           <p:cNvPr id="11" name="">
             <a:extLst xmlns:a="http://schemas.openxmlformats.org/drawingml/2006/main">
               <a:ext uri="{FF2B5EF4-FFF2-40B4-BE49-F238E27FC236}">
-                <a16:creationId xmlns:a16="http://schemas.microsoft.com/office/drawing/2014/main" id="{ED51146E-F65F-4AFA-8092-5C5F0668FDAA}"/>
+                <a16:creationId xmlns:a16="http://schemas.microsoft.com/office/drawing/2014/main" id="{2B893AD9-81D5-4D8A-B47C-BB10191F0347}"/>
               </a:ext>
             </a:extLst>
           </p:cNvPr>
@@ -6579,7 +6579,7 @@
           <p:cNvPr id="12" name="">
             <a:extLst xmlns:a="http://schemas.openxmlformats.org/drawingml/2006/main">
               <a:ext uri="{FF2B5EF4-FFF2-40B4-BE49-F238E27FC236}">
-                <a16:creationId xmlns:a16="http://schemas.microsoft.com/office/drawing/2014/main" id="{707F5BB0-CEC1-49B9-B424-C575767E7720}"/>
+                <a16:creationId xmlns:a16="http://schemas.microsoft.com/office/drawing/2014/main" id="{C0F4889B-3840-4689-AE10-00199D88CD74}"/>
               </a:ext>
             </a:extLst>
           </p:cNvPr>
@@ -6612,7 +6612,7 @@
           <p:cNvPr id="13" name="">
             <a:extLst xmlns:a="http://schemas.openxmlformats.org/drawingml/2006/main">
               <a:ext uri="{FF2B5EF4-FFF2-40B4-BE49-F238E27FC236}">
-                <a16:creationId xmlns:a16="http://schemas.microsoft.com/office/drawing/2014/main" id="{DDBD6A73-A34F-4779-A0E3-6A17A18BA0E0}"/>
+                <a16:creationId xmlns:a16="http://schemas.microsoft.com/office/drawing/2014/main" id="{7BA2165B-E9EF-46D6-A41D-A8D9A5FCCC53}"/>
               </a:ext>
             </a:extLst>
           </p:cNvPr>
@@ -6687,7 +6687,7 @@
           <p:cNvPr id="14" name="">
             <a:extLst xmlns:a="http://schemas.openxmlformats.org/drawingml/2006/main">
               <a:ext uri="{FF2B5EF4-FFF2-40B4-BE49-F238E27FC236}">
-                <a16:creationId xmlns:a16="http://schemas.microsoft.com/office/drawing/2014/main" id="{3FCCE651-3340-430A-867C-454953EA75D4}"/>
+                <a16:creationId xmlns:a16="http://schemas.microsoft.com/office/drawing/2014/main" id="{C1B5517D-02D5-42B3-B174-D5CA690E9283}"/>
               </a:ext>
             </a:extLst>
           </p:cNvPr>
@@ -6722,7 +6722,7 @@
           <p:cNvPr id="15" name="">
             <a:extLst xmlns:a="http://schemas.openxmlformats.org/drawingml/2006/main">
               <a:ext uri="{FF2B5EF4-FFF2-40B4-BE49-F238E27FC236}">
-                <a16:creationId xmlns:a16="http://schemas.microsoft.com/office/drawing/2014/main" id="{D7854F1C-541E-4795-BB7D-7CEC38D97B57}"/>
+                <a16:creationId xmlns:a16="http://schemas.microsoft.com/office/drawing/2014/main" id="{1A1E0697-767B-4998-9C26-C7ACFB0011E8}"/>
               </a:ext>
             </a:extLst>
           </p:cNvPr>
@@ -6757,7 +6757,7 @@
           <p:cNvPr id="16" name="">
             <a:extLst xmlns:a="http://schemas.openxmlformats.org/drawingml/2006/main">
               <a:ext uri="{FF2B5EF4-FFF2-40B4-BE49-F238E27FC236}">
-                <a16:creationId xmlns:a16="http://schemas.microsoft.com/office/drawing/2014/main" id="{C6C1C7B5-9B33-4FCB-AD15-5B7931439FF2}"/>
+                <a16:creationId xmlns:a16="http://schemas.microsoft.com/office/drawing/2014/main" id="{3F525599-6856-4836-894C-3722D0C14D9E}"/>
               </a:ext>
             </a:extLst>
           </p:cNvPr>
@@ -6815,7 +6815,7 @@
           <p:cNvPr id="17" name="">
             <a:extLst xmlns:a="http://schemas.openxmlformats.org/drawingml/2006/main">
               <a:ext uri="{FF2B5EF4-FFF2-40B4-BE49-F238E27FC236}">
-                <a16:creationId xmlns:a16="http://schemas.microsoft.com/office/drawing/2014/main" id="{E7652316-9406-418D-9A47-8F15A442D2B5}"/>
+                <a16:creationId xmlns:a16="http://schemas.microsoft.com/office/drawing/2014/main" id="{BF7D4763-7271-4AB9-8D3C-B622AB701222}"/>
               </a:ext>
             </a:extLst>
           </p:cNvPr>
@@ -6907,7 +6907,7 @@
           <p:cNvPr id="18" name="">
             <a:extLst xmlns:a="http://schemas.openxmlformats.org/drawingml/2006/main">
               <a:ext uri="{FF2B5EF4-FFF2-40B4-BE49-F238E27FC236}">
-                <a16:creationId xmlns:a16="http://schemas.microsoft.com/office/drawing/2014/main" id="{C5C0CD3A-43F5-42D6-BD9D-B308EA68EDB4}"/>
+                <a16:creationId xmlns:a16="http://schemas.microsoft.com/office/drawing/2014/main" id="{E0D65D5E-B585-4054-B53B-00D146C2C58E}"/>
               </a:ext>
             </a:extLst>
           </p:cNvPr>
@@ -6944,7 +6944,7 @@
           <p:cNvPr id="19" name="">
             <a:extLst xmlns:a="http://schemas.openxmlformats.org/drawingml/2006/main">
               <a:ext uri="{FF2B5EF4-FFF2-40B4-BE49-F238E27FC236}">
-                <a16:creationId xmlns:a16="http://schemas.microsoft.com/office/drawing/2014/main" id="{C3D7DFA0-E29D-40E3-83E1-3BE6240D2BFC}"/>
+                <a16:creationId xmlns:a16="http://schemas.microsoft.com/office/drawing/2014/main" id="{A84996C3-66B5-44EF-9CC8-367026EC2707}"/>
               </a:ext>
             </a:extLst>
           </p:cNvPr>
@@ -6979,7 +6979,7 @@
           <p:cNvPr id="20" name="">
             <a:extLst xmlns:a="http://schemas.openxmlformats.org/drawingml/2006/main">
               <a:ext uri="{FF2B5EF4-FFF2-40B4-BE49-F238E27FC236}">
-                <a16:creationId xmlns:a16="http://schemas.microsoft.com/office/drawing/2014/main" id="{2462642F-1698-4D4F-A78A-31644144CC0A}"/>
+                <a16:creationId xmlns:a16="http://schemas.microsoft.com/office/drawing/2014/main" id="{485F01DB-35A1-4E7A-95B2-B6F415815E88}"/>
               </a:ext>
             </a:extLst>
           </p:cNvPr>
@@ -7037,7 +7037,7 @@
           <p:cNvPr id="21" name="">
             <a:extLst xmlns:a="http://schemas.openxmlformats.org/drawingml/2006/main">
               <a:ext uri="{FF2B5EF4-FFF2-40B4-BE49-F238E27FC236}">
-                <a16:creationId xmlns:a16="http://schemas.microsoft.com/office/drawing/2014/main" id="{5E5E52F4-651B-4023-A898-CD1101607EF0}"/>
+                <a16:creationId xmlns:a16="http://schemas.microsoft.com/office/drawing/2014/main" id="{8A89806E-05DB-4813-97B8-D077B3BDC34B}"/>
               </a:ext>
             </a:extLst>
           </p:cNvPr>
@@ -7112,7 +7112,7 @@
           <p:cNvPr id="22" name="">
             <a:extLst xmlns:a="http://schemas.openxmlformats.org/drawingml/2006/main">
               <a:ext uri="{FF2B5EF4-FFF2-40B4-BE49-F238E27FC236}">
-                <a16:creationId xmlns:a16="http://schemas.microsoft.com/office/drawing/2014/main" id="{DFD08784-2FCA-4381-9FA6-E790B413FEF8}"/>
+                <a16:creationId xmlns:a16="http://schemas.microsoft.com/office/drawing/2014/main" id="{080179DE-3D04-4C22-85C0-155F7E46CAD0}"/>
               </a:ext>
             </a:extLst>
           </p:cNvPr>
@@ -7149,7 +7149,7 @@
           <p:cNvPr id="23" name="">
             <a:extLst xmlns:a="http://schemas.openxmlformats.org/drawingml/2006/main">
               <a:ext uri="{FF2B5EF4-FFF2-40B4-BE49-F238E27FC236}">
-                <a16:creationId xmlns:a16="http://schemas.microsoft.com/office/drawing/2014/main" id="{E1A98BB8-C7D5-437E-9BB2-2603587F619C}"/>
+                <a16:creationId xmlns:a16="http://schemas.microsoft.com/office/drawing/2014/main" id="{12685967-B6B6-4D18-9B10-C0378A607448}"/>
               </a:ext>
             </a:extLst>
           </p:cNvPr>
@@ -7184,7 +7184,7 @@
           <p:cNvPr id="24" name="">
             <a:extLst xmlns:a="http://schemas.openxmlformats.org/drawingml/2006/main">
               <a:ext uri="{FF2B5EF4-FFF2-40B4-BE49-F238E27FC236}">
-                <a16:creationId xmlns:a16="http://schemas.microsoft.com/office/drawing/2014/main" id="{E7701DAB-176C-4F1A-A54F-4EC43B8DF16B}"/>
+                <a16:creationId xmlns:a16="http://schemas.microsoft.com/office/drawing/2014/main" id="{688BE405-ADA1-4032-B931-01AA03C0AD52}"/>
               </a:ext>
             </a:extLst>
           </p:cNvPr>
@@ -7242,7 +7242,7 @@
           <p:cNvPr id="25" name="">
             <a:extLst xmlns:a="http://schemas.openxmlformats.org/drawingml/2006/main">
               <a:ext uri="{FF2B5EF4-FFF2-40B4-BE49-F238E27FC236}">
-                <a16:creationId xmlns:a16="http://schemas.microsoft.com/office/drawing/2014/main" id="{4025825A-1E18-4D1E-8053-FC1122777C36}"/>
+                <a16:creationId xmlns:a16="http://schemas.microsoft.com/office/drawing/2014/main" id="{B6195A30-CA7F-4D81-93B2-2D66CE07777A}"/>
               </a:ext>
             </a:extLst>
           </p:cNvPr>
@@ -7317,7 +7317,7 @@
           <p:cNvPr id="26" name="">
             <a:extLst xmlns:a="http://schemas.openxmlformats.org/drawingml/2006/main">
               <a:ext uri="{FF2B5EF4-FFF2-40B4-BE49-F238E27FC236}">
-                <a16:creationId xmlns:a16="http://schemas.microsoft.com/office/drawing/2014/main" id="{8BC51728-040A-4647-94AA-EC0159B2242E}"/>
+                <a16:creationId xmlns:a16="http://schemas.microsoft.com/office/drawing/2014/main" id="{72192983-648D-47BB-89BB-4E240B79DC4C}"/>
               </a:ext>
             </a:extLst>
           </p:cNvPr>
@@ -7352,7 +7352,7 @@
           <p:cNvPr id="27" name="">
             <a:extLst xmlns:a="http://schemas.openxmlformats.org/drawingml/2006/main">
               <a:ext uri="{FF2B5EF4-FFF2-40B4-BE49-F238E27FC236}">
-                <a16:creationId xmlns:a16="http://schemas.microsoft.com/office/drawing/2014/main" id="{21807D95-707A-4D37-9056-87136B12CFE3}"/>
+                <a16:creationId xmlns:a16="http://schemas.microsoft.com/office/drawing/2014/main" id="{15700A4B-6841-4F61-8C83-D0565F51BD5B}"/>
               </a:ext>
             </a:extLst>
           </p:cNvPr>
@@ -7387,7 +7387,7 @@
           <p:cNvPr id="28" name="">
             <a:extLst xmlns:a="http://schemas.openxmlformats.org/drawingml/2006/main">
               <a:ext uri="{FF2B5EF4-FFF2-40B4-BE49-F238E27FC236}">
-                <a16:creationId xmlns:a16="http://schemas.microsoft.com/office/drawing/2014/main" id="{D7B3F8CD-2C18-4D77-877F-B759271BA50B}"/>
+                <a16:creationId xmlns:a16="http://schemas.microsoft.com/office/drawing/2014/main" id="{6746FB12-B3CC-4939-B356-0B8EB84236B0}"/>
               </a:ext>
             </a:extLst>
           </p:cNvPr>
@@ -7445,7 +7445,7 @@
           <p:cNvPr id="29" name="">
             <a:extLst xmlns:a="http://schemas.openxmlformats.org/drawingml/2006/main">
               <a:ext uri="{FF2B5EF4-FFF2-40B4-BE49-F238E27FC236}">
-                <a16:creationId xmlns:a16="http://schemas.microsoft.com/office/drawing/2014/main" id="{0C318382-F0F4-4C16-9CB1-226502764E2B}"/>
+                <a16:creationId xmlns:a16="http://schemas.microsoft.com/office/drawing/2014/main" id="{B9B22DEA-F9E3-4D78-B9CA-C1F46244C4AB}"/>
               </a:ext>
             </a:extLst>
           </p:cNvPr>
@@ -7503,7 +7503,7 @@
           <p:cNvPr id="30" name="">
             <a:extLst xmlns:a="http://schemas.openxmlformats.org/drawingml/2006/main">
               <a:ext uri="{FF2B5EF4-FFF2-40B4-BE49-F238E27FC236}">
-                <a16:creationId xmlns:a16="http://schemas.microsoft.com/office/drawing/2014/main" id="{748299AC-8E26-4A8C-A11A-E73051B72810}"/>
+                <a16:creationId xmlns:a16="http://schemas.microsoft.com/office/drawing/2014/main" id="{98FC0606-F49D-4CF5-9171-A2D513400360}"/>
               </a:ext>
             </a:extLst>
           </p:cNvPr>
@@ -7538,7 +7538,7 @@
           <p:cNvPr id="31" name="">
             <a:extLst xmlns:a="http://schemas.openxmlformats.org/drawingml/2006/main">
               <a:ext uri="{FF2B5EF4-FFF2-40B4-BE49-F238E27FC236}">
-                <a16:creationId xmlns:a16="http://schemas.microsoft.com/office/drawing/2014/main" id="{8620376C-1A2F-4807-A55A-7D569E2E3467}"/>
+                <a16:creationId xmlns:a16="http://schemas.microsoft.com/office/drawing/2014/main" id="{49E0466E-BD81-4330-B3F8-3FC897C2CBB5}"/>
               </a:ext>
             </a:extLst>
           </p:cNvPr>
@@ -7596,7 +7596,7 @@
           <p:cNvPr id="32" name="">
             <a:extLst xmlns:a="http://schemas.openxmlformats.org/drawingml/2006/main">
               <a:ext uri="{FF2B5EF4-FFF2-40B4-BE49-F238E27FC236}">
-                <a16:creationId xmlns:a16="http://schemas.microsoft.com/office/drawing/2014/main" id="{BAC7CE47-1FBD-4437-A507-6FF64C66303F}"/>
+                <a16:creationId xmlns:a16="http://schemas.microsoft.com/office/drawing/2014/main" id="{B88DE70F-B4F5-445F-AB6B-D3A5D6D704E8}"/>
               </a:ext>
             </a:extLst>
           </p:cNvPr>
@@ -7654,7 +7654,7 @@
           <p:cNvPr id="33" name="">
             <a:extLst xmlns:a="http://schemas.openxmlformats.org/drawingml/2006/main">
               <a:ext uri="{FF2B5EF4-FFF2-40B4-BE49-F238E27FC236}">
-                <a16:creationId xmlns:a16="http://schemas.microsoft.com/office/drawing/2014/main" id="{0BF795FA-2AB2-402C-8341-33180E69A23D}"/>
+                <a16:creationId xmlns:a16="http://schemas.microsoft.com/office/drawing/2014/main" id="{3C86D310-FF81-48EB-A668-1085D89C7EFD}"/>
               </a:ext>
             </a:extLst>
           </p:cNvPr>
@@ -7710,7 +7710,7 @@
     </p:spTree>
     <p:extLst>
       <p:ext uri="{BB962C8B-B14F-4D97-AF65-F5344CB8AC3E}">
-        <p14:creationId xmlns:p14="http://schemas.microsoft.com/office/powerpoint/2010/main" val="751935747"/>
+        <p14:creationId xmlns:p14="http://schemas.microsoft.com/office/powerpoint/2010/main" val="1334124735"/>
       </p:ext>
     </p:extLst>
   </p:cSld>
@@ -7741,7 +7741,7 @@
           <p:cNvPr id="1" name="Slide Number Placeholder 5">
             <a:extLst xmlns:a="http://schemas.openxmlformats.org/drawingml/2006/main">
               <a:ext uri="{FF2B5EF4-FFF2-40B4-BE49-F238E27FC236}">
-                <a16:creationId xmlns:a16="http://schemas.microsoft.com/office/drawing/2014/main" id="{C5A324B5-703D-4DE1-A920-5C56CD46E34C}"/>
+                <a16:creationId xmlns:a16="http://schemas.microsoft.com/office/drawing/2014/main" id="{E12CE447-476B-4BAE-A1FF-E669E79965E6}"/>
               </a:ext>
             </a:extLst>
           </p:cNvPr>
@@ -7777,7 +7777,7 @@
           <p:nvPr/>
         </p:nvPicPr>
         <p:blipFill>
-          <a:blip xmlns:r="http://schemas.openxmlformats.org/officeDocument/2006/relationships" xmlns:a="http://schemas.openxmlformats.org/drawingml/2006/main" r:embed="R1d6812a3b8b9464a"/>
+          <a:blip xmlns:r="http://schemas.openxmlformats.org/officeDocument/2006/relationships" xmlns:a="http://schemas.openxmlformats.org/drawingml/2006/main" r:embed="Rf5fefd5a0f61438b"/>
           <a:srcRect xmlns:a="http://schemas.openxmlformats.org/drawingml/2006/main" l="0" t="21875" r="0" b="21875"/>
           <a:stretch xmlns:a="http://schemas.openxmlformats.org/drawingml/2006/main">
             <a:fillRect l="0" t="0" r="0" b="0"/>
@@ -7798,7 +7798,7 @@
           <p:cNvPr id="3" name="">
             <a:extLst xmlns:a="http://schemas.openxmlformats.org/drawingml/2006/main">
               <a:ext uri="{FF2B5EF4-FFF2-40B4-BE49-F238E27FC236}">
-                <a16:creationId xmlns:a16="http://schemas.microsoft.com/office/drawing/2014/main" id="{61B2F2FE-D45E-4F28-8207-98FD5FDD3AC6}"/>
+                <a16:creationId xmlns:a16="http://schemas.microsoft.com/office/drawing/2014/main" id="{9384C98C-857B-44F1-8730-842DD6CF5344}"/>
               </a:ext>
             </a:extLst>
           </p:cNvPr>
@@ -7833,7 +7833,7 @@
           <p:cNvPr id="4" name="">
             <a:extLst xmlns:a="http://schemas.openxmlformats.org/drawingml/2006/main">
               <a:ext uri="{FF2B5EF4-FFF2-40B4-BE49-F238E27FC236}">
-                <a16:creationId xmlns:a16="http://schemas.microsoft.com/office/drawing/2014/main" id="{7959BEDD-BB45-4594-B509-1B3C33A56CFE}"/>
+                <a16:creationId xmlns:a16="http://schemas.microsoft.com/office/drawing/2014/main" id="{D674D4FC-FFC7-4ABB-9406-1E580C6EA1C0}"/>
               </a:ext>
             </a:extLst>
           </p:cNvPr>
@@ -7868,7 +7868,7 @@
           <p:cNvPr id="5" name="">
             <a:extLst xmlns:a="http://schemas.openxmlformats.org/drawingml/2006/main">
               <a:ext uri="{FF2B5EF4-FFF2-40B4-BE49-F238E27FC236}">
-                <a16:creationId xmlns:a16="http://schemas.microsoft.com/office/drawing/2014/main" id="{17D64DE0-A02E-4316-B61D-10346678C851}"/>
+                <a16:creationId xmlns:a16="http://schemas.microsoft.com/office/drawing/2014/main" id="{C420D122-7475-4611-8B91-7969E183BC8A}"/>
               </a:ext>
             </a:extLst>
           </p:cNvPr>
@@ -7905,7 +7905,7 @@
           <p:cNvPr id="6" name="">
             <a:extLst xmlns:a="http://schemas.openxmlformats.org/drawingml/2006/main">
               <a:ext uri="{FF2B5EF4-FFF2-40B4-BE49-F238E27FC236}">
-                <a16:creationId xmlns:a16="http://schemas.microsoft.com/office/drawing/2014/main" id="{AB646430-18B3-4305-9232-7FF46E50C256}"/>
+                <a16:creationId xmlns:a16="http://schemas.microsoft.com/office/drawing/2014/main" id="{F714CD26-F999-4CFC-BF53-65E57786D881}"/>
               </a:ext>
             </a:extLst>
           </p:cNvPr>
@@ -7942,7 +7942,7 @@
           <p:cNvPr id="7" name="">
             <a:extLst xmlns:a="http://schemas.openxmlformats.org/drawingml/2006/main">
               <a:ext uri="{FF2B5EF4-FFF2-40B4-BE49-F238E27FC236}">
-                <a16:creationId xmlns:a16="http://schemas.microsoft.com/office/drawing/2014/main" id="{FDB720F7-2A5A-422E-8757-5A878BC7BB72}"/>
+                <a16:creationId xmlns:a16="http://schemas.microsoft.com/office/drawing/2014/main" id="{02D6D254-8613-4E69-9273-8735EA4E55E9}"/>
               </a:ext>
             </a:extLst>
           </p:cNvPr>
@@ -7979,7 +7979,7 @@
           <p:cNvPr id="8" name="">
             <a:extLst xmlns:a="http://schemas.openxmlformats.org/drawingml/2006/main">
               <a:ext uri="{FF2B5EF4-FFF2-40B4-BE49-F238E27FC236}">
-                <a16:creationId xmlns:a16="http://schemas.microsoft.com/office/drawing/2014/main" id="{2399A639-A4BA-4DAB-ACCC-327AA5299386}"/>
+                <a16:creationId xmlns:a16="http://schemas.microsoft.com/office/drawing/2014/main" id="{0591ADF7-41AF-41F4-9340-7444EB809B0C}"/>
               </a:ext>
             </a:extLst>
           </p:cNvPr>
@@ -8016,7 +8016,7 @@
           <p:cNvPr id="9" name="">
             <a:extLst xmlns:a="http://schemas.openxmlformats.org/drawingml/2006/main">
               <a:ext uri="{FF2B5EF4-FFF2-40B4-BE49-F238E27FC236}">
-                <a16:creationId xmlns:a16="http://schemas.microsoft.com/office/drawing/2014/main" id="{C0A2039F-D8D0-490E-9BB1-DBE84AF7F2D1}"/>
+                <a16:creationId xmlns:a16="http://schemas.microsoft.com/office/drawing/2014/main" id="{D9DC9BC4-0E6C-4EE2-BC5A-436B80B9535C}"/>
               </a:ext>
             </a:extLst>
           </p:cNvPr>
@@ -8074,7 +8074,7 @@
           <p:cNvPr id="10" name="">
             <a:extLst xmlns:a="http://schemas.openxmlformats.org/drawingml/2006/main">
               <a:ext uri="{FF2B5EF4-FFF2-40B4-BE49-F238E27FC236}">
-                <a16:creationId xmlns:a16="http://schemas.microsoft.com/office/drawing/2014/main" id="{45C244AB-0B59-43E5-B5EC-F76E79FB8DFC}"/>
+                <a16:creationId xmlns:a16="http://schemas.microsoft.com/office/drawing/2014/main" id="{7CE02FFF-EEEA-40A7-A81C-C67523107C97}"/>
               </a:ext>
             </a:extLst>
           </p:cNvPr>
@@ -8132,7 +8132,7 @@
           <p:cNvPr id="11" name="">
             <a:extLst xmlns:a="http://schemas.openxmlformats.org/drawingml/2006/main">
               <a:ext uri="{FF2B5EF4-FFF2-40B4-BE49-F238E27FC236}">
-                <a16:creationId xmlns:a16="http://schemas.microsoft.com/office/drawing/2014/main" id="{7BE741BC-1DC6-4436-A22F-1C6BC89BC0A6}"/>
+                <a16:creationId xmlns:a16="http://schemas.microsoft.com/office/drawing/2014/main" id="{5501C4DE-1AB1-49EE-8F4D-EEE3056FB8DB}"/>
               </a:ext>
             </a:extLst>
           </p:cNvPr>
@@ -8167,7 +8167,7 @@
           <p:cNvPr id="12" name="">
             <a:extLst xmlns:a="http://schemas.openxmlformats.org/drawingml/2006/main">
               <a:ext uri="{FF2B5EF4-FFF2-40B4-BE49-F238E27FC236}">
-                <a16:creationId xmlns:a16="http://schemas.microsoft.com/office/drawing/2014/main" id="{E57007D5-B23F-4F57-9F56-F8260D413C2F}"/>
+                <a16:creationId xmlns:a16="http://schemas.microsoft.com/office/drawing/2014/main" id="{194F14CF-00C9-4026-86A4-3BB98A44D8DD}"/>
               </a:ext>
             </a:extLst>
           </p:cNvPr>
@@ -8200,7 +8200,7 @@
           <p:cNvPr id="13" name="">
             <a:extLst xmlns:a="http://schemas.openxmlformats.org/drawingml/2006/main">
               <a:ext uri="{FF2B5EF4-FFF2-40B4-BE49-F238E27FC236}">
-                <a16:creationId xmlns:a16="http://schemas.microsoft.com/office/drawing/2014/main" id="{24DED332-EC8F-4056-9BF5-4E280D55EA2D}"/>
+                <a16:creationId xmlns:a16="http://schemas.microsoft.com/office/drawing/2014/main" id="{4D74C4C6-B265-47A0-86B9-465FA1616555}"/>
               </a:ext>
             </a:extLst>
           </p:cNvPr>
@@ -8275,7 +8275,7 @@
           <p:cNvPr id="14" name="">
             <a:extLst xmlns:a="http://schemas.openxmlformats.org/drawingml/2006/main">
               <a:ext uri="{FF2B5EF4-FFF2-40B4-BE49-F238E27FC236}">
-                <a16:creationId xmlns:a16="http://schemas.microsoft.com/office/drawing/2014/main" id="{6616EE7A-29E9-49A9-B9C3-94D1BFA5316A}"/>
+                <a16:creationId xmlns:a16="http://schemas.microsoft.com/office/drawing/2014/main" id="{FC204420-6ADF-4D67-994B-BA6B4007DDDE}"/>
               </a:ext>
             </a:extLst>
           </p:cNvPr>
@@ -8312,7 +8312,7 @@
           <p:cNvPr id="15" name="">
             <a:extLst xmlns:a="http://schemas.openxmlformats.org/drawingml/2006/main">
               <a:ext uri="{FF2B5EF4-FFF2-40B4-BE49-F238E27FC236}">
-                <a16:creationId xmlns:a16="http://schemas.microsoft.com/office/drawing/2014/main" id="{2CB5823A-65DE-4AC6-A67C-F076881D20AB}"/>
+                <a16:creationId xmlns:a16="http://schemas.microsoft.com/office/drawing/2014/main" id="{9209A18E-E9B6-45DD-A455-1ED8AE0E0ADE}"/>
               </a:ext>
             </a:extLst>
           </p:cNvPr>
@@ -8347,7 +8347,7 @@
           <p:cNvPr id="16" name="">
             <a:extLst xmlns:a="http://schemas.openxmlformats.org/drawingml/2006/main">
               <a:ext uri="{FF2B5EF4-FFF2-40B4-BE49-F238E27FC236}">
-                <a16:creationId xmlns:a16="http://schemas.microsoft.com/office/drawing/2014/main" id="{5E64E7AA-3DCA-471A-B191-EE78BDFE688B}"/>
+                <a16:creationId xmlns:a16="http://schemas.microsoft.com/office/drawing/2014/main" id="{53114F34-ECD2-47AE-9750-7EFCD885A2A2}"/>
               </a:ext>
             </a:extLst>
           </p:cNvPr>
@@ -8405,7 +8405,7 @@
           <p:cNvPr id="17" name="">
             <a:extLst xmlns:a="http://schemas.openxmlformats.org/drawingml/2006/main">
               <a:ext uri="{FF2B5EF4-FFF2-40B4-BE49-F238E27FC236}">
-                <a16:creationId xmlns:a16="http://schemas.microsoft.com/office/drawing/2014/main" id="{2B9952A4-C291-4474-8422-69F17DB59045}"/>
+                <a16:creationId xmlns:a16="http://schemas.microsoft.com/office/drawing/2014/main" id="{E9762C3E-5BFE-4E89-9858-4F96FCA60DA1}"/>
               </a:ext>
             </a:extLst>
           </p:cNvPr>
@@ -8497,7 +8497,7 @@
           <p:cNvPr id="18" name="">
             <a:extLst xmlns:a="http://schemas.openxmlformats.org/drawingml/2006/main">
               <a:ext uri="{FF2B5EF4-FFF2-40B4-BE49-F238E27FC236}">
-                <a16:creationId xmlns:a16="http://schemas.microsoft.com/office/drawing/2014/main" id="{662A3FE3-3267-4CC2-B09F-6522B3B07365}"/>
+                <a16:creationId xmlns:a16="http://schemas.microsoft.com/office/drawing/2014/main" id="{70B5254B-ACCD-4D1C-9F67-2AA61F079F11}"/>
               </a:ext>
             </a:extLst>
           </p:cNvPr>
@@ -8534,7 +8534,7 @@
           <p:cNvPr id="19" name="">
             <a:extLst xmlns:a="http://schemas.openxmlformats.org/drawingml/2006/main">
               <a:ext uri="{FF2B5EF4-FFF2-40B4-BE49-F238E27FC236}">
-                <a16:creationId xmlns:a16="http://schemas.microsoft.com/office/drawing/2014/main" id="{3A421F04-87AF-4F4A-8F2D-B2859542A882}"/>
+                <a16:creationId xmlns:a16="http://schemas.microsoft.com/office/drawing/2014/main" id="{4B43475D-2D26-4759-86E7-44C3E684D0B3}"/>
               </a:ext>
             </a:extLst>
           </p:cNvPr>
@@ -8569,7 +8569,7 @@
           <p:cNvPr id="20" name="">
             <a:extLst xmlns:a="http://schemas.openxmlformats.org/drawingml/2006/main">
               <a:ext uri="{FF2B5EF4-FFF2-40B4-BE49-F238E27FC236}">
-                <a16:creationId xmlns:a16="http://schemas.microsoft.com/office/drawing/2014/main" id="{6106E394-51E1-446F-B0E4-546B8231BBD2}"/>
+                <a16:creationId xmlns:a16="http://schemas.microsoft.com/office/drawing/2014/main" id="{A82723D2-9D1C-41E6-B378-B4726A082954}"/>
               </a:ext>
             </a:extLst>
           </p:cNvPr>
@@ -8627,7 +8627,7 @@
           <p:cNvPr id="21" name="">
             <a:extLst xmlns:a="http://schemas.openxmlformats.org/drawingml/2006/main">
               <a:ext uri="{FF2B5EF4-FFF2-40B4-BE49-F238E27FC236}">
-                <a16:creationId xmlns:a16="http://schemas.microsoft.com/office/drawing/2014/main" id="{E7B54CAA-7662-4797-962A-649C569EE18D}"/>
+                <a16:creationId xmlns:a16="http://schemas.microsoft.com/office/drawing/2014/main" id="{3FD1B59D-F125-4B43-BE10-F3573BCFE656}"/>
               </a:ext>
             </a:extLst>
           </p:cNvPr>
@@ -8719,7 +8719,7 @@
           <p:cNvPr id="22" name="">
             <a:extLst xmlns:a="http://schemas.openxmlformats.org/drawingml/2006/main">
               <a:ext uri="{FF2B5EF4-FFF2-40B4-BE49-F238E27FC236}">
-                <a16:creationId xmlns:a16="http://schemas.microsoft.com/office/drawing/2014/main" id="{D2503BE2-7F93-474F-A496-6C46CEF25EAA}"/>
+                <a16:creationId xmlns:a16="http://schemas.microsoft.com/office/drawing/2014/main" id="{EE253744-BD0D-4069-894C-EA795F9ECD3E}"/>
               </a:ext>
             </a:extLst>
           </p:cNvPr>
@@ -8756,7 +8756,7 @@
           <p:cNvPr id="23" name="">
             <a:extLst xmlns:a="http://schemas.openxmlformats.org/drawingml/2006/main">
               <a:ext uri="{FF2B5EF4-FFF2-40B4-BE49-F238E27FC236}">
-                <a16:creationId xmlns:a16="http://schemas.microsoft.com/office/drawing/2014/main" id="{668B35FA-AEE1-4133-ADD7-DD23D2951851}"/>
+                <a16:creationId xmlns:a16="http://schemas.microsoft.com/office/drawing/2014/main" id="{2D707A71-4E3F-46E1-9732-88E0B9141339}"/>
               </a:ext>
             </a:extLst>
           </p:cNvPr>
@@ -8791,7 +8791,7 @@
           <p:cNvPr id="24" name="">
             <a:extLst xmlns:a="http://schemas.openxmlformats.org/drawingml/2006/main">
               <a:ext uri="{FF2B5EF4-FFF2-40B4-BE49-F238E27FC236}">
-                <a16:creationId xmlns:a16="http://schemas.microsoft.com/office/drawing/2014/main" id="{B4A3851C-8F00-4BDF-8A4C-8AB2C5384126}"/>
+                <a16:creationId xmlns:a16="http://schemas.microsoft.com/office/drawing/2014/main" id="{7282EE9B-4BF9-44D8-8AEF-641926AABD04}"/>
               </a:ext>
             </a:extLst>
           </p:cNvPr>
@@ -8849,7 +8849,7 @@
           <p:cNvPr id="25" name="">
             <a:extLst xmlns:a="http://schemas.openxmlformats.org/drawingml/2006/main">
               <a:ext uri="{FF2B5EF4-FFF2-40B4-BE49-F238E27FC236}">
-                <a16:creationId xmlns:a16="http://schemas.microsoft.com/office/drawing/2014/main" id="{03DD5F7A-C3BF-4B1D-ADB1-B3EBCD4E0F00}"/>
+                <a16:creationId xmlns:a16="http://schemas.microsoft.com/office/drawing/2014/main" id="{CFA31F5B-056A-422E-95CB-57290A037C35}"/>
               </a:ext>
             </a:extLst>
           </p:cNvPr>
@@ -8941,7 +8941,7 @@
           <p:cNvPr id="26" name="">
             <a:extLst xmlns:a="http://schemas.openxmlformats.org/drawingml/2006/main">
               <a:ext uri="{FF2B5EF4-FFF2-40B4-BE49-F238E27FC236}">
-                <a16:creationId xmlns:a16="http://schemas.microsoft.com/office/drawing/2014/main" id="{8953D308-2021-4BE5-87D8-7F13B5B87093}"/>
+                <a16:creationId xmlns:a16="http://schemas.microsoft.com/office/drawing/2014/main" id="{12E5A192-4B27-4910-8DD0-684A70251EF5}"/>
               </a:ext>
             </a:extLst>
           </p:cNvPr>
@@ -8978,7 +8978,7 @@
           <p:cNvPr id="27" name="">
             <a:extLst xmlns:a="http://schemas.openxmlformats.org/drawingml/2006/main">
               <a:ext uri="{FF2B5EF4-FFF2-40B4-BE49-F238E27FC236}">
-                <a16:creationId xmlns:a16="http://schemas.microsoft.com/office/drawing/2014/main" id="{13846B14-87AF-4A6A-AE9F-0CE2FED9520A}"/>
+                <a16:creationId xmlns:a16="http://schemas.microsoft.com/office/drawing/2014/main" id="{08D5E5B2-93AF-452B-A5F3-944FA8AAA5C1}"/>
               </a:ext>
             </a:extLst>
           </p:cNvPr>
@@ -9013,7 +9013,7 @@
           <p:cNvPr id="28" name="">
             <a:extLst xmlns:a="http://schemas.openxmlformats.org/drawingml/2006/main">
               <a:ext uri="{FF2B5EF4-FFF2-40B4-BE49-F238E27FC236}">
-                <a16:creationId xmlns:a16="http://schemas.microsoft.com/office/drawing/2014/main" id="{7B127880-AC1A-4A32-B764-FAF5AC5D7180}"/>
+                <a16:creationId xmlns:a16="http://schemas.microsoft.com/office/drawing/2014/main" id="{A929C73F-2793-418F-BEE5-39B8C6370CCB}"/>
               </a:ext>
             </a:extLst>
           </p:cNvPr>
@@ -9071,7 +9071,7 @@
           <p:cNvPr id="29" name="">
             <a:extLst xmlns:a="http://schemas.openxmlformats.org/drawingml/2006/main">
               <a:ext uri="{FF2B5EF4-FFF2-40B4-BE49-F238E27FC236}">
-                <a16:creationId xmlns:a16="http://schemas.microsoft.com/office/drawing/2014/main" id="{B87DDA68-AD73-41C1-9F4C-00724DFA959A}"/>
+                <a16:creationId xmlns:a16="http://schemas.microsoft.com/office/drawing/2014/main" id="{BB262265-C31E-47B6-9962-D26263C9AE0A}"/>
               </a:ext>
             </a:extLst>
           </p:cNvPr>
@@ -9106,7 +9106,7 @@
           <p:cNvPr id="30" name="">
             <a:extLst xmlns:a="http://schemas.openxmlformats.org/drawingml/2006/main">
               <a:ext uri="{FF2B5EF4-FFF2-40B4-BE49-F238E27FC236}">
-                <a16:creationId xmlns:a16="http://schemas.microsoft.com/office/drawing/2014/main" id="{47D88000-761D-4B38-9433-03A513A6373F}"/>
+                <a16:creationId xmlns:a16="http://schemas.microsoft.com/office/drawing/2014/main" id="{3ADDA5AA-8322-4516-9F4C-BCDA73BF404D}"/>
               </a:ext>
             </a:extLst>
           </p:cNvPr>
@@ -9141,7 +9141,7 @@
           <p:cNvPr id="31" name="">
             <a:extLst xmlns:a="http://schemas.openxmlformats.org/drawingml/2006/main">
               <a:ext uri="{FF2B5EF4-FFF2-40B4-BE49-F238E27FC236}">
-                <a16:creationId xmlns:a16="http://schemas.microsoft.com/office/drawing/2014/main" id="{0ECC065B-57BE-455A-8B29-56728A3C6E7E}"/>
+                <a16:creationId xmlns:a16="http://schemas.microsoft.com/office/drawing/2014/main" id="{41B1CFEB-7923-4272-A48D-63C5016A8136}"/>
               </a:ext>
             </a:extLst>
           </p:cNvPr>
@@ -9199,7 +9199,7 @@
           <p:cNvPr id="32" name="">
             <a:extLst xmlns:a="http://schemas.openxmlformats.org/drawingml/2006/main">
               <a:ext uri="{FF2B5EF4-FFF2-40B4-BE49-F238E27FC236}">
-                <a16:creationId xmlns:a16="http://schemas.microsoft.com/office/drawing/2014/main" id="{FFA2C25A-CE07-4A84-B57F-40E90621391D}"/>
+                <a16:creationId xmlns:a16="http://schemas.microsoft.com/office/drawing/2014/main" id="{9ED95CE8-3833-4EDB-8C64-4EC18ED39753}"/>
               </a:ext>
             </a:extLst>
           </p:cNvPr>
@@ -9255,7 +9255,7 @@
     </p:spTree>
     <p:extLst>
       <p:ext uri="{BB962C8B-B14F-4D97-AF65-F5344CB8AC3E}">
-        <p14:creationId xmlns:p14="http://schemas.microsoft.com/office/powerpoint/2010/main" val="99417897"/>
+        <p14:creationId xmlns:p14="http://schemas.microsoft.com/office/powerpoint/2010/main" val="812584234"/>
       </p:ext>
     </p:extLst>
   </p:cSld>
@@ -9286,7 +9286,7 @@
           <p:cNvPr id="1" name="Slide Number Placeholder 5">
             <a:extLst xmlns:a="http://schemas.openxmlformats.org/drawingml/2006/main">
               <a:ext uri="{FF2B5EF4-FFF2-40B4-BE49-F238E27FC236}">
-                <a16:creationId xmlns:a16="http://schemas.microsoft.com/office/drawing/2014/main" id="{C5A324B5-703D-4DE1-A920-5C56CD46E34C}"/>
+                <a16:creationId xmlns:a16="http://schemas.microsoft.com/office/drawing/2014/main" id="{E12CE447-476B-4BAE-A1FF-E669E79965E6}"/>
               </a:ext>
             </a:extLst>
           </p:cNvPr>
@@ -9322,7 +9322,7 @@
           <p:nvPr/>
         </p:nvPicPr>
         <p:blipFill>
-          <a:blip xmlns:r="http://schemas.openxmlformats.org/officeDocument/2006/relationships" xmlns:a="http://schemas.openxmlformats.org/drawingml/2006/main" r:embed="R0e7ce579abfa434b"/>
+          <a:blip xmlns:r="http://schemas.openxmlformats.org/officeDocument/2006/relationships" xmlns:a="http://schemas.openxmlformats.org/drawingml/2006/main" r:embed="R7fdde2bcaa84465d"/>
           <a:srcRect xmlns:a="http://schemas.openxmlformats.org/drawingml/2006/main" l="0" t="21875" r="0" b="21875"/>
           <a:stretch xmlns:a="http://schemas.openxmlformats.org/drawingml/2006/main">
             <a:fillRect l="0" t="0" r="0" b="0"/>
@@ -9343,7 +9343,7 @@
           <p:cNvPr id="3" name="">
             <a:extLst xmlns:a="http://schemas.openxmlformats.org/drawingml/2006/main">
               <a:ext uri="{FF2B5EF4-FFF2-40B4-BE49-F238E27FC236}">
-                <a16:creationId xmlns:a16="http://schemas.microsoft.com/office/drawing/2014/main" id="{DDF047B0-BD97-4FB1-949F-A75CD910C2F4}"/>
+                <a16:creationId xmlns:a16="http://schemas.microsoft.com/office/drawing/2014/main" id="{F8A3BDA3-164C-4348-967A-151849033020}"/>
               </a:ext>
             </a:extLst>
           </p:cNvPr>
@@ -9378,7 +9378,7 @@
           <p:cNvPr id="4" name="">
             <a:extLst xmlns:a="http://schemas.openxmlformats.org/drawingml/2006/main">
               <a:ext uri="{FF2B5EF4-FFF2-40B4-BE49-F238E27FC236}">
-                <a16:creationId xmlns:a16="http://schemas.microsoft.com/office/drawing/2014/main" id="{2E327F05-6E32-4292-9696-4F0A795E889D}"/>
+                <a16:creationId xmlns:a16="http://schemas.microsoft.com/office/drawing/2014/main" id="{B989BD80-9A48-4456-BFD6-5D50361B952D}"/>
               </a:ext>
             </a:extLst>
           </p:cNvPr>
@@ -9413,7 +9413,7 @@
           <p:cNvPr id="5" name="">
             <a:extLst xmlns:a="http://schemas.openxmlformats.org/drawingml/2006/main">
               <a:ext uri="{FF2B5EF4-FFF2-40B4-BE49-F238E27FC236}">
-                <a16:creationId xmlns:a16="http://schemas.microsoft.com/office/drawing/2014/main" id="{4461BA9D-DB25-4DF4-A5C5-3A778BF31F82}"/>
+                <a16:creationId xmlns:a16="http://schemas.microsoft.com/office/drawing/2014/main" id="{19F73437-AC02-4D5A-8E1F-7E3E10EF9F7E}"/>
               </a:ext>
             </a:extLst>
           </p:cNvPr>
@@ -9450,7 +9450,7 @@
           <p:cNvPr id="6" name="">
             <a:extLst xmlns:a="http://schemas.openxmlformats.org/drawingml/2006/main">
               <a:ext uri="{FF2B5EF4-FFF2-40B4-BE49-F238E27FC236}">
-                <a16:creationId xmlns:a16="http://schemas.microsoft.com/office/drawing/2014/main" id="{0F91BCC9-4B84-43A8-AAA9-6C8F9C6E14D5}"/>
+                <a16:creationId xmlns:a16="http://schemas.microsoft.com/office/drawing/2014/main" id="{DBD224AD-07FC-4280-A326-81AE245899D6}"/>
               </a:ext>
             </a:extLst>
           </p:cNvPr>
@@ -9487,7 +9487,7 @@
           <p:cNvPr id="7" name="">
             <a:extLst xmlns:a="http://schemas.openxmlformats.org/drawingml/2006/main">
               <a:ext uri="{FF2B5EF4-FFF2-40B4-BE49-F238E27FC236}">
-                <a16:creationId xmlns:a16="http://schemas.microsoft.com/office/drawing/2014/main" id="{C4C9DC7C-C5E6-4C2A-BEA7-745C94D8FD51}"/>
+                <a16:creationId xmlns:a16="http://schemas.microsoft.com/office/drawing/2014/main" id="{F3E4CD8B-ACEF-48A2-A82C-52B0F59A9129}"/>
               </a:ext>
             </a:extLst>
           </p:cNvPr>
@@ -9524,7 +9524,7 @@
           <p:cNvPr id="8" name="">
             <a:extLst xmlns:a="http://schemas.openxmlformats.org/drawingml/2006/main">
               <a:ext uri="{FF2B5EF4-FFF2-40B4-BE49-F238E27FC236}">
-                <a16:creationId xmlns:a16="http://schemas.microsoft.com/office/drawing/2014/main" id="{05B8CCD5-242D-4FC5-A877-A686480633BA}"/>
+                <a16:creationId xmlns:a16="http://schemas.microsoft.com/office/drawing/2014/main" id="{C810F4EA-692C-4BFC-B5E8-3D32FB9E1BB6}"/>
               </a:ext>
             </a:extLst>
           </p:cNvPr>
@@ -9561,7 +9561,7 @@
           <p:cNvPr id="9" name="">
             <a:extLst xmlns:a="http://schemas.openxmlformats.org/drawingml/2006/main">
               <a:ext uri="{FF2B5EF4-FFF2-40B4-BE49-F238E27FC236}">
-                <a16:creationId xmlns:a16="http://schemas.microsoft.com/office/drawing/2014/main" id="{488BB663-9821-4F3F-9787-81E1B5110488}"/>
+                <a16:creationId xmlns:a16="http://schemas.microsoft.com/office/drawing/2014/main" id="{6B014754-AD80-4A21-815C-E0EB354FF22B}"/>
               </a:ext>
             </a:extLst>
           </p:cNvPr>
@@ -9619,7 +9619,7 @@
           <p:cNvPr id="10" name="">
             <a:extLst xmlns:a="http://schemas.openxmlformats.org/drawingml/2006/main">
               <a:ext uri="{FF2B5EF4-FFF2-40B4-BE49-F238E27FC236}">
-                <a16:creationId xmlns:a16="http://schemas.microsoft.com/office/drawing/2014/main" id="{4F106679-F6B4-4D70-83E8-13A6A605C6A6}"/>
+                <a16:creationId xmlns:a16="http://schemas.microsoft.com/office/drawing/2014/main" id="{4C46C21C-1DA6-4AD7-A8D4-594B588FE722}"/>
               </a:ext>
             </a:extLst>
           </p:cNvPr>
@@ -9677,7 +9677,7 @@
           <p:cNvPr id="11" name="">
             <a:extLst xmlns:a="http://schemas.openxmlformats.org/drawingml/2006/main">
               <a:ext uri="{FF2B5EF4-FFF2-40B4-BE49-F238E27FC236}">
-                <a16:creationId xmlns:a16="http://schemas.microsoft.com/office/drawing/2014/main" id="{8BEC2E9F-13C0-4026-9D12-4E6DBB68E5A0}"/>
+                <a16:creationId xmlns:a16="http://schemas.microsoft.com/office/drawing/2014/main" id="{96655942-F299-484D-B577-A2699FB22AC7}"/>
               </a:ext>
             </a:extLst>
           </p:cNvPr>
@@ -9712,7 +9712,7 @@
           <p:cNvPr id="12" name="">
             <a:extLst xmlns:a="http://schemas.openxmlformats.org/drawingml/2006/main">
               <a:ext uri="{FF2B5EF4-FFF2-40B4-BE49-F238E27FC236}">
-                <a16:creationId xmlns:a16="http://schemas.microsoft.com/office/drawing/2014/main" id="{51737D00-E93F-4B61-9FB6-F0E5543EDB10}"/>
+                <a16:creationId xmlns:a16="http://schemas.microsoft.com/office/drawing/2014/main" id="{80D40DFE-A5B5-4A93-BD11-A21FB5DB31AD}"/>
               </a:ext>
             </a:extLst>
           </p:cNvPr>
@@ -9745,7 +9745,7 @@
           <p:cNvPr id="13" name="">
             <a:extLst xmlns:a="http://schemas.openxmlformats.org/drawingml/2006/main">
               <a:ext uri="{FF2B5EF4-FFF2-40B4-BE49-F238E27FC236}">
-                <a16:creationId xmlns:a16="http://schemas.microsoft.com/office/drawing/2014/main" id="{A4F00738-7BCC-45DB-A342-10A7C76A719A}"/>
+                <a16:creationId xmlns:a16="http://schemas.microsoft.com/office/drawing/2014/main" id="{931C6D8F-3120-4711-A56B-D6C5898A1D63}"/>
               </a:ext>
             </a:extLst>
           </p:cNvPr>
@@ -9820,7 +9820,7 @@
           <p:cNvPr id="14" name="">
             <a:extLst xmlns:a="http://schemas.openxmlformats.org/drawingml/2006/main">
               <a:ext uri="{FF2B5EF4-FFF2-40B4-BE49-F238E27FC236}">
-                <a16:creationId xmlns:a16="http://schemas.microsoft.com/office/drawing/2014/main" id="{08D42142-3319-4FA2-8C89-C0D3EC14146E}"/>
+                <a16:creationId xmlns:a16="http://schemas.microsoft.com/office/drawing/2014/main" id="{C693D743-A8BE-4AFC-8E1C-5A4957D736F0}"/>
               </a:ext>
             </a:extLst>
           </p:cNvPr>
@@ -9855,7 +9855,7 @@
           <p:cNvPr id="15" name="">
             <a:extLst xmlns:a="http://schemas.openxmlformats.org/drawingml/2006/main">
               <a:ext uri="{FF2B5EF4-FFF2-40B4-BE49-F238E27FC236}">
-                <a16:creationId xmlns:a16="http://schemas.microsoft.com/office/drawing/2014/main" id="{E4C860FF-F82B-45FA-B0F9-06CD44E39E0A}"/>
+                <a16:creationId xmlns:a16="http://schemas.microsoft.com/office/drawing/2014/main" id="{DF852EBA-8860-4B61-8325-F2F7BECD1C6F}"/>
               </a:ext>
             </a:extLst>
           </p:cNvPr>
@@ -9890,7 +9890,7 @@
           <p:cNvPr id="16" name="">
             <a:extLst xmlns:a="http://schemas.openxmlformats.org/drawingml/2006/main">
               <a:ext uri="{FF2B5EF4-FFF2-40B4-BE49-F238E27FC236}">
-                <a16:creationId xmlns:a16="http://schemas.microsoft.com/office/drawing/2014/main" id="{A180CEC6-176B-4771-B296-E6FE5ED79BDF}"/>
+                <a16:creationId xmlns:a16="http://schemas.microsoft.com/office/drawing/2014/main" id="{D60B118E-E968-4552-A15E-2E27E9E9DE35}"/>
               </a:ext>
             </a:extLst>
           </p:cNvPr>
@@ -9948,7 +9948,7 @@
           <p:cNvPr id="17" name="">
             <a:extLst xmlns:a="http://schemas.openxmlformats.org/drawingml/2006/main">
               <a:ext uri="{FF2B5EF4-FFF2-40B4-BE49-F238E27FC236}">
-                <a16:creationId xmlns:a16="http://schemas.microsoft.com/office/drawing/2014/main" id="{0D3C555A-8731-4340-B9F4-6C494C42B973}"/>
+                <a16:creationId xmlns:a16="http://schemas.microsoft.com/office/drawing/2014/main" id="{55C7226F-0481-4462-92D1-14C71601BF62}"/>
               </a:ext>
             </a:extLst>
           </p:cNvPr>
@@ -9985,7 +9985,7 @@
           <p:cNvPr id="18" name="">
             <a:extLst xmlns:a="http://schemas.openxmlformats.org/drawingml/2006/main">
               <a:ext uri="{FF2B5EF4-FFF2-40B4-BE49-F238E27FC236}">
-                <a16:creationId xmlns:a16="http://schemas.microsoft.com/office/drawing/2014/main" id="{25BA4AD0-3216-4F08-AFF1-F9AC24937619}"/>
+                <a16:creationId xmlns:a16="http://schemas.microsoft.com/office/drawing/2014/main" id="{7D529E99-A171-447D-9481-A2B956D8030A}"/>
               </a:ext>
             </a:extLst>
           </p:cNvPr>
@@ -10020,7 +10020,7 @@
           <p:cNvPr id="19" name="">
             <a:extLst xmlns:a="http://schemas.openxmlformats.org/drawingml/2006/main">
               <a:ext uri="{FF2B5EF4-FFF2-40B4-BE49-F238E27FC236}">
-                <a16:creationId xmlns:a16="http://schemas.microsoft.com/office/drawing/2014/main" id="{08C902E2-EA23-4271-9330-D8470AC0BF02}"/>
+                <a16:creationId xmlns:a16="http://schemas.microsoft.com/office/drawing/2014/main" id="{1D1828DA-6B7C-44F6-8AEF-F22F68E64F92}"/>
               </a:ext>
             </a:extLst>
           </p:cNvPr>
@@ -10078,7 +10078,7 @@
           <p:cNvPr id="20" name="">
             <a:extLst xmlns:a="http://schemas.openxmlformats.org/drawingml/2006/main">
               <a:ext uri="{FF2B5EF4-FFF2-40B4-BE49-F238E27FC236}">
-                <a16:creationId xmlns:a16="http://schemas.microsoft.com/office/drawing/2014/main" id="{90D3B9E6-59F8-4578-B777-809BC7A8DA82}"/>
+                <a16:creationId xmlns:a16="http://schemas.microsoft.com/office/drawing/2014/main" id="{3D6F4A8C-62E6-43C9-B993-F96F0ACF1F6F}"/>
               </a:ext>
             </a:extLst>
           </p:cNvPr>
@@ -10204,7 +10204,7 @@
           <p:cNvPr id="21" name="">
             <a:extLst xmlns:a="http://schemas.openxmlformats.org/drawingml/2006/main">
               <a:ext uri="{FF2B5EF4-FFF2-40B4-BE49-F238E27FC236}">
-                <a16:creationId xmlns:a16="http://schemas.microsoft.com/office/drawing/2014/main" id="{2225EF23-6A5A-468B-92A3-B99C21528727}"/>
+                <a16:creationId xmlns:a16="http://schemas.microsoft.com/office/drawing/2014/main" id="{E14FD467-79BE-496D-990D-28AE914E00F0}"/>
               </a:ext>
             </a:extLst>
           </p:cNvPr>
@@ -10241,7 +10241,7 @@
           <p:cNvPr id="22" name="">
             <a:extLst xmlns:a="http://schemas.openxmlformats.org/drawingml/2006/main">
               <a:ext uri="{FF2B5EF4-FFF2-40B4-BE49-F238E27FC236}">
-                <a16:creationId xmlns:a16="http://schemas.microsoft.com/office/drawing/2014/main" id="{BCF72D9E-37EA-4ABD-AF01-F9BBBDAEC973}"/>
+                <a16:creationId xmlns:a16="http://schemas.microsoft.com/office/drawing/2014/main" id="{BBBA4C57-1F54-4578-B8F9-0A3E6F400B24}"/>
               </a:ext>
             </a:extLst>
           </p:cNvPr>
@@ -10276,7 +10276,7 @@
           <p:cNvPr id="23" name="">
             <a:extLst xmlns:a="http://schemas.openxmlformats.org/drawingml/2006/main">
               <a:ext uri="{FF2B5EF4-FFF2-40B4-BE49-F238E27FC236}">
-                <a16:creationId xmlns:a16="http://schemas.microsoft.com/office/drawing/2014/main" id="{F6870F87-FD10-4F27-B615-DDB18A4672FC}"/>
+                <a16:creationId xmlns:a16="http://schemas.microsoft.com/office/drawing/2014/main" id="{B6F745D5-D36F-4F23-A539-691074D1BC26}"/>
               </a:ext>
             </a:extLst>
           </p:cNvPr>
@@ -10334,7 +10334,7 @@
           <p:cNvPr id="24" name="">
             <a:extLst xmlns:a="http://schemas.openxmlformats.org/drawingml/2006/main">
               <a:ext uri="{FF2B5EF4-FFF2-40B4-BE49-F238E27FC236}">
-                <a16:creationId xmlns:a16="http://schemas.microsoft.com/office/drawing/2014/main" id="{4EA00D9B-5D08-4A39-B79C-184EA11EA058}"/>
+                <a16:creationId xmlns:a16="http://schemas.microsoft.com/office/drawing/2014/main" id="{F439B610-1D93-41B8-BC76-81D853C99D89}"/>
               </a:ext>
             </a:extLst>
           </p:cNvPr>
@@ -10443,7 +10443,7 @@
           <p:cNvPr id="25" name="">
             <a:extLst xmlns:a="http://schemas.openxmlformats.org/drawingml/2006/main">
               <a:ext uri="{FF2B5EF4-FFF2-40B4-BE49-F238E27FC236}">
-                <a16:creationId xmlns:a16="http://schemas.microsoft.com/office/drawing/2014/main" id="{69448C08-0606-4C79-938B-B6C69A57A842}"/>
+                <a16:creationId xmlns:a16="http://schemas.microsoft.com/office/drawing/2014/main" id="{7F2D40E3-8D8D-4478-AA9B-E712EEEF84E8}"/>
               </a:ext>
             </a:extLst>
           </p:cNvPr>
@@ -10480,7 +10480,7 @@
           <p:cNvPr id="26" name="">
             <a:extLst xmlns:a="http://schemas.openxmlformats.org/drawingml/2006/main">
               <a:ext uri="{FF2B5EF4-FFF2-40B4-BE49-F238E27FC236}">
-                <a16:creationId xmlns:a16="http://schemas.microsoft.com/office/drawing/2014/main" id="{6357F5A5-98C5-43C0-AD0C-C4948D5667B2}"/>
+                <a16:creationId xmlns:a16="http://schemas.microsoft.com/office/drawing/2014/main" id="{03450718-6289-4910-B027-ACB1BF949EB5}"/>
               </a:ext>
             </a:extLst>
           </p:cNvPr>
@@ -10515,7 +10515,7 @@
           <p:cNvPr id="27" name="">
             <a:extLst xmlns:a="http://schemas.openxmlformats.org/drawingml/2006/main">
               <a:ext uri="{FF2B5EF4-FFF2-40B4-BE49-F238E27FC236}">
-                <a16:creationId xmlns:a16="http://schemas.microsoft.com/office/drawing/2014/main" id="{729D0B0C-48BD-42C0-9CA4-40FABEB1FE92}"/>
+                <a16:creationId xmlns:a16="http://schemas.microsoft.com/office/drawing/2014/main" id="{51F33D46-6EA7-4768-83CB-FB59E8028736}"/>
               </a:ext>
             </a:extLst>
           </p:cNvPr>
@@ -10573,7 +10573,7 @@
           <p:cNvPr id="28" name="">
             <a:extLst xmlns:a="http://schemas.openxmlformats.org/drawingml/2006/main">
               <a:ext uri="{FF2B5EF4-FFF2-40B4-BE49-F238E27FC236}">
-                <a16:creationId xmlns:a16="http://schemas.microsoft.com/office/drawing/2014/main" id="{9CDA8C75-B166-4140-96CF-FA754CA6077A}"/>
+                <a16:creationId xmlns:a16="http://schemas.microsoft.com/office/drawing/2014/main" id="{FD1405D4-C34A-44D1-8976-61D9BAD8C899}"/>
               </a:ext>
             </a:extLst>
           </p:cNvPr>
@@ -10682,7 +10682,7 @@
           <p:cNvPr id="29" name="">
             <a:extLst xmlns:a="http://schemas.openxmlformats.org/drawingml/2006/main">
               <a:ext uri="{FF2B5EF4-FFF2-40B4-BE49-F238E27FC236}">
-                <a16:creationId xmlns:a16="http://schemas.microsoft.com/office/drawing/2014/main" id="{562BC306-3FD4-449F-8042-E34E8E195FE0}"/>
+                <a16:creationId xmlns:a16="http://schemas.microsoft.com/office/drawing/2014/main" id="{A74820F1-A166-48D9-8D42-A62CB801A981}"/>
               </a:ext>
             </a:extLst>
           </p:cNvPr>
@@ -10719,7 +10719,7 @@
           <p:cNvPr id="30" name="">
             <a:extLst xmlns:a="http://schemas.openxmlformats.org/drawingml/2006/main">
               <a:ext uri="{FF2B5EF4-FFF2-40B4-BE49-F238E27FC236}">
-                <a16:creationId xmlns:a16="http://schemas.microsoft.com/office/drawing/2014/main" id="{942E9819-8EEB-43F4-B9B7-374859C0D2CF}"/>
+                <a16:creationId xmlns:a16="http://schemas.microsoft.com/office/drawing/2014/main" id="{2D044B2C-CBCF-46A1-90E6-0974D3D021AC}"/>
               </a:ext>
             </a:extLst>
           </p:cNvPr>
@@ -10754,7 +10754,7 @@
           <p:cNvPr id="31" name="">
             <a:extLst xmlns:a="http://schemas.openxmlformats.org/drawingml/2006/main">
               <a:ext uri="{FF2B5EF4-FFF2-40B4-BE49-F238E27FC236}">
-                <a16:creationId xmlns:a16="http://schemas.microsoft.com/office/drawing/2014/main" id="{252D5C5B-7DFC-4847-9652-2116CDF028F1}"/>
+                <a16:creationId xmlns:a16="http://schemas.microsoft.com/office/drawing/2014/main" id="{F2A9465A-FB7E-4CD9-8208-574CCED5AA93}"/>
               </a:ext>
             </a:extLst>
           </p:cNvPr>
@@ -10812,7 +10812,7 @@
           <p:cNvPr id="32" name="">
             <a:extLst xmlns:a="http://schemas.openxmlformats.org/drawingml/2006/main">
               <a:ext uri="{FF2B5EF4-FFF2-40B4-BE49-F238E27FC236}">
-                <a16:creationId xmlns:a16="http://schemas.microsoft.com/office/drawing/2014/main" id="{3EFEEC5B-CAB9-4282-9263-5AC502228566}"/>
+                <a16:creationId xmlns:a16="http://schemas.microsoft.com/office/drawing/2014/main" id="{4D46B4E7-F4E1-422D-950A-6C9082351D84}"/>
               </a:ext>
             </a:extLst>
           </p:cNvPr>
@@ -10921,7 +10921,7 @@
           <p:cNvPr id="33" name="">
             <a:extLst xmlns:a="http://schemas.openxmlformats.org/drawingml/2006/main">
               <a:ext uri="{FF2B5EF4-FFF2-40B4-BE49-F238E27FC236}">
-                <a16:creationId xmlns:a16="http://schemas.microsoft.com/office/drawing/2014/main" id="{4D65464F-007B-4FB3-9715-83D167711C15}"/>
+                <a16:creationId xmlns:a16="http://schemas.microsoft.com/office/drawing/2014/main" id="{9212EB29-B888-49AC-889C-8ABD933A38A8}"/>
               </a:ext>
             </a:extLst>
           </p:cNvPr>
@@ -10975,7 +10975,7 @@
           <p:cNvPr id="34" name="">
             <a:extLst xmlns:a="http://schemas.openxmlformats.org/drawingml/2006/main">
               <a:ext uri="{FF2B5EF4-FFF2-40B4-BE49-F238E27FC236}">
-                <a16:creationId xmlns:a16="http://schemas.microsoft.com/office/drawing/2014/main" id="{BE7195E9-33E3-4B8B-9DCE-494CD8E0011F}"/>
+                <a16:creationId xmlns:a16="http://schemas.microsoft.com/office/drawing/2014/main" id="{ABDB2FF6-7079-425F-9BAE-AE7C9DDA8777}"/>
               </a:ext>
             </a:extLst>
           </p:cNvPr>
@@ -11008,7 +11008,7 @@
           <p:cNvPr id="35" name="">
             <a:extLst xmlns:a="http://schemas.openxmlformats.org/drawingml/2006/main">
               <a:ext uri="{FF2B5EF4-FFF2-40B4-BE49-F238E27FC236}">
-                <a16:creationId xmlns:a16="http://schemas.microsoft.com/office/drawing/2014/main" id="{C51EF0EE-BB50-4922-93FB-B9EEDEECC31B}"/>
+                <a16:creationId xmlns:a16="http://schemas.microsoft.com/office/drawing/2014/main" id="{A04A5203-CE74-4E6E-9BF6-E88886974334}"/>
               </a:ext>
             </a:extLst>
           </p:cNvPr>
@@ -11062,7 +11062,7 @@
           <p:cNvPr id="36" name="">
             <a:extLst xmlns:a="http://schemas.openxmlformats.org/drawingml/2006/main">
               <a:ext uri="{FF2B5EF4-FFF2-40B4-BE49-F238E27FC236}">
-                <a16:creationId xmlns:a16="http://schemas.microsoft.com/office/drawing/2014/main" id="{4C0242FD-F93D-4712-AC6B-DF041A289DBC}"/>
+                <a16:creationId xmlns:a16="http://schemas.microsoft.com/office/drawing/2014/main" id="{CA8EDD70-14B4-409B-9F80-89A96BF5868A}"/>
               </a:ext>
             </a:extLst>
           </p:cNvPr>
@@ -11095,7 +11095,7 @@
           <p:cNvPr id="37" name="">
             <a:extLst xmlns:a="http://schemas.openxmlformats.org/drawingml/2006/main">
               <a:ext uri="{FF2B5EF4-FFF2-40B4-BE49-F238E27FC236}">
-                <a16:creationId xmlns:a16="http://schemas.microsoft.com/office/drawing/2014/main" id="{D6A4F2D4-C854-4B66-BCE6-2ECBFAFB5B4D}"/>
+                <a16:creationId xmlns:a16="http://schemas.microsoft.com/office/drawing/2014/main" id="{0E5997D5-4180-43F0-97E2-0DB2AA0D02B5}"/>
               </a:ext>
             </a:extLst>
           </p:cNvPr>
@@ -11149,7 +11149,7 @@
           <p:cNvPr id="38" name="">
             <a:extLst xmlns:a="http://schemas.openxmlformats.org/drawingml/2006/main">
               <a:ext uri="{FF2B5EF4-FFF2-40B4-BE49-F238E27FC236}">
-                <a16:creationId xmlns:a16="http://schemas.microsoft.com/office/drawing/2014/main" id="{2E63A4A7-9836-4C60-BCE4-0E9A3DFBF3B6}"/>
+                <a16:creationId xmlns:a16="http://schemas.microsoft.com/office/drawing/2014/main" id="{7FE86AE0-C9EB-47E4-B081-BAB93661FBAF}"/>
               </a:ext>
             </a:extLst>
           </p:cNvPr>
@@ -11182,7 +11182,7 @@
           <p:cNvPr id="39" name="">
             <a:extLst xmlns:a="http://schemas.openxmlformats.org/drawingml/2006/main">
               <a:ext uri="{FF2B5EF4-FFF2-40B4-BE49-F238E27FC236}">
-                <a16:creationId xmlns:a16="http://schemas.microsoft.com/office/drawing/2014/main" id="{11142204-8FA1-4A6E-887A-6A788F991D46}"/>
+                <a16:creationId xmlns:a16="http://schemas.microsoft.com/office/drawing/2014/main" id="{837864E7-C0F5-4CEC-A310-A7B639444E6F}"/>
               </a:ext>
             </a:extLst>
           </p:cNvPr>
@@ -11236,7 +11236,7 @@
           <p:cNvPr id="40" name="">
             <a:extLst xmlns:a="http://schemas.openxmlformats.org/drawingml/2006/main">
               <a:ext uri="{FF2B5EF4-FFF2-40B4-BE49-F238E27FC236}">
-                <a16:creationId xmlns:a16="http://schemas.microsoft.com/office/drawing/2014/main" id="{8D7B9C03-49F3-46B9-80CE-ED6E79D2F7DF}"/>
+                <a16:creationId xmlns:a16="http://schemas.microsoft.com/office/drawing/2014/main" id="{E00D854F-CF2F-410F-9E88-BE89E727DC57}"/>
               </a:ext>
             </a:extLst>
           </p:cNvPr>
@@ -11292,7 +11292,7 @@
     </p:spTree>
     <p:extLst>
       <p:ext uri="{BB962C8B-B14F-4D97-AF65-F5344CB8AC3E}">
-        <p14:creationId xmlns:p14="http://schemas.microsoft.com/office/powerpoint/2010/main" val="1927756945"/>
+        <p14:creationId xmlns:p14="http://schemas.microsoft.com/office/powerpoint/2010/main" val="739240916"/>
       </p:ext>
     </p:extLst>
   </p:cSld>
@@ -11323,7 +11323,7 @@
           <p:cNvPr id="1" name="Slide Number Placeholder 5">
             <a:extLst xmlns:a="http://schemas.openxmlformats.org/drawingml/2006/main">
               <a:ext uri="{FF2B5EF4-FFF2-40B4-BE49-F238E27FC236}">
-                <a16:creationId xmlns:a16="http://schemas.microsoft.com/office/drawing/2014/main" id="{C5A324B5-703D-4DE1-A920-5C56CD46E34C}"/>
+                <a16:creationId xmlns:a16="http://schemas.microsoft.com/office/drawing/2014/main" id="{E12CE447-476B-4BAE-A1FF-E669E79965E6}"/>
               </a:ext>
             </a:extLst>
           </p:cNvPr>
@@ -11359,7 +11359,7 @@
           <p:nvPr/>
         </p:nvPicPr>
         <p:blipFill>
-          <a:blip xmlns:r="http://schemas.openxmlformats.org/officeDocument/2006/relationships" xmlns:a="http://schemas.openxmlformats.org/drawingml/2006/main" r:embed="Rc884012f1a7a44fc"/>
+          <a:blip xmlns:r="http://schemas.openxmlformats.org/officeDocument/2006/relationships" xmlns:a="http://schemas.openxmlformats.org/drawingml/2006/main" r:embed="R51662ef22ae54aae"/>
           <a:srcRect xmlns:a="http://schemas.openxmlformats.org/drawingml/2006/main" l="0" t="21875" r="0" b="21875"/>
           <a:stretch xmlns:a="http://schemas.openxmlformats.org/drawingml/2006/main">
             <a:fillRect l="0" t="0" r="0" b="0"/>
@@ -11380,7 +11380,7 @@
           <p:cNvPr id="3" name="">
             <a:extLst xmlns:a="http://schemas.openxmlformats.org/drawingml/2006/main">
               <a:ext uri="{FF2B5EF4-FFF2-40B4-BE49-F238E27FC236}">
-                <a16:creationId xmlns:a16="http://schemas.microsoft.com/office/drawing/2014/main" id="{32662D91-CC16-4BA9-9F77-3352D9287FCA}"/>
+                <a16:creationId xmlns:a16="http://schemas.microsoft.com/office/drawing/2014/main" id="{06D18CE6-4C0D-4415-83B2-E2E382F332BB}"/>
               </a:ext>
             </a:extLst>
           </p:cNvPr>
@@ -11415,7 +11415,7 @@
           <p:cNvPr id="4" name="">
             <a:extLst xmlns:a="http://schemas.openxmlformats.org/drawingml/2006/main">
               <a:ext uri="{FF2B5EF4-FFF2-40B4-BE49-F238E27FC236}">
-                <a16:creationId xmlns:a16="http://schemas.microsoft.com/office/drawing/2014/main" id="{362F377D-EA6F-41A8-BE2F-4CACECD93FE0}"/>
+                <a16:creationId xmlns:a16="http://schemas.microsoft.com/office/drawing/2014/main" id="{627D553A-B099-4940-86EB-C985A9209950}"/>
               </a:ext>
             </a:extLst>
           </p:cNvPr>
@@ -11450,7 +11450,7 @@
           <p:cNvPr id="5" name="">
             <a:extLst xmlns:a="http://schemas.openxmlformats.org/drawingml/2006/main">
               <a:ext uri="{FF2B5EF4-FFF2-40B4-BE49-F238E27FC236}">
-                <a16:creationId xmlns:a16="http://schemas.microsoft.com/office/drawing/2014/main" id="{6C6F955B-6AEE-4408-BAF3-1CB3E2D67D0E}"/>
+                <a16:creationId xmlns:a16="http://schemas.microsoft.com/office/drawing/2014/main" id="{409B5C03-9E5A-40F5-9DF2-E636B6A79CD7}"/>
               </a:ext>
             </a:extLst>
           </p:cNvPr>
@@ -11487,7 +11487,7 @@
           <p:cNvPr id="6" name="">
             <a:extLst xmlns:a="http://schemas.openxmlformats.org/drawingml/2006/main">
               <a:ext uri="{FF2B5EF4-FFF2-40B4-BE49-F238E27FC236}">
-                <a16:creationId xmlns:a16="http://schemas.microsoft.com/office/drawing/2014/main" id="{5E23E7A4-2781-4E0A-ABB7-EFEC3557FC8F}"/>
+                <a16:creationId xmlns:a16="http://schemas.microsoft.com/office/drawing/2014/main" id="{7D2D13BD-DAE5-4A8A-9458-32C619A27A71}"/>
               </a:ext>
             </a:extLst>
           </p:cNvPr>
@@ -11524,7 +11524,7 @@
           <p:cNvPr id="7" name="">
             <a:extLst xmlns:a="http://schemas.openxmlformats.org/drawingml/2006/main">
               <a:ext uri="{FF2B5EF4-FFF2-40B4-BE49-F238E27FC236}">
-                <a16:creationId xmlns:a16="http://schemas.microsoft.com/office/drawing/2014/main" id="{61D86E52-6A98-4679-A129-44EDBC28C260}"/>
+                <a16:creationId xmlns:a16="http://schemas.microsoft.com/office/drawing/2014/main" id="{E304AF91-058B-4E0F-B6D2-49B08A472EC4}"/>
               </a:ext>
             </a:extLst>
           </p:cNvPr>
@@ -11561,7 +11561,7 @@
           <p:cNvPr id="8" name="">
             <a:extLst xmlns:a="http://schemas.openxmlformats.org/drawingml/2006/main">
               <a:ext uri="{FF2B5EF4-FFF2-40B4-BE49-F238E27FC236}">
-                <a16:creationId xmlns:a16="http://schemas.microsoft.com/office/drawing/2014/main" id="{B959B027-F796-4924-A652-F8DDD7EA26F1}"/>
+                <a16:creationId xmlns:a16="http://schemas.microsoft.com/office/drawing/2014/main" id="{48CFCE25-6705-4DEE-8C48-C3A7C7469D58}"/>
               </a:ext>
             </a:extLst>
           </p:cNvPr>
@@ -11598,7 +11598,7 @@
           <p:cNvPr id="9" name="">
             <a:extLst xmlns:a="http://schemas.openxmlformats.org/drawingml/2006/main">
               <a:ext uri="{FF2B5EF4-FFF2-40B4-BE49-F238E27FC236}">
-                <a16:creationId xmlns:a16="http://schemas.microsoft.com/office/drawing/2014/main" id="{46667764-4C5D-4AA1-8B1B-78133CC6360F}"/>
+                <a16:creationId xmlns:a16="http://schemas.microsoft.com/office/drawing/2014/main" id="{0F662108-2B6A-449B-AFA7-8A54267A8580}"/>
               </a:ext>
             </a:extLst>
           </p:cNvPr>
@@ -11656,7 +11656,7 @@
           <p:cNvPr id="10" name="">
             <a:extLst xmlns:a="http://schemas.openxmlformats.org/drawingml/2006/main">
               <a:ext uri="{FF2B5EF4-FFF2-40B4-BE49-F238E27FC236}">
-                <a16:creationId xmlns:a16="http://schemas.microsoft.com/office/drawing/2014/main" id="{56E0C1F7-CDF0-4823-BF2F-C5D93438C2FB}"/>
+                <a16:creationId xmlns:a16="http://schemas.microsoft.com/office/drawing/2014/main" id="{F504E3B5-79AF-4024-AF6E-5458E6B18A8E}"/>
               </a:ext>
             </a:extLst>
           </p:cNvPr>
@@ -11714,7 +11714,7 @@
           <p:cNvPr id="11" name="">
             <a:extLst xmlns:a="http://schemas.openxmlformats.org/drawingml/2006/main">
               <a:ext uri="{FF2B5EF4-FFF2-40B4-BE49-F238E27FC236}">
-                <a16:creationId xmlns:a16="http://schemas.microsoft.com/office/drawing/2014/main" id="{24669CBD-F850-4AE3-9042-24A33D44EC9F}"/>
+                <a16:creationId xmlns:a16="http://schemas.microsoft.com/office/drawing/2014/main" id="{86856388-A3C8-4670-B4AF-A32589215E7A}"/>
               </a:ext>
             </a:extLst>
           </p:cNvPr>
@@ -11749,7 +11749,7 @@
           <p:cNvPr id="12" name="">
             <a:extLst xmlns:a="http://schemas.openxmlformats.org/drawingml/2006/main">
               <a:ext uri="{FF2B5EF4-FFF2-40B4-BE49-F238E27FC236}">
-                <a16:creationId xmlns:a16="http://schemas.microsoft.com/office/drawing/2014/main" id="{02AB1B6E-AB1E-4BFE-A34F-AEF7FAA6281B}"/>
+                <a16:creationId xmlns:a16="http://schemas.microsoft.com/office/drawing/2014/main" id="{F0C7C468-F504-498A-A603-3DC259FC8E79}"/>
               </a:ext>
             </a:extLst>
           </p:cNvPr>
@@ -11782,7 +11782,7 @@
           <p:cNvPr id="13" name="">
             <a:extLst xmlns:a="http://schemas.openxmlformats.org/drawingml/2006/main">
               <a:ext uri="{FF2B5EF4-FFF2-40B4-BE49-F238E27FC236}">
-                <a16:creationId xmlns:a16="http://schemas.microsoft.com/office/drawing/2014/main" id="{D7910122-8DE8-48A3-80A6-E5FD059CAE44}"/>
+                <a16:creationId xmlns:a16="http://schemas.microsoft.com/office/drawing/2014/main" id="{73F9E196-E330-4195-9685-A6BCFC0E0C08}"/>
               </a:ext>
             </a:extLst>
           </p:cNvPr>
@@ -11857,7 +11857,7 @@
           <p:cNvPr id="14" name="">
             <a:extLst xmlns:a="http://schemas.openxmlformats.org/drawingml/2006/main">
               <a:ext uri="{FF2B5EF4-FFF2-40B4-BE49-F238E27FC236}">
-                <a16:creationId xmlns:a16="http://schemas.microsoft.com/office/drawing/2014/main" id="{CABBF6F4-ADD4-4B43-9661-3897F3BCE601}"/>
+                <a16:creationId xmlns:a16="http://schemas.microsoft.com/office/drawing/2014/main" id="{61750C2E-A4E9-4BC3-A538-E061671AEB77}"/>
               </a:ext>
             </a:extLst>
           </p:cNvPr>
@@ -11892,7 +11892,7 @@
           <p:cNvPr id="15" name="">
             <a:extLst xmlns:a="http://schemas.openxmlformats.org/drawingml/2006/main">
               <a:ext uri="{FF2B5EF4-FFF2-40B4-BE49-F238E27FC236}">
-                <a16:creationId xmlns:a16="http://schemas.microsoft.com/office/drawing/2014/main" id="{D4787C24-ABE2-4499-BBC9-5C64D938A822}"/>
+                <a16:creationId xmlns:a16="http://schemas.microsoft.com/office/drawing/2014/main" id="{1929C17C-1BDE-42B6-9336-575A831E42EF}"/>
               </a:ext>
             </a:extLst>
           </p:cNvPr>
@@ -11927,7 +11927,7 @@
           <p:cNvPr id="16" name="">
             <a:extLst xmlns:a="http://schemas.openxmlformats.org/drawingml/2006/main">
               <a:ext uri="{FF2B5EF4-FFF2-40B4-BE49-F238E27FC236}">
-                <a16:creationId xmlns:a16="http://schemas.microsoft.com/office/drawing/2014/main" id="{F6156ACD-8946-4E51-9F5D-A58FA19B322B}"/>
+                <a16:creationId xmlns:a16="http://schemas.microsoft.com/office/drawing/2014/main" id="{1D04031E-401B-4CA0-8DFB-B238B5D04FF6}"/>
               </a:ext>
             </a:extLst>
           </p:cNvPr>
@@ -11985,7 +11985,7 @@
           <p:cNvPr id="17" name="">
             <a:extLst xmlns:a="http://schemas.openxmlformats.org/drawingml/2006/main">
               <a:ext uri="{FF2B5EF4-FFF2-40B4-BE49-F238E27FC236}">
-                <a16:creationId xmlns:a16="http://schemas.microsoft.com/office/drawing/2014/main" id="{9C5C89C2-19E0-4D4B-8B51-15342EAEC15B}"/>
+                <a16:creationId xmlns:a16="http://schemas.microsoft.com/office/drawing/2014/main" id="{C4F5742D-965A-4DCD-B493-5CEAF49467BE}"/>
               </a:ext>
             </a:extLst>
           </p:cNvPr>
@@ -12022,7 +12022,7 @@
           <p:cNvPr id="18" name="">
             <a:extLst xmlns:a="http://schemas.openxmlformats.org/drawingml/2006/main">
               <a:ext uri="{FF2B5EF4-FFF2-40B4-BE49-F238E27FC236}">
-                <a16:creationId xmlns:a16="http://schemas.microsoft.com/office/drawing/2014/main" id="{FA8A512E-EF05-4BDD-892F-B3EB952928B9}"/>
+                <a16:creationId xmlns:a16="http://schemas.microsoft.com/office/drawing/2014/main" id="{C162741C-46CA-41BE-B816-49B6E66429DB}"/>
               </a:ext>
             </a:extLst>
           </p:cNvPr>
@@ -12057,7 +12057,7 @@
           <p:cNvPr id="19" name="">
             <a:extLst xmlns:a="http://schemas.openxmlformats.org/drawingml/2006/main">
               <a:ext uri="{FF2B5EF4-FFF2-40B4-BE49-F238E27FC236}">
-                <a16:creationId xmlns:a16="http://schemas.microsoft.com/office/drawing/2014/main" id="{7A9AA7F4-8209-444D-A0DF-FE805C4B2F18}"/>
+                <a16:creationId xmlns:a16="http://schemas.microsoft.com/office/drawing/2014/main" id="{606A782E-A49C-4693-9277-50BFD57FB61E}"/>
               </a:ext>
             </a:extLst>
           </p:cNvPr>
@@ -12115,7 +12115,7 @@
           <p:cNvPr id="20" name="">
             <a:extLst xmlns:a="http://schemas.openxmlformats.org/drawingml/2006/main">
               <a:ext uri="{FF2B5EF4-FFF2-40B4-BE49-F238E27FC236}">
-                <a16:creationId xmlns:a16="http://schemas.microsoft.com/office/drawing/2014/main" id="{0F59BD76-EBE7-4812-9737-5AA08258CDE1}"/>
+                <a16:creationId xmlns:a16="http://schemas.microsoft.com/office/drawing/2014/main" id="{AA64EA51-D710-4E0D-B864-0D5071399AE3}"/>
               </a:ext>
             </a:extLst>
           </p:cNvPr>
@@ -12224,7 +12224,7 @@
           <p:cNvPr id="21" name="">
             <a:extLst xmlns:a="http://schemas.openxmlformats.org/drawingml/2006/main">
               <a:ext uri="{FF2B5EF4-FFF2-40B4-BE49-F238E27FC236}">
-                <a16:creationId xmlns:a16="http://schemas.microsoft.com/office/drawing/2014/main" id="{97B66CED-1BAD-45C1-89E9-B55E658A3122}"/>
+                <a16:creationId xmlns:a16="http://schemas.microsoft.com/office/drawing/2014/main" id="{7793E34E-76BB-4618-AFC5-43F94E6D8686}"/>
               </a:ext>
             </a:extLst>
           </p:cNvPr>
@@ -12261,7 +12261,7 @@
           <p:cNvPr id="22" name="">
             <a:extLst xmlns:a="http://schemas.openxmlformats.org/drawingml/2006/main">
               <a:ext uri="{FF2B5EF4-FFF2-40B4-BE49-F238E27FC236}">
-                <a16:creationId xmlns:a16="http://schemas.microsoft.com/office/drawing/2014/main" id="{0D7F9FBC-8E74-4523-8CAA-BBA42D3051A2}"/>
+                <a16:creationId xmlns:a16="http://schemas.microsoft.com/office/drawing/2014/main" id="{93C03E04-D76C-43C3-AEC5-E844B2048548}"/>
               </a:ext>
             </a:extLst>
           </p:cNvPr>
@@ -12296,7 +12296,7 @@
           <p:cNvPr id="23" name="">
             <a:extLst xmlns:a="http://schemas.openxmlformats.org/drawingml/2006/main">
               <a:ext uri="{FF2B5EF4-FFF2-40B4-BE49-F238E27FC236}">
-                <a16:creationId xmlns:a16="http://schemas.microsoft.com/office/drawing/2014/main" id="{1E3B8964-8534-4CE4-B8B1-315A85209D35}"/>
+                <a16:creationId xmlns:a16="http://schemas.microsoft.com/office/drawing/2014/main" id="{B51EB596-1212-4A4D-BA74-DF3F94FAF25E}"/>
               </a:ext>
             </a:extLst>
           </p:cNvPr>
@@ -12354,7 +12354,7 @@
           <p:cNvPr id="24" name="">
             <a:extLst xmlns:a="http://schemas.openxmlformats.org/drawingml/2006/main">
               <a:ext uri="{FF2B5EF4-FFF2-40B4-BE49-F238E27FC236}">
-                <a16:creationId xmlns:a16="http://schemas.microsoft.com/office/drawing/2014/main" id="{0092F6D5-4F83-494E-A3DB-4857DDA49BCF}"/>
+                <a16:creationId xmlns:a16="http://schemas.microsoft.com/office/drawing/2014/main" id="{E979F6BC-0559-42C0-AE5E-5287E7977577}"/>
               </a:ext>
             </a:extLst>
           </p:cNvPr>
@@ -12463,7 +12463,7 @@
           <p:cNvPr id="25" name="">
             <a:extLst xmlns:a="http://schemas.openxmlformats.org/drawingml/2006/main">
               <a:ext uri="{FF2B5EF4-FFF2-40B4-BE49-F238E27FC236}">
-                <a16:creationId xmlns:a16="http://schemas.microsoft.com/office/drawing/2014/main" id="{3699BAAC-1341-4C31-9868-85C3F79DE255}"/>
+                <a16:creationId xmlns:a16="http://schemas.microsoft.com/office/drawing/2014/main" id="{C133ADE3-D919-4773-B4BF-6D0CA3D4827D}"/>
               </a:ext>
             </a:extLst>
           </p:cNvPr>
@@ -12500,7 +12500,7 @@
           <p:cNvPr id="26" name="">
             <a:extLst xmlns:a="http://schemas.openxmlformats.org/drawingml/2006/main">
               <a:ext uri="{FF2B5EF4-FFF2-40B4-BE49-F238E27FC236}">
-                <a16:creationId xmlns:a16="http://schemas.microsoft.com/office/drawing/2014/main" id="{4CAC300B-EB8F-4CCD-8C7B-65765CFC6BB4}"/>
+                <a16:creationId xmlns:a16="http://schemas.microsoft.com/office/drawing/2014/main" id="{2B7DC544-7156-4D40-925B-CB8DFE86EC3E}"/>
               </a:ext>
             </a:extLst>
           </p:cNvPr>
@@ -12535,7 +12535,7 @@
           <p:cNvPr id="27" name="">
             <a:extLst xmlns:a="http://schemas.openxmlformats.org/drawingml/2006/main">
               <a:ext uri="{FF2B5EF4-FFF2-40B4-BE49-F238E27FC236}">
-                <a16:creationId xmlns:a16="http://schemas.microsoft.com/office/drawing/2014/main" id="{29D07B63-1BBB-4D6D-B274-720E6FC11F2F}"/>
+                <a16:creationId xmlns:a16="http://schemas.microsoft.com/office/drawing/2014/main" id="{6A6C197D-466E-4AF4-8848-8EB9A9BE357A}"/>
               </a:ext>
             </a:extLst>
           </p:cNvPr>
@@ -12593,7 +12593,7 @@
           <p:cNvPr id="28" name="">
             <a:extLst xmlns:a="http://schemas.openxmlformats.org/drawingml/2006/main">
               <a:ext uri="{FF2B5EF4-FFF2-40B4-BE49-F238E27FC236}">
-                <a16:creationId xmlns:a16="http://schemas.microsoft.com/office/drawing/2014/main" id="{4D5097AB-BF9A-4903-AE50-30150CCF5ED8}"/>
+                <a16:creationId xmlns:a16="http://schemas.microsoft.com/office/drawing/2014/main" id="{59DBB416-20FE-45FD-860A-979CED5079D1}"/>
               </a:ext>
             </a:extLst>
           </p:cNvPr>
@@ -12702,7 +12702,7 @@
           <p:cNvPr id="29" name="">
             <a:extLst xmlns:a="http://schemas.openxmlformats.org/drawingml/2006/main">
               <a:ext uri="{FF2B5EF4-FFF2-40B4-BE49-F238E27FC236}">
-                <a16:creationId xmlns:a16="http://schemas.microsoft.com/office/drawing/2014/main" id="{B8CB9F7D-5EF6-4CD9-AEE8-B7243E0CE221}"/>
+                <a16:creationId xmlns:a16="http://schemas.microsoft.com/office/drawing/2014/main" id="{FEEE00CC-6220-4594-9B9C-825F29C70903}"/>
               </a:ext>
             </a:extLst>
           </p:cNvPr>
@@ -12739,7 +12739,7 @@
           <p:cNvPr id="30" name="">
             <a:extLst xmlns:a="http://schemas.openxmlformats.org/drawingml/2006/main">
               <a:ext uri="{FF2B5EF4-FFF2-40B4-BE49-F238E27FC236}">
-                <a16:creationId xmlns:a16="http://schemas.microsoft.com/office/drawing/2014/main" id="{4DE1EFD8-2511-44B2-AB54-B5E807847EF9}"/>
+                <a16:creationId xmlns:a16="http://schemas.microsoft.com/office/drawing/2014/main" id="{EE64DE0D-24A2-4C21-A8F0-A2FA4611A612}"/>
               </a:ext>
             </a:extLst>
           </p:cNvPr>
@@ -12774,7 +12774,7 @@
           <p:cNvPr id="31" name="">
             <a:extLst xmlns:a="http://schemas.openxmlformats.org/drawingml/2006/main">
               <a:ext uri="{FF2B5EF4-FFF2-40B4-BE49-F238E27FC236}">
-                <a16:creationId xmlns:a16="http://schemas.microsoft.com/office/drawing/2014/main" id="{83B4A6E9-6BB6-46CA-9886-0EB5664D4B04}"/>
+                <a16:creationId xmlns:a16="http://schemas.microsoft.com/office/drawing/2014/main" id="{FECE3605-E843-4848-B316-A9D7AA6373C3}"/>
               </a:ext>
             </a:extLst>
           </p:cNvPr>
@@ -12832,7 +12832,7 @@
           <p:cNvPr id="32" name="">
             <a:extLst xmlns:a="http://schemas.openxmlformats.org/drawingml/2006/main">
               <a:ext uri="{FF2B5EF4-FFF2-40B4-BE49-F238E27FC236}">
-                <a16:creationId xmlns:a16="http://schemas.microsoft.com/office/drawing/2014/main" id="{1A6EE750-1E9E-460A-AC2C-B1240BCED3C8}"/>
+                <a16:creationId xmlns:a16="http://schemas.microsoft.com/office/drawing/2014/main" id="{371C49AA-87C0-4BED-B39F-D268F60D0FD6}"/>
               </a:ext>
             </a:extLst>
           </p:cNvPr>
@@ -12941,7 +12941,7 @@
           <p:cNvPr id="33" name="">
             <a:extLst xmlns:a="http://schemas.openxmlformats.org/drawingml/2006/main">
               <a:ext uri="{FF2B5EF4-FFF2-40B4-BE49-F238E27FC236}">
-                <a16:creationId xmlns:a16="http://schemas.microsoft.com/office/drawing/2014/main" id="{3D55D282-11CF-41B4-A093-44202E20BBB5}"/>
+                <a16:creationId xmlns:a16="http://schemas.microsoft.com/office/drawing/2014/main" id="{F4725FEA-8A5A-42EF-92D3-8406C8F530E4}"/>
               </a:ext>
             </a:extLst>
           </p:cNvPr>
@@ -12995,7 +12995,7 @@
           <p:cNvPr id="34" name="">
             <a:extLst xmlns:a="http://schemas.openxmlformats.org/drawingml/2006/main">
               <a:ext uri="{FF2B5EF4-FFF2-40B4-BE49-F238E27FC236}">
-                <a16:creationId xmlns:a16="http://schemas.microsoft.com/office/drawing/2014/main" id="{7CB18FCF-190C-4044-8E9A-153BE5B8F080}"/>
+                <a16:creationId xmlns:a16="http://schemas.microsoft.com/office/drawing/2014/main" id="{CACA3172-57A6-4B6F-9265-36682497B6FD}"/>
               </a:ext>
             </a:extLst>
           </p:cNvPr>
@@ -13028,7 +13028,7 @@
           <p:cNvPr id="35" name="">
             <a:extLst xmlns:a="http://schemas.openxmlformats.org/drawingml/2006/main">
               <a:ext uri="{FF2B5EF4-FFF2-40B4-BE49-F238E27FC236}">
-                <a16:creationId xmlns:a16="http://schemas.microsoft.com/office/drawing/2014/main" id="{19011405-99DA-446B-BAB7-3659CFA487A3}"/>
+                <a16:creationId xmlns:a16="http://schemas.microsoft.com/office/drawing/2014/main" id="{811D0E9F-DA18-4D91-AD54-031F0AECC8B9}"/>
               </a:ext>
             </a:extLst>
           </p:cNvPr>
@@ -13082,7 +13082,7 @@
           <p:cNvPr id="36" name="">
             <a:extLst xmlns:a="http://schemas.openxmlformats.org/drawingml/2006/main">
               <a:ext uri="{FF2B5EF4-FFF2-40B4-BE49-F238E27FC236}">
-                <a16:creationId xmlns:a16="http://schemas.microsoft.com/office/drawing/2014/main" id="{C56314CD-BFCD-4841-BC9F-03433DF6A59A}"/>
+                <a16:creationId xmlns:a16="http://schemas.microsoft.com/office/drawing/2014/main" id="{6ECDD42F-DE88-44B0-9A5D-0A25627B21EC}"/>
               </a:ext>
             </a:extLst>
           </p:cNvPr>
@@ -13115,7 +13115,7 @@
           <p:cNvPr id="37" name="">
             <a:extLst xmlns:a="http://schemas.openxmlformats.org/drawingml/2006/main">
               <a:ext uri="{FF2B5EF4-FFF2-40B4-BE49-F238E27FC236}">
-                <a16:creationId xmlns:a16="http://schemas.microsoft.com/office/drawing/2014/main" id="{A0DF561B-A7BA-423F-9594-4FE8A7F7B261}"/>
+                <a16:creationId xmlns:a16="http://schemas.microsoft.com/office/drawing/2014/main" id="{373C9C87-4385-4867-B1EC-83D3736787B6}"/>
               </a:ext>
             </a:extLst>
           </p:cNvPr>
@@ -13169,7 +13169,7 @@
           <p:cNvPr id="38" name="">
             <a:extLst xmlns:a="http://schemas.openxmlformats.org/drawingml/2006/main">
               <a:ext uri="{FF2B5EF4-FFF2-40B4-BE49-F238E27FC236}">
-                <a16:creationId xmlns:a16="http://schemas.microsoft.com/office/drawing/2014/main" id="{2B03E13C-0C86-45CE-9FC6-3F1164F36858}"/>
+                <a16:creationId xmlns:a16="http://schemas.microsoft.com/office/drawing/2014/main" id="{7846CE5A-71A4-49C8-ACFC-AF3EABD11329}"/>
               </a:ext>
             </a:extLst>
           </p:cNvPr>
@@ -13202,7 +13202,7 @@
           <p:cNvPr id="39" name="">
             <a:extLst xmlns:a="http://schemas.openxmlformats.org/drawingml/2006/main">
               <a:ext uri="{FF2B5EF4-FFF2-40B4-BE49-F238E27FC236}">
-                <a16:creationId xmlns:a16="http://schemas.microsoft.com/office/drawing/2014/main" id="{F1408503-F784-409B-B584-15BBB0BCB965}"/>
+                <a16:creationId xmlns:a16="http://schemas.microsoft.com/office/drawing/2014/main" id="{BFF65069-7B56-402A-AD83-ECCEB27D7199}"/>
               </a:ext>
             </a:extLst>
           </p:cNvPr>
@@ -13256,7 +13256,7 @@
           <p:cNvPr id="40" name="">
             <a:extLst xmlns:a="http://schemas.openxmlformats.org/drawingml/2006/main">
               <a:ext uri="{FF2B5EF4-FFF2-40B4-BE49-F238E27FC236}">
-                <a16:creationId xmlns:a16="http://schemas.microsoft.com/office/drawing/2014/main" id="{ABB4E55C-F368-4D3B-AB90-C720F4A72B48}"/>
+                <a16:creationId xmlns:a16="http://schemas.microsoft.com/office/drawing/2014/main" id="{68752777-C132-4F5F-B011-8B16558D1E8B}"/>
               </a:ext>
             </a:extLst>
           </p:cNvPr>
@@ -13312,7 +13312,7 @@
     </p:spTree>
     <p:extLst>
       <p:ext uri="{BB962C8B-B14F-4D97-AF65-F5344CB8AC3E}">
-        <p14:creationId xmlns:p14="http://schemas.microsoft.com/office/powerpoint/2010/main" val="657065476"/>
+        <p14:creationId xmlns:p14="http://schemas.microsoft.com/office/powerpoint/2010/main" val="1394357154"/>
       </p:ext>
     </p:extLst>
   </p:cSld>
@@ -13343,7 +13343,7 @@
           <p:cNvPr id="1" name="Slide Number Placeholder 5">
             <a:extLst xmlns:a="http://schemas.openxmlformats.org/drawingml/2006/main">
               <a:ext uri="{FF2B5EF4-FFF2-40B4-BE49-F238E27FC236}">
-                <a16:creationId xmlns:a16="http://schemas.microsoft.com/office/drawing/2014/main" id="{C5A324B5-703D-4DE1-A920-5C56CD46E34C}"/>
+                <a16:creationId xmlns:a16="http://schemas.microsoft.com/office/drawing/2014/main" id="{E12CE447-476B-4BAE-A1FF-E669E79965E6}"/>
               </a:ext>
             </a:extLst>
           </p:cNvPr>
@@ -13379,7 +13379,7 @@
           <p:nvPr/>
         </p:nvPicPr>
         <p:blipFill>
-          <a:blip xmlns:r="http://schemas.openxmlformats.org/officeDocument/2006/relationships" xmlns:a="http://schemas.openxmlformats.org/drawingml/2006/main" r:embed="R5ac2505a1bf54d95"/>
+          <a:blip xmlns:r="http://schemas.openxmlformats.org/officeDocument/2006/relationships" xmlns:a="http://schemas.openxmlformats.org/drawingml/2006/main" r:embed="R203812fe74f849a7"/>
           <a:srcRect xmlns:a="http://schemas.openxmlformats.org/drawingml/2006/main" l="0" t="21875" r="0" b="21875"/>
           <a:stretch xmlns:a="http://schemas.openxmlformats.org/drawingml/2006/main">
             <a:fillRect l="0" t="0" r="0" b="0"/>
@@ -13400,7 +13400,7 @@
           <p:cNvPr id="3" name="">
             <a:extLst xmlns:a="http://schemas.openxmlformats.org/drawingml/2006/main">
               <a:ext uri="{FF2B5EF4-FFF2-40B4-BE49-F238E27FC236}">
-                <a16:creationId xmlns:a16="http://schemas.microsoft.com/office/drawing/2014/main" id="{B0176DA0-CB94-4D45-B2FD-83FAAE336ADC}"/>
+                <a16:creationId xmlns:a16="http://schemas.microsoft.com/office/drawing/2014/main" id="{A11CAA33-5EA0-4A45-BCD5-8CD7D73E3548}"/>
               </a:ext>
             </a:extLst>
           </p:cNvPr>
@@ -13435,7 +13435,7 @@
           <p:cNvPr id="4" name="">
             <a:extLst xmlns:a="http://schemas.openxmlformats.org/drawingml/2006/main">
               <a:ext uri="{FF2B5EF4-FFF2-40B4-BE49-F238E27FC236}">
-                <a16:creationId xmlns:a16="http://schemas.microsoft.com/office/drawing/2014/main" id="{6927C78D-1C19-43E7-A9A9-C24F229832C8}"/>
+                <a16:creationId xmlns:a16="http://schemas.microsoft.com/office/drawing/2014/main" id="{F3F14A8D-B64A-4829-8A9F-5BB5C4DFAF7F}"/>
               </a:ext>
             </a:extLst>
           </p:cNvPr>
@@ -13470,7 +13470,7 @@
           <p:cNvPr id="5" name="">
             <a:extLst xmlns:a="http://schemas.openxmlformats.org/drawingml/2006/main">
               <a:ext uri="{FF2B5EF4-FFF2-40B4-BE49-F238E27FC236}">
-                <a16:creationId xmlns:a16="http://schemas.microsoft.com/office/drawing/2014/main" id="{665400EB-13AA-4F36-A6A0-6B5FF7C8E12E}"/>
+                <a16:creationId xmlns:a16="http://schemas.microsoft.com/office/drawing/2014/main" id="{537B1EB2-451A-4699-8250-C8FE5928B42D}"/>
               </a:ext>
             </a:extLst>
           </p:cNvPr>
@@ -13507,7 +13507,7 @@
           <p:cNvPr id="6" name="">
             <a:extLst xmlns:a="http://schemas.openxmlformats.org/drawingml/2006/main">
               <a:ext uri="{FF2B5EF4-FFF2-40B4-BE49-F238E27FC236}">
-                <a16:creationId xmlns:a16="http://schemas.microsoft.com/office/drawing/2014/main" id="{F7092360-00C3-4DD7-B539-D43FA5852356}"/>
+                <a16:creationId xmlns:a16="http://schemas.microsoft.com/office/drawing/2014/main" id="{6CD9E060-CC3C-4AA6-8C91-985578BE0349}"/>
               </a:ext>
             </a:extLst>
           </p:cNvPr>
@@ -13544,7 +13544,7 @@
           <p:cNvPr id="7" name="">
             <a:extLst xmlns:a="http://schemas.openxmlformats.org/drawingml/2006/main">
               <a:ext uri="{FF2B5EF4-FFF2-40B4-BE49-F238E27FC236}">
-                <a16:creationId xmlns:a16="http://schemas.microsoft.com/office/drawing/2014/main" id="{2BF73D49-DFB1-4856-8EDE-11C2335CC4E9}"/>
+                <a16:creationId xmlns:a16="http://schemas.microsoft.com/office/drawing/2014/main" id="{1D8143B9-7917-460C-8DD4-4EF606227B9D}"/>
               </a:ext>
             </a:extLst>
           </p:cNvPr>
@@ -13581,7 +13581,7 @@
           <p:cNvPr id="8" name="">
             <a:extLst xmlns:a="http://schemas.openxmlformats.org/drawingml/2006/main">
               <a:ext uri="{FF2B5EF4-FFF2-40B4-BE49-F238E27FC236}">
-                <a16:creationId xmlns:a16="http://schemas.microsoft.com/office/drawing/2014/main" id="{250125A6-EBA8-46D6-BB49-9D3F23E9ED1C}"/>
+                <a16:creationId xmlns:a16="http://schemas.microsoft.com/office/drawing/2014/main" id="{CDCC7253-DECC-4808-9FD7-B2AB2C2BD343}"/>
               </a:ext>
             </a:extLst>
           </p:cNvPr>
@@ -13618,7 +13618,7 @@
           <p:cNvPr id="9" name="">
             <a:extLst xmlns:a="http://schemas.openxmlformats.org/drawingml/2006/main">
               <a:ext uri="{FF2B5EF4-FFF2-40B4-BE49-F238E27FC236}">
-                <a16:creationId xmlns:a16="http://schemas.microsoft.com/office/drawing/2014/main" id="{A267F57E-8669-4375-BB82-9C55AFA3B4FC}"/>
+                <a16:creationId xmlns:a16="http://schemas.microsoft.com/office/drawing/2014/main" id="{A3ECED39-FF42-49A5-AC22-BAC2957C6060}"/>
               </a:ext>
             </a:extLst>
           </p:cNvPr>
@@ -13676,7 +13676,7 @@
           <p:cNvPr id="10" name="">
             <a:extLst xmlns:a="http://schemas.openxmlformats.org/drawingml/2006/main">
               <a:ext uri="{FF2B5EF4-FFF2-40B4-BE49-F238E27FC236}">
-                <a16:creationId xmlns:a16="http://schemas.microsoft.com/office/drawing/2014/main" id="{90AD5F5B-033F-4783-BBCA-4C7595EB6A8D}"/>
+                <a16:creationId xmlns:a16="http://schemas.microsoft.com/office/drawing/2014/main" id="{592907F2-785B-4EC2-B2BF-F4B07AD6AF2E}"/>
               </a:ext>
             </a:extLst>
           </p:cNvPr>
@@ -13734,7 +13734,7 @@
           <p:cNvPr id="11" name="">
             <a:extLst xmlns:a="http://schemas.openxmlformats.org/drawingml/2006/main">
               <a:ext uri="{FF2B5EF4-FFF2-40B4-BE49-F238E27FC236}">
-                <a16:creationId xmlns:a16="http://schemas.microsoft.com/office/drawing/2014/main" id="{7CA47789-0948-4065-A810-E572F7449B89}"/>
+                <a16:creationId xmlns:a16="http://schemas.microsoft.com/office/drawing/2014/main" id="{91E2F72D-F54C-412A-8549-A9C859033B0B}"/>
               </a:ext>
             </a:extLst>
           </p:cNvPr>
@@ -13769,7 +13769,7 @@
           <p:cNvPr id="12" name="">
             <a:extLst xmlns:a="http://schemas.openxmlformats.org/drawingml/2006/main">
               <a:ext uri="{FF2B5EF4-FFF2-40B4-BE49-F238E27FC236}">
-                <a16:creationId xmlns:a16="http://schemas.microsoft.com/office/drawing/2014/main" id="{C426C54D-298F-4CD7-908D-9B460B91446A}"/>
+                <a16:creationId xmlns:a16="http://schemas.microsoft.com/office/drawing/2014/main" id="{62338E28-16F0-4DBF-86BF-C8D14CBAF63D}"/>
               </a:ext>
             </a:extLst>
           </p:cNvPr>
@@ -13802,7 +13802,7 @@
           <p:cNvPr id="13" name="">
             <a:extLst xmlns:a="http://schemas.openxmlformats.org/drawingml/2006/main">
               <a:ext uri="{FF2B5EF4-FFF2-40B4-BE49-F238E27FC236}">
-                <a16:creationId xmlns:a16="http://schemas.microsoft.com/office/drawing/2014/main" id="{F7B24E1E-675F-4434-B927-574FD6F08AAA}"/>
+                <a16:creationId xmlns:a16="http://schemas.microsoft.com/office/drawing/2014/main" id="{6FD86669-4F43-43EA-9945-A2F643F0B993}"/>
               </a:ext>
             </a:extLst>
           </p:cNvPr>
@@ -13877,7 +13877,7 @@
           <p:cNvPr id="14" name="">
             <a:extLst xmlns:a="http://schemas.openxmlformats.org/drawingml/2006/main">
               <a:ext uri="{FF2B5EF4-FFF2-40B4-BE49-F238E27FC236}">
-                <a16:creationId xmlns:a16="http://schemas.microsoft.com/office/drawing/2014/main" id="{F7213B3A-AB04-4B57-B4B6-C5B5C07B2698}"/>
+                <a16:creationId xmlns:a16="http://schemas.microsoft.com/office/drawing/2014/main" id="{E5E94A83-2065-44D3-A5C2-9C047A0E988D}"/>
               </a:ext>
             </a:extLst>
           </p:cNvPr>
@@ -13914,7 +13914,7 @@
           <p:cNvPr id="15" name="">
             <a:extLst xmlns:a="http://schemas.openxmlformats.org/drawingml/2006/main">
               <a:ext uri="{FF2B5EF4-FFF2-40B4-BE49-F238E27FC236}">
-                <a16:creationId xmlns:a16="http://schemas.microsoft.com/office/drawing/2014/main" id="{A4BD73D5-33FA-43E1-A8F1-2766EA47A339}"/>
+                <a16:creationId xmlns:a16="http://schemas.microsoft.com/office/drawing/2014/main" id="{5D1AF7E6-B777-4AD9-84FE-B4FE92E28301}"/>
               </a:ext>
             </a:extLst>
           </p:cNvPr>
@@ -13949,7 +13949,7 @@
           <p:cNvPr id="16" name="">
             <a:extLst xmlns:a="http://schemas.openxmlformats.org/drawingml/2006/main">
               <a:ext uri="{FF2B5EF4-FFF2-40B4-BE49-F238E27FC236}">
-                <a16:creationId xmlns:a16="http://schemas.microsoft.com/office/drawing/2014/main" id="{E680CC7A-2EEC-4CBE-BFA4-6105EA9B9EF9}"/>
+                <a16:creationId xmlns:a16="http://schemas.microsoft.com/office/drawing/2014/main" id="{C1F5BC5D-67F4-476F-BC39-49042DD35074}"/>
               </a:ext>
             </a:extLst>
           </p:cNvPr>
@@ -14007,7 +14007,7 @@
           <p:cNvPr id="17" name="">
             <a:extLst xmlns:a="http://schemas.openxmlformats.org/drawingml/2006/main">
               <a:ext uri="{FF2B5EF4-FFF2-40B4-BE49-F238E27FC236}">
-                <a16:creationId xmlns:a16="http://schemas.microsoft.com/office/drawing/2014/main" id="{45723F24-6935-4A6A-B3DB-02C301BCC8B7}"/>
+                <a16:creationId xmlns:a16="http://schemas.microsoft.com/office/drawing/2014/main" id="{77FB79B9-2473-4358-9082-124A81237859}"/>
               </a:ext>
             </a:extLst>
           </p:cNvPr>
@@ -14116,7 +14116,7 @@
           <p:cNvPr id="18" name="">
             <a:extLst xmlns:a="http://schemas.openxmlformats.org/drawingml/2006/main">
               <a:ext uri="{FF2B5EF4-FFF2-40B4-BE49-F238E27FC236}">
-                <a16:creationId xmlns:a16="http://schemas.microsoft.com/office/drawing/2014/main" id="{E59EDBA6-0024-4973-BAD1-8D1597DED986}"/>
+                <a16:creationId xmlns:a16="http://schemas.microsoft.com/office/drawing/2014/main" id="{5DB06B90-B995-4AF4-8BD0-D9B3B05C8E1C}"/>
               </a:ext>
             </a:extLst>
           </p:cNvPr>
@@ -14149,7 +14149,7 @@
           <p:cNvPr id="19" name="">
             <a:extLst xmlns:a="http://schemas.openxmlformats.org/drawingml/2006/main">
               <a:ext uri="{FF2B5EF4-FFF2-40B4-BE49-F238E27FC236}">
-                <a16:creationId xmlns:a16="http://schemas.microsoft.com/office/drawing/2014/main" id="{5E61E24B-DC60-4380-8BB9-6AF372CCDD61}"/>
+                <a16:creationId xmlns:a16="http://schemas.microsoft.com/office/drawing/2014/main" id="{32E8CFD5-D802-40C9-819E-DA20FE63DDB4}"/>
               </a:ext>
             </a:extLst>
           </p:cNvPr>
@@ -14186,7 +14186,7 @@
           <p:cNvPr id="20" name="">
             <a:extLst xmlns:a="http://schemas.openxmlformats.org/drawingml/2006/main">
               <a:ext uri="{FF2B5EF4-FFF2-40B4-BE49-F238E27FC236}">
-                <a16:creationId xmlns:a16="http://schemas.microsoft.com/office/drawing/2014/main" id="{E35C5716-FDA8-482B-8F52-2DD2BFB9FBC3}"/>
+                <a16:creationId xmlns:a16="http://schemas.microsoft.com/office/drawing/2014/main" id="{176DF6F3-4529-4CE9-AC4D-EF47822FCDDA}"/>
               </a:ext>
             </a:extLst>
           </p:cNvPr>
@@ -14221,7 +14221,7 @@
           <p:cNvPr id="21" name="">
             <a:extLst xmlns:a="http://schemas.openxmlformats.org/drawingml/2006/main">
               <a:ext uri="{FF2B5EF4-FFF2-40B4-BE49-F238E27FC236}">
-                <a16:creationId xmlns:a16="http://schemas.microsoft.com/office/drawing/2014/main" id="{637DCC7B-B0E2-4444-9F3C-0FCC9C6C957E}"/>
+                <a16:creationId xmlns:a16="http://schemas.microsoft.com/office/drawing/2014/main" id="{CB87B3A2-1056-4F58-A51C-3279C0E47B8E}"/>
               </a:ext>
             </a:extLst>
           </p:cNvPr>
@@ -14279,7 +14279,7 @@
           <p:cNvPr id="22" name="">
             <a:extLst xmlns:a="http://schemas.openxmlformats.org/drawingml/2006/main">
               <a:ext uri="{FF2B5EF4-FFF2-40B4-BE49-F238E27FC236}">
-                <a16:creationId xmlns:a16="http://schemas.microsoft.com/office/drawing/2014/main" id="{6F08D250-0BF9-41C3-AA3E-9A4D61909DF1}"/>
+                <a16:creationId xmlns:a16="http://schemas.microsoft.com/office/drawing/2014/main" id="{08F41C24-A61E-4E29-A5E6-2BA8885CC5CF}"/>
               </a:ext>
             </a:extLst>
           </p:cNvPr>
@@ -14388,7 +14388,7 @@
           <p:cNvPr id="23" name="">
             <a:extLst xmlns:a="http://schemas.openxmlformats.org/drawingml/2006/main">
               <a:ext uri="{FF2B5EF4-FFF2-40B4-BE49-F238E27FC236}">
-                <a16:creationId xmlns:a16="http://schemas.microsoft.com/office/drawing/2014/main" id="{E77F8F86-64D9-4A03-9AFF-72A1B5FE3FC0}"/>
+                <a16:creationId xmlns:a16="http://schemas.microsoft.com/office/drawing/2014/main" id="{E06257DF-BEAB-4C74-8AC9-5A2013CC2BA4}"/>
               </a:ext>
             </a:extLst>
           </p:cNvPr>
@@ -14421,7 +14421,7 @@
           <p:cNvPr id="24" name="">
             <a:extLst xmlns:a="http://schemas.openxmlformats.org/drawingml/2006/main">
               <a:ext uri="{FF2B5EF4-FFF2-40B4-BE49-F238E27FC236}">
-                <a16:creationId xmlns:a16="http://schemas.microsoft.com/office/drawing/2014/main" id="{5B19AC11-8A8C-4AC7-946A-81E3687275DE}"/>
+                <a16:creationId xmlns:a16="http://schemas.microsoft.com/office/drawing/2014/main" id="{CB9F27A0-B788-4E48-B211-5C69678C4EBF}"/>
               </a:ext>
             </a:extLst>
           </p:cNvPr>
@@ -14458,7 +14458,7 @@
           <p:cNvPr id="25" name="">
             <a:extLst xmlns:a="http://schemas.openxmlformats.org/drawingml/2006/main">
               <a:ext uri="{FF2B5EF4-FFF2-40B4-BE49-F238E27FC236}">
-                <a16:creationId xmlns:a16="http://schemas.microsoft.com/office/drawing/2014/main" id="{3C35DB87-1DAE-495F-9554-3F7CF50A7281}"/>
+                <a16:creationId xmlns:a16="http://schemas.microsoft.com/office/drawing/2014/main" id="{FFA7F26A-DAC4-4B2C-98E2-9BB2A1DCF1F7}"/>
               </a:ext>
             </a:extLst>
           </p:cNvPr>
@@ -14493,7 +14493,7 @@
           <p:cNvPr id="26" name="">
             <a:extLst xmlns:a="http://schemas.openxmlformats.org/drawingml/2006/main">
               <a:ext uri="{FF2B5EF4-FFF2-40B4-BE49-F238E27FC236}">
-                <a16:creationId xmlns:a16="http://schemas.microsoft.com/office/drawing/2014/main" id="{C847720D-698C-4B95-8B72-4F4BB513F5C6}"/>
+                <a16:creationId xmlns:a16="http://schemas.microsoft.com/office/drawing/2014/main" id="{AD189B84-D955-48CA-ACF3-4F182B28DD04}"/>
               </a:ext>
             </a:extLst>
           </p:cNvPr>
@@ -14551,7 +14551,7 @@
           <p:cNvPr id="27" name="">
             <a:extLst xmlns:a="http://schemas.openxmlformats.org/drawingml/2006/main">
               <a:ext uri="{FF2B5EF4-FFF2-40B4-BE49-F238E27FC236}">
-                <a16:creationId xmlns:a16="http://schemas.microsoft.com/office/drawing/2014/main" id="{12A67CFA-0FA8-4E69-8746-3352D9546D71}"/>
+                <a16:creationId xmlns:a16="http://schemas.microsoft.com/office/drawing/2014/main" id="{9773D69F-FB95-46A1-8BA6-67BE6BD506F9}"/>
               </a:ext>
             </a:extLst>
           </p:cNvPr>
@@ -14643,7 +14643,7 @@
           <p:cNvPr id="28" name="">
             <a:extLst xmlns:a="http://schemas.openxmlformats.org/drawingml/2006/main">
               <a:ext uri="{FF2B5EF4-FFF2-40B4-BE49-F238E27FC236}">
-                <a16:creationId xmlns:a16="http://schemas.microsoft.com/office/drawing/2014/main" id="{555C44C3-A32C-4CAF-94C6-A81CD34BA484}"/>
+                <a16:creationId xmlns:a16="http://schemas.microsoft.com/office/drawing/2014/main" id="{62A27BF9-1237-42CF-9155-DC39A8C12A42}"/>
               </a:ext>
             </a:extLst>
           </p:cNvPr>
@@ -14678,7 +14678,7 @@
           <p:cNvPr id="29" name="">
             <a:extLst xmlns:a="http://schemas.openxmlformats.org/drawingml/2006/main">
               <a:ext uri="{FF2B5EF4-FFF2-40B4-BE49-F238E27FC236}">
-                <a16:creationId xmlns:a16="http://schemas.microsoft.com/office/drawing/2014/main" id="{0C6EE6FA-2580-4E58-92A8-4AF9D2BEC5AD}"/>
+                <a16:creationId xmlns:a16="http://schemas.microsoft.com/office/drawing/2014/main" id="{8440B62C-4558-4FCC-BD2F-1EB153B31AF9}"/>
               </a:ext>
             </a:extLst>
           </p:cNvPr>
@@ -14713,7 +14713,7 @@
           <p:cNvPr id="30" name="">
             <a:extLst xmlns:a="http://schemas.openxmlformats.org/drawingml/2006/main">
               <a:ext uri="{FF2B5EF4-FFF2-40B4-BE49-F238E27FC236}">
-                <a16:creationId xmlns:a16="http://schemas.microsoft.com/office/drawing/2014/main" id="{6A074246-2878-42F2-B089-F8FEDD5EE8E3}"/>
+                <a16:creationId xmlns:a16="http://schemas.microsoft.com/office/drawing/2014/main" id="{2035AB98-EAA3-4B06-B2C4-7250E2064B2C}"/>
               </a:ext>
             </a:extLst>
           </p:cNvPr>
@@ -14771,7 +14771,7 @@
           <p:cNvPr id="31" name="">
             <a:extLst xmlns:a="http://schemas.openxmlformats.org/drawingml/2006/main">
               <a:ext uri="{FF2B5EF4-FFF2-40B4-BE49-F238E27FC236}">
-                <a16:creationId xmlns:a16="http://schemas.microsoft.com/office/drawing/2014/main" id="{B4810F55-A541-447F-A71F-7DB5C9780238}"/>
+                <a16:creationId xmlns:a16="http://schemas.microsoft.com/office/drawing/2014/main" id="{12C1452E-2D2F-47A5-B221-D2DB671FED75}"/>
               </a:ext>
             </a:extLst>
           </p:cNvPr>
@@ -14827,7 +14827,7 @@
     </p:spTree>
     <p:extLst>
       <p:ext uri="{BB962C8B-B14F-4D97-AF65-F5344CB8AC3E}">
-        <p14:creationId xmlns:p14="http://schemas.microsoft.com/office/powerpoint/2010/main" val="159160505"/>
+        <p14:creationId xmlns:p14="http://schemas.microsoft.com/office/powerpoint/2010/main" val="1908421148"/>
       </p:ext>
     </p:extLst>
   </p:cSld>
@@ -14858,7 +14858,7 @@
           <p:cNvPr id="1" name="Slide Number Placeholder 5">
             <a:extLst xmlns:a="http://schemas.openxmlformats.org/drawingml/2006/main">
               <a:ext uri="{FF2B5EF4-FFF2-40B4-BE49-F238E27FC236}">
-                <a16:creationId xmlns:a16="http://schemas.microsoft.com/office/drawing/2014/main" id="{C5A324B5-703D-4DE1-A920-5C56CD46E34C}"/>
+                <a16:creationId xmlns:a16="http://schemas.microsoft.com/office/drawing/2014/main" id="{E12CE447-476B-4BAE-A1FF-E669E79965E6}"/>
               </a:ext>
             </a:extLst>
           </p:cNvPr>
@@ -14894,7 +14894,7 @@
           <p:nvPr/>
         </p:nvPicPr>
         <p:blipFill>
-          <a:blip xmlns:r="http://schemas.openxmlformats.org/officeDocument/2006/relationships" xmlns:a="http://schemas.openxmlformats.org/drawingml/2006/main" r:embed="R557a5ae816884c30"/>
+          <a:blip xmlns:r="http://schemas.openxmlformats.org/officeDocument/2006/relationships" xmlns:a="http://schemas.openxmlformats.org/drawingml/2006/main" r:embed="R2336609a21444d95"/>
           <a:srcRect xmlns:a="http://schemas.openxmlformats.org/drawingml/2006/main" l="0" t="21875" r="0" b="21875"/>
           <a:stretch xmlns:a="http://schemas.openxmlformats.org/drawingml/2006/main">
             <a:fillRect l="0" t="0" r="0" b="0"/>
@@ -14915,7 +14915,7 @@
           <p:cNvPr id="3" name="">
             <a:extLst xmlns:a="http://schemas.openxmlformats.org/drawingml/2006/main">
               <a:ext uri="{FF2B5EF4-FFF2-40B4-BE49-F238E27FC236}">
-                <a16:creationId xmlns:a16="http://schemas.microsoft.com/office/drawing/2014/main" id="{863D9984-C04E-4B2F-AFC3-82E6C94A8EB9}"/>
+                <a16:creationId xmlns:a16="http://schemas.microsoft.com/office/drawing/2014/main" id="{30CA5D47-C4E0-4A8E-8F69-C675713A3AFC}"/>
               </a:ext>
             </a:extLst>
           </p:cNvPr>
@@ -14950,7 +14950,7 @@
           <p:cNvPr id="4" name="">
             <a:extLst xmlns:a="http://schemas.openxmlformats.org/drawingml/2006/main">
               <a:ext uri="{FF2B5EF4-FFF2-40B4-BE49-F238E27FC236}">
-                <a16:creationId xmlns:a16="http://schemas.microsoft.com/office/drawing/2014/main" id="{47632623-F1D3-4547-A15C-9781F58C26C1}"/>
+                <a16:creationId xmlns:a16="http://schemas.microsoft.com/office/drawing/2014/main" id="{A76A70C4-38AD-493B-9C7F-C6403F2118F6}"/>
               </a:ext>
             </a:extLst>
           </p:cNvPr>
@@ -14985,7 +14985,7 @@
           <p:cNvPr id="5" name="">
             <a:extLst xmlns:a="http://schemas.openxmlformats.org/drawingml/2006/main">
               <a:ext uri="{FF2B5EF4-FFF2-40B4-BE49-F238E27FC236}">
-                <a16:creationId xmlns:a16="http://schemas.microsoft.com/office/drawing/2014/main" id="{FEFF29E7-5A0C-484A-8413-D17DDCD72398}"/>
+                <a16:creationId xmlns:a16="http://schemas.microsoft.com/office/drawing/2014/main" id="{E11F7184-FC2F-4DBB-8C82-917A76F8F6E7}"/>
               </a:ext>
             </a:extLst>
           </p:cNvPr>
@@ -15022,7 +15022,7 @@
           <p:cNvPr id="6" name="">
             <a:extLst xmlns:a="http://schemas.openxmlformats.org/drawingml/2006/main">
               <a:ext uri="{FF2B5EF4-FFF2-40B4-BE49-F238E27FC236}">
-                <a16:creationId xmlns:a16="http://schemas.microsoft.com/office/drawing/2014/main" id="{43B71630-46D2-45ED-8B30-78C05C8A97E7}"/>
+                <a16:creationId xmlns:a16="http://schemas.microsoft.com/office/drawing/2014/main" id="{5EC8B7CF-629E-44AA-AECD-58D981B218F6}"/>
               </a:ext>
             </a:extLst>
           </p:cNvPr>
@@ -15059,7 +15059,7 @@
           <p:cNvPr id="7" name="">
             <a:extLst xmlns:a="http://schemas.openxmlformats.org/drawingml/2006/main">
               <a:ext uri="{FF2B5EF4-FFF2-40B4-BE49-F238E27FC236}">
-                <a16:creationId xmlns:a16="http://schemas.microsoft.com/office/drawing/2014/main" id="{62F62BB9-2552-44AA-B081-5AE82F40A275}"/>
+                <a16:creationId xmlns:a16="http://schemas.microsoft.com/office/drawing/2014/main" id="{7BB2938C-FEAD-4422-A33A-D017EA940132}"/>
               </a:ext>
             </a:extLst>
           </p:cNvPr>
@@ -15096,7 +15096,7 @@
           <p:cNvPr id="8" name="">
             <a:extLst xmlns:a="http://schemas.openxmlformats.org/drawingml/2006/main">
               <a:ext uri="{FF2B5EF4-FFF2-40B4-BE49-F238E27FC236}">
-                <a16:creationId xmlns:a16="http://schemas.microsoft.com/office/drawing/2014/main" id="{B2E3A9A4-7DEA-49C6-9807-10BC1CD0D7DB}"/>
+                <a16:creationId xmlns:a16="http://schemas.microsoft.com/office/drawing/2014/main" id="{35D0A677-A012-44A0-B3D6-652C23B24AA0}"/>
               </a:ext>
             </a:extLst>
           </p:cNvPr>
@@ -15133,7 +15133,7 @@
           <p:cNvPr id="9" name="">
             <a:extLst xmlns:a="http://schemas.openxmlformats.org/drawingml/2006/main">
               <a:ext uri="{FF2B5EF4-FFF2-40B4-BE49-F238E27FC236}">
-                <a16:creationId xmlns:a16="http://schemas.microsoft.com/office/drawing/2014/main" id="{3E3E4714-78B3-4630-971F-4B7ED6498E23}"/>
+                <a16:creationId xmlns:a16="http://schemas.microsoft.com/office/drawing/2014/main" id="{29D9D992-C308-4EA1-83A8-EB0E015C4837}"/>
               </a:ext>
             </a:extLst>
           </p:cNvPr>
@@ -15191,7 +15191,7 @@
           <p:cNvPr id="10" name="">
             <a:extLst xmlns:a="http://schemas.openxmlformats.org/drawingml/2006/main">
               <a:ext uri="{FF2B5EF4-FFF2-40B4-BE49-F238E27FC236}">
-                <a16:creationId xmlns:a16="http://schemas.microsoft.com/office/drawing/2014/main" id="{08524345-1E28-48F4-999F-54B3F1FF0B58}"/>
+                <a16:creationId xmlns:a16="http://schemas.microsoft.com/office/drawing/2014/main" id="{01DCC677-AA51-4D35-BB4E-13D1D82E3471}"/>
               </a:ext>
             </a:extLst>
           </p:cNvPr>
@@ -15249,7 +15249,7 @@
           <p:cNvPr id="11" name="">
             <a:extLst xmlns:a="http://schemas.openxmlformats.org/drawingml/2006/main">
               <a:ext uri="{FF2B5EF4-FFF2-40B4-BE49-F238E27FC236}">
-                <a16:creationId xmlns:a16="http://schemas.microsoft.com/office/drawing/2014/main" id="{0D4FC634-9291-4348-BA16-893CABFA1A3E}"/>
+                <a16:creationId xmlns:a16="http://schemas.microsoft.com/office/drawing/2014/main" id="{39F1F3A0-C083-46D8-A510-D8B1F79F8BD6}"/>
               </a:ext>
             </a:extLst>
           </p:cNvPr>
@@ -15284,7 +15284,7 @@
           <p:cNvPr id="12" name="">
             <a:extLst xmlns:a="http://schemas.openxmlformats.org/drawingml/2006/main">
               <a:ext uri="{FF2B5EF4-FFF2-40B4-BE49-F238E27FC236}">
-                <a16:creationId xmlns:a16="http://schemas.microsoft.com/office/drawing/2014/main" id="{A205963A-7D47-4474-855A-28451B35729E}"/>
+                <a16:creationId xmlns:a16="http://schemas.microsoft.com/office/drawing/2014/main" id="{5F4AF19C-DA5C-4241-BD5C-B7468ECC4917}"/>
               </a:ext>
             </a:extLst>
           </p:cNvPr>
@@ -15317,7 +15317,7 @@
           <p:cNvPr id="13" name="">
             <a:extLst xmlns:a="http://schemas.openxmlformats.org/drawingml/2006/main">
               <a:ext uri="{FF2B5EF4-FFF2-40B4-BE49-F238E27FC236}">
-                <a16:creationId xmlns:a16="http://schemas.microsoft.com/office/drawing/2014/main" id="{395EB8D1-E04C-4C12-92F0-9CE834DBB7ED}"/>
+                <a16:creationId xmlns:a16="http://schemas.microsoft.com/office/drawing/2014/main" id="{CEE212F1-B5A8-499F-9A81-0FDB54EBA1CE}"/>
               </a:ext>
             </a:extLst>
           </p:cNvPr>
@@ -15392,7 +15392,7 @@
           <p:cNvPr id="14" name="">
             <a:extLst xmlns:a="http://schemas.openxmlformats.org/drawingml/2006/main">
               <a:ext uri="{FF2B5EF4-FFF2-40B4-BE49-F238E27FC236}">
-                <a16:creationId xmlns:a16="http://schemas.microsoft.com/office/drawing/2014/main" id="{A332C973-F6CA-452D-A1F2-C3D7E7FCAA27}"/>
+                <a16:creationId xmlns:a16="http://schemas.microsoft.com/office/drawing/2014/main" id="{10C24E03-0283-4611-A45D-9A49F134D6FB}"/>
               </a:ext>
             </a:extLst>
           </p:cNvPr>
@@ -15429,7 +15429,7 @@
           <p:cNvPr id="15" name="">
             <a:extLst xmlns:a="http://schemas.openxmlformats.org/drawingml/2006/main">
               <a:ext uri="{FF2B5EF4-FFF2-40B4-BE49-F238E27FC236}">
-                <a16:creationId xmlns:a16="http://schemas.microsoft.com/office/drawing/2014/main" id="{74FFFC3B-6234-4976-AC3F-83FB0A46881A}"/>
+                <a16:creationId xmlns:a16="http://schemas.microsoft.com/office/drawing/2014/main" id="{63098BCC-4D2E-4D15-94C7-C16B708EEDC8}"/>
               </a:ext>
             </a:extLst>
           </p:cNvPr>
@@ -15464,7 +15464,7 @@
           <p:cNvPr id="16" name="">
             <a:extLst xmlns:a="http://schemas.openxmlformats.org/drawingml/2006/main">
               <a:ext uri="{FF2B5EF4-FFF2-40B4-BE49-F238E27FC236}">
-                <a16:creationId xmlns:a16="http://schemas.microsoft.com/office/drawing/2014/main" id="{6A8CC2E8-DC5E-459F-A5F1-39733FF996D3}"/>
+                <a16:creationId xmlns:a16="http://schemas.microsoft.com/office/drawing/2014/main" id="{9433C0D1-C0D1-4A68-8C20-E1098E813F80}"/>
               </a:ext>
             </a:extLst>
           </p:cNvPr>
@@ -15522,7 +15522,7 @@
           <p:cNvPr id="17" name="">
             <a:extLst xmlns:a="http://schemas.openxmlformats.org/drawingml/2006/main">
               <a:ext uri="{FF2B5EF4-FFF2-40B4-BE49-F238E27FC236}">
-                <a16:creationId xmlns:a16="http://schemas.microsoft.com/office/drawing/2014/main" id="{CA17FD2E-1859-4C84-BD96-D4EB2A72F5D2}"/>
+                <a16:creationId xmlns:a16="http://schemas.microsoft.com/office/drawing/2014/main" id="{C79CCD4C-46FD-4391-B582-342048F8FD7A}"/>
               </a:ext>
             </a:extLst>
           </p:cNvPr>
@@ -15614,7 +15614,7 @@
           <p:cNvPr id="18" name="">
             <a:extLst xmlns:a="http://schemas.openxmlformats.org/drawingml/2006/main">
               <a:ext uri="{FF2B5EF4-FFF2-40B4-BE49-F238E27FC236}">
-                <a16:creationId xmlns:a16="http://schemas.microsoft.com/office/drawing/2014/main" id="{C2E68F0F-B1A4-4191-8B07-3196AA8C29E7}"/>
+                <a16:creationId xmlns:a16="http://schemas.microsoft.com/office/drawing/2014/main" id="{23A9897D-91C4-44BE-A66D-D0DCC8E9195A}"/>
               </a:ext>
             </a:extLst>
           </p:cNvPr>
@@ -15651,7 +15651,7 @@
           <p:cNvPr id="19" name="">
             <a:extLst xmlns:a="http://schemas.openxmlformats.org/drawingml/2006/main">
               <a:ext uri="{FF2B5EF4-FFF2-40B4-BE49-F238E27FC236}">
-                <a16:creationId xmlns:a16="http://schemas.microsoft.com/office/drawing/2014/main" id="{172A3708-29C4-4B44-834B-416BF1DC1897}"/>
+                <a16:creationId xmlns:a16="http://schemas.microsoft.com/office/drawing/2014/main" id="{A1CCE9CF-910F-4EFB-93C6-C104BDDFC8D7}"/>
               </a:ext>
             </a:extLst>
           </p:cNvPr>
@@ -15686,7 +15686,7 @@
           <p:cNvPr id="20" name="">
             <a:extLst xmlns:a="http://schemas.openxmlformats.org/drawingml/2006/main">
               <a:ext uri="{FF2B5EF4-FFF2-40B4-BE49-F238E27FC236}">
-                <a16:creationId xmlns:a16="http://schemas.microsoft.com/office/drawing/2014/main" id="{F99E9EDD-4FD7-49AF-A5E6-3D3987AFAE80}"/>
+                <a16:creationId xmlns:a16="http://schemas.microsoft.com/office/drawing/2014/main" id="{E2CB9F38-CB71-4C30-8CAD-67A4A0FE1824}"/>
               </a:ext>
             </a:extLst>
           </p:cNvPr>
@@ -15744,7 +15744,7 @@
           <p:cNvPr id="21" name="">
             <a:extLst xmlns:a="http://schemas.openxmlformats.org/drawingml/2006/main">
               <a:ext uri="{FF2B5EF4-FFF2-40B4-BE49-F238E27FC236}">
-                <a16:creationId xmlns:a16="http://schemas.microsoft.com/office/drawing/2014/main" id="{5F16CE58-7A02-4CE9-94D7-1F680026A3D1}"/>
+                <a16:creationId xmlns:a16="http://schemas.microsoft.com/office/drawing/2014/main" id="{D930F14A-BC8E-4E9C-8E51-23631C186561}"/>
               </a:ext>
             </a:extLst>
           </p:cNvPr>
@@ -15836,7 +15836,7 @@
           <p:cNvPr id="22" name="">
             <a:extLst xmlns:a="http://schemas.openxmlformats.org/drawingml/2006/main">
               <a:ext uri="{FF2B5EF4-FFF2-40B4-BE49-F238E27FC236}">
-                <a16:creationId xmlns:a16="http://schemas.microsoft.com/office/drawing/2014/main" id="{D05E2398-A52E-471C-BE53-672390926094}"/>
+                <a16:creationId xmlns:a16="http://schemas.microsoft.com/office/drawing/2014/main" id="{0C8A54C4-EC7C-41D7-B062-0564E6D3D345}"/>
               </a:ext>
             </a:extLst>
           </p:cNvPr>
@@ -15873,7 +15873,7 @@
           <p:cNvPr id="23" name="">
             <a:extLst xmlns:a="http://schemas.openxmlformats.org/drawingml/2006/main">
               <a:ext uri="{FF2B5EF4-FFF2-40B4-BE49-F238E27FC236}">
-                <a16:creationId xmlns:a16="http://schemas.microsoft.com/office/drawing/2014/main" id="{FD5F3443-7C29-4062-A317-E95701EE5D9C}"/>
+                <a16:creationId xmlns:a16="http://schemas.microsoft.com/office/drawing/2014/main" id="{EF944F62-B7A9-4C76-80E5-136515B698F0}"/>
               </a:ext>
             </a:extLst>
           </p:cNvPr>
@@ -15908,7 +15908,7 @@
           <p:cNvPr id="24" name="">
             <a:extLst xmlns:a="http://schemas.openxmlformats.org/drawingml/2006/main">
               <a:ext uri="{FF2B5EF4-FFF2-40B4-BE49-F238E27FC236}">
-                <a16:creationId xmlns:a16="http://schemas.microsoft.com/office/drawing/2014/main" id="{E3B24FDA-3CB2-4801-AEDE-EDD7F4D224A0}"/>
+                <a16:creationId xmlns:a16="http://schemas.microsoft.com/office/drawing/2014/main" id="{9A341710-5718-4153-91E2-9447732121C3}"/>
               </a:ext>
             </a:extLst>
           </p:cNvPr>
@@ -15966,7 +15966,7 @@
           <p:cNvPr id="25" name="">
             <a:extLst xmlns:a="http://schemas.openxmlformats.org/drawingml/2006/main">
               <a:ext uri="{FF2B5EF4-FFF2-40B4-BE49-F238E27FC236}">
-                <a16:creationId xmlns:a16="http://schemas.microsoft.com/office/drawing/2014/main" id="{B8D74735-560F-4D56-B6D5-1888F97CA4C7}"/>
+                <a16:creationId xmlns:a16="http://schemas.microsoft.com/office/drawing/2014/main" id="{AC5A20A5-9A6B-4FE6-9B2B-52D6C7B9299E}"/>
               </a:ext>
             </a:extLst>
           </p:cNvPr>
@@ -16041,7 +16041,7 @@
           <p:cNvPr id="26" name="">
             <a:extLst xmlns:a="http://schemas.openxmlformats.org/drawingml/2006/main">
               <a:ext uri="{FF2B5EF4-FFF2-40B4-BE49-F238E27FC236}">
-                <a16:creationId xmlns:a16="http://schemas.microsoft.com/office/drawing/2014/main" id="{2CB4D230-FD4B-4CEE-A3FC-4EFD15196DD4}"/>
+                <a16:creationId xmlns:a16="http://schemas.microsoft.com/office/drawing/2014/main" id="{02225F26-2534-43B4-8E02-C5B10FC2461D}"/>
               </a:ext>
             </a:extLst>
           </p:cNvPr>
@@ -16076,7 +16076,7 @@
           <p:cNvPr id="27" name="">
             <a:extLst xmlns:a="http://schemas.openxmlformats.org/drawingml/2006/main">
               <a:ext uri="{FF2B5EF4-FFF2-40B4-BE49-F238E27FC236}">
-                <a16:creationId xmlns:a16="http://schemas.microsoft.com/office/drawing/2014/main" id="{DD6E0FDC-DDDB-4D68-A6AA-EEADE81A7ECC}"/>
+                <a16:creationId xmlns:a16="http://schemas.microsoft.com/office/drawing/2014/main" id="{FF3A20F7-7166-4626-AF4C-F6B974A6FD88}"/>
               </a:ext>
             </a:extLst>
           </p:cNvPr>
@@ -16111,7 +16111,7 @@
           <p:cNvPr id="28" name="">
             <a:extLst xmlns:a="http://schemas.openxmlformats.org/drawingml/2006/main">
               <a:ext uri="{FF2B5EF4-FFF2-40B4-BE49-F238E27FC236}">
-                <a16:creationId xmlns:a16="http://schemas.microsoft.com/office/drawing/2014/main" id="{F21200E9-3A22-43D3-963D-AD5869151DF3}"/>
+                <a16:creationId xmlns:a16="http://schemas.microsoft.com/office/drawing/2014/main" id="{16D284DE-607A-40C1-B78A-98BF6414C63C}"/>
               </a:ext>
             </a:extLst>
           </p:cNvPr>
@@ -16169,7 +16169,7 @@
           <p:cNvPr id="29" name="">
             <a:extLst xmlns:a="http://schemas.openxmlformats.org/drawingml/2006/main">
               <a:ext uri="{FF2B5EF4-FFF2-40B4-BE49-F238E27FC236}">
-                <a16:creationId xmlns:a16="http://schemas.microsoft.com/office/drawing/2014/main" id="{6E56D51A-7F31-44DF-B4EA-94FE54C8DCC2}"/>
+                <a16:creationId xmlns:a16="http://schemas.microsoft.com/office/drawing/2014/main" id="{4DD2F103-22B9-4905-8DD9-B667DF5142FC}"/>
               </a:ext>
             </a:extLst>
           </p:cNvPr>
@@ -16227,7 +16227,7 @@
           <p:cNvPr id="30" name="">
             <a:extLst xmlns:a="http://schemas.openxmlformats.org/drawingml/2006/main">
               <a:ext uri="{FF2B5EF4-FFF2-40B4-BE49-F238E27FC236}">
-                <a16:creationId xmlns:a16="http://schemas.microsoft.com/office/drawing/2014/main" id="{8F36BBB0-A0F9-405C-83AD-8F30AC550B5E}"/>
+                <a16:creationId xmlns:a16="http://schemas.microsoft.com/office/drawing/2014/main" id="{10481A7D-810F-4083-8058-5DB035718985}"/>
               </a:ext>
             </a:extLst>
           </p:cNvPr>
@@ -16262,7 +16262,7 @@
           <p:cNvPr id="31" name="">
             <a:extLst xmlns:a="http://schemas.openxmlformats.org/drawingml/2006/main">
               <a:ext uri="{FF2B5EF4-FFF2-40B4-BE49-F238E27FC236}">
-                <a16:creationId xmlns:a16="http://schemas.microsoft.com/office/drawing/2014/main" id="{757A48BB-462D-48F8-9435-2F21B104BF69}"/>
+                <a16:creationId xmlns:a16="http://schemas.microsoft.com/office/drawing/2014/main" id="{47C24B9F-5584-4FFF-88F6-4AD081A1F027}"/>
               </a:ext>
             </a:extLst>
           </p:cNvPr>
@@ -16320,7 +16320,7 @@
           <p:cNvPr id="32" name="">
             <a:extLst xmlns:a="http://schemas.openxmlformats.org/drawingml/2006/main">
               <a:ext uri="{FF2B5EF4-FFF2-40B4-BE49-F238E27FC236}">
-                <a16:creationId xmlns:a16="http://schemas.microsoft.com/office/drawing/2014/main" id="{14471FF4-6734-4AB1-8486-C47CC675472B}"/>
+                <a16:creationId xmlns:a16="http://schemas.microsoft.com/office/drawing/2014/main" id="{5E234A58-F897-42F0-B49F-C3B3886FD69F}"/>
               </a:ext>
             </a:extLst>
           </p:cNvPr>
@@ -16378,7 +16378,7 @@
           <p:cNvPr id="33" name="">
             <a:extLst xmlns:a="http://schemas.openxmlformats.org/drawingml/2006/main">
               <a:ext uri="{FF2B5EF4-FFF2-40B4-BE49-F238E27FC236}">
-                <a16:creationId xmlns:a16="http://schemas.microsoft.com/office/drawing/2014/main" id="{ECEA90C6-4F7D-4829-B31E-1469AB748743}"/>
+                <a16:creationId xmlns:a16="http://schemas.microsoft.com/office/drawing/2014/main" id="{1B9D13BC-ACB0-4CD9-9184-DDADDA4174A4}"/>
               </a:ext>
             </a:extLst>
           </p:cNvPr>
@@ -16434,7 +16434,7 @@
     </p:spTree>
     <p:extLst>
       <p:ext uri="{BB962C8B-B14F-4D97-AF65-F5344CB8AC3E}">
-        <p14:creationId xmlns:p14="http://schemas.microsoft.com/office/powerpoint/2010/main" val="927262257"/>
+        <p14:creationId xmlns:p14="http://schemas.microsoft.com/office/powerpoint/2010/main" val="1981200296"/>
       </p:ext>
     </p:extLst>
   </p:cSld>
@@ -16465,7 +16465,7 @@
           <p:cNvPr id="1" name="Slide Number Placeholder 5">
             <a:extLst xmlns:a="http://schemas.openxmlformats.org/drawingml/2006/main">
               <a:ext uri="{FF2B5EF4-FFF2-40B4-BE49-F238E27FC236}">
-                <a16:creationId xmlns:a16="http://schemas.microsoft.com/office/drawing/2014/main" id="{C5A324B5-703D-4DE1-A920-5C56CD46E34C}"/>
+                <a16:creationId xmlns:a16="http://schemas.microsoft.com/office/drawing/2014/main" id="{E12CE447-476B-4BAE-A1FF-E669E79965E6}"/>
               </a:ext>
             </a:extLst>
           </p:cNvPr>
@@ -16501,7 +16501,7 @@
           <p:nvPr/>
         </p:nvPicPr>
         <p:blipFill>
-          <a:blip xmlns:r="http://schemas.openxmlformats.org/officeDocument/2006/relationships" xmlns:a="http://schemas.openxmlformats.org/drawingml/2006/main" r:embed="Ra0197854dfb34d72"/>
+          <a:blip xmlns:r="http://schemas.openxmlformats.org/officeDocument/2006/relationships" xmlns:a="http://schemas.openxmlformats.org/drawingml/2006/main" r:embed="R7af939c822d740e5"/>
           <a:srcRect xmlns:a="http://schemas.openxmlformats.org/drawingml/2006/main" l="0" t="21875" r="0" b="21875"/>
           <a:stretch xmlns:a="http://schemas.openxmlformats.org/drawingml/2006/main">
             <a:fillRect l="0" t="0" r="0" b="0"/>
@@ -16522,7 +16522,7 @@
           <p:cNvPr id="3" name="">
             <a:extLst xmlns:a="http://schemas.openxmlformats.org/drawingml/2006/main">
               <a:ext uri="{FF2B5EF4-FFF2-40B4-BE49-F238E27FC236}">
-                <a16:creationId xmlns:a16="http://schemas.microsoft.com/office/drawing/2014/main" id="{BFA0D2E2-0B2A-45DC-B946-DEE407162D36}"/>
+                <a16:creationId xmlns:a16="http://schemas.microsoft.com/office/drawing/2014/main" id="{66ABB4A3-709F-4CFF-8E7B-0B8343E00882}"/>
               </a:ext>
             </a:extLst>
           </p:cNvPr>
@@ -16557,7 +16557,7 @@
           <p:cNvPr id="4" name="">
             <a:extLst xmlns:a="http://schemas.openxmlformats.org/drawingml/2006/main">
               <a:ext uri="{FF2B5EF4-FFF2-40B4-BE49-F238E27FC236}">
-                <a16:creationId xmlns:a16="http://schemas.microsoft.com/office/drawing/2014/main" id="{A30C6255-3D6B-4AF1-AD1C-80CA1FA80DF5}"/>
+                <a16:creationId xmlns:a16="http://schemas.microsoft.com/office/drawing/2014/main" id="{4E68818B-5A51-4D94-B4DC-086B41846A73}"/>
               </a:ext>
             </a:extLst>
           </p:cNvPr>
@@ -16592,7 +16592,7 @@
           <p:cNvPr id="5" name="">
             <a:extLst xmlns:a="http://schemas.openxmlformats.org/drawingml/2006/main">
               <a:ext uri="{FF2B5EF4-FFF2-40B4-BE49-F238E27FC236}">
-                <a16:creationId xmlns:a16="http://schemas.microsoft.com/office/drawing/2014/main" id="{8A92944E-8826-4688-83ED-1E8EA5523001}"/>
+                <a16:creationId xmlns:a16="http://schemas.microsoft.com/office/drawing/2014/main" id="{120C6A25-FD81-423E-B678-F09496111C7F}"/>
               </a:ext>
             </a:extLst>
           </p:cNvPr>
@@ -16629,7 +16629,7 @@
           <p:cNvPr id="6" name="">
             <a:extLst xmlns:a="http://schemas.openxmlformats.org/drawingml/2006/main">
               <a:ext uri="{FF2B5EF4-FFF2-40B4-BE49-F238E27FC236}">
-                <a16:creationId xmlns:a16="http://schemas.microsoft.com/office/drawing/2014/main" id="{19507A67-F143-473B-8DB4-5FEC2E063B27}"/>
+                <a16:creationId xmlns:a16="http://schemas.microsoft.com/office/drawing/2014/main" id="{4BD4A9D5-7F40-4935-A1BD-EE28A951771F}"/>
               </a:ext>
             </a:extLst>
           </p:cNvPr>
@@ -16666,7 +16666,7 @@
           <p:cNvPr id="7" name="">
             <a:extLst xmlns:a="http://schemas.openxmlformats.org/drawingml/2006/main">
               <a:ext uri="{FF2B5EF4-FFF2-40B4-BE49-F238E27FC236}">
-                <a16:creationId xmlns:a16="http://schemas.microsoft.com/office/drawing/2014/main" id="{76EC90BC-7281-4544-ADBC-42601215D2AA}"/>
+                <a16:creationId xmlns:a16="http://schemas.microsoft.com/office/drawing/2014/main" id="{E2202ED4-8414-4CCF-B662-9A2EEA900B95}"/>
               </a:ext>
             </a:extLst>
           </p:cNvPr>
@@ -16703,7 +16703,7 @@
           <p:cNvPr id="8" name="">
             <a:extLst xmlns:a="http://schemas.openxmlformats.org/drawingml/2006/main">
               <a:ext uri="{FF2B5EF4-FFF2-40B4-BE49-F238E27FC236}">
-                <a16:creationId xmlns:a16="http://schemas.microsoft.com/office/drawing/2014/main" id="{C86B5D6F-F681-4086-A9DF-AAB0C662DBB3}"/>
+                <a16:creationId xmlns:a16="http://schemas.microsoft.com/office/drawing/2014/main" id="{CA60DBA4-F83A-4E70-8601-073DC52695C0}"/>
               </a:ext>
             </a:extLst>
           </p:cNvPr>
@@ -16740,7 +16740,7 @@
           <p:cNvPr id="9" name="">
             <a:extLst xmlns:a="http://schemas.openxmlformats.org/drawingml/2006/main">
               <a:ext uri="{FF2B5EF4-FFF2-40B4-BE49-F238E27FC236}">
-                <a16:creationId xmlns:a16="http://schemas.microsoft.com/office/drawing/2014/main" id="{05CE1304-2484-44A7-BA02-204412C92DEE}"/>
+                <a16:creationId xmlns:a16="http://schemas.microsoft.com/office/drawing/2014/main" id="{72385720-2918-4945-9480-0AD3A024E583}"/>
               </a:ext>
             </a:extLst>
           </p:cNvPr>
@@ -16798,7 +16798,7 @@
           <p:cNvPr id="10" name="">
             <a:extLst xmlns:a="http://schemas.openxmlformats.org/drawingml/2006/main">
               <a:ext uri="{FF2B5EF4-FFF2-40B4-BE49-F238E27FC236}">
-                <a16:creationId xmlns:a16="http://schemas.microsoft.com/office/drawing/2014/main" id="{E82529E7-E1EB-4CA7-8129-F824AEFB7D32}"/>
+                <a16:creationId xmlns:a16="http://schemas.microsoft.com/office/drawing/2014/main" id="{9EDEED1D-4B84-478A-88E2-06CA363DD609}"/>
               </a:ext>
             </a:extLst>
           </p:cNvPr>
@@ -16856,7 +16856,7 @@
           <p:cNvPr id="11" name="">
             <a:extLst xmlns:a="http://schemas.openxmlformats.org/drawingml/2006/main">
               <a:ext uri="{FF2B5EF4-FFF2-40B4-BE49-F238E27FC236}">
-                <a16:creationId xmlns:a16="http://schemas.microsoft.com/office/drawing/2014/main" id="{49C7CF1C-FE7C-4696-BF5C-AE00216B8793}"/>
+                <a16:creationId xmlns:a16="http://schemas.microsoft.com/office/drawing/2014/main" id="{AFE0D3B6-3486-4DE0-A9F8-8AF0A65064AD}"/>
               </a:ext>
             </a:extLst>
           </p:cNvPr>
@@ -16891,7 +16891,7 @@
           <p:cNvPr id="12" name="">
             <a:extLst xmlns:a="http://schemas.openxmlformats.org/drawingml/2006/main">
               <a:ext uri="{FF2B5EF4-FFF2-40B4-BE49-F238E27FC236}">
-                <a16:creationId xmlns:a16="http://schemas.microsoft.com/office/drawing/2014/main" id="{853DA2A9-8B4B-4BF0-8B75-1E87A95D8799}"/>
+                <a16:creationId xmlns:a16="http://schemas.microsoft.com/office/drawing/2014/main" id="{71AF5ED5-902D-4828-8E53-3BAABDCED272}"/>
               </a:ext>
             </a:extLst>
           </p:cNvPr>
@@ -16924,7 +16924,7 @@
           <p:cNvPr id="13" name="">
             <a:extLst xmlns:a="http://schemas.openxmlformats.org/drawingml/2006/main">
               <a:ext uri="{FF2B5EF4-FFF2-40B4-BE49-F238E27FC236}">
-                <a16:creationId xmlns:a16="http://schemas.microsoft.com/office/drawing/2014/main" id="{2A1A6403-D6B4-4342-914B-90307BC29DB4}"/>
+                <a16:creationId xmlns:a16="http://schemas.microsoft.com/office/drawing/2014/main" id="{D55737C5-A7C9-44BC-9638-F0DD2970C5DA}"/>
               </a:ext>
             </a:extLst>
           </p:cNvPr>
@@ -16999,7 +16999,7 @@
           <p:cNvPr id="14" name="">
             <a:extLst xmlns:a="http://schemas.openxmlformats.org/drawingml/2006/main">
               <a:ext uri="{FF2B5EF4-FFF2-40B4-BE49-F238E27FC236}">
-                <a16:creationId xmlns:a16="http://schemas.microsoft.com/office/drawing/2014/main" id="{8AAB9ED8-EE75-4115-BE76-027FF38A19EF}"/>
+                <a16:creationId xmlns:a16="http://schemas.microsoft.com/office/drawing/2014/main" id="{D7EE6A33-0C3F-400E-A348-2C6FA08BBE74}"/>
               </a:ext>
             </a:extLst>
           </p:cNvPr>
@@ -17036,7 +17036,7 @@
           <p:cNvPr id="15" name="">
             <a:extLst xmlns:a="http://schemas.openxmlformats.org/drawingml/2006/main">
               <a:ext uri="{FF2B5EF4-FFF2-40B4-BE49-F238E27FC236}">
-                <a16:creationId xmlns:a16="http://schemas.microsoft.com/office/drawing/2014/main" id="{C311E37F-45E5-4062-A1C2-2B835B607F41}"/>
+                <a16:creationId xmlns:a16="http://schemas.microsoft.com/office/drawing/2014/main" id="{FD8B4411-8D49-4D0F-A7A6-4D1871B03831}"/>
               </a:ext>
             </a:extLst>
           </p:cNvPr>
@@ -17071,7 +17071,7 @@
           <p:cNvPr id="16" name="">
             <a:extLst xmlns:a="http://schemas.openxmlformats.org/drawingml/2006/main">
               <a:ext uri="{FF2B5EF4-FFF2-40B4-BE49-F238E27FC236}">
-                <a16:creationId xmlns:a16="http://schemas.microsoft.com/office/drawing/2014/main" id="{3759F061-939F-41BA-B0AA-F4A9B8AAFD97}"/>
+                <a16:creationId xmlns:a16="http://schemas.microsoft.com/office/drawing/2014/main" id="{769FC0FD-A793-430A-A358-C7F7B4094FA3}"/>
               </a:ext>
             </a:extLst>
           </p:cNvPr>
@@ -17129,7 +17129,7 @@
           <p:cNvPr id="17" name="">
             <a:extLst xmlns:a="http://schemas.openxmlformats.org/drawingml/2006/main">
               <a:ext uri="{FF2B5EF4-FFF2-40B4-BE49-F238E27FC236}">
-                <a16:creationId xmlns:a16="http://schemas.microsoft.com/office/drawing/2014/main" id="{30F07CD5-CFEC-4D49-A563-D58E340BF40B}"/>
+                <a16:creationId xmlns:a16="http://schemas.microsoft.com/office/drawing/2014/main" id="{2C37BAFF-B46A-4AAF-BD09-787DA4F490AB}"/>
               </a:ext>
             </a:extLst>
           </p:cNvPr>
@@ -17255,7 +17255,7 @@
           <p:cNvPr id="18" name="">
             <a:extLst xmlns:a="http://schemas.openxmlformats.org/drawingml/2006/main">
               <a:ext uri="{FF2B5EF4-FFF2-40B4-BE49-F238E27FC236}">
-                <a16:creationId xmlns:a16="http://schemas.microsoft.com/office/drawing/2014/main" id="{D84BE2B0-F85E-4617-851B-900F34B4FAE8}"/>
+                <a16:creationId xmlns:a16="http://schemas.microsoft.com/office/drawing/2014/main" id="{CF839CA2-73CE-47CE-9FE4-363B0CECE580}"/>
               </a:ext>
             </a:extLst>
           </p:cNvPr>
@@ -17292,7 +17292,7 @@
           <p:cNvPr id="19" name="">
             <a:extLst xmlns:a="http://schemas.openxmlformats.org/drawingml/2006/main">
               <a:ext uri="{FF2B5EF4-FFF2-40B4-BE49-F238E27FC236}">
-                <a16:creationId xmlns:a16="http://schemas.microsoft.com/office/drawing/2014/main" id="{28F1CA94-F7FB-4F8A-ACC1-B71A512C1BC8}"/>
+                <a16:creationId xmlns:a16="http://schemas.microsoft.com/office/drawing/2014/main" id="{49292B6F-41CD-49CB-8EFB-FB2CF3AEF941}"/>
               </a:ext>
             </a:extLst>
           </p:cNvPr>
@@ -17327,7 +17327,7 @@
           <p:cNvPr id="20" name="">
             <a:extLst xmlns:a="http://schemas.openxmlformats.org/drawingml/2006/main">
               <a:ext uri="{FF2B5EF4-FFF2-40B4-BE49-F238E27FC236}">
-                <a16:creationId xmlns:a16="http://schemas.microsoft.com/office/drawing/2014/main" id="{62EFE705-0D47-4A0F-A994-D750C77B88AB}"/>
+                <a16:creationId xmlns:a16="http://schemas.microsoft.com/office/drawing/2014/main" id="{F739D388-3C6B-4C7E-ADF8-CC296E3415F4}"/>
               </a:ext>
             </a:extLst>
           </p:cNvPr>
@@ -17385,7 +17385,7 @@
           <p:cNvPr id="21" name="">
             <a:extLst xmlns:a="http://schemas.openxmlformats.org/drawingml/2006/main">
               <a:ext uri="{FF2B5EF4-FFF2-40B4-BE49-F238E27FC236}">
-                <a16:creationId xmlns:a16="http://schemas.microsoft.com/office/drawing/2014/main" id="{600710A0-176B-4E58-9198-6311EF2B083E}"/>
+                <a16:creationId xmlns:a16="http://schemas.microsoft.com/office/drawing/2014/main" id="{BE7FED42-3CD0-42CC-91DC-CE8C61DFF20D}"/>
               </a:ext>
             </a:extLst>
           </p:cNvPr>
@@ -17511,7 +17511,7 @@
           <p:cNvPr id="22" name="">
             <a:extLst xmlns:a="http://schemas.openxmlformats.org/drawingml/2006/main">
               <a:ext uri="{FF2B5EF4-FFF2-40B4-BE49-F238E27FC236}">
-                <a16:creationId xmlns:a16="http://schemas.microsoft.com/office/drawing/2014/main" id="{708EEDEC-150F-4B53-8242-DA79E099C839}"/>
+                <a16:creationId xmlns:a16="http://schemas.microsoft.com/office/drawing/2014/main" id="{D57D7BFF-43C3-426F-BF4E-60C4BEBCAD61}"/>
               </a:ext>
             </a:extLst>
           </p:cNvPr>
@@ -17548,7 +17548,7 @@
           <p:cNvPr id="23" name="">
             <a:extLst xmlns:a="http://schemas.openxmlformats.org/drawingml/2006/main">
               <a:ext uri="{FF2B5EF4-FFF2-40B4-BE49-F238E27FC236}">
-                <a16:creationId xmlns:a16="http://schemas.microsoft.com/office/drawing/2014/main" id="{5B1449BC-E6C0-4B4B-937F-2CE68EE50B12}"/>
+                <a16:creationId xmlns:a16="http://schemas.microsoft.com/office/drawing/2014/main" id="{435B6FBC-5AB2-4FF0-8084-6D11D3E91BFB}"/>
               </a:ext>
             </a:extLst>
           </p:cNvPr>
@@ -17583,7 +17583,7 @@
           <p:cNvPr id="24" name="">
             <a:extLst xmlns:a="http://schemas.openxmlformats.org/drawingml/2006/main">
               <a:ext uri="{FF2B5EF4-FFF2-40B4-BE49-F238E27FC236}">
-                <a16:creationId xmlns:a16="http://schemas.microsoft.com/office/drawing/2014/main" id="{0DD39425-013A-4523-8DA5-FF7D79C6E0C9}"/>
+                <a16:creationId xmlns:a16="http://schemas.microsoft.com/office/drawing/2014/main" id="{45C214DA-F06A-431F-8136-276DC2F21F75}"/>
               </a:ext>
             </a:extLst>
           </p:cNvPr>
@@ -17641,7 +17641,7 @@
           <p:cNvPr id="25" name="">
             <a:extLst xmlns:a="http://schemas.openxmlformats.org/drawingml/2006/main">
               <a:ext uri="{FF2B5EF4-FFF2-40B4-BE49-F238E27FC236}">
-                <a16:creationId xmlns:a16="http://schemas.microsoft.com/office/drawing/2014/main" id="{1645ED6C-7480-4150-9C0B-A5D471854284}"/>
+                <a16:creationId xmlns:a16="http://schemas.microsoft.com/office/drawing/2014/main" id="{BEFE507B-A861-412D-A502-45441CDD598B}"/>
               </a:ext>
             </a:extLst>
           </p:cNvPr>
@@ -17784,7 +17784,7 @@
           <p:cNvPr id="26" name="">
             <a:extLst xmlns:a="http://schemas.openxmlformats.org/drawingml/2006/main">
               <a:ext uri="{FF2B5EF4-FFF2-40B4-BE49-F238E27FC236}">
-                <a16:creationId xmlns:a16="http://schemas.microsoft.com/office/drawing/2014/main" id="{112CEC19-D78A-4526-90B2-8DF63089A926}"/>
+                <a16:creationId xmlns:a16="http://schemas.microsoft.com/office/drawing/2014/main" id="{8E1980B6-AA43-4C8C-9EA0-08BFA8931FBF}"/>
               </a:ext>
             </a:extLst>
           </p:cNvPr>
@@ -17819,7 +17819,7 @@
           <p:cNvPr id="27" name="">
             <a:extLst xmlns:a="http://schemas.openxmlformats.org/drawingml/2006/main">
               <a:ext uri="{FF2B5EF4-FFF2-40B4-BE49-F238E27FC236}">
-                <a16:creationId xmlns:a16="http://schemas.microsoft.com/office/drawing/2014/main" id="{64FADB35-955C-47C2-AB46-1E1E4C26A722}"/>
+                <a16:creationId xmlns:a16="http://schemas.microsoft.com/office/drawing/2014/main" id="{1BCBDE02-712D-4135-9DFC-9A49072B768A}"/>
               </a:ext>
             </a:extLst>
           </p:cNvPr>
@@ -17854,7 +17854,7 @@
           <p:cNvPr id="28" name="">
             <a:extLst xmlns:a="http://schemas.openxmlformats.org/drawingml/2006/main">
               <a:ext uri="{FF2B5EF4-FFF2-40B4-BE49-F238E27FC236}">
-                <a16:creationId xmlns:a16="http://schemas.microsoft.com/office/drawing/2014/main" id="{913C5D34-E7C0-448D-A5CD-AD115D1B6D5D}"/>
+                <a16:creationId xmlns:a16="http://schemas.microsoft.com/office/drawing/2014/main" id="{D367BCA0-3C63-4F9E-A93F-71A59454B15B}"/>
               </a:ext>
             </a:extLst>
           </p:cNvPr>
@@ -17912,7 +17912,7 @@
           <p:cNvPr id="29" name="">
             <a:extLst xmlns:a="http://schemas.openxmlformats.org/drawingml/2006/main">
               <a:ext uri="{FF2B5EF4-FFF2-40B4-BE49-F238E27FC236}">
-                <a16:creationId xmlns:a16="http://schemas.microsoft.com/office/drawing/2014/main" id="{FB1007FA-0C02-4D0E-868A-4B35E2AC0ED9}"/>
+                <a16:creationId xmlns:a16="http://schemas.microsoft.com/office/drawing/2014/main" id="{A02BEB14-A4DE-48AB-BDA2-53F2C7408465}"/>
               </a:ext>
             </a:extLst>
           </p:cNvPr>
@@ -17968,7 +17968,7 @@
     </p:spTree>
     <p:extLst>
       <p:ext uri="{BB962C8B-B14F-4D97-AF65-F5344CB8AC3E}">
-        <p14:creationId xmlns:p14="http://schemas.microsoft.com/office/powerpoint/2010/main" val="2006858898"/>
+        <p14:creationId xmlns:p14="http://schemas.microsoft.com/office/powerpoint/2010/main" val="1262752408"/>
       </p:ext>
     </p:extLst>
   </p:cSld>
@@ -17999,7 +17999,7 @@
           <p:cNvPr id="1" name="Slide Number Placeholder 5">
             <a:extLst xmlns:a="http://schemas.openxmlformats.org/drawingml/2006/main">
               <a:ext uri="{FF2B5EF4-FFF2-40B4-BE49-F238E27FC236}">
-                <a16:creationId xmlns:a16="http://schemas.microsoft.com/office/drawing/2014/main" id="{C5A324B5-703D-4DE1-A920-5C56CD46E34C}"/>
+                <a16:creationId xmlns:a16="http://schemas.microsoft.com/office/drawing/2014/main" id="{E12CE447-476B-4BAE-A1FF-E669E79965E6}"/>
               </a:ext>
             </a:extLst>
           </p:cNvPr>
@@ -18035,7 +18035,7 @@
           <p:nvPr/>
         </p:nvPicPr>
         <p:blipFill>
-          <a:blip xmlns:r="http://schemas.openxmlformats.org/officeDocument/2006/relationships" xmlns:a="http://schemas.openxmlformats.org/drawingml/2006/main" r:embed="R1dedcff105f94e16"/>
+          <a:blip xmlns:r="http://schemas.openxmlformats.org/officeDocument/2006/relationships" xmlns:a="http://schemas.openxmlformats.org/drawingml/2006/main" r:embed="R269a7dfc5c2d45b8"/>
           <a:srcRect xmlns:a="http://schemas.openxmlformats.org/drawingml/2006/main" l="0" t="21875" r="0" b="21875"/>
           <a:stretch xmlns:a="http://schemas.openxmlformats.org/drawingml/2006/main">
             <a:fillRect l="0" t="0" r="0" b="0"/>
@@ -18056,7 +18056,7 @@
           <p:cNvPr id="3" name="">
             <a:extLst xmlns:a="http://schemas.openxmlformats.org/drawingml/2006/main">
               <a:ext uri="{FF2B5EF4-FFF2-40B4-BE49-F238E27FC236}">
-                <a16:creationId xmlns:a16="http://schemas.microsoft.com/office/drawing/2014/main" id="{AA651BDD-34A9-4D0D-BAAC-36FAFEF87800}"/>
+                <a16:creationId xmlns:a16="http://schemas.microsoft.com/office/drawing/2014/main" id="{76818D23-B15D-45D3-91C3-6EC89210A6B2}"/>
               </a:ext>
             </a:extLst>
           </p:cNvPr>
@@ -18091,7 +18091,7 @@
           <p:cNvPr id="4" name="">
             <a:extLst xmlns:a="http://schemas.openxmlformats.org/drawingml/2006/main">
               <a:ext uri="{FF2B5EF4-FFF2-40B4-BE49-F238E27FC236}">
-                <a16:creationId xmlns:a16="http://schemas.microsoft.com/office/drawing/2014/main" id="{CA987624-E1AB-4977-8313-163E86980EF6}"/>
+                <a16:creationId xmlns:a16="http://schemas.microsoft.com/office/drawing/2014/main" id="{C1743759-0C0B-473B-913F-9E911D5C28A6}"/>
               </a:ext>
             </a:extLst>
           </p:cNvPr>
@@ -18126,7 +18126,7 @@
           <p:cNvPr id="5" name="">
             <a:extLst xmlns:a="http://schemas.openxmlformats.org/drawingml/2006/main">
               <a:ext uri="{FF2B5EF4-FFF2-40B4-BE49-F238E27FC236}">
-                <a16:creationId xmlns:a16="http://schemas.microsoft.com/office/drawing/2014/main" id="{E984F2C4-BC3A-41A1-A552-E3164B238FCB}"/>
+                <a16:creationId xmlns:a16="http://schemas.microsoft.com/office/drawing/2014/main" id="{8C12B079-E22C-4C5F-9B56-2CFB12C4CC52}"/>
               </a:ext>
             </a:extLst>
           </p:cNvPr>
@@ -18163,7 +18163,7 @@
           <p:cNvPr id="6" name="">
             <a:extLst xmlns:a="http://schemas.openxmlformats.org/drawingml/2006/main">
               <a:ext uri="{FF2B5EF4-FFF2-40B4-BE49-F238E27FC236}">
-                <a16:creationId xmlns:a16="http://schemas.microsoft.com/office/drawing/2014/main" id="{D59B79DB-10B3-4BF9-A942-9E139B0AAF2C}"/>
+                <a16:creationId xmlns:a16="http://schemas.microsoft.com/office/drawing/2014/main" id="{713C69E6-4859-456C-AEEA-F29410A66050}"/>
               </a:ext>
             </a:extLst>
           </p:cNvPr>
@@ -18200,7 +18200,7 @@
           <p:cNvPr id="7" name="">
             <a:extLst xmlns:a="http://schemas.openxmlformats.org/drawingml/2006/main">
               <a:ext uri="{FF2B5EF4-FFF2-40B4-BE49-F238E27FC236}">
-                <a16:creationId xmlns:a16="http://schemas.microsoft.com/office/drawing/2014/main" id="{796C8285-CB20-4B3D-9926-9E0A24070BD4}"/>
+                <a16:creationId xmlns:a16="http://schemas.microsoft.com/office/drawing/2014/main" id="{E2DD8F25-174A-4274-8FE3-040759AC5DDD}"/>
               </a:ext>
             </a:extLst>
           </p:cNvPr>
@@ -18237,7 +18237,7 @@
           <p:cNvPr id="8" name="">
             <a:extLst xmlns:a="http://schemas.openxmlformats.org/drawingml/2006/main">
               <a:ext uri="{FF2B5EF4-FFF2-40B4-BE49-F238E27FC236}">
-                <a16:creationId xmlns:a16="http://schemas.microsoft.com/office/drawing/2014/main" id="{E32AD0B5-1EA0-495C-BE51-99FFA911832C}"/>
+                <a16:creationId xmlns:a16="http://schemas.microsoft.com/office/drawing/2014/main" id="{041953D7-B75B-47A3-BBA8-7C150D8D3472}"/>
               </a:ext>
             </a:extLst>
           </p:cNvPr>
@@ -18274,7 +18274,7 @@
           <p:cNvPr id="9" name="">
             <a:extLst xmlns:a="http://schemas.openxmlformats.org/drawingml/2006/main">
               <a:ext uri="{FF2B5EF4-FFF2-40B4-BE49-F238E27FC236}">
-                <a16:creationId xmlns:a16="http://schemas.microsoft.com/office/drawing/2014/main" id="{006ABBBE-1D5D-4E02-AC0B-35CE34FE3550}"/>
+                <a16:creationId xmlns:a16="http://schemas.microsoft.com/office/drawing/2014/main" id="{68BC78A3-27CE-4AA5-8A29-CA353E819674}"/>
               </a:ext>
             </a:extLst>
           </p:cNvPr>
@@ -18332,7 +18332,7 @@
           <p:cNvPr id="10" name="">
             <a:extLst xmlns:a="http://schemas.openxmlformats.org/drawingml/2006/main">
               <a:ext uri="{FF2B5EF4-FFF2-40B4-BE49-F238E27FC236}">
-                <a16:creationId xmlns:a16="http://schemas.microsoft.com/office/drawing/2014/main" id="{FDFD3504-5A2D-4B78-898D-FF4FBD123420}"/>
+                <a16:creationId xmlns:a16="http://schemas.microsoft.com/office/drawing/2014/main" id="{9155F077-AD21-46F6-AADC-609B3646D8C7}"/>
               </a:ext>
             </a:extLst>
           </p:cNvPr>
@@ -18390,7 +18390,7 @@
           <p:cNvPr id="11" name="">
             <a:extLst xmlns:a="http://schemas.openxmlformats.org/drawingml/2006/main">
               <a:ext uri="{FF2B5EF4-FFF2-40B4-BE49-F238E27FC236}">
-                <a16:creationId xmlns:a16="http://schemas.microsoft.com/office/drawing/2014/main" id="{F5D9998A-1DF6-44AD-9841-A428942517F2}"/>
+                <a16:creationId xmlns:a16="http://schemas.microsoft.com/office/drawing/2014/main" id="{B4AADD52-C3BE-4CB3-95F0-BF794213F42B}"/>
               </a:ext>
             </a:extLst>
           </p:cNvPr>
@@ -18425,7 +18425,7 @@
           <p:cNvPr id="12" name="">
             <a:extLst xmlns:a="http://schemas.openxmlformats.org/drawingml/2006/main">
               <a:ext uri="{FF2B5EF4-FFF2-40B4-BE49-F238E27FC236}">
-                <a16:creationId xmlns:a16="http://schemas.microsoft.com/office/drawing/2014/main" id="{D6087E92-13B5-49B4-9315-1EA9FA9974D8}"/>
+                <a16:creationId xmlns:a16="http://schemas.microsoft.com/office/drawing/2014/main" id="{AA933734-6B89-4C0C-8D34-DB324689A0C2}"/>
               </a:ext>
             </a:extLst>
           </p:cNvPr>
@@ -18458,7 +18458,7 @@
           <p:cNvPr id="13" name="">
             <a:extLst xmlns:a="http://schemas.openxmlformats.org/drawingml/2006/main">
               <a:ext uri="{FF2B5EF4-FFF2-40B4-BE49-F238E27FC236}">
-                <a16:creationId xmlns:a16="http://schemas.microsoft.com/office/drawing/2014/main" id="{75C7CA2E-0BFD-42B0-8858-C01677894132}"/>
+                <a16:creationId xmlns:a16="http://schemas.microsoft.com/office/drawing/2014/main" id="{298ADF0E-E3A7-4E0B-B0BB-54344DAD2571}"/>
               </a:ext>
             </a:extLst>
           </p:cNvPr>
@@ -18533,7 +18533,7 @@
           <p:cNvPr id="14" name="">
             <a:extLst xmlns:a="http://schemas.openxmlformats.org/drawingml/2006/main">
               <a:ext uri="{FF2B5EF4-FFF2-40B4-BE49-F238E27FC236}">
-                <a16:creationId xmlns:a16="http://schemas.microsoft.com/office/drawing/2014/main" id="{34FA060D-3F25-4919-9F7A-55828F3CFDC9}"/>
+                <a16:creationId xmlns:a16="http://schemas.microsoft.com/office/drawing/2014/main" id="{C5D288F8-147B-4287-8449-E30D8090C15E}"/>
               </a:ext>
             </a:extLst>
           </p:cNvPr>
@@ -18568,7 +18568,7 @@
           <p:cNvPr id="15" name="">
             <a:extLst xmlns:a="http://schemas.openxmlformats.org/drawingml/2006/main">
               <a:ext uri="{FF2B5EF4-FFF2-40B4-BE49-F238E27FC236}">
-                <a16:creationId xmlns:a16="http://schemas.microsoft.com/office/drawing/2014/main" id="{EEFB58D6-182E-45B5-BB03-6DA521DDD0C3}"/>
+                <a16:creationId xmlns:a16="http://schemas.microsoft.com/office/drawing/2014/main" id="{2F94D1A6-6670-415A-A016-CAE08EF1A11F}"/>
               </a:ext>
             </a:extLst>
           </p:cNvPr>
@@ -18603,7 +18603,7 @@
           <p:cNvPr id="16" name="">
             <a:extLst xmlns:a="http://schemas.openxmlformats.org/drawingml/2006/main">
               <a:ext uri="{FF2B5EF4-FFF2-40B4-BE49-F238E27FC236}">
-                <a16:creationId xmlns:a16="http://schemas.microsoft.com/office/drawing/2014/main" id="{B458A3A1-421B-4764-8E7E-E412B796BE7E}"/>
+                <a16:creationId xmlns:a16="http://schemas.microsoft.com/office/drawing/2014/main" id="{2C358938-31CA-412F-9F3C-C7311E38B0F7}"/>
               </a:ext>
             </a:extLst>
           </p:cNvPr>
@@ -18661,7 +18661,7 @@
           <p:cNvPr id="17" name="">
             <a:extLst xmlns:a="http://schemas.openxmlformats.org/drawingml/2006/main">
               <a:ext uri="{FF2B5EF4-FFF2-40B4-BE49-F238E27FC236}">
-                <a16:creationId xmlns:a16="http://schemas.microsoft.com/office/drawing/2014/main" id="{FB9BE67B-CC57-4DD3-8ED5-1058C4C4FA13}"/>
+                <a16:creationId xmlns:a16="http://schemas.microsoft.com/office/drawing/2014/main" id="{784DCA01-9A89-4543-B3DB-990F24A91D43}"/>
               </a:ext>
             </a:extLst>
           </p:cNvPr>
@@ -18698,7 +18698,7 @@
           <p:cNvPr id="18" name="">
             <a:extLst xmlns:a="http://schemas.openxmlformats.org/drawingml/2006/main">
               <a:ext uri="{FF2B5EF4-FFF2-40B4-BE49-F238E27FC236}">
-                <a16:creationId xmlns:a16="http://schemas.microsoft.com/office/drawing/2014/main" id="{5796A4BF-DC93-4BC2-899D-81A2993B0081}"/>
+                <a16:creationId xmlns:a16="http://schemas.microsoft.com/office/drawing/2014/main" id="{7D2725EE-FF75-4014-B06C-6B8A0F2F50C2}"/>
               </a:ext>
             </a:extLst>
           </p:cNvPr>
@@ -18733,7 +18733,7 @@
           <p:cNvPr id="19" name="">
             <a:extLst xmlns:a="http://schemas.openxmlformats.org/drawingml/2006/main">
               <a:ext uri="{FF2B5EF4-FFF2-40B4-BE49-F238E27FC236}">
-                <a16:creationId xmlns:a16="http://schemas.microsoft.com/office/drawing/2014/main" id="{11465F05-DA54-4253-B1C4-D1ACF8B9C0F1}"/>
+                <a16:creationId xmlns:a16="http://schemas.microsoft.com/office/drawing/2014/main" id="{093D5E45-AC07-486B-AD4B-91C6E9955B6E}"/>
               </a:ext>
             </a:extLst>
           </p:cNvPr>
@@ -18791,7 +18791,7 @@
           <p:cNvPr id="20" name="">
             <a:extLst xmlns:a="http://schemas.openxmlformats.org/drawingml/2006/main">
               <a:ext uri="{FF2B5EF4-FFF2-40B4-BE49-F238E27FC236}">
-                <a16:creationId xmlns:a16="http://schemas.microsoft.com/office/drawing/2014/main" id="{502568BF-5BAB-49A7-8C4D-553E0F99BC6E}"/>
+                <a16:creationId xmlns:a16="http://schemas.microsoft.com/office/drawing/2014/main" id="{7E4077C2-8818-4729-9F63-902AFD12E6D9}"/>
               </a:ext>
             </a:extLst>
           </p:cNvPr>
@@ -18883,7 +18883,7 @@
           <p:cNvPr id="21" name="">
             <a:extLst xmlns:a="http://schemas.openxmlformats.org/drawingml/2006/main">
               <a:ext uri="{FF2B5EF4-FFF2-40B4-BE49-F238E27FC236}">
-                <a16:creationId xmlns:a16="http://schemas.microsoft.com/office/drawing/2014/main" id="{C4E53400-E878-47E1-A6DD-13AEBE15ECC8}"/>
+                <a16:creationId xmlns:a16="http://schemas.microsoft.com/office/drawing/2014/main" id="{0DFE64DF-5A1D-46F2-8E80-FAF3026DD5E8}"/>
               </a:ext>
             </a:extLst>
           </p:cNvPr>
@@ -18920,7 +18920,7 @@
           <p:cNvPr id="22" name="">
             <a:extLst xmlns:a="http://schemas.openxmlformats.org/drawingml/2006/main">
               <a:ext uri="{FF2B5EF4-FFF2-40B4-BE49-F238E27FC236}">
-                <a16:creationId xmlns:a16="http://schemas.microsoft.com/office/drawing/2014/main" id="{128111A1-497D-480F-AAE2-ABE50D1F21B1}"/>
+                <a16:creationId xmlns:a16="http://schemas.microsoft.com/office/drawing/2014/main" id="{3324517A-759D-4354-8E55-BDA95BC489EB}"/>
               </a:ext>
             </a:extLst>
           </p:cNvPr>
@@ -18955,7 +18955,7 @@
           <p:cNvPr id="23" name="">
             <a:extLst xmlns:a="http://schemas.openxmlformats.org/drawingml/2006/main">
               <a:ext uri="{FF2B5EF4-FFF2-40B4-BE49-F238E27FC236}">
-                <a16:creationId xmlns:a16="http://schemas.microsoft.com/office/drawing/2014/main" id="{1F0B772D-661C-4011-B4FD-693257D380B3}"/>
+                <a16:creationId xmlns:a16="http://schemas.microsoft.com/office/drawing/2014/main" id="{87901807-40CE-49FC-B2E6-E4357D6EFC97}"/>
               </a:ext>
             </a:extLst>
           </p:cNvPr>
@@ -19013,7 +19013,7 @@
           <p:cNvPr id="24" name="">
             <a:extLst xmlns:a="http://schemas.openxmlformats.org/drawingml/2006/main">
               <a:ext uri="{FF2B5EF4-FFF2-40B4-BE49-F238E27FC236}">
-                <a16:creationId xmlns:a16="http://schemas.microsoft.com/office/drawing/2014/main" id="{ACCFA194-6581-4D29-A573-5DB3A1F1B247}"/>
+                <a16:creationId xmlns:a16="http://schemas.microsoft.com/office/drawing/2014/main" id="{DD53FCA9-6302-4A69-A545-47EB4ED2825E}"/>
               </a:ext>
             </a:extLst>
           </p:cNvPr>
@@ -19105,7 +19105,7 @@
           <p:cNvPr id="25" name="">
             <a:extLst xmlns:a="http://schemas.openxmlformats.org/drawingml/2006/main">
               <a:ext uri="{FF2B5EF4-FFF2-40B4-BE49-F238E27FC236}">
-                <a16:creationId xmlns:a16="http://schemas.microsoft.com/office/drawing/2014/main" id="{5A7B3066-2BEF-4C92-A2EC-6598E18DA483}"/>
+                <a16:creationId xmlns:a16="http://schemas.microsoft.com/office/drawing/2014/main" id="{FF503D38-B0F1-4CC8-9AE4-19C82CD60729}"/>
               </a:ext>
             </a:extLst>
           </p:cNvPr>
@@ -19142,7 +19142,7 @@
           <p:cNvPr id="26" name="">
             <a:extLst xmlns:a="http://schemas.openxmlformats.org/drawingml/2006/main">
               <a:ext uri="{FF2B5EF4-FFF2-40B4-BE49-F238E27FC236}">
-                <a16:creationId xmlns:a16="http://schemas.microsoft.com/office/drawing/2014/main" id="{4750FD4E-1238-4E8F-9745-0301ABB41157}"/>
+                <a16:creationId xmlns:a16="http://schemas.microsoft.com/office/drawing/2014/main" id="{24702C47-6650-4A42-9B5D-41B779CDA719}"/>
               </a:ext>
             </a:extLst>
           </p:cNvPr>
@@ -19177,7 +19177,7 @@
           <p:cNvPr id="27" name="">
             <a:extLst xmlns:a="http://schemas.openxmlformats.org/drawingml/2006/main">
               <a:ext uri="{FF2B5EF4-FFF2-40B4-BE49-F238E27FC236}">
-                <a16:creationId xmlns:a16="http://schemas.microsoft.com/office/drawing/2014/main" id="{79EB2EC0-84FC-4C5A-870F-8745C0A5B2DF}"/>
+                <a16:creationId xmlns:a16="http://schemas.microsoft.com/office/drawing/2014/main" id="{D054D9D2-02FF-475F-9B61-7823E7C2B6DA}"/>
               </a:ext>
             </a:extLst>
           </p:cNvPr>
@@ -19235,7 +19235,7 @@
           <p:cNvPr id="28" name="">
             <a:extLst xmlns:a="http://schemas.openxmlformats.org/drawingml/2006/main">
               <a:ext uri="{FF2B5EF4-FFF2-40B4-BE49-F238E27FC236}">
-                <a16:creationId xmlns:a16="http://schemas.microsoft.com/office/drawing/2014/main" id="{96593E35-CB61-4BC7-85E3-84FCA7908C5C}"/>
+                <a16:creationId xmlns:a16="http://schemas.microsoft.com/office/drawing/2014/main" id="{18EE8F0E-1BCF-463D-BB1C-F9658FA37535}"/>
               </a:ext>
             </a:extLst>
           </p:cNvPr>
@@ -19327,7 +19327,7 @@
           <p:cNvPr id="29" name="">
             <a:extLst xmlns:a="http://schemas.openxmlformats.org/drawingml/2006/main">
               <a:ext uri="{FF2B5EF4-FFF2-40B4-BE49-F238E27FC236}">
-                <a16:creationId xmlns:a16="http://schemas.microsoft.com/office/drawing/2014/main" id="{52D63802-DC76-4326-A466-9B5FCDC0B622}"/>
+                <a16:creationId xmlns:a16="http://schemas.microsoft.com/office/drawing/2014/main" id="{02EBD374-0999-498D-84E1-09049394767D}"/>
               </a:ext>
             </a:extLst>
           </p:cNvPr>
@@ -19381,7 +19381,7 @@
           <p:cNvPr id="30" name="">
             <a:extLst xmlns:a="http://schemas.openxmlformats.org/drawingml/2006/main">
               <a:ext uri="{FF2B5EF4-FFF2-40B4-BE49-F238E27FC236}">
-                <a16:creationId xmlns:a16="http://schemas.microsoft.com/office/drawing/2014/main" id="{13B1BF04-7479-4698-B482-BF138831D449}"/>
+                <a16:creationId xmlns:a16="http://schemas.microsoft.com/office/drawing/2014/main" id="{598F1EA4-3123-48D2-AF91-5089EA0F1827}"/>
               </a:ext>
             </a:extLst>
           </p:cNvPr>
@@ -19437,7 +19437,7 @@
     </p:spTree>
     <p:extLst>
       <p:ext uri="{BB962C8B-B14F-4D97-AF65-F5344CB8AC3E}">
-        <p14:creationId xmlns:p14="http://schemas.microsoft.com/office/powerpoint/2010/main" val="134257553"/>
+        <p14:creationId xmlns:p14="http://schemas.microsoft.com/office/powerpoint/2010/main" val="1768761511"/>
       </p:ext>
     </p:extLst>
   </p:cSld>
@@ -19468,7 +19468,7 @@
           <p:cNvPr id="1" name="Slide Number Placeholder 5">
             <a:extLst xmlns:a="http://schemas.openxmlformats.org/drawingml/2006/main">
               <a:ext uri="{FF2B5EF4-FFF2-40B4-BE49-F238E27FC236}">
-                <a16:creationId xmlns:a16="http://schemas.microsoft.com/office/drawing/2014/main" id="{C5A324B5-703D-4DE1-A920-5C56CD46E34C}"/>
+                <a16:creationId xmlns:a16="http://schemas.microsoft.com/office/drawing/2014/main" id="{E12CE447-476B-4BAE-A1FF-E669E79965E6}"/>
               </a:ext>
             </a:extLst>
           </p:cNvPr>
@@ -19504,7 +19504,7 @@
           <p:nvPr/>
         </p:nvPicPr>
         <p:blipFill>
-          <a:blip xmlns:r="http://schemas.openxmlformats.org/officeDocument/2006/relationships" xmlns:a="http://schemas.openxmlformats.org/drawingml/2006/main" r:embed="R97a9d3a0c9bf405e"/>
+          <a:blip xmlns:r="http://schemas.openxmlformats.org/officeDocument/2006/relationships" xmlns:a="http://schemas.openxmlformats.org/drawingml/2006/main" r:embed="Rce274e8403d24e64"/>
           <a:srcRect xmlns:a="http://schemas.openxmlformats.org/drawingml/2006/main" l="0" t="21875" r="0" b="21875"/>
           <a:stretch xmlns:a="http://schemas.openxmlformats.org/drawingml/2006/main">
             <a:fillRect l="0" t="0" r="0" b="0"/>
@@ -19525,7 +19525,7 @@
           <p:cNvPr id="3" name="">
             <a:extLst xmlns:a="http://schemas.openxmlformats.org/drawingml/2006/main">
               <a:ext uri="{FF2B5EF4-FFF2-40B4-BE49-F238E27FC236}">
-                <a16:creationId xmlns:a16="http://schemas.microsoft.com/office/drawing/2014/main" id="{3ED40EF8-A044-4A27-93A1-8DD4A2CDDA36}"/>
+                <a16:creationId xmlns:a16="http://schemas.microsoft.com/office/drawing/2014/main" id="{EA23B219-1FDC-421B-A3A6-64ABD1CBE6A8}"/>
               </a:ext>
             </a:extLst>
           </p:cNvPr>
@@ -19560,7 +19560,7 @@
           <p:cNvPr id="4" name="">
             <a:extLst xmlns:a="http://schemas.openxmlformats.org/drawingml/2006/main">
               <a:ext uri="{FF2B5EF4-FFF2-40B4-BE49-F238E27FC236}">
-                <a16:creationId xmlns:a16="http://schemas.microsoft.com/office/drawing/2014/main" id="{34BE7815-B288-4279-93D6-9503359827F4}"/>
+                <a16:creationId xmlns:a16="http://schemas.microsoft.com/office/drawing/2014/main" id="{B74A005E-E8ED-4469-9794-57228C889436}"/>
               </a:ext>
             </a:extLst>
           </p:cNvPr>
@@ -19595,7 +19595,7 @@
           <p:cNvPr id="5" name="">
             <a:extLst xmlns:a="http://schemas.openxmlformats.org/drawingml/2006/main">
               <a:ext uri="{FF2B5EF4-FFF2-40B4-BE49-F238E27FC236}">
-                <a16:creationId xmlns:a16="http://schemas.microsoft.com/office/drawing/2014/main" id="{D5B7E861-892A-4950-B127-ACA0FD500AC4}"/>
+                <a16:creationId xmlns:a16="http://schemas.microsoft.com/office/drawing/2014/main" id="{CA2B3121-D3E5-47CB-994D-BFA93004F5EF}"/>
               </a:ext>
             </a:extLst>
           </p:cNvPr>
@@ -19632,7 +19632,7 @@
           <p:cNvPr id="6" name="">
             <a:extLst xmlns:a="http://schemas.openxmlformats.org/drawingml/2006/main">
               <a:ext uri="{FF2B5EF4-FFF2-40B4-BE49-F238E27FC236}">
-                <a16:creationId xmlns:a16="http://schemas.microsoft.com/office/drawing/2014/main" id="{187D8410-DAD0-49B7-8226-8F31FA4E5B37}"/>
+                <a16:creationId xmlns:a16="http://schemas.microsoft.com/office/drawing/2014/main" id="{EFCBF658-7ADE-45E5-BD97-62E313A95546}"/>
               </a:ext>
             </a:extLst>
           </p:cNvPr>
@@ -19669,7 +19669,7 @@
           <p:cNvPr id="7" name="">
             <a:extLst xmlns:a="http://schemas.openxmlformats.org/drawingml/2006/main">
               <a:ext uri="{FF2B5EF4-FFF2-40B4-BE49-F238E27FC236}">
-                <a16:creationId xmlns:a16="http://schemas.microsoft.com/office/drawing/2014/main" id="{0C4FDDD1-7832-495D-87B7-96DAF8BA00BE}"/>
+                <a16:creationId xmlns:a16="http://schemas.microsoft.com/office/drawing/2014/main" id="{7806656D-238C-456E-A5FB-7FDA4B94D16C}"/>
               </a:ext>
             </a:extLst>
           </p:cNvPr>
@@ -19706,7 +19706,7 @@
           <p:cNvPr id="8" name="">
             <a:extLst xmlns:a="http://schemas.openxmlformats.org/drawingml/2006/main">
               <a:ext uri="{FF2B5EF4-FFF2-40B4-BE49-F238E27FC236}">
-                <a16:creationId xmlns:a16="http://schemas.microsoft.com/office/drawing/2014/main" id="{D2331B4B-F071-44F8-AD6B-4C486AFA9D49}"/>
+                <a16:creationId xmlns:a16="http://schemas.microsoft.com/office/drawing/2014/main" id="{B2B2ED55-5B5C-4352-AE3F-7C04459E60F8}"/>
               </a:ext>
             </a:extLst>
           </p:cNvPr>
@@ -19743,7 +19743,7 @@
           <p:cNvPr id="9" name="">
             <a:extLst xmlns:a="http://schemas.openxmlformats.org/drawingml/2006/main">
               <a:ext uri="{FF2B5EF4-FFF2-40B4-BE49-F238E27FC236}">
-                <a16:creationId xmlns:a16="http://schemas.microsoft.com/office/drawing/2014/main" id="{81D4DB5D-46CD-4056-AFC7-EB34FC3167D4}"/>
+                <a16:creationId xmlns:a16="http://schemas.microsoft.com/office/drawing/2014/main" id="{5A91ABC1-5415-43D7-BC18-C7D4E22B19D1}"/>
               </a:ext>
             </a:extLst>
           </p:cNvPr>
@@ -19801,7 +19801,7 @@
           <p:cNvPr id="10" name="">
             <a:extLst xmlns:a="http://schemas.openxmlformats.org/drawingml/2006/main">
               <a:ext uri="{FF2B5EF4-FFF2-40B4-BE49-F238E27FC236}">
-                <a16:creationId xmlns:a16="http://schemas.microsoft.com/office/drawing/2014/main" id="{E90CFB92-0D23-47A0-9EB1-5F8A21DE14F4}"/>
+                <a16:creationId xmlns:a16="http://schemas.microsoft.com/office/drawing/2014/main" id="{DFE9AC40-4785-42AF-9F7A-688AB1249C09}"/>
               </a:ext>
             </a:extLst>
           </p:cNvPr>
@@ -19859,7 +19859,7 @@
           <p:cNvPr id="11" name="">
             <a:extLst xmlns:a="http://schemas.openxmlformats.org/drawingml/2006/main">
               <a:ext uri="{FF2B5EF4-FFF2-40B4-BE49-F238E27FC236}">
-                <a16:creationId xmlns:a16="http://schemas.microsoft.com/office/drawing/2014/main" id="{BE4501B5-0B42-4220-8A63-6F5C92F3250F}"/>
+                <a16:creationId xmlns:a16="http://schemas.microsoft.com/office/drawing/2014/main" id="{3BDD6A73-E0B0-4FCC-BE22-0FC1B528C5F5}"/>
               </a:ext>
             </a:extLst>
           </p:cNvPr>
@@ -19894,7 +19894,7 @@
           <p:cNvPr id="12" name="">
             <a:extLst xmlns:a="http://schemas.openxmlformats.org/drawingml/2006/main">
               <a:ext uri="{FF2B5EF4-FFF2-40B4-BE49-F238E27FC236}">
-                <a16:creationId xmlns:a16="http://schemas.microsoft.com/office/drawing/2014/main" id="{828A8D4A-97EB-41B9-B3DD-A6EA8C2B969F}"/>
+                <a16:creationId xmlns:a16="http://schemas.microsoft.com/office/drawing/2014/main" id="{19C987E3-7886-4931-826A-FFD357BE7838}"/>
               </a:ext>
             </a:extLst>
           </p:cNvPr>
@@ -19927,7 +19927,7 @@
           <p:cNvPr id="13" name="">
             <a:extLst xmlns:a="http://schemas.openxmlformats.org/drawingml/2006/main">
               <a:ext uri="{FF2B5EF4-FFF2-40B4-BE49-F238E27FC236}">
-                <a16:creationId xmlns:a16="http://schemas.microsoft.com/office/drawing/2014/main" id="{B85E2E45-FE28-4A07-A37A-D5C05C91B5E8}"/>
+                <a16:creationId xmlns:a16="http://schemas.microsoft.com/office/drawing/2014/main" id="{97EFDC21-BD97-4906-ADA6-C2714EDEE16D}"/>
               </a:ext>
             </a:extLst>
           </p:cNvPr>
@@ -20002,7 +20002,7 @@
           <p:cNvPr id="14" name="">
             <a:extLst xmlns:a="http://schemas.openxmlformats.org/drawingml/2006/main">
               <a:ext uri="{FF2B5EF4-FFF2-40B4-BE49-F238E27FC236}">
-                <a16:creationId xmlns:a16="http://schemas.microsoft.com/office/drawing/2014/main" id="{96638370-C9EE-4D6A-B1DA-D39D4BB324FA}"/>
+                <a16:creationId xmlns:a16="http://schemas.microsoft.com/office/drawing/2014/main" id="{24B9D0DA-A1F4-41E4-A89C-95330AEB1DCC}"/>
               </a:ext>
             </a:extLst>
           </p:cNvPr>
@@ -20039,7 +20039,7 @@
           <p:cNvPr id="15" name="">
             <a:extLst xmlns:a="http://schemas.openxmlformats.org/drawingml/2006/main">
               <a:ext uri="{FF2B5EF4-FFF2-40B4-BE49-F238E27FC236}">
-                <a16:creationId xmlns:a16="http://schemas.microsoft.com/office/drawing/2014/main" id="{86AA4EF5-4E5E-42C1-97B5-E54B5BAE72AF}"/>
+                <a16:creationId xmlns:a16="http://schemas.microsoft.com/office/drawing/2014/main" id="{9C824847-677B-48B5-9F34-A421429AA0D5}"/>
               </a:ext>
             </a:extLst>
           </p:cNvPr>
@@ -20074,7 +20074,7 @@
           <p:cNvPr id="16" name="">
             <a:extLst xmlns:a="http://schemas.openxmlformats.org/drawingml/2006/main">
               <a:ext uri="{FF2B5EF4-FFF2-40B4-BE49-F238E27FC236}">
-                <a16:creationId xmlns:a16="http://schemas.microsoft.com/office/drawing/2014/main" id="{CF5BE442-CEF4-4A60-8678-B285A85CF07B}"/>
+                <a16:creationId xmlns:a16="http://schemas.microsoft.com/office/drawing/2014/main" id="{9E1A3FA7-525A-4E31-91F1-86350AE785DD}"/>
               </a:ext>
             </a:extLst>
           </p:cNvPr>
@@ -20132,7 +20132,7 @@
           <p:cNvPr id="17" name="">
             <a:extLst xmlns:a="http://schemas.openxmlformats.org/drawingml/2006/main">
               <a:ext uri="{FF2B5EF4-FFF2-40B4-BE49-F238E27FC236}">
-                <a16:creationId xmlns:a16="http://schemas.microsoft.com/office/drawing/2014/main" id="{9FBA5160-0529-416D-BCC2-76E3E9C2C32C}"/>
+                <a16:creationId xmlns:a16="http://schemas.microsoft.com/office/drawing/2014/main" id="{9AC9B2E5-95BF-4770-B7E9-1A8959D2274E}"/>
               </a:ext>
             </a:extLst>
           </p:cNvPr>
@@ -20224,7 +20224,7 @@
           <p:cNvPr id="18" name="">
             <a:extLst xmlns:a="http://schemas.openxmlformats.org/drawingml/2006/main">
               <a:ext uri="{FF2B5EF4-FFF2-40B4-BE49-F238E27FC236}">
-                <a16:creationId xmlns:a16="http://schemas.microsoft.com/office/drawing/2014/main" id="{04F8E94D-0915-43FD-A303-101B6B2AA808}"/>
+                <a16:creationId xmlns:a16="http://schemas.microsoft.com/office/drawing/2014/main" id="{9DFAB654-CA3E-40CA-899D-6375A353E31F}"/>
               </a:ext>
             </a:extLst>
           </p:cNvPr>
@@ -20261,7 +20261,7 @@
           <p:cNvPr id="19" name="">
             <a:extLst xmlns:a="http://schemas.openxmlformats.org/drawingml/2006/main">
               <a:ext uri="{FF2B5EF4-FFF2-40B4-BE49-F238E27FC236}">
-                <a16:creationId xmlns:a16="http://schemas.microsoft.com/office/drawing/2014/main" id="{ACC33DEB-7E64-4526-B6DA-0D625EB6B0CD}"/>
+                <a16:creationId xmlns:a16="http://schemas.microsoft.com/office/drawing/2014/main" id="{BD6EAD98-AE58-4C3A-8EEB-CE8AC3316800}"/>
               </a:ext>
             </a:extLst>
           </p:cNvPr>
@@ -20296,7 +20296,7 @@
           <p:cNvPr id="20" name="">
             <a:extLst xmlns:a="http://schemas.openxmlformats.org/drawingml/2006/main">
               <a:ext uri="{FF2B5EF4-FFF2-40B4-BE49-F238E27FC236}">
-                <a16:creationId xmlns:a16="http://schemas.microsoft.com/office/drawing/2014/main" id="{2DA53F90-5998-4DF4-B09F-9241CB1F136E}"/>
+                <a16:creationId xmlns:a16="http://schemas.microsoft.com/office/drawing/2014/main" id="{16892F0C-0EDA-4E4A-B102-FA246BC41414}"/>
               </a:ext>
             </a:extLst>
           </p:cNvPr>
@@ -20354,7 +20354,7 @@
           <p:cNvPr id="21" name="">
             <a:extLst xmlns:a="http://schemas.openxmlformats.org/drawingml/2006/main">
               <a:ext uri="{FF2B5EF4-FFF2-40B4-BE49-F238E27FC236}">
-                <a16:creationId xmlns:a16="http://schemas.microsoft.com/office/drawing/2014/main" id="{DE415BB1-96AF-46CB-ABA3-5F28A2AF0777}"/>
+                <a16:creationId xmlns:a16="http://schemas.microsoft.com/office/drawing/2014/main" id="{B6B531BA-7A49-4A0D-B0ED-CDBF5E7CD6E7}"/>
               </a:ext>
             </a:extLst>
           </p:cNvPr>
@@ -20429,7 +20429,7 @@
           <p:cNvPr id="22" name="">
             <a:extLst xmlns:a="http://schemas.openxmlformats.org/drawingml/2006/main">
               <a:ext uri="{FF2B5EF4-FFF2-40B4-BE49-F238E27FC236}">
-                <a16:creationId xmlns:a16="http://schemas.microsoft.com/office/drawing/2014/main" id="{0B7A7164-98DF-4916-BE99-72F414A510B6}"/>
+                <a16:creationId xmlns:a16="http://schemas.microsoft.com/office/drawing/2014/main" id="{562B0672-1921-4DE5-BEF8-298143783999}"/>
               </a:ext>
             </a:extLst>
           </p:cNvPr>
@@ -20466,7 +20466,7 @@
           <p:cNvPr id="23" name="">
             <a:extLst xmlns:a="http://schemas.openxmlformats.org/drawingml/2006/main">
               <a:ext uri="{FF2B5EF4-FFF2-40B4-BE49-F238E27FC236}">
-                <a16:creationId xmlns:a16="http://schemas.microsoft.com/office/drawing/2014/main" id="{E377B1D2-5DD5-49E6-9CD1-AED35A06AC47}"/>
+                <a16:creationId xmlns:a16="http://schemas.microsoft.com/office/drawing/2014/main" id="{19512C37-FEC4-4201-8F13-0EA9F1542DB7}"/>
               </a:ext>
             </a:extLst>
           </p:cNvPr>
@@ -20501,7 +20501,7 @@
           <p:cNvPr id="24" name="">
             <a:extLst xmlns:a="http://schemas.openxmlformats.org/drawingml/2006/main">
               <a:ext uri="{FF2B5EF4-FFF2-40B4-BE49-F238E27FC236}">
-                <a16:creationId xmlns:a16="http://schemas.microsoft.com/office/drawing/2014/main" id="{C6F8EEDE-660F-41F1-BB18-85905EA7A74F}"/>
+                <a16:creationId xmlns:a16="http://schemas.microsoft.com/office/drawing/2014/main" id="{A4BB9A12-4E8D-4D4B-A7BC-54E06DEE4C1B}"/>
               </a:ext>
             </a:extLst>
           </p:cNvPr>
@@ -20559,7 +20559,7 @@
           <p:cNvPr id="25" name="">
             <a:extLst xmlns:a="http://schemas.openxmlformats.org/drawingml/2006/main">
               <a:ext uri="{FF2B5EF4-FFF2-40B4-BE49-F238E27FC236}">
-                <a16:creationId xmlns:a16="http://schemas.microsoft.com/office/drawing/2014/main" id="{F86DBB6B-F2F9-4EE6-91B0-CEC7234D30AC}"/>
+                <a16:creationId xmlns:a16="http://schemas.microsoft.com/office/drawing/2014/main" id="{59139619-2F79-4016-AC4C-7133824505A6}"/>
               </a:ext>
             </a:extLst>
           </p:cNvPr>
@@ -20634,7 +20634,7 @@
           <p:cNvPr id="26" name="">
             <a:extLst xmlns:a="http://schemas.openxmlformats.org/drawingml/2006/main">
               <a:ext uri="{FF2B5EF4-FFF2-40B4-BE49-F238E27FC236}">
-                <a16:creationId xmlns:a16="http://schemas.microsoft.com/office/drawing/2014/main" id="{369C52FE-1970-45CC-A799-4BB15356344A}"/>
+                <a16:creationId xmlns:a16="http://schemas.microsoft.com/office/drawing/2014/main" id="{D63F14EB-D6D6-4A99-8D40-B9E8CAB1AEC8}"/>
               </a:ext>
             </a:extLst>
           </p:cNvPr>
@@ -20669,7 +20669,7 @@
           <p:cNvPr id="27" name="">
             <a:extLst xmlns:a="http://schemas.openxmlformats.org/drawingml/2006/main">
               <a:ext uri="{FF2B5EF4-FFF2-40B4-BE49-F238E27FC236}">
-                <a16:creationId xmlns:a16="http://schemas.microsoft.com/office/drawing/2014/main" id="{07E9419D-44EB-419B-89D0-195A343DFA02}"/>
+                <a16:creationId xmlns:a16="http://schemas.microsoft.com/office/drawing/2014/main" id="{DA4CFE49-BEFD-43B2-AB48-FA924D6A0A42}"/>
               </a:ext>
             </a:extLst>
           </p:cNvPr>
@@ -20704,7 +20704,7 @@
           <p:cNvPr id="28" name="">
             <a:extLst xmlns:a="http://schemas.openxmlformats.org/drawingml/2006/main">
               <a:ext uri="{FF2B5EF4-FFF2-40B4-BE49-F238E27FC236}">
-                <a16:creationId xmlns:a16="http://schemas.microsoft.com/office/drawing/2014/main" id="{BE2B81BC-A45F-4D08-8E1B-0FE993406F43}"/>
+                <a16:creationId xmlns:a16="http://schemas.microsoft.com/office/drawing/2014/main" id="{CDB9CC04-AC8C-40E1-AC6A-95EB544FF7DC}"/>
               </a:ext>
             </a:extLst>
           </p:cNvPr>
@@ -20762,7 +20762,7 @@
           <p:cNvPr id="29" name="">
             <a:extLst xmlns:a="http://schemas.openxmlformats.org/drawingml/2006/main">
               <a:ext uri="{FF2B5EF4-FFF2-40B4-BE49-F238E27FC236}">
-                <a16:creationId xmlns:a16="http://schemas.microsoft.com/office/drawing/2014/main" id="{EA09FA2B-25F6-43E8-8E01-3EE8D54C26F2}"/>
+                <a16:creationId xmlns:a16="http://schemas.microsoft.com/office/drawing/2014/main" id="{CA1DCFD2-3529-4B0B-9C3A-FB93082EA81B}"/>
               </a:ext>
             </a:extLst>
           </p:cNvPr>
@@ -20820,7 +20820,7 @@
           <p:cNvPr id="30" name="">
             <a:extLst xmlns:a="http://schemas.openxmlformats.org/drawingml/2006/main">
               <a:ext uri="{FF2B5EF4-FFF2-40B4-BE49-F238E27FC236}">
-                <a16:creationId xmlns:a16="http://schemas.microsoft.com/office/drawing/2014/main" id="{9EB601E4-FA2C-4E27-BA0D-0DD43DE4D343}"/>
+                <a16:creationId xmlns:a16="http://schemas.microsoft.com/office/drawing/2014/main" id="{DAFAD79D-C3B3-408D-A469-889BA5D7C32E}"/>
               </a:ext>
             </a:extLst>
           </p:cNvPr>
@@ -20855,7 +20855,7 @@
           <p:cNvPr id="31" name="">
             <a:extLst xmlns:a="http://schemas.openxmlformats.org/drawingml/2006/main">
               <a:ext uri="{FF2B5EF4-FFF2-40B4-BE49-F238E27FC236}">
-                <a16:creationId xmlns:a16="http://schemas.microsoft.com/office/drawing/2014/main" id="{A3F28CE0-1C3D-4C0B-9110-0D814E591303}"/>
+                <a16:creationId xmlns:a16="http://schemas.microsoft.com/office/drawing/2014/main" id="{F7878BAA-B863-471A-B790-4B38C3E23F59}"/>
               </a:ext>
             </a:extLst>
           </p:cNvPr>
@@ -20913,7 +20913,7 @@
           <p:cNvPr id="32" name="">
             <a:extLst xmlns:a="http://schemas.openxmlformats.org/drawingml/2006/main">
               <a:ext uri="{FF2B5EF4-FFF2-40B4-BE49-F238E27FC236}">
-                <a16:creationId xmlns:a16="http://schemas.microsoft.com/office/drawing/2014/main" id="{807B55EB-14E9-40B7-913E-509B99AC8E48}"/>
+                <a16:creationId xmlns:a16="http://schemas.microsoft.com/office/drawing/2014/main" id="{59BD7354-D222-4042-8006-85271BE459A0}"/>
               </a:ext>
             </a:extLst>
           </p:cNvPr>
@@ -20971,7 +20971,7 @@
           <p:cNvPr id="33" name="">
             <a:extLst xmlns:a="http://schemas.openxmlformats.org/drawingml/2006/main">
               <a:ext uri="{FF2B5EF4-FFF2-40B4-BE49-F238E27FC236}">
-                <a16:creationId xmlns:a16="http://schemas.microsoft.com/office/drawing/2014/main" id="{B8D1CAD0-9770-49E2-8E9F-314A67963A39}"/>
+                <a16:creationId xmlns:a16="http://schemas.microsoft.com/office/drawing/2014/main" id="{FC2BDAFD-AAA5-46D4-82A6-1D417BBA2E93}"/>
               </a:ext>
             </a:extLst>
           </p:cNvPr>
@@ -21027,7 +21027,7 @@
     </p:spTree>
     <p:extLst>
       <p:ext uri="{BB962C8B-B14F-4D97-AF65-F5344CB8AC3E}">
-        <p14:creationId xmlns:p14="http://schemas.microsoft.com/office/powerpoint/2010/main" val="1930331160"/>
+        <p14:creationId xmlns:p14="http://schemas.microsoft.com/office/powerpoint/2010/main" val="968263222"/>
       </p:ext>
     </p:extLst>
   </p:cSld>
@@ -21058,7 +21058,7 @@
           <p:cNvPr id="1" name="Slide Number Placeholder 5">
             <a:extLst xmlns:a="http://schemas.openxmlformats.org/drawingml/2006/main">
               <a:ext uri="{FF2B5EF4-FFF2-40B4-BE49-F238E27FC236}">
-                <a16:creationId xmlns:a16="http://schemas.microsoft.com/office/drawing/2014/main" id="{C5A324B5-703D-4DE1-A920-5C56CD46E34C}"/>
+                <a16:creationId xmlns:a16="http://schemas.microsoft.com/office/drawing/2014/main" id="{E12CE447-476B-4BAE-A1FF-E669E79965E6}"/>
               </a:ext>
             </a:extLst>
           </p:cNvPr>
@@ -21094,7 +21094,7 @@
           <p:nvPr/>
         </p:nvPicPr>
         <p:blipFill>
-          <a:blip xmlns:r="http://schemas.openxmlformats.org/officeDocument/2006/relationships" xmlns:a="http://schemas.openxmlformats.org/drawingml/2006/main" r:embed="Ra93379ac45db4fd3"/>
+          <a:blip xmlns:r="http://schemas.openxmlformats.org/officeDocument/2006/relationships" xmlns:a="http://schemas.openxmlformats.org/drawingml/2006/main" r:embed="Rb81ea05725de443f"/>
           <a:srcRect xmlns:a="http://schemas.openxmlformats.org/drawingml/2006/main" l="0" t="21875" r="0" b="21875"/>
           <a:stretch xmlns:a="http://schemas.openxmlformats.org/drawingml/2006/main">
             <a:fillRect l="0" t="0" r="0" b="0"/>
@@ -21115,7 +21115,7 @@
           <p:cNvPr id="3" name="">
             <a:extLst xmlns:a="http://schemas.openxmlformats.org/drawingml/2006/main">
               <a:ext uri="{FF2B5EF4-FFF2-40B4-BE49-F238E27FC236}">
-                <a16:creationId xmlns:a16="http://schemas.microsoft.com/office/drawing/2014/main" id="{39FD8399-878E-46BF-B7BE-04FC3E6E095A}"/>
+                <a16:creationId xmlns:a16="http://schemas.microsoft.com/office/drawing/2014/main" id="{C95BBB47-9165-4794-8BEB-BC0ADD34FB9F}"/>
               </a:ext>
             </a:extLst>
           </p:cNvPr>
@@ -21150,7 +21150,7 @@
           <p:cNvPr id="4" name="">
             <a:extLst xmlns:a="http://schemas.openxmlformats.org/drawingml/2006/main">
               <a:ext uri="{FF2B5EF4-FFF2-40B4-BE49-F238E27FC236}">
-                <a16:creationId xmlns:a16="http://schemas.microsoft.com/office/drawing/2014/main" id="{81988EED-6C18-4895-A11E-5B91C0F44B94}"/>
+                <a16:creationId xmlns:a16="http://schemas.microsoft.com/office/drawing/2014/main" id="{2306754F-0257-49FF-97D6-C311E98B1F67}"/>
               </a:ext>
             </a:extLst>
           </p:cNvPr>
@@ -21185,7 +21185,7 @@
           <p:cNvPr id="5" name="">
             <a:extLst xmlns:a="http://schemas.openxmlformats.org/drawingml/2006/main">
               <a:ext uri="{FF2B5EF4-FFF2-40B4-BE49-F238E27FC236}">
-                <a16:creationId xmlns:a16="http://schemas.microsoft.com/office/drawing/2014/main" id="{FA1793DC-BA29-49E7-A213-9122821B450D}"/>
+                <a16:creationId xmlns:a16="http://schemas.microsoft.com/office/drawing/2014/main" id="{238C9EE0-BB03-4B18-AA48-AF191A3916B7}"/>
               </a:ext>
             </a:extLst>
           </p:cNvPr>
@@ -21222,7 +21222,7 @@
           <p:cNvPr id="6" name="">
             <a:extLst xmlns:a="http://schemas.openxmlformats.org/drawingml/2006/main">
               <a:ext uri="{FF2B5EF4-FFF2-40B4-BE49-F238E27FC236}">
-                <a16:creationId xmlns:a16="http://schemas.microsoft.com/office/drawing/2014/main" id="{C84F53D4-A9F8-4401-AE49-4890F594E76E}"/>
+                <a16:creationId xmlns:a16="http://schemas.microsoft.com/office/drawing/2014/main" id="{9A0E4700-6338-46A4-9FA9-E898E2D7AAEF}"/>
               </a:ext>
             </a:extLst>
           </p:cNvPr>
@@ -21259,7 +21259,7 @@
           <p:cNvPr id="7" name="">
             <a:extLst xmlns:a="http://schemas.openxmlformats.org/drawingml/2006/main">
               <a:ext uri="{FF2B5EF4-FFF2-40B4-BE49-F238E27FC236}">
-                <a16:creationId xmlns:a16="http://schemas.microsoft.com/office/drawing/2014/main" id="{E4B8EBF0-7301-482B-B3B1-4D4C2EA1E556}"/>
+                <a16:creationId xmlns:a16="http://schemas.microsoft.com/office/drawing/2014/main" id="{34931C99-AD58-4211-8B11-9F498A613F71}"/>
               </a:ext>
             </a:extLst>
           </p:cNvPr>
@@ -21296,7 +21296,7 @@
           <p:cNvPr id="8" name="">
             <a:extLst xmlns:a="http://schemas.openxmlformats.org/drawingml/2006/main">
               <a:ext uri="{FF2B5EF4-FFF2-40B4-BE49-F238E27FC236}">
-                <a16:creationId xmlns:a16="http://schemas.microsoft.com/office/drawing/2014/main" id="{80C74EBA-563C-4419-8293-6E982BA6CEA3}"/>
+                <a16:creationId xmlns:a16="http://schemas.microsoft.com/office/drawing/2014/main" id="{DDA7DC33-B406-46DE-843A-1B722FAA09A5}"/>
               </a:ext>
             </a:extLst>
           </p:cNvPr>
@@ -21333,7 +21333,7 @@
           <p:cNvPr id="9" name="">
             <a:extLst xmlns:a="http://schemas.openxmlformats.org/drawingml/2006/main">
               <a:ext uri="{FF2B5EF4-FFF2-40B4-BE49-F238E27FC236}">
-                <a16:creationId xmlns:a16="http://schemas.microsoft.com/office/drawing/2014/main" id="{BDD70E91-9C99-4A49-B315-474499E52E66}"/>
+                <a16:creationId xmlns:a16="http://schemas.microsoft.com/office/drawing/2014/main" id="{06511CF3-1DF8-4365-9A13-255833BD7E8F}"/>
               </a:ext>
             </a:extLst>
           </p:cNvPr>
@@ -21391,7 +21391,7 @@
           <p:cNvPr id="10" name="">
             <a:extLst xmlns:a="http://schemas.openxmlformats.org/drawingml/2006/main">
               <a:ext uri="{FF2B5EF4-FFF2-40B4-BE49-F238E27FC236}">
-                <a16:creationId xmlns:a16="http://schemas.microsoft.com/office/drawing/2014/main" id="{A28877E1-4964-488B-A620-BA6B2E8E89BA}"/>
+                <a16:creationId xmlns:a16="http://schemas.microsoft.com/office/drawing/2014/main" id="{0CA5DE55-61FB-47BB-9797-CDB6589C6CD1}"/>
               </a:ext>
             </a:extLst>
           </p:cNvPr>
@@ -21449,7 +21449,7 @@
           <p:cNvPr id="11" name="">
             <a:extLst xmlns:a="http://schemas.openxmlformats.org/drawingml/2006/main">
               <a:ext uri="{FF2B5EF4-FFF2-40B4-BE49-F238E27FC236}">
-                <a16:creationId xmlns:a16="http://schemas.microsoft.com/office/drawing/2014/main" id="{69F91392-A850-4155-956E-BB69F062330C}"/>
+                <a16:creationId xmlns:a16="http://schemas.microsoft.com/office/drawing/2014/main" id="{F9C8BDA7-52E6-49D2-B818-005F10B4492C}"/>
               </a:ext>
             </a:extLst>
           </p:cNvPr>
@@ -21484,7 +21484,7 @@
           <p:cNvPr id="12" name="">
             <a:extLst xmlns:a="http://schemas.openxmlformats.org/drawingml/2006/main">
               <a:ext uri="{FF2B5EF4-FFF2-40B4-BE49-F238E27FC236}">
-                <a16:creationId xmlns:a16="http://schemas.microsoft.com/office/drawing/2014/main" id="{CE206BFC-2C1B-4337-AEB5-B7C042A179B7}"/>
+                <a16:creationId xmlns:a16="http://schemas.microsoft.com/office/drawing/2014/main" id="{0744AFA6-9497-4453-870C-1C93ACDABABF}"/>
               </a:ext>
             </a:extLst>
           </p:cNvPr>
@@ -21517,7 +21517,7 @@
           <p:cNvPr id="13" name="">
             <a:extLst xmlns:a="http://schemas.openxmlformats.org/drawingml/2006/main">
               <a:ext uri="{FF2B5EF4-FFF2-40B4-BE49-F238E27FC236}">
-                <a16:creationId xmlns:a16="http://schemas.microsoft.com/office/drawing/2014/main" id="{ABC8187B-7231-4AF2-AA1D-C5AF7C6EAFAD}"/>
+                <a16:creationId xmlns:a16="http://schemas.microsoft.com/office/drawing/2014/main" id="{C31D58EF-7466-4155-86A5-11239B066E2E}"/>
               </a:ext>
             </a:extLst>
           </p:cNvPr>
@@ -21592,7 +21592,7 @@
           <p:cNvPr id="14" name="">
             <a:extLst xmlns:a="http://schemas.openxmlformats.org/drawingml/2006/main">
               <a:ext uri="{FF2B5EF4-FFF2-40B4-BE49-F238E27FC236}">
-                <a16:creationId xmlns:a16="http://schemas.microsoft.com/office/drawing/2014/main" id="{5034869A-7258-485E-8BBB-AC634539B9E9}"/>
+                <a16:creationId xmlns:a16="http://schemas.microsoft.com/office/drawing/2014/main" id="{C2F618B4-53D2-428A-9E28-A0F3DB479C1A}"/>
               </a:ext>
             </a:extLst>
           </p:cNvPr>
@@ -21627,7 +21627,7 @@
           <p:cNvPr id="15" name="">
             <a:extLst xmlns:a="http://schemas.openxmlformats.org/drawingml/2006/main">
               <a:ext uri="{FF2B5EF4-FFF2-40B4-BE49-F238E27FC236}">
-                <a16:creationId xmlns:a16="http://schemas.microsoft.com/office/drawing/2014/main" id="{1BE8BCC9-2854-491C-AA87-8D5473D06314}"/>
+                <a16:creationId xmlns:a16="http://schemas.microsoft.com/office/drawing/2014/main" id="{E1ED32DC-6210-47FC-83CA-E57265B7B235}"/>
               </a:ext>
             </a:extLst>
           </p:cNvPr>
@@ -21662,7 +21662,7 @@
           <p:cNvPr id="16" name="">
             <a:extLst xmlns:a="http://schemas.openxmlformats.org/drawingml/2006/main">
               <a:ext uri="{FF2B5EF4-FFF2-40B4-BE49-F238E27FC236}">
-                <a16:creationId xmlns:a16="http://schemas.microsoft.com/office/drawing/2014/main" id="{F2F8AE6C-AA6A-468A-9A07-E2251AEE40CD}"/>
+                <a16:creationId xmlns:a16="http://schemas.microsoft.com/office/drawing/2014/main" id="{1D4CE18C-93F9-4CE3-A78B-0BE093C9725A}"/>
               </a:ext>
             </a:extLst>
           </p:cNvPr>
@@ -21720,7 +21720,7 @@
           <p:cNvPr id="17" name="">
             <a:extLst xmlns:a="http://schemas.openxmlformats.org/drawingml/2006/main">
               <a:ext uri="{FF2B5EF4-FFF2-40B4-BE49-F238E27FC236}">
-                <a16:creationId xmlns:a16="http://schemas.microsoft.com/office/drawing/2014/main" id="{1D6A13F8-2593-4152-BC1F-6BA2405CD8C7}"/>
+                <a16:creationId xmlns:a16="http://schemas.microsoft.com/office/drawing/2014/main" id="{5C1AB72A-419C-451F-8133-6D0F90D3DF65}"/>
               </a:ext>
             </a:extLst>
           </p:cNvPr>
@@ -21757,7 +21757,7 @@
           <p:cNvPr id="18" name="">
             <a:extLst xmlns:a="http://schemas.openxmlformats.org/drawingml/2006/main">
               <a:ext uri="{FF2B5EF4-FFF2-40B4-BE49-F238E27FC236}">
-                <a16:creationId xmlns:a16="http://schemas.microsoft.com/office/drawing/2014/main" id="{398ACFFC-565C-4B3F-9550-217C932CAABE}"/>
+                <a16:creationId xmlns:a16="http://schemas.microsoft.com/office/drawing/2014/main" id="{DB6D2E87-E2BA-4A9A-AF5F-1E0B6CFB5F8E}"/>
               </a:ext>
             </a:extLst>
           </p:cNvPr>
@@ -21792,7 +21792,7 @@
           <p:cNvPr id="19" name="">
             <a:extLst xmlns:a="http://schemas.openxmlformats.org/drawingml/2006/main">
               <a:ext uri="{FF2B5EF4-FFF2-40B4-BE49-F238E27FC236}">
-                <a16:creationId xmlns:a16="http://schemas.microsoft.com/office/drawing/2014/main" id="{8C266F9E-C348-4D3A-9AB6-10FD1F43673C}"/>
+                <a16:creationId xmlns:a16="http://schemas.microsoft.com/office/drawing/2014/main" id="{0497C5D2-B7F2-48C1-A5A7-759C9AD3BF16}"/>
               </a:ext>
             </a:extLst>
           </p:cNvPr>
@@ -21850,7 +21850,7 @@
           <p:cNvPr id="20" name="">
             <a:extLst xmlns:a="http://schemas.openxmlformats.org/drawingml/2006/main">
               <a:ext uri="{FF2B5EF4-FFF2-40B4-BE49-F238E27FC236}">
-                <a16:creationId xmlns:a16="http://schemas.microsoft.com/office/drawing/2014/main" id="{E16E6958-5371-4141-BF1B-BB8575FFF733}"/>
+                <a16:creationId xmlns:a16="http://schemas.microsoft.com/office/drawing/2014/main" id="{F1FF67FF-5A4A-4072-96F5-D90B52AE6C62}"/>
               </a:ext>
             </a:extLst>
           </p:cNvPr>
@@ -21942,7 +21942,7 @@
           <p:cNvPr id="21" name="">
             <a:extLst xmlns:a="http://schemas.openxmlformats.org/drawingml/2006/main">
               <a:ext uri="{FF2B5EF4-FFF2-40B4-BE49-F238E27FC236}">
-                <a16:creationId xmlns:a16="http://schemas.microsoft.com/office/drawing/2014/main" id="{4977256D-8AC4-4858-847E-A5FBAB11D3BC}"/>
+                <a16:creationId xmlns:a16="http://schemas.microsoft.com/office/drawing/2014/main" id="{B5A243F3-05FB-4B35-AEFD-CCF5D0F7ABF6}"/>
               </a:ext>
             </a:extLst>
           </p:cNvPr>
@@ -21979,7 +21979,7 @@
           <p:cNvPr id="22" name="">
             <a:extLst xmlns:a="http://schemas.openxmlformats.org/drawingml/2006/main">
               <a:ext uri="{FF2B5EF4-FFF2-40B4-BE49-F238E27FC236}">
-                <a16:creationId xmlns:a16="http://schemas.microsoft.com/office/drawing/2014/main" id="{946FE4AD-DD40-4436-A5BE-76395B2E420E}"/>
+                <a16:creationId xmlns:a16="http://schemas.microsoft.com/office/drawing/2014/main" id="{8A55DFF6-FB71-46DC-89FF-1E32DA57AFFE}"/>
               </a:ext>
             </a:extLst>
           </p:cNvPr>
@@ -22014,7 +22014,7 @@
           <p:cNvPr id="23" name="">
             <a:extLst xmlns:a="http://schemas.openxmlformats.org/drawingml/2006/main">
               <a:ext uri="{FF2B5EF4-FFF2-40B4-BE49-F238E27FC236}">
-                <a16:creationId xmlns:a16="http://schemas.microsoft.com/office/drawing/2014/main" id="{B9553D70-1E82-4465-B135-B29E2D7E9C57}"/>
+                <a16:creationId xmlns:a16="http://schemas.microsoft.com/office/drawing/2014/main" id="{EF10AEB4-1C3B-4C2B-A386-03DF92A7C68B}"/>
               </a:ext>
             </a:extLst>
           </p:cNvPr>
@@ -22072,7 +22072,7 @@
           <p:cNvPr id="24" name="">
             <a:extLst xmlns:a="http://schemas.openxmlformats.org/drawingml/2006/main">
               <a:ext uri="{FF2B5EF4-FFF2-40B4-BE49-F238E27FC236}">
-                <a16:creationId xmlns:a16="http://schemas.microsoft.com/office/drawing/2014/main" id="{2956D7A2-C0A3-4E64-AE3F-37528B7D56D3}"/>
+                <a16:creationId xmlns:a16="http://schemas.microsoft.com/office/drawing/2014/main" id="{FC18C74D-FF3E-494B-859E-B2D21F23C0A6}"/>
               </a:ext>
             </a:extLst>
           </p:cNvPr>
@@ -22181,7 +22181,7 @@
           <p:cNvPr id="25" name="">
             <a:extLst xmlns:a="http://schemas.openxmlformats.org/drawingml/2006/main">
               <a:ext uri="{FF2B5EF4-FFF2-40B4-BE49-F238E27FC236}">
-                <a16:creationId xmlns:a16="http://schemas.microsoft.com/office/drawing/2014/main" id="{27F13121-B859-4359-80E5-93CDF5B471C2}"/>
+                <a16:creationId xmlns:a16="http://schemas.microsoft.com/office/drawing/2014/main" id="{E3255291-28D7-4ABA-8B45-913F6713D761}"/>
               </a:ext>
             </a:extLst>
           </p:cNvPr>
@@ -22214,7 +22214,7 @@
           <p:cNvPr id="26" name="">
             <a:extLst xmlns:a="http://schemas.openxmlformats.org/drawingml/2006/main">
               <a:ext uri="{FF2B5EF4-FFF2-40B4-BE49-F238E27FC236}">
-                <a16:creationId xmlns:a16="http://schemas.microsoft.com/office/drawing/2014/main" id="{DDFC1ED3-FAE7-420B-8179-54D2245F5E08}"/>
+                <a16:creationId xmlns:a16="http://schemas.microsoft.com/office/drawing/2014/main" id="{62AAF860-CAF6-4A7E-9EA2-C37C24A37EE8}"/>
               </a:ext>
             </a:extLst>
           </p:cNvPr>
@@ -22268,7 +22268,7 @@
           <p:cNvPr id="27" name="">
             <a:extLst xmlns:a="http://schemas.openxmlformats.org/drawingml/2006/main">
               <a:ext uri="{FF2B5EF4-FFF2-40B4-BE49-F238E27FC236}">
-                <a16:creationId xmlns:a16="http://schemas.microsoft.com/office/drawing/2014/main" id="{9F4BBC79-A199-4225-8EC9-20584ED1B75F}"/>
+                <a16:creationId xmlns:a16="http://schemas.microsoft.com/office/drawing/2014/main" id="{BF47C9D9-149A-4356-B9C0-77EEC2E1F71B}"/>
               </a:ext>
             </a:extLst>
           </p:cNvPr>
@@ -22324,7 +22324,7 @@
     </p:spTree>
     <p:extLst>
       <p:ext uri="{BB962C8B-B14F-4D97-AF65-F5344CB8AC3E}">
-        <p14:creationId xmlns:p14="http://schemas.microsoft.com/office/powerpoint/2010/main" val="278678487"/>
+        <p14:creationId xmlns:p14="http://schemas.microsoft.com/office/powerpoint/2010/main" val="1174361897"/>
       </p:ext>
     </p:extLst>
   </p:cSld>

</xml_diff>

<commit_message>
organoid: update build deck fonts patch
</commit_message>
<xml_diff>
--- a/collections/organoid/presentation/brain-organoid-question-journey/outputs/output.pptx
+++ b/collections/organoid/presentation/brain-organoid-question-journey/outputs/output.pptx
@@ -24138,14 +24138,14 @@
     </a:clrScheme>
     <a:fontScheme name="Office">
       <a:majorFont>
-        <a:latin typeface="Calibri Light"/>
-        <a:ea typeface="Calibri Light"/>
-        <a:cs typeface="Calibri Light"/>
+        <a:latin typeface="Arial"/>
+        <a:ea typeface="Malgun Gothic"/>
+        <a:cs typeface="Arial"/>
       </a:majorFont>
       <a:minorFont>
-        <a:latin typeface="Calibri"/>
-        <a:ea typeface="Calibri"/>
-        <a:cs typeface="Calibri"/>
+        <a:latin typeface="Arial"/>
+        <a:ea typeface="Malgun Gothic"/>
+        <a:cs typeface="Arial"/>
       </a:minorFont>
     </a:fontScheme>
     <a:fmtScheme name="ChatGPT">

</xml_diff>